<commit_message>
docs(deck): speaker notes on every slide
Co-Authored-By: Claude Opus 5.5 <noreply@anthropic.com>
</commit_message>
<xml_diff>
--- a/docs/MK-Workstation-Overview.pptx
+++ b/docs/MK-Workstation-Overview.pptx
@@ -120,40 +120,40 @@
   <p:extLst>
     <p:ext uri="{521415D9-36F7-43E2-AB2F-B90AF26B5E84}">
       <p14:sectionLst xmlns:p14="http://schemas.microsoft.com/office/powerpoint/2010/main">
-        <p14:section name="Introduction" id="{8afaae0c-c0fe-d73f-6d63-d97c7a996e2f}">
+        <p14:section name="Introduction" id="{c7eab502-350c-e47f-9b86-8e6a6f4995b9}">
           <p14:sldIdLst>
             <p14:sldId id="256"/>
             <p14:sldId id="257"/>
           </p14:sldIdLst>
         </p14:section>
-        <p14:section name="Your desktop" id="{f16ee782-c136-1a6a-7bcb-1e95aab66506}">
+        <p14:section name="Your desktop" id="{ed974c15-597a-bcfe-c83a-8774bd858e2b}">
           <p14:sldIdLst>
             <p14:sldId id="258"/>
             <p14:sldId id="259"/>
             <p14:sldId id="260"/>
           </p14:sldIdLst>
         </p14:section>
-        <p14:section name="MK Notes" id="{301c69b8-0420-321a-80fd-64aa6780ef68}">
+        <p14:section name="MK Notes" id="{65de2850-f9fa-44d9-852f-c3bb52d4bd1b}">
           <p14:sldIdLst>
             <p14:sldId id="261"/>
             <p14:sldId id="262"/>
           </p14:sldIdLst>
         </p14:section>
-        <p14:section name="Focus and tools" id="{5e5ee783-0940-fa91-3c87-b6d30ba1a433}">
+        <p14:section name="Focus and tools" id="{1e00c473-e657-deea-23a0-4c5f7495f06b}">
           <p14:sldIdLst>
             <p14:sldId id="263"/>
             <p14:sldId id="264"/>
             <p14:sldId id="265"/>
           </p14:sldIdLst>
         </p14:section>
-        <p14:section name="Your computer" id="{1381de5a-cf23-964c-db97-f82fa92b5321}">
+        <p14:section name="Your computer" id="{18d463dc-6249-b302-56d1-7d31d3447606}">
           <p14:sldIdLst>
             <p14:sldId id="266"/>
             <p14:sldId id="267"/>
             <p14:sldId id="268"/>
           </p14:sldIdLst>
         </p14:section>
-        <p14:section name="Get started" id="{90d8be71-231d-4070-c3b5-a376759a68ca}">
+        <p14:section name="Get started" id="{8abba257-a351-6ef1-4ac3-2f7f5e14aab8}">
           <p14:sldIdLst>
             <p14:sldId id="269"/>
           </p14:sldIdLst>
@@ -650,7 +650,7 @@
           <a:p>
             <a:r>
               <a:rPr lang="en-US" dirty="0"/>
-              <a:t/>
+              <a:t>The apps people ask for are there on first login, including Joplin, ONLYOFFICE, Zen and VS Code. The app lists are plain text files you can edit.</a:t>
             </a:r>
             <a:endParaRPr lang="en-US" dirty="0"/>
           </a:p>
@@ -738,7 +738,7 @@
           <a:p>
             <a:r>
               <a:rPr lang="en-US" dirty="0"/>
-              <a:t/>
+              <a:t>It checks the hardware first: fingerprint or face unlock where there's a reader, power profiles on battery, speaker tuning, touch and 2-in-1 support, the right video driver.</a:t>
             </a:r>
             <a:endParaRPr lang="en-US" dirty="0"/>
           </a:p>
@@ -826,7 +826,7 @@
           <a:p>
             <a:r>
               <a:rPr lang="en-US" dirty="0"/>
-              <a:t/>
+              <a:t>Shortcuts follow Windows and macOS habits. Super+/ shows every one live and lets you change any key.</a:t>
             </a:r>
             <a:endParaRPr lang="en-US" dirty="0"/>
           </a:p>
@@ -914,7 +914,7 @@
           <a:p>
             <a:r>
               <a:rPr lang="en-US" dirty="0"/>
-              <a:t/>
+              <a:t>Every change is snapshotted, mk restore undoes it and mk uninstall removes MK's tools. mk doctor checks health; mk update updates everything.</a:t>
             </a:r>
             <a:endParaRPr lang="en-US" dirty="0"/>
           </a:p>
@@ -1002,7 +1002,7 @@
           <a:p>
             <a:r>
               <a:rPr lang="en-US" dirty="0"/>
-              <a:t/>
+              <a:t>Clone, change into the folder, run setup with sudo. It asks before anything optional, like face unlock. Then log out and back in.</a:t>
             </a:r>
             <a:endParaRPr lang="en-US" dirty="0"/>
           </a:p>
@@ -1090,7 +1090,7 @@
           <a:p>
             <a:r>
               <a:rPr lang="en-US" dirty="0"/>
-              <a:t/>
+              <a:t>Fedora is a great base but bare. Setting it up by hand takes a weekend; MK does it in one command and about fifteen minutes, and everything stays a normal GNOME setting you can undo.</a:t>
             </a:r>
             <a:endParaRPr lang="en-US" dirty="0"/>
           </a:p>
@@ -1266,7 +1266,7 @@
           <a:p>
             <a:r>
               <a:rPr lang="en-US" dirty="0"/>
-              <a:t/>
+              <a:t>Windows-style snapping: Super and the arrows for halves and quarters, Super+Z for layouts, Snap Assist offers the other windows for the free space.</a:t>
             </a:r>
             <a:endParaRPr lang="en-US" dirty="0"/>
           </a:p>
@@ -1354,7 +1354,7 @@
           <a:p>
             <a:r>
               <a:rPr lang="en-US" dirty="0"/>
-              <a:t/>
+              <a:t>After login the light runs round the screen once the desktop is ready, and the greeting shows your pinned tasks and next reminder. The colours across the desktop come from your wallpaper.</a:t>
             </a:r>
             <a:endParaRPr lang="en-US" dirty="0"/>
           </a:p>
@@ -1442,7 +1442,7 @@
           <a:p>
             <a:r>
               <a:rPr lang="en-US" dirty="0"/>
-              <a:t/>
+              <a:t>MK Notes keeps notes as plain Markdown files. Links, backlinks and a graph; draw with a pen; paste screenshots; edit with a live preview. The same notes are on your phone.</a:t>
             </a:r>
             <a:endParaRPr lang="en-US" dirty="0"/>
           </a:p>
@@ -1530,7 +1530,7 @@
           <a:p>
             <a:r>
               <a:rPr lang="en-US" dirty="0"/>
-              <a:t/>
+              <a:t>Sync to your phone over Wi-Fi, PDF export, publishing as a website and version history are built in, plus a tasks view, a daily-notes calendar, focus mode and your own look.</a:t>
             </a:r>
             <a:endParaRPr lang="en-US" dirty="0"/>
           </a:p>
@@ -1618,7 +1618,7 @@
           <a:p>
             <a:r>
               <a:rPr lang="en-US" dirty="0"/>
-              <a:t/>
+              <a:t>The focus timer counts down in the top bar. Step away and a screensaver plays over your work; when time's up there's a small celebration instead of an alarm.</a:t>
             </a:r>
             <a:endParaRPr lang="en-US" dirty="0"/>
           </a:p>
@@ -1706,7 +1706,7 @@
           <a:p>
             <a:r>
               <a:rPr lang="en-US" dirty="0"/>
-              <a:t/>
+              <a:t>A light system monitor in the top bar with honest numbers, clipboard history on Super+V, a keep-awake switch and the usual tray icons.</a:t>
             </a:r>
             <a:endParaRPr lang="en-US" dirty="0"/>
           </a:p>
@@ -2533,7 +2533,7 @@
       </p:grpSpPr>
       <p:pic>
         <p:nvPicPr>
-          <p:cNvPr id="2" name="hero" descr="/tmp/tmp.Shm5PlvpZ0/img/welcome.jpg">    </p:cNvPr>
+          <p:cNvPr id="2" name="hero" descr="/tmp/tmp.WjEaqILH74/img/welcome.jpg">    </p:cNvPr>
           <p:cNvPicPr>
             <a:picLocks noChangeAspect="1"/>
           </p:cNvPicPr>
@@ -2805,7 +2805,7 @@
       </p:sp>
       <p:pic>
         <p:nvPicPr>
-          <p:cNvPr id="4" name="app-129" descr="/tmp/tmp.Shm5PlvpZ0/apps/app.zen_browser.zen.png">    </p:cNvPr>
+          <p:cNvPr id="5" name="app-129" descr="/tmp/tmp.WjEaqILH74/apps/app.zen_browser.zen.png">    </p:cNvPr>
           <p:cNvPicPr>
             <a:picLocks noChangeAspect="1"/>
           </p:cNvPicPr>
@@ -2829,7 +2829,7 @@
       </p:pic>
       <p:sp>
         <p:nvSpPr>
-          <p:cNvPr id="5" name="applabel-130"/>
+          <p:cNvPr id="6" name="applabel-130"/>
           <p:cNvSpPr txBox="1"/>
           <p:nvPr/>
         </p:nvSpPr>
@@ -2865,7 +2865,7 @@
       </p:sp>
       <p:pic>
         <p:nvPicPr>
-          <p:cNvPr id="6" name="app-131" descr="/tmp/tmp.Shm5PlvpZ0/apps/net.cozic.joplin_desktop.png">    </p:cNvPr>
+          <p:cNvPr id="7" name="app-131" descr="/tmp/tmp.WjEaqILH74/apps/net.cozic.joplin_desktop.png">    </p:cNvPr>
           <p:cNvPicPr>
             <a:picLocks noChangeAspect="1"/>
           </p:cNvPicPr>
@@ -2889,7 +2889,7 @@
       </p:pic>
       <p:sp>
         <p:nvSpPr>
-          <p:cNvPr id="7" name="applabel-132"/>
+          <p:cNvPr id="8" name="applabel-132"/>
           <p:cNvSpPr txBox="1"/>
           <p:nvPr/>
         </p:nvSpPr>
@@ -2925,7 +2925,7 @@
       </p:sp>
       <p:pic>
         <p:nvPicPr>
-          <p:cNvPr id="8" name="app-133" descr="/tmp/tmp.Shm5PlvpZ0/apps/org.onlyoffice.desktopeditors.png">    </p:cNvPr>
+          <p:cNvPr id="9" name="app-133" descr="/tmp/tmp.WjEaqILH74/apps/org.onlyoffice.desktopeditors.png">    </p:cNvPr>
           <p:cNvPicPr>
             <a:picLocks noChangeAspect="1"/>
           </p:cNvPicPr>
@@ -2949,7 +2949,7 @@
       </p:pic>
       <p:sp>
         <p:nvSpPr>
-          <p:cNvPr id="9" name="applabel-134"/>
+          <p:cNvPr id="10" name="applabel-134"/>
           <p:cNvSpPr txBox="1"/>
           <p:nvPr/>
         </p:nvSpPr>
@@ -2985,7 +2985,7 @@
       </p:sp>
       <p:pic>
         <p:nvPicPr>
-          <p:cNvPr id="10" name="app-135" descr="/tmp/tmp.Shm5PlvpZ0/apps/vscode.png">    </p:cNvPr>
+          <p:cNvPr id="11" name="app-135" descr="/tmp/tmp.WjEaqILH74/apps/vscode.png">    </p:cNvPr>
           <p:cNvPicPr>
             <a:picLocks noChangeAspect="1"/>
           </p:cNvPicPr>
@@ -3009,7 +3009,7 @@
       </p:pic>
       <p:sp>
         <p:nvSpPr>
-          <p:cNvPr id="11" name="applabel-136"/>
+          <p:cNvPr id="12" name="applabel-136"/>
           <p:cNvSpPr txBox="1"/>
           <p:nvPr/>
         </p:nvSpPr>
@@ -3045,7 +3045,7 @@
       </p:sp>
       <p:pic>
         <p:nvPicPr>
-          <p:cNvPr id="12" name="app-137" descr="/tmp/tmp.Shm5PlvpZ0/apps/com.spotify.Client.png">    </p:cNvPr>
+          <p:cNvPr id="13" name="app-137" descr="/tmp/tmp.WjEaqILH74/apps/com.spotify.Client.png">    </p:cNvPr>
           <p:cNvPicPr>
             <a:picLocks noChangeAspect="1"/>
           </p:cNvPicPr>
@@ -3069,7 +3069,7 @@
       </p:pic>
       <p:sp>
         <p:nvSpPr>
-          <p:cNvPr id="13" name="applabel-138"/>
+          <p:cNvPr id="14" name="applabel-138"/>
           <p:cNvSpPr txBox="1"/>
           <p:nvPr/>
         </p:nvSpPr>
@@ -3105,7 +3105,7 @@
       </p:sp>
       <p:pic>
         <p:nvPicPr>
-          <p:cNvPr id="14" name="app-139" descr="/tmp/tmp.Shm5PlvpZ0/apps/net.lutris.Lutris.png">    </p:cNvPr>
+          <p:cNvPr id="15" name="app-139" descr="/tmp/tmp.WjEaqILH74/apps/net.lutris.Lutris.png">    </p:cNvPr>
           <p:cNvPicPr>
             <a:picLocks noChangeAspect="1"/>
           </p:cNvPicPr>
@@ -3129,7 +3129,7 @@
       </p:pic>
       <p:sp>
         <p:nvSpPr>
-          <p:cNvPr id="15" name="applabel-140"/>
+          <p:cNvPr id="16" name="applabel-140"/>
           <p:cNvSpPr txBox="1"/>
           <p:nvPr/>
         </p:nvSpPr>
@@ -3165,7 +3165,7 @@
       </p:sp>
       <p:pic>
         <p:nvPicPr>
-          <p:cNvPr id="16" name="app-141" descr="/tmp/tmp.Shm5PlvpZ0/apps/com.mattjakeman.ExtensionManager.png">    </p:cNvPr>
+          <p:cNvPr id="17" name="app-141" descr="/tmp/tmp.WjEaqILH74/apps/com.mattjakeman.ExtensionManager.png">    </p:cNvPr>
           <p:cNvPicPr>
             <a:picLocks noChangeAspect="1"/>
           </p:cNvPicPr>
@@ -3189,7 +3189,7 @@
       </p:pic>
       <p:sp>
         <p:nvSpPr>
-          <p:cNvPr id="17" name="applabel-142"/>
+          <p:cNvPr id="18" name="applabel-142"/>
           <p:cNvSpPr txBox="1"/>
           <p:nvPr/>
         </p:nvSpPr>
@@ -3225,7 +3225,7 @@
       </p:sp>
       <p:pic>
         <p:nvPicPr>
-          <p:cNvPr id="18" name="app-143" descr="/tmp/tmp.Shm5PlvpZ0/apps/net.sonobus.SonoBus.png">    </p:cNvPr>
+          <p:cNvPr id="19" name="app-143" descr="/tmp/tmp.WjEaqILH74/apps/net.sonobus.SonoBus.png">    </p:cNvPr>
           <p:cNvPicPr>
             <a:picLocks noChangeAspect="1"/>
           </p:cNvPicPr>
@@ -3249,7 +3249,7 @@
       </p:pic>
       <p:sp>
         <p:nvSpPr>
-          <p:cNvPr id="19" name="applabel-144"/>
+          <p:cNvPr id="20" name="applabel-144"/>
           <p:cNvSpPr txBox="1"/>
           <p:nvPr/>
         </p:nvSpPr>
@@ -3285,7 +3285,7 @@
       </p:sp>
       <p:pic>
         <p:nvPicPr>
-          <p:cNvPr id="20" name="app-145" descr="/tmp/tmp.Shm5PlvpZ0/apps/com.github.tenderowl.frog.png">    </p:cNvPr>
+          <p:cNvPr id="21" name="app-145" descr="/tmp/tmp.WjEaqILH74/apps/com.github.tenderowl.frog.png">    </p:cNvPr>
           <p:cNvPicPr>
             <a:picLocks noChangeAspect="1"/>
           </p:cNvPicPr>
@@ -3309,7 +3309,7 @@
       </p:pic>
       <p:sp>
         <p:nvSpPr>
-          <p:cNvPr id="21" name="applabel-146"/>
+          <p:cNvPr id="22" name="applabel-146"/>
           <p:cNvSpPr txBox="1"/>
           <p:nvPr/>
         </p:nvSpPr>
@@ -3345,7 +3345,7 @@
       </p:sp>
       <p:pic>
         <p:nvPicPr>
-          <p:cNvPr id="22" name="app-147" descr="/tmp/tmp.Shm5PlvpZ0/apps/one.alynx.FlipClock.png">    </p:cNvPr>
+          <p:cNvPr id="23" name="app-147" descr="/tmp/tmp.WjEaqILH74/apps/one.alynx.FlipClock.png">    </p:cNvPr>
           <p:cNvPicPr>
             <a:picLocks noChangeAspect="1"/>
           </p:cNvPicPr>
@@ -3369,7 +3369,7 @@
       </p:pic>
       <p:sp>
         <p:nvSpPr>
-          <p:cNvPr id="23" name="applabel-148"/>
+          <p:cNvPr id="24" name="applabel-148"/>
           <p:cNvSpPr txBox="1"/>
           <p:nvPr/>
         </p:nvSpPr>
@@ -3405,7 +3405,7 @@
       </p:sp>
       <p:pic>
         <p:nvPicPr>
-          <p:cNvPr id="24" name="app-149" descr="/tmp/tmp.Shm5PlvpZ0/apps/io.github.mehulk.MkNotes.png">    </p:cNvPr>
+          <p:cNvPr id="25" name="app-149" descr="/tmp/tmp.WjEaqILH74/apps/io.github.mehulk.MkNotes.png">    </p:cNvPr>
           <p:cNvPicPr>
             <a:picLocks noChangeAspect="1"/>
           </p:cNvPicPr>
@@ -3429,7 +3429,7 @@
       </p:pic>
       <p:sp>
         <p:nvSpPr>
-          <p:cNvPr id="25" name="applabel-150"/>
+          <p:cNvPr id="26" name="applabel-150"/>
           <p:cNvSpPr txBox="1"/>
           <p:nvPr/>
         </p:nvSpPr>
@@ -3465,7 +3465,7 @@
       </p:sp>
       <p:pic>
         <p:nvPicPr>
-          <p:cNvPr id="26" name="app-151" descr="/tmp/tmp.Shm5PlvpZ0/apps/io.github.mehulk.MkCompanion.png">    </p:cNvPr>
+          <p:cNvPr id="27" name="app-151" descr="/tmp/tmp.WjEaqILH74/apps/io.github.mehulk.MkCompanion.png">    </p:cNvPr>
           <p:cNvPicPr>
             <a:picLocks noChangeAspect="1"/>
           </p:cNvPicPr>
@@ -3489,7 +3489,7 @@
       </p:pic>
       <p:sp>
         <p:nvSpPr>
-          <p:cNvPr id="27" name="applabel-152"/>
+          <p:cNvPr id="28" name="applabel-152"/>
           <p:cNvSpPr txBox="1"/>
           <p:nvPr/>
         </p:nvSpPr>
@@ -3525,7 +3525,7 @@
       </p:sp>
       <p:pic>
         <p:nvPicPr>
-          <p:cNvPr id="28" name="app-153" descr="/tmp/tmp.Shm5PlvpZ0/apps/io.github.mehulk.MkTimer.png">    </p:cNvPr>
+          <p:cNvPr id="29" name="app-153" descr="/tmp/tmp.WjEaqILH74/apps/io.github.mehulk.MkTimer.png">    </p:cNvPr>
           <p:cNvPicPr>
             <a:picLocks noChangeAspect="1"/>
           </p:cNvPicPr>
@@ -3549,7 +3549,7 @@
       </p:pic>
       <p:sp>
         <p:nvSpPr>
-          <p:cNvPr id="29" name="applabel-154"/>
+          <p:cNvPr id="30" name="applabel-154"/>
           <p:cNvSpPr txBox="1"/>
           <p:nvPr/>
         </p:nvSpPr>
@@ -3585,7 +3585,7 @@
       </p:sp>
       <p:pic>
         <p:nvPicPr>
-          <p:cNvPr id="30" name="app-155" descr="/tmp/tmp.Shm5PlvpZ0/apps/io.github.mehulk.MkShortcuts.png">    </p:cNvPr>
+          <p:cNvPr id="31" name="app-155" descr="/tmp/tmp.WjEaqILH74/apps/io.github.mehulk.MkShortcuts.png">    </p:cNvPr>
           <p:cNvPicPr>
             <a:picLocks noChangeAspect="1"/>
           </p:cNvPicPr>
@@ -3609,7 +3609,7 @@
       </p:pic>
       <p:sp>
         <p:nvSpPr>
-          <p:cNvPr id="31" name="applabel-156"/>
+          <p:cNvPr id="32" name="applabel-156"/>
           <p:cNvSpPr txBox="1"/>
           <p:nvPr/>
         </p:nvSpPr>
@@ -3645,7 +3645,7 @@
       </p:sp>
       <p:sp>
         <p:nvSpPr>
-          <p:cNvPr id="32" name="Text 16"/>
+          <p:cNvPr id="33" name="Text 16"/>
           <p:cNvSpPr txBox="1"/>
           <p:nvPr/>
         </p:nvSpPr>
@@ -3827,7 +3827,7 @@
       </p:sp>
       <p:sp>
         <p:nvSpPr>
-          <p:cNvPr id="4" name="card-157"/>
+          <p:cNvPr id="5" name="card-157"/>
           <p:cNvSpPr/>
           <p:nvPr/>
         </p:nvSpPr>
@@ -3849,7 +3849,7 @@
       </p:sp>
       <p:sp>
         <p:nvSpPr>
-          <p:cNvPr id="5" name="dot-158"/>
+          <p:cNvPr id="6" name="dot-158"/>
           <p:cNvSpPr/>
           <p:nvPr/>
         </p:nvSpPr>
@@ -3869,7 +3869,7 @@
       </p:sp>
       <p:pic>
         <p:nvPicPr>
-          <p:cNvPr id="6" name="icon-159" descr="/tmp/tmp.Shm5PlvpZ0/icons/auth-fingerprint.png">    </p:cNvPr>
+          <p:cNvPr id="7" name="icon-159" descr="/tmp/tmp.WjEaqILH74/icons/auth-fingerprint.png">    </p:cNvPr>
           <p:cNvPicPr>
             <a:picLocks noChangeAspect="1"/>
           </p:cNvPicPr>
@@ -3893,7 +3893,7 @@
       </p:pic>
       <p:sp>
         <p:nvSpPr>
-          <p:cNvPr id="7" name="cardtext-160"/>
+          <p:cNvPr id="8" name="cardtext-160"/>
           <p:cNvSpPr txBox="1"/>
           <p:nvPr/>
         </p:nvSpPr>
@@ -3949,7 +3949,7 @@
       </p:sp>
       <p:sp>
         <p:nvSpPr>
-          <p:cNvPr id="8" name="card-161"/>
+          <p:cNvPr id="9" name="card-161"/>
           <p:cNvSpPr/>
           <p:nvPr/>
         </p:nvSpPr>
@@ -3971,7 +3971,7 @@
       </p:sp>
       <p:sp>
         <p:nvSpPr>
-          <p:cNvPr id="9" name="dot-162"/>
+          <p:cNvPr id="10" name="dot-162"/>
           <p:cNvSpPr/>
           <p:nvPr/>
         </p:nvSpPr>
@@ -3991,7 +3991,7 @@
       </p:sp>
       <p:pic>
         <p:nvPicPr>
-          <p:cNvPr id="10" name="icon-163" descr="/tmp/tmp.Shm5PlvpZ0/icons/battery-full.png">    </p:cNvPr>
+          <p:cNvPr id="11" name="icon-163" descr="/tmp/tmp.WjEaqILH74/icons/battery-full.png">    </p:cNvPr>
           <p:cNvPicPr>
             <a:picLocks noChangeAspect="1"/>
           </p:cNvPicPr>
@@ -4015,7 +4015,7 @@
       </p:pic>
       <p:sp>
         <p:nvSpPr>
-          <p:cNvPr id="11" name="cardtext-164"/>
+          <p:cNvPr id="12" name="cardtext-164"/>
           <p:cNvSpPr txBox="1"/>
           <p:nvPr/>
         </p:nvSpPr>
@@ -4071,7 +4071,7 @@
       </p:sp>
       <p:sp>
         <p:nvSpPr>
-          <p:cNvPr id="12" name="card-165"/>
+          <p:cNvPr id="13" name="card-165"/>
           <p:cNvSpPr/>
           <p:nvPr/>
         </p:nvSpPr>
@@ -4093,7 +4093,7 @@
       </p:sp>
       <p:sp>
         <p:nvSpPr>
-          <p:cNvPr id="13" name="dot-166"/>
+          <p:cNvPr id="14" name="dot-166"/>
           <p:cNvSpPr/>
           <p:nvPr/>
         </p:nvSpPr>
@@ -4113,7 +4113,7 @@
       </p:sp>
       <p:pic>
         <p:nvPicPr>
-          <p:cNvPr id="14" name="icon-167" descr="/tmp/tmp.Shm5PlvpZ0/icons/audio-speakers.png">    </p:cNvPr>
+          <p:cNvPr id="15" name="icon-167" descr="/tmp/tmp.WjEaqILH74/icons/audio-speakers.png">    </p:cNvPr>
           <p:cNvPicPr>
             <a:picLocks noChangeAspect="1"/>
           </p:cNvPicPr>
@@ -4137,7 +4137,7 @@
       </p:pic>
       <p:sp>
         <p:nvSpPr>
-          <p:cNvPr id="15" name="cardtext-168"/>
+          <p:cNvPr id="16" name="cardtext-168"/>
           <p:cNvSpPr txBox="1"/>
           <p:nvPr/>
         </p:nvSpPr>
@@ -4193,7 +4193,7 @@
       </p:sp>
       <p:sp>
         <p:nvSpPr>
-          <p:cNvPr id="16" name="card-169"/>
+          <p:cNvPr id="17" name="card-169"/>
           <p:cNvSpPr/>
           <p:nvPr/>
         </p:nvSpPr>
@@ -4215,7 +4215,7 @@
       </p:sp>
       <p:sp>
         <p:nvSpPr>
-          <p:cNvPr id="17" name="dot-170"/>
+          <p:cNvPr id="18" name="dot-170"/>
           <p:cNvSpPr/>
           <p:nvPr/>
         </p:nvSpPr>
@@ -4235,7 +4235,7 @@
       </p:sp>
       <p:pic>
         <p:nvPicPr>
-          <p:cNvPr id="18" name="icon-171" descr="/tmp/tmp.Shm5PlvpZ0/icons/input-tablet.png">    </p:cNvPr>
+          <p:cNvPr id="19" name="icon-171" descr="/tmp/tmp.WjEaqILH74/icons/input-tablet.png">    </p:cNvPr>
           <p:cNvPicPr>
             <a:picLocks noChangeAspect="1"/>
           </p:cNvPicPr>
@@ -4259,7 +4259,7 @@
       </p:pic>
       <p:sp>
         <p:nvSpPr>
-          <p:cNvPr id="19" name="cardtext-172"/>
+          <p:cNvPr id="20" name="cardtext-172"/>
           <p:cNvSpPr txBox="1"/>
           <p:nvPr/>
         </p:nvSpPr>
@@ -4315,7 +4315,7 @@
       </p:sp>
       <p:sp>
         <p:nvSpPr>
-          <p:cNvPr id="20" name="card-173"/>
+          <p:cNvPr id="21" name="card-173"/>
           <p:cNvSpPr/>
           <p:nvPr/>
         </p:nvSpPr>
@@ -4337,7 +4337,7 @@
       </p:sp>
       <p:sp>
         <p:nvSpPr>
-          <p:cNvPr id="21" name="dot-174"/>
+          <p:cNvPr id="22" name="dot-174"/>
           <p:cNvSpPr/>
           <p:nvPr/>
         </p:nvSpPr>
@@ -4357,7 +4357,7 @@
       </p:sp>
       <p:pic>
         <p:nvPicPr>
-          <p:cNvPr id="22" name="icon-175" descr="/tmp/tmp.Shm5PlvpZ0/icons/video-display.png">    </p:cNvPr>
+          <p:cNvPr id="23" name="icon-175" descr="/tmp/tmp.WjEaqILH74/icons/video-display.png">    </p:cNvPr>
           <p:cNvPicPr>
             <a:picLocks noChangeAspect="1"/>
           </p:cNvPicPr>
@@ -4381,7 +4381,7 @@
       </p:pic>
       <p:sp>
         <p:nvSpPr>
-          <p:cNvPr id="23" name="cardtext-176"/>
+          <p:cNvPr id="24" name="cardtext-176"/>
           <p:cNvSpPr txBox="1"/>
           <p:nvPr/>
         </p:nvSpPr>
@@ -4437,7 +4437,7 @@
       </p:sp>
       <p:sp>
         <p:nvSpPr>
-          <p:cNvPr id="24" name="card-177"/>
+          <p:cNvPr id="25" name="card-177"/>
           <p:cNvSpPr/>
           <p:nvPr/>
         </p:nvSpPr>
@@ -4459,7 +4459,7 @@
       </p:sp>
       <p:sp>
         <p:nvSpPr>
-          <p:cNvPr id="25" name="dot-178"/>
+          <p:cNvPr id="26" name="dot-178"/>
           <p:cNvSpPr/>
           <p:nvPr/>
         </p:nvSpPr>
@@ -4479,7 +4479,7 @@
       </p:sp>
       <p:pic>
         <p:nvPicPr>
-          <p:cNvPr id="26" name="icon-179" descr="/tmp/tmp.Shm5PlvpZ0/icons/system-run.png">    </p:cNvPr>
+          <p:cNvPr id="27" name="icon-179" descr="/tmp/tmp.WjEaqILH74/icons/system-run.png">    </p:cNvPr>
           <p:cNvPicPr>
             <a:picLocks noChangeAspect="1"/>
           </p:cNvPicPr>
@@ -4503,7 +4503,7 @@
       </p:pic>
       <p:sp>
         <p:nvSpPr>
-          <p:cNvPr id="27" name="cardtext-180"/>
+          <p:cNvPr id="28" name="cardtext-180"/>
           <p:cNvSpPr txBox="1"/>
           <p:nvPr/>
         </p:nvSpPr>
@@ -4705,7 +4705,7 @@
       </p:sp>
       <p:sp>
         <p:nvSpPr>
-          <p:cNvPr id="4" name="key-181"/>
+          <p:cNvPr id="5" name="key-181"/>
           <p:cNvSpPr/>
           <p:nvPr/>
         </p:nvSpPr>
@@ -4727,7 +4727,7 @@
       </p:sp>
       <p:sp>
         <p:nvSpPr>
-          <p:cNvPr id="5" name="keytext-182"/>
+          <p:cNvPr id="6" name="keytext-182"/>
           <p:cNvSpPr txBox="1"/>
           <p:nvPr/>
         </p:nvSpPr>
@@ -4763,7 +4763,7 @@
       </p:sp>
       <p:sp>
         <p:nvSpPr>
-          <p:cNvPr id="6" name="keylabel-183"/>
+          <p:cNvPr id="7" name="keylabel-183"/>
           <p:cNvSpPr txBox="1"/>
           <p:nvPr/>
         </p:nvSpPr>
@@ -4799,7 +4799,7 @@
       </p:sp>
       <p:sp>
         <p:nvSpPr>
-          <p:cNvPr id="7" name="key-184"/>
+          <p:cNvPr id="8" name="key-184"/>
           <p:cNvSpPr/>
           <p:nvPr/>
         </p:nvSpPr>
@@ -4821,7 +4821,7 @@
       </p:sp>
       <p:sp>
         <p:nvSpPr>
-          <p:cNvPr id="8" name="keytext-185"/>
+          <p:cNvPr id="9" name="keytext-185"/>
           <p:cNvSpPr txBox="1"/>
           <p:nvPr/>
         </p:nvSpPr>
@@ -4857,7 +4857,7 @@
       </p:sp>
       <p:sp>
         <p:nvSpPr>
-          <p:cNvPr id="9" name="keylabel-186"/>
+          <p:cNvPr id="10" name="keylabel-186"/>
           <p:cNvSpPr txBox="1"/>
           <p:nvPr/>
         </p:nvSpPr>
@@ -4893,7 +4893,7 @@
       </p:sp>
       <p:sp>
         <p:nvSpPr>
-          <p:cNvPr id="10" name="key-187"/>
+          <p:cNvPr id="11" name="key-187"/>
           <p:cNvSpPr/>
           <p:nvPr/>
         </p:nvSpPr>
@@ -4915,7 +4915,7 @@
       </p:sp>
       <p:sp>
         <p:nvSpPr>
-          <p:cNvPr id="11" name="keytext-188"/>
+          <p:cNvPr id="12" name="keytext-188"/>
           <p:cNvSpPr txBox="1"/>
           <p:nvPr/>
         </p:nvSpPr>
@@ -4951,7 +4951,7 @@
       </p:sp>
       <p:sp>
         <p:nvSpPr>
-          <p:cNvPr id="12" name="keylabel-189"/>
+          <p:cNvPr id="13" name="keylabel-189"/>
           <p:cNvSpPr txBox="1"/>
           <p:nvPr/>
         </p:nvSpPr>
@@ -4987,7 +4987,7 @@
       </p:sp>
       <p:sp>
         <p:nvSpPr>
-          <p:cNvPr id="13" name="key-190"/>
+          <p:cNvPr id="14" name="key-190"/>
           <p:cNvSpPr/>
           <p:nvPr/>
         </p:nvSpPr>
@@ -5009,7 +5009,7 @@
       </p:sp>
       <p:sp>
         <p:nvSpPr>
-          <p:cNvPr id="14" name="keytext-191"/>
+          <p:cNvPr id="15" name="keytext-191"/>
           <p:cNvSpPr txBox="1"/>
           <p:nvPr/>
         </p:nvSpPr>
@@ -5045,7 +5045,7 @@
       </p:sp>
       <p:sp>
         <p:nvSpPr>
-          <p:cNvPr id="15" name="keylabel-192"/>
+          <p:cNvPr id="16" name="keylabel-192"/>
           <p:cNvSpPr txBox="1"/>
           <p:nvPr/>
         </p:nvSpPr>
@@ -5081,7 +5081,7 @@
       </p:sp>
       <p:sp>
         <p:nvSpPr>
-          <p:cNvPr id="16" name="key-193"/>
+          <p:cNvPr id="17" name="key-193"/>
           <p:cNvSpPr/>
           <p:nvPr/>
         </p:nvSpPr>
@@ -5103,7 +5103,7 @@
       </p:sp>
       <p:sp>
         <p:nvSpPr>
-          <p:cNvPr id="17" name="keytext-194"/>
+          <p:cNvPr id="18" name="keytext-194"/>
           <p:cNvSpPr txBox="1"/>
           <p:nvPr/>
         </p:nvSpPr>
@@ -5139,7 +5139,7 @@
       </p:sp>
       <p:sp>
         <p:nvSpPr>
-          <p:cNvPr id="18" name="keylabel-195"/>
+          <p:cNvPr id="19" name="keylabel-195"/>
           <p:cNvSpPr txBox="1"/>
           <p:nvPr/>
         </p:nvSpPr>
@@ -5175,7 +5175,7 @@
       </p:sp>
       <p:sp>
         <p:nvSpPr>
-          <p:cNvPr id="19" name="key-196"/>
+          <p:cNvPr id="20" name="key-196"/>
           <p:cNvSpPr/>
           <p:nvPr/>
         </p:nvSpPr>
@@ -5197,7 +5197,7 @@
       </p:sp>
       <p:sp>
         <p:nvSpPr>
-          <p:cNvPr id="20" name="keytext-197"/>
+          <p:cNvPr id="21" name="keytext-197"/>
           <p:cNvSpPr txBox="1"/>
           <p:nvPr/>
         </p:nvSpPr>
@@ -5233,7 +5233,7 @@
       </p:sp>
       <p:sp>
         <p:nvSpPr>
-          <p:cNvPr id="21" name="keylabel-198"/>
+          <p:cNvPr id="22" name="keylabel-198"/>
           <p:cNvSpPr txBox="1"/>
           <p:nvPr/>
         </p:nvSpPr>
@@ -5269,7 +5269,7 @@
       </p:sp>
       <p:sp>
         <p:nvSpPr>
-          <p:cNvPr id="22" name="key-199"/>
+          <p:cNvPr id="23" name="key-199"/>
           <p:cNvSpPr/>
           <p:nvPr/>
         </p:nvSpPr>
@@ -5291,7 +5291,7 @@
       </p:sp>
       <p:sp>
         <p:nvSpPr>
-          <p:cNvPr id="23" name="keytext-200"/>
+          <p:cNvPr id="24" name="keytext-200"/>
           <p:cNvSpPr txBox="1"/>
           <p:nvPr/>
         </p:nvSpPr>
@@ -5327,7 +5327,7 @@
       </p:sp>
       <p:sp>
         <p:nvSpPr>
-          <p:cNvPr id="24" name="keylabel-201"/>
+          <p:cNvPr id="25" name="keylabel-201"/>
           <p:cNvSpPr txBox="1"/>
           <p:nvPr/>
         </p:nvSpPr>
@@ -5363,7 +5363,7 @@
       </p:sp>
       <p:sp>
         <p:nvSpPr>
-          <p:cNvPr id="25" name="key-202"/>
+          <p:cNvPr id="26" name="key-202"/>
           <p:cNvSpPr/>
           <p:nvPr/>
         </p:nvSpPr>
@@ -5385,7 +5385,7 @@
       </p:sp>
       <p:sp>
         <p:nvSpPr>
-          <p:cNvPr id="26" name="keytext-203"/>
+          <p:cNvPr id="27" name="keytext-203"/>
           <p:cNvSpPr txBox="1"/>
           <p:nvPr/>
         </p:nvSpPr>
@@ -5421,7 +5421,7 @@
       </p:sp>
       <p:sp>
         <p:nvSpPr>
-          <p:cNvPr id="27" name="keylabel-204"/>
+          <p:cNvPr id="28" name="keylabel-204"/>
           <p:cNvSpPr txBox="1"/>
           <p:nvPr/>
         </p:nvSpPr>
@@ -5457,7 +5457,7 @@
       </p:sp>
       <p:sp>
         <p:nvSpPr>
-          <p:cNvPr id="28" name="key-205"/>
+          <p:cNvPr id="29" name="key-205"/>
           <p:cNvSpPr/>
           <p:nvPr/>
         </p:nvSpPr>
@@ -5479,7 +5479,7 @@
       </p:sp>
       <p:sp>
         <p:nvSpPr>
-          <p:cNvPr id="29" name="keytext-206"/>
+          <p:cNvPr id="30" name="keytext-206"/>
           <p:cNvSpPr txBox="1"/>
           <p:nvPr/>
         </p:nvSpPr>
@@ -5515,7 +5515,7 @@
       </p:sp>
       <p:sp>
         <p:nvSpPr>
-          <p:cNvPr id="30" name="keylabel-207"/>
+          <p:cNvPr id="31" name="keylabel-207"/>
           <p:cNvSpPr txBox="1"/>
           <p:nvPr/>
         </p:nvSpPr>
@@ -5551,7 +5551,7 @@
       </p:sp>
       <p:sp>
         <p:nvSpPr>
-          <p:cNvPr id="31" name="key-208"/>
+          <p:cNvPr id="32" name="key-208"/>
           <p:cNvSpPr/>
           <p:nvPr/>
         </p:nvSpPr>
@@ -5573,7 +5573,7 @@
       </p:sp>
       <p:sp>
         <p:nvSpPr>
-          <p:cNvPr id="32" name="keytext-209"/>
+          <p:cNvPr id="33" name="keytext-209"/>
           <p:cNvSpPr txBox="1"/>
           <p:nvPr/>
         </p:nvSpPr>
@@ -5609,7 +5609,7 @@
       </p:sp>
       <p:sp>
         <p:nvSpPr>
-          <p:cNvPr id="33" name="keylabel-210"/>
+          <p:cNvPr id="34" name="keylabel-210"/>
           <p:cNvSpPr txBox="1"/>
           <p:nvPr/>
         </p:nvSpPr>
@@ -5645,7 +5645,7 @@
       </p:sp>
       <p:pic>
         <p:nvPicPr>
-          <p:cNvPr id="34" name="shortcuts" descr="/tmp/tmp.Shm5PlvpZ0/img/shortcuts.jpg">    </p:cNvPr>
+          <p:cNvPr id="35" name="shortcuts" descr="/tmp/tmp.WjEaqILH74/img/shortcuts.jpg">    </p:cNvPr>
           <p:cNvPicPr>
             <a:picLocks noChangeAspect="1"/>
           </p:cNvPicPr>
@@ -5676,7 +5676,7 @@
       </p:pic>
       <p:sp>
         <p:nvSpPr>
-          <p:cNvPr id="35" name="caption-211"/>
+          <p:cNvPr id="36" name="caption-211"/>
           <p:cNvSpPr txBox="1"/>
           <p:nvPr/>
         </p:nvSpPr>
@@ -5858,7 +5858,7 @@
       </p:sp>
       <p:sp>
         <p:nvSpPr>
-          <p:cNvPr id="4" name="dot-212"/>
+          <p:cNvPr id="5" name="dot-212"/>
           <p:cNvSpPr/>
           <p:nvPr/>
         </p:nvSpPr>
@@ -5878,7 +5878,7 @@
       </p:sp>
       <p:pic>
         <p:nvPicPr>
-          <p:cNvPr id="5" name="icon-213" descr="/tmp/tmp.Shm5PlvpZ0/icons/document-open-recent.png">    </p:cNvPr>
+          <p:cNvPr id="6" name="icon-213" descr="/tmp/tmp.WjEaqILH74/icons/document-open-recent.png">    </p:cNvPr>
           <p:cNvPicPr>
             <a:picLocks noChangeAspect="1"/>
           </p:cNvPicPr>
@@ -5902,7 +5902,7 @@
       </p:pic>
       <p:sp>
         <p:nvSpPr>
-          <p:cNvPr id="6" name="row-214"/>
+          <p:cNvPr id="7" name="row-214"/>
           <p:cNvSpPr txBox="1"/>
           <p:nvPr/>
         </p:nvSpPr>
@@ -5958,7 +5958,7 @@
       </p:sp>
       <p:sp>
         <p:nvSpPr>
-          <p:cNvPr id="7" name="dot-215"/>
+          <p:cNvPr id="8" name="dot-215"/>
           <p:cNvSpPr/>
           <p:nvPr/>
         </p:nvSpPr>
@@ -5978,7 +5978,7 @@
       </p:sp>
       <p:pic>
         <p:nvPicPr>
-          <p:cNvPr id="8" name="icon-216" descr="/tmp/tmp.Shm5PlvpZ0/icons/user-trash.png">    </p:cNvPr>
+          <p:cNvPr id="9" name="icon-216" descr="/tmp/tmp.WjEaqILH74/icons/user-trash.png">    </p:cNvPr>
           <p:cNvPicPr>
             <a:picLocks noChangeAspect="1"/>
           </p:cNvPicPr>
@@ -6002,7 +6002,7 @@
       </p:pic>
       <p:sp>
         <p:nvSpPr>
-          <p:cNvPr id="9" name="row-217"/>
+          <p:cNvPr id="10" name="row-217"/>
           <p:cNvSpPr txBox="1"/>
           <p:nvPr/>
         </p:nvSpPr>
@@ -6058,7 +6058,7 @@
       </p:sp>
       <p:sp>
         <p:nvSpPr>
-          <p:cNvPr id="10" name="dot-218"/>
+          <p:cNvPr id="11" name="dot-218"/>
           <p:cNvSpPr/>
           <p:nvPr/>
         </p:nvSpPr>
@@ -6078,7 +6078,7 @@
       </p:sp>
       <p:pic>
         <p:nvPicPr>
-          <p:cNvPr id="11" name="icon-219" descr="/tmp/tmp.Shm5PlvpZ0/icons/checkbox-checked.png">    </p:cNvPr>
+          <p:cNvPr id="12" name="icon-219" descr="/tmp/tmp.WjEaqILH74/icons/checkbox-checked.png">    </p:cNvPr>
           <p:cNvPicPr>
             <a:picLocks noChangeAspect="1"/>
           </p:cNvPicPr>
@@ -6102,7 +6102,7 @@
       </p:pic>
       <p:sp>
         <p:nvSpPr>
-          <p:cNvPr id="12" name="row-220"/>
+          <p:cNvPr id="13" name="row-220"/>
           <p:cNvSpPr txBox="1"/>
           <p:nvPr/>
         </p:nvSpPr>
@@ -6158,7 +6158,7 @@
       </p:sp>
       <p:sp>
         <p:nvSpPr>
-          <p:cNvPr id="13" name="dot-221"/>
+          <p:cNvPr id="14" name="dot-221"/>
           <p:cNvSpPr/>
           <p:nvPr/>
         </p:nvSpPr>
@@ -6178,7 +6178,7 @@
       </p:sp>
       <p:pic>
         <p:nvPicPr>
-          <p:cNvPr id="14" name="icon-222" descr="/tmp/tmp.Shm5PlvpZ0/icons/x-office-document.png">    </p:cNvPr>
+          <p:cNvPr id="15" name="icon-222" descr="/tmp/tmp.WjEaqILH74/icons/x-office-document.png">    </p:cNvPr>
           <p:cNvPicPr>
             <a:picLocks noChangeAspect="1"/>
           </p:cNvPicPr>
@@ -6202,7 +6202,7 @@
       </p:pic>
       <p:sp>
         <p:nvSpPr>
-          <p:cNvPr id="15" name="row-223"/>
+          <p:cNvPr id="16" name="row-223"/>
           <p:cNvSpPr txBox="1"/>
           <p:nvPr/>
         </p:nvSpPr>
@@ -6258,7 +6258,7 @@
       </p:sp>
       <p:sp>
         <p:nvSpPr>
-          <p:cNvPr id="16" name="dot-224"/>
+          <p:cNvPr id="17" name="dot-224"/>
           <p:cNvSpPr/>
           <p:nvPr/>
         </p:nvSpPr>
@@ -6278,7 +6278,7 @@
       </p:sp>
       <p:pic>
         <p:nvPicPr>
-          <p:cNvPr id="17" name="icon-225" descr="/tmp/tmp.Shm5PlvpZ0/icons/software-update-available.png">    </p:cNvPr>
+          <p:cNvPr id="18" name="icon-225" descr="/tmp/tmp.WjEaqILH74/icons/software-update-available.png">    </p:cNvPr>
           <p:cNvPicPr>
             <a:picLocks noChangeAspect="1"/>
           </p:cNvPicPr>
@@ -6302,7 +6302,7 @@
       </p:pic>
       <p:sp>
         <p:nvSpPr>
-          <p:cNvPr id="18" name="row-226"/>
+          <p:cNvPr id="19" name="row-226"/>
           <p:cNvSpPr txBox="1"/>
           <p:nvPr/>
         </p:nvSpPr>
@@ -6358,7 +6358,7 @@
       </p:sp>
       <p:pic>
         <p:nvPicPr>
-          <p:cNvPr id="19" name="companion" descr="/tmp/tmp.Shm5PlvpZ0/img/companion.jpg">    </p:cNvPr>
+          <p:cNvPr id="20" name="companion" descr="/tmp/tmp.WjEaqILH74/img/companion.jpg">    </p:cNvPr>
           <p:cNvPicPr>
             <a:picLocks noChangeAspect="1"/>
           </p:cNvPicPr>
@@ -6389,7 +6389,7 @@
       </p:pic>
       <p:sp>
         <p:nvSpPr>
-          <p:cNvPr id="20" name="caption-227"/>
+          <p:cNvPr id="21" name="caption-227"/>
           <p:cNvSpPr txBox="1"/>
           <p:nvPr/>
         </p:nvSpPr>
@@ -7031,7 +7031,7 @@
       </p:sp>
       <p:sp>
         <p:nvSpPr>
-          <p:cNvPr id="4" name="Text 2"/>
+          <p:cNvPr id="5" name="Text 2"/>
           <p:cNvSpPr txBox="1"/>
           <p:nvPr/>
         </p:nvSpPr>
@@ -7067,7 +7067,7 @@
       </p:sp>
       <p:sp>
         <p:nvSpPr>
-          <p:cNvPr id="5" name="dot-1"/>
+          <p:cNvPr id="6" name="dot-1"/>
           <p:cNvSpPr/>
           <p:nvPr/>
         </p:nvSpPr>
@@ -7087,7 +7087,7 @@
       </p:sp>
       <p:pic>
         <p:nvPicPr>
-          <p:cNvPr id="6" name="icon-2" descr="/tmp/tmp.Shm5PlvpZ0/icons/edit-undo.png">    </p:cNvPr>
+          <p:cNvPr id="7" name="icon-2" descr="/tmp/tmp.WjEaqILH74/icons/edit-undo.png">    </p:cNvPr>
           <p:cNvPicPr>
             <a:picLocks noChangeAspect="1"/>
           </p:cNvPicPr>
@@ -7111,7 +7111,7 @@
       </p:pic>
       <p:sp>
         <p:nvSpPr>
-          <p:cNvPr id="7" name="row-3"/>
+          <p:cNvPr id="8" name="row-3"/>
           <p:cNvSpPr txBox="1"/>
           <p:nvPr/>
         </p:nvSpPr>
@@ -7167,7 +7167,7 @@
       </p:sp>
       <p:sp>
         <p:nvSpPr>
-          <p:cNvPr id="8" name="dot-4"/>
+          <p:cNvPr id="9" name="dot-4"/>
           <p:cNvSpPr/>
           <p:nvPr/>
         </p:nvSpPr>
@@ -7187,7 +7187,7 @@
       </p:sp>
       <p:pic>
         <p:nvPicPr>
-          <p:cNvPr id="9" name="icon-5" descr="/tmp/tmp.Shm5PlvpZ0/icons/software-update-available.png">    </p:cNvPr>
+          <p:cNvPr id="10" name="icon-5" descr="/tmp/tmp.WjEaqILH74/icons/software-update-available.png">    </p:cNvPr>
           <p:cNvPicPr>
             <a:picLocks noChangeAspect="1"/>
           </p:cNvPicPr>
@@ -7211,7 +7211,7 @@
       </p:pic>
       <p:sp>
         <p:nvSpPr>
-          <p:cNvPr id="10" name="row-6"/>
+          <p:cNvPr id="11" name="row-6"/>
           <p:cNvSpPr txBox="1"/>
           <p:nvPr/>
         </p:nvSpPr>
@@ -7267,7 +7267,7 @@
       </p:sp>
       <p:sp>
         <p:nvSpPr>
-          <p:cNvPr id="11" name="stat-7"/>
+          <p:cNvPr id="12" name="stat-7"/>
           <p:cNvSpPr/>
           <p:nvPr/>
         </p:nvSpPr>
@@ -7289,7 +7289,7 @@
       </p:sp>
       <p:sp>
         <p:nvSpPr>
-          <p:cNvPr id="12" name="statbig-8"/>
+          <p:cNvPr id="13" name="statbig-8"/>
           <p:cNvSpPr txBox="1"/>
           <p:nvPr/>
         </p:nvSpPr>
@@ -7325,7 +7325,7 @@
       </p:sp>
       <p:sp>
         <p:nvSpPr>
-          <p:cNvPr id="13" name="statsmall-9"/>
+          <p:cNvPr id="14" name="statsmall-9"/>
           <p:cNvSpPr txBox="1"/>
           <p:nvPr/>
         </p:nvSpPr>
@@ -7375,7 +7375,7 @@
       </p:sp>
       <p:sp>
         <p:nvSpPr>
-          <p:cNvPr id="14" name="stat-10"/>
+          <p:cNvPr id="15" name="stat-10"/>
           <p:cNvSpPr/>
           <p:nvPr/>
         </p:nvSpPr>
@@ -7397,7 +7397,7 @@
       </p:sp>
       <p:sp>
         <p:nvSpPr>
-          <p:cNvPr id="15" name="statbig-11"/>
+          <p:cNvPr id="16" name="statbig-11"/>
           <p:cNvSpPr txBox="1"/>
           <p:nvPr/>
         </p:nvSpPr>
@@ -7433,7 +7433,7 @@
       </p:sp>
       <p:sp>
         <p:nvSpPr>
-          <p:cNvPr id="16" name="statsmall-12"/>
+          <p:cNvPr id="17" name="statsmall-12"/>
           <p:cNvSpPr txBox="1"/>
           <p:nvPr/>
         </p:nvSpPr>
@@ -7483,7 +7483,7 @@
       </p:sp>
       <p:sp>
         <p:nvSpPr>
-          <p:cNvPr id="17" name="stat-13"/>
+          <p:cNvPr id="18" name="stat-13"/>
           <p:cNvSpPr/>
           <p:nvPr/>
         </p:nvSpPr>
@@ -7505,7 +7505,7 @@
       </p:sp>
       <p:sp>
         <p:nvSpPr>
-          <p:cNvPr id="18" name="statbig-14"/>
+          <p:cNvPr id="19" name="statbig-14"/>
           <p:cNvSpPr txBox="1"/>
           <p:nvPr/>
         </p:nvSpPr>
@@ -7541,7 +7541,7 @@
       </p:sp>
       <p:sp>
         <p:nvSpPr>
-          <p:cNvPr id="19" name="statsmall-15"/>
+          <p:cNvPr id="20" name="statsmall-15"/>
           <p:cNvSpPr txBox="1"/>
           <p:nvPr/>
         </p:nvSpPr>
@@ -7591,7 +7591,7 @@
       </p:sp>
       <p:sp>
         <p:nvSpPr>
-          <p:cNvPr id="20" name="stat-16"/>
+          <p:cNvPr id="21" name="stat-16"/>
           <p:cNvSpPr/>
           <p:nvPr/>
         </p:nvSpPr>
@@ -7613,7 +7613,7 @@
       </p:sp>
       <p:sp>
         <p:nvSpPr>
-          <p:cNvPr id="21" name="statbig-17"/>
+          <p:cNvPr id="22" name="statbig-17"/>
           <p:cNvSpPr txBox="1"/>
           <p:nvPr/>
         </p:nvSpPr>
@@ -7649,7 +7649,7 @@
       </p:sp>
       <p:sp>
         <p:nvSpPr>
-          <p:cNvPr id="22" name="statsmall-18"/>
+          <p:cNvPr id="23" name="statsmall-18"/>
           <p:cNvSpPr txBox="1"/>
           <p:nvPr/>
         </p:nvSpPr>
@@ -7845,7 +7845,7 @@
       </p:sp>
       <p:pic>
         <p:nvPicPr>
-          <p:cNvPr id="4" name="alttab-19" descr="/tmp/tmp.Shm5PlvpZ0/img/alttab.jpg">    </p:cNvPr>
+          <p:cNvPr id="4" name="alttab-19" descr="/tmp/tmp.WjEaqILH74/img/alttab.jpg">    </p:cNvPr>
           <p:cNvPicPr>
             <a:picLocks noChangeAspect="1"/>
           </p:cNvPicPr>
@@ -7932,7 +7932,7 @@
       </p:sp>
       <p:pic>
         <p:nvPicPr>
-          <p:cNvPr id="7" name="icon-22" descr="/tmp/tmp.Shm5PlvpZ0/icons/input-touchpad.png">    </p:cNvPr>
+          <p:cNvPr id="7" name="icon-22" descr="/tmp/tmp.WjEaqILH74/icons/input-touchpad.png">    </p:cNvPr>
           <p:cNvPicPr>
             <a:picLocks noChangeAspect="1"/>
           </p:cNvPicPr>
@@ -8032,7 +8032,7 @@
       </p:sp>
       <p:pic>
         <p:nvPicPr>
-          <p:cNvPr id="10" name="icon-25" descr="/tmp/tmp.Shm5PlvpZ0/icons/view-grid.png">    </p:cNvPr>
+          <p:cNvPr id="10" name="icon-25" descr="/tmp/tmp.WjEaqILH74/icons/view-grid.png">    </p:cNvPr>
           <p:cNvPicPr>
             <a:picLocks noChangeAspect="1"/>
           </p:cNvPicPr>
@@ -8132,7 +8132,7 @@
       </p:sp>
       <p:pic>
         <p:nvPicPr>
-          <p:cNvPr id="13" name="icon-28" descr="/tmp/tmp.Shm5PlvpZ0/icons/system-run.png">    </p:cNvPr>
+          <p:cNvPr id="13" name="icon-28" descr="/tmp/tmp.WjEaqILH74/icons/system-run.png">    </p:cNvPr>
           <p:cNvPicPr>
             <a:picLocks noChangeAspect="1"/>
           </p:cNvPicPr>
@@ -8232,7 +8232,7 @@
       </p:sp>
       <p:pic>
         <p:nvPicPr>
-          <p:cNvPr id="16" name="icon-31" descr="/tmp/tmp.Shm5PlvpZ0/icons/view-reveal.png">    </p:cNvPr>
+          <p:cNvPr id="16" name="icon-31" descr="/tmp/tmp.WjEaqILH74/icons/view-reveal.png">    </p:cNvPr>
           <p:cNvPicPr>
             <a:picLocks noChangeAspect="1"/>
           </p:cNvPicPr>
@@ -8458,7 +8458,7 @@
       </p:sp>
       <p:pic>
         <p:nvPicPr>
-          <p:cNvPr id="4" name="tiled-33" descr="/tmp/tmp.Shm5PlvpZ0/img/tiled.jpg">    </p:cNvPr>
+          <p:cNvPr id="5" name="tiled-33" descr="/tmp/tmp.WjEaqILH74/img/tiled.jpg">    </p:cNvPr>
           <p:cNvPicPr>
             <a:picLocks noChangeAspect="1"/>
           </p:cNvPicPr>
@@ -8489,7 +8489,7 @@
       </p:pic>
       <p:sp>
         <p:nvSpPr>
-          <p:cNvPr id="5" name="caption-34"/>
+          <p:cNvPr id="6" name="caption-34"/>
           <p:cNvSpPr txBox="1"/>
           <p:nvPr/>
         </p:nvSpPr>
@@ -8525,7 +8525,7 @@
       </p:sp>
       <p:sp>
         <p:nvSpPr>
-          <p:cNvPr id="6" name="dot-35"/>
+          <p:cNvPr id="7" name="dot-35"/>
           <p:cNvSpPr/>
           <p:nvPr/>
         </p:nvSpPr>
@@ -8545,7 +8545,7 @@
       </p:sp>
       <p:pic>
         <p:nvPicPr>
-          <p:cNvPr id="7" name="icon-36" descr="/tmp/tmp.Shm5PlvpZ0/icons/view-dual.png">    </p:cNvPr>
+          <p:cNvPr id="8" name="icon-36" descr="/tmp/tmp.WjEaqILH74/icons/view-dual.png">    </p:cNvPr>
           <p:cNvPicPr>
             <a:picLocks noChangeAspect="1"/>
           </p:cNvPicPr>
@@ -8569,7 +8569,7 @@
       </p:pic>
       <p:sp>
         <p:nvSpPr>
-          <p:cNvPr id="8" name="row-37"/>
+          <p:cNvPr id="9" name="row-37"/>
           <p:cNvSpPr txBox="1"/>
           <p:nvPr/>
         </p:nvSpPr>
@@ -8625,7 +8625,7 @@
       </p:sp>
       <p:sp>
         <p:nvSpPr>
-          <p:cNvPr id="9" name="dot-38"/>
+          <p:cNvPr id="10" name="dot-38"/>
           <p:cNvSpPr/>
           <p:nvPr/>
         </p:nvSpPr>
@@ -8645,7 +8645,7 @@
       </p:sp>
       <p:pic>
         <p:nvPicPr>
-          <p:cNvPr id="10" name="icon-39" descr="/tmp/tmp.Shm5PlvpZ0/icons/window-new.png">    </p:cNvPr>
+          <p:cNvPr id="11" name="icon-39" descr="/tmp/tmp.WjEaqILH74/icons/window-new.png">    </p:cNvPr>
           <p:cNvPicPr>
             <a:picLocks noChangeAspect="1"/>
           </p:cNvPicPr>
@@ -8669,7 +8669,7 @@
       </p:pic>
       <p:sp>
         <p:nvSpPr>
-          <p:cNvPr id="11" name="row-40"/>
+          <p:cNvPr id="12" name="row-40"/>
           <p:cNvSpPr txBox="1"/>
           <p:nvPr/>
         </p:nvSpPr>
@@ -8725,7 +8725,7 @@
       </p:sp>
       <p:sp>
         <p:nvSpPr>
-          <p:cNvPr id="12" name="dot-41"/>
+          <p:cNvPr id="13" name="dot-41"/>
           <p:cNvSpPr/>
           <p:nvPr/>
         </p:nvSpPr>
@@ -8745,7 +8745,7 @@
       </p:sp>
       <p:pic>
         <p:nvPicPr>
-          <p:cNvPr id="13" name="icon-42" descr="/tmp/tmp.Shm5PlvpZ0/icons/view-pin.png">    </p:cNvPr>
+          <p:cNvPr id="14" name="icon-42" descr="/tmp/tmp.WjEaqILH74/icons/view-pin.png">    </p:cNvPr>
           <p:cNvPicPr>
             <a:picLocks noChangeAspect="1"/>
           </p:cNvPicPr>
@@ -8769,7 +8769,7 @@
       </p:pic>
       <p:sp>
         <p:nvSpPr>
-          <p:cNvPr id="14" name="row-43"/>
+          <p:cNvPr id="15" name="row-43"/>
           <p:cNvSpPr txBox="1"/>
           <p:nvPr/>
         </p:nvSpPr>
@@ -8825,7 +8825,7 @@
       </p:sp>
       <p:sp>
         <p:nvSpPr>
-          <p:cNvPr id="15" name="dot-44"/>
+          <p:cNvPr id="16" name="dot-44"/>
           <p:cNvSpPr/>
           <p:nvPr/>
         </p:nvSpPr>
@@ -8845,7 +8845,7 @@
       </p:sp>
       <p:pic>
         <p:nvPicPr>
-          <p:cNvPr id="16" name="icon-45" descr="/tmp/tmp.Shm5PlvpZ0/icons/view-grid.png">    </p:cNvPr>
+          <p:cNvPr id="17" name="icon-45" descr="/tmp/tmp.WjEaqILH74/icons/view-grid.png">    </p:cNvPr>
           <p:cNvPicPr>
             <a:picLocks noChangeAspect="1"/>
           </p:cNvPicPr>
@@ -8869,7 +8869,7 @@
       </p:pic>
       <p:sp>
         <p:nvSpPr>
-          <p:cNvPr id="17" name="row-46"/>
+          <p:cNvPr id="18" name="row-46"/>
           <p:cNvSpPr txBox="1"/>
           <p:nvPr/>
         </p:nvSpPr>
@@ -9071,7 +9071,7 @@
       </p:sp>
       <p:pic>
         <p:nvPicPr>
-          <p:cNvPr id="4" name="welcome-47" descr="/tmp/tmp.Shm5PlvpZ0/img/welcome.jpg">    </p:cNvPr>
+          <p:cNvPr id="5" name="welcome-47" descr="/tmp/tmp.WjEaqILH74/img/welcome.jpg">    </p:cNvPr>
           <p:cNvPicPr>
             <a:picLocks noChangeAspect="1"/>
           </p:cNvPicPr>
@@ -9102,7 +9102,7 @@
       </p:pic>
       <p:sp>
         <p:nvSpPr>
-          <p:cNvPr id="5" name="caption-48"/>
+          <p:cNvPr id="6" name="caption-48"/>
           <p:cNvSpPr txBox="1"/>
           <p:nvPr/>
         </p:nvSpPr>
@@ -9138,7 +9138,7 @@
       </p:sp>
       <p:sp>
         <p:nvSpPr>
-          <p:cNvPr id="6" name="dot-49"/>
+          <p:cNvPr id="7" name="dot-49"/>
           <p:cNvSpPr/>
           <p:nvPr/>
         </p:nvSpPr>
@@ -9158,7 +9158,7 @@
       </p:sp>
       <p:pic>
         <p:nvPicPr>
-          <p:cNvPr id="7" name="icon-50" descr="/tmp/tmp.Shm5PlvpZ0/icons/weather-clear-night.png">    </p:cNvPr>
+          <p:cNvPr id="8" name="icon-50" descr="/tmp/tmp.WjEaqILH74/icons/weather-clear-night.png">    </p:cNvPr>
           <p:cNvPicPr>
             <a:picLocks noChangeAspect="1"/>
           </p:cNvPicPr>
@@ -9182,7 +9182,7 @@
       </p:pic>
       <p:sp>
         <p:nvSpPr>
-          <p:cNvPr id="8" name="row-51"/>
+          <p:cNvPr id="9" name="row-51"/>
           <p:cNvSpPr txBox="1"/>
           <p:nvPr/>
         </p:nvSpPr>
@@ -9238,7 +9238,7 @@
       </p:sp>
       <p:sp>
         <p:nvSpPr>
-          <p:cNvPr id="9" name="dot-52"/>
+          <p:cNvPr id="10" name="dot-52"/>
           <p:cNvSpPr/>
           <p:nvPr/>
         </p:nvSpPr>
@@ -9258,7 +9258,7 @@
       </p:sp>
       <p:pic>
         <p:nvPicPr>
-          <p:cNvPr id="10" name="icon-53" descr="/tmp/tmp.Shm5PlvpZ0/icons/view-pin.png">    </p:cNvPr>
+          <p:cNvPr id="11" name="icon-53" descr="/tmp/tmp.WjEaqILH74/icons/view-pin.png">    </p:cNvPr>
           <p:cNvPicPr>
             <a:picLocks noChangeAspect="1"/>
           </p:cNvPicPr>
@@ -9282,7 +9282,7 @@
       </p:pic>
       <p:sp>
         <p:nvSpPr>
-          <p:cNvPr id="11" name="row-54"/>
+          <p:cNvPr id="12" name="row-54"/>
           <p:cNvSpPr txBox="1"/>
           <p:nvPr/>
         </p:nvSpPr>
@@ -9338,7 +9338,7 @@
       </p:sp>
       <p:sp>
         <p:nvSpPr>
-          <p:cNvPr id="12" name="dot-55"/>
+          <p:cNvPr id="13" name="dot-55"/>
           <p:cNvSpPr/>
           <p:nvPr/>
         </p:nvSpPr>
@@ -9358,7 +9358,7 @@
       </p:sp>
       <p:pic>
         <p:nvPicPr>
-          <p:cNvPr id="13" name="icon-56" descr="/tmp/tmp.Shm5PlvpZ0/icons/face-smile.png">    </p:cNvPr>
+          <p:cNvPr id="14" name="icon-56" descr="/tmp/tmp.WjEaqILH74/icons/face-smile.png">    </p:cNvPr>
           <p:cNvPicPr>
             <a:picLocks noChangeAspect="1"/>
           </p:cNvPicPr>
@@ -9382,7 +9382,7 @@
       </p:pic>
       <p:sp>
         <p:nvSpPr>
-          <p:cNvPr id="14" name="row-57"/>
+          <p:cNvPr id="15" name="row-57"/>
           <p:cNvSpPr txBox="1"/>
           <p:nvPr/>
         </p:nvSpPr>
@@ -9438,7 +9438,7 @@
       </p:sp>
       <p:sp>
         <p:nvSpPr>
-          <p:cNvPr id="15" name="dot-58"/>
+          <p:cNvPr id="16" name="dot-58"/>
           <p:cNvSpPr/>
           <p:nvPr/>
         </p:nvSpPr>
@@ -9458,7 +9458,7 @@
       </p:sp>
       <p:pic>
         <p:nvPicPr>
-          <p:cNvPr id="16" name="icon-59" descr="/tmp/tmp.Shm5PlvpZ0/icons/preferences-color.png">    </p:cNvPr>
+          <p:cNvPr id="17" name="icon-59" descr="/tmp/tmp.WjEaqILH74/icons/preferences-color.png">    </p:cNvPr>
           <p:cNvPicPr>
             <a:picLocks noChangeAspect="1"/>
           </p:cNvPicPr>
@@ -9482,7 +9482,7 @@
       </p:pic>
       <p:sp>
         <p:nvSpPr>
-          <p:cNvPr id="17" name="row-60"/>
+          <p:cNvPr id="18" name="row-60"/>
           <p:cNvSpPr txBox="1"/>
           <p:nvPr/>
         </p:nvSpPr>
@@ -9684,7 +9684,7 @@
       </p:sp>
       <p:pic>
         <p:nvPicPr>
-          <p:cNvPr id="4" name="notes-split-61" descr="/tmp/tmp.Shm5PlvpZ0/img/notes-split.jpg">    </p:cNvPr>
+          <p:cNvPr id="5" name="notes-split-61" descr="/tmp/tmp.WjEaqILH74/img/notes-split.jpg">    </p:cNvPr>
           <p:cNvPicPr>
             <a:picLocks noChangeAspect="1"/>
           </p:cNvPicPr>
@@ -9715,7 +9715,7 @@
       </p:pic>
       <p:pic>
         <p:nvPicPr>
-          <p:cNvPr id="5" name="phone" descr="/tmp/tmp.Shm5PlvpZ0/img/phone-note.jpg">    </p:cNvPr>
+          <p:cNvPr id="6" name="phone" descr="/tmp/tmp.WjEaqILH74/img/phone-note.jpg">    </p:cNvPr>
           <p:cNvPicPr>
             <a:picLocks noChangeAspect="1"/>
           </p:cNvPicPr>
@@ -9746,7 +9746,7 @@
       </p:pic>
       <p:sp>
         <p:nvSpPr>
-          <p:cNvPr id="6" name="caption-62"/>
+          <p:cNvPr id="7" name="caption-62"/>
           <p:cNvSpPr txBox="1"/>
           <p:nvPr/>
         </p:nvSpPr>
@@ -9782,7 +9782,7 @@
       </p:sp>
       <p:sp>
         <p:nvSpPr>
-          <p:cNvPr id="7" name="dot-63"/>
+          <p:cNvPr id="8" name="dot-63"/>
           <p:cNvSpPr/>
           <p:nvPr/>
         </p:nvSpPr>
@@ -9802,7 +9802,7 @@
       </p:sp>
       <p:pic>
         <p:nvPicPr>
-          <p:cNvPr id="8" name="icon-64" descr="/tmp/tmp.Shm5PlvpZ0/icons/x-office-document.png">    </p:cNvPr>
+          <p:cNvPr id="9" name="icon-64" descr="/tmp/tmp.WjEaqILH74/icons/x-office-document.png">    </p:cNvPr>
           <p:cNvPicPr>
             <a:picLocks noChangeAspect="1"/>
           </p:cNvPicPr>
@@ -9826,7 +9826,7 @@
       </p:pic>
       <p:sp>
         <p:nvSpPr>
-          <p:cNvPr id="9" name="row-65"/>
+          <p:cNvPr id="10" name="row-65"/>
           <p:cNvSpPr txBox="1"/>
           <p:nvPr/>
         </p:nvSpPr>
@@ -9882,7 +9882,7 @@
       </p:sp>
       <p:sp>
         <p:nvSpPr>
-          <p:cNvPr id="10" name="dot-66"/>
+          <p:cNvPr id="11" name="dot-66"/>
           <p:cNvSpPr/>
           <p:nvPr/>
         </p:nvSpPr>
@@ -9902,7 +9902,7 @@
       </p:sp>
       <p:pic>
         <p:nvPicPr>
-          <p:cNvPr id="11" name="icon-67" descr="/tmp/tmp.Shm5PlvpZ0/icons/network-workgroup.png">    </p:cNvPr>
+          <p:cNvPr id="12" name="icon-67" descr="/tmp/tmp.WjEaqILH74/icons/network-workgroup.png">    </p:cNvPr>
           <p:cNvPicPr>
             <a:picLocks noChangeAspect="1"/>
           </p:cNvPicPr>
@@ -9926,7 +9926,7 @@
       </p:pic>
       <p:sp>
         <p:nvSpPr>
-          <p:cNvPr id="12" name="row-68"/>
+          <p:cNvPr id="13" name="row-68"/>
           <p:cNvSpPr txBox="1"/>
           <p:nvPr/>
         </p:nvSpPr>
@@ -9982,7 +9982,7 @@
       </p:sp>
       <p:sp>
         <p:nvSpPr>
-          <p:cNvPr id="13" name="dot-69"/>
+          <p:cNvPr id="14" name="dot-69"/>
           <p:cNvSpPr/>
           <p:nvPr/>
         </p:nvSpPr>
@@ -10002,7 +10002,7 @@
       </p:sp>
       <p:pic>
         <p:nvPicPr>
-          <p:cNvPr id="14" name="icon-70" descr="/tmp/tmp.Shm5PlvpZ0/icons/applications-graphics.png">    </p:cNvPr>
+          <p:cNvPr id="15" name="icon-70" descr="/tmp/tmp.WjEaqILH74/icons/applications-graphics.png">    </p:cNvPr>
           <p:cNvPicPr>
             <a:picLocks noChangeAspect="1"/>
           </p:cNvPicPr>
@@ -10026,7 +10026,7 @@
       </p:pic>
       <p:sp>
         <p:nvSpPr>
-          <p:cNvPr id="15" name="row-71"/>
+          <p:cNvPr id="16" name="row-71"/>
           <p:cNvSpPr txBox="1"/>
           <p:nvPr/>
         </p:nvSpPr>
@@ -10082,7 +10082,7 @@
       </p:sp>
       <p:sp>
         <p:nvSpPr>
-          <p:cNvPr id="16" name="dot-72"/>
+          <p:cNvPr id="17" name="dot-72"/>
           <p:cNvSpPr/>
           <p:nvPr/>
         </p:nvSpPr>
@@ -10102,7 +10102,7 @@
       </p:sp>
       <p:pic>
         <p:nvPicPr>
-          <p:cNvPr id="17" name="icon-73" descr="/tmp/tmp.Shm5PlvpZ0/icons/edit-paste.png">    </p:cNvPr>
+          <p:cNvPr id="18" name="icon-73" descr="/tmp/tmp.WjEaqILH74/icons/edit-paste.png">    </p:cNvPr>
           <p:cNvPicPr>
             <a:picLocks noChangeAspect="1"/>
           </p:cNvPicPr>
@@ -10126,7 +10126,7 @@
       </p:pic>
       <p:sp>
         <p:nvSpPr>
-          <p:cNvPr id="18" name="row-74"/>
+          <p:cNvPr id="19" name="row-74"/>
           <p:cNvSpPr txBox="1"/>
           <p:nvPr/>
         </p:nvSpPr>
@@ -10328,7 +10328,7 @@
       </p:sp>
       <p:sp>
         <p:nvSpPr>
-          <p:cNvPr id="4" name="card-75"/>
+          <p:cNvPr id="5" name="card-75"/>
           <p:cNvSpPr/>
           <p:nvPr/>
         </p:nvSpPr>
@@ -10350,7 +10350,7 @@
       </p:sp>
       <p:sp>
         <p:nvSpPr>
-          <p:cNvPr id="5" name="dot-76"/>
+          <p:cNvPr id="6" name="dot-76"/>
           <p:cNvSpPr/>
           <p:nvPr/>
         </p:nvSpPr>
@@ -10370,7 +10370,7 @@
       </p:sp>
       <p:pic>
         <p:nvPicPr>
-          <p:cNvPr id="6" name="icon-77" descr="/tmp/tmp.Shm5PlvpZ0/icons/emblem-system.png">    </p:cNvPr>
+          <p:cNvPr id="7" name="icon-77" descr="/tmp/tmp.WjEaqILH74/icons/emblem-system.png">    </p:cNvPr>
           <p:cNvPicPr>
             <a:picLocks noChangeAspect="1"/>
           </p:cNvPicPr>
@@ -10394,7 +10394,7 @@
       </p:pic>
       <p:sp>
         <p:nvSpPr>
-          <p:cNvPr id="7" name="cardtext-78"/>
+          <p:cNvPr id="8" name="cardtext-78"/>
           <p:cNvSpPr txBox="1"/>
           <p:nvPr/>
         </p:nvSpPr>
@@ -10450,7 +10450,7 @@
       </p:sp>
       <p:sp>
         <p:nvSpPr>
-          <p:cNvPr id="8" name="card-79"/>
+          <p:cNvPr id="9" name="card-79"/>
           <p:cNvSpPr/>
           <p:nvPr/>
         </p:nvSpPr>
@@ -10472,7 +10472,7 @@
       </p:sp>
       <p:sp>
         <p:nvSpPr>
-          <p:cNvPr id="9" name="dot-80"/>
+          <p:cNvPr id="10" name="dot-80"/>
           <p:cNvSpPr/>
           <p:nvPr/>
         </p:nvSpPr>
@@ -10492,7 +10492,7 @@
       </p:sp>
       <p:pic>
         <p:nvPicPr>
-          <p:cNvPr id="10" name="icon-81" descr="/tmp/tmp.Shm5PlvpZ0/icons/x-office-document.png">    </p:cNvPr>
+          <p:cNvPr id="11" name="icon-81" descr="/tmp/tmp.WjEaqILH74/icons/x-office-document.png">    </p:cNvPr>
           <p:cNvPicPr>
             <a:picLocks noChangeAspect="1"/>
           </p:cNvPicPr>
@@ -10516,7 +10516,7 @@
       </p:pic>
       <p:sp>
         <p:nvSpPr>
-          <p:cNvPr id="11" name="cardtext-82"/>
+          <p:cNvPr id="12" name="cardtext-82"/>
           <p:cNvSpPr txBox="1"/>
           <p:nvPr/>
         </p:nvSpPr>
@@ -10572,7 +10572,7 @@
       </p:sp>
       <p:sp>
         <p:nvSpPr>
-          <p:cNvPr id="12" name="card-83"/>
+          <p:cNvPr id="13" name="card-83"/>
           <p:cNvSpPr/>
           <p:nvPr/>
         </p:nvSpPr>
@@ -10594,7 +10594,7 @@
       </p:sp>
       <p:sp>
         <p:nvSpPr>
-          <p:cNvPr id="13" name="dot-84"/>
+          <p:cNvPr id="14" name="dot-84"/>
           <p:cNvSpPr/>
           <p:nvPr/>
         </p:nvSpPr>
@@ -10614,7 +10614,7 @@
       </p:sp>
       <p:pic>
         <p:nvPicPr>
-          <p:cNvPr id="14" name="icon-85" descr="/tmp/tmp.Shm5PlvpZ0/icons/network-workgroup.png">    </p:cNvPr>
+          <p:cNvPr id="15" name="icon-85" descr="/tmp/tmp.WjEaqILH74/icons/network-workgroup.png">    </p:cNvPr>
           <p:cNvPicPr>
             <a:picLocks noChangeAspect="1"/>
           </p:cNvPicPr>
@@ -10638,7 +10638,7 @@
       </p:pic>
       <p:sp>
         <p:nvSpPr>
-          <p:cNvPr id="15" name="cardtext-86"/>
+          <p:cNvPr id="16" name="cardtext-86"/>
           <p:cNvSpPr txBox="1"/>
           <p:nvPr/>
         </p:nvSpPr>
@@ -10694,7 +10694,7 @@
       </p:sp>
       <p:sp>
         <p:nvSpPr>
-          <p:cNvPr id="16" name="card-87"/>
+          <p:cNvPr id="17" name="card-87"/>
           <p:cNvSpPr/>
           <p:nvPr/>
         </p:nvSpPr>
@@ -10716,7 +10716,7 @@
       </p:sp>
       <p:sp>
         <p:nvSpPr>
-          <p:cNvPr id="17" name="dot-88"/>
+          <p:cNvPr id="18" name="dot-88"/>
           <p:cNvSpPr/>
           <p:nvPr/>
         </p:nvSpPr>
@@ -10736,7 +10736,7 @@
       </p:sp>
       <p:pic>
         <p:nvPicPr>
-          <p:cNvPr id="18" name="icon-89" descr="/tmp/tmp.Shm5PlvpZ0/icons/document-open-recent.png">    </p:cNvPr>
+          <p:cNvPr id="19" name="icon-89" descr="/tmp/tmp.WjEaqILH74/icons/document-open-recent.png">    </p:cNvPr>
           <p:cNvPicPr>
             <a:picLocks noChangeAspect="1"/>
           </p:cNvPicPr>
@@ -10760,7 +10760,7 @@
       </p:pic>
       <p:sp>
         <p:nvSpPr>
-          <p:cNvPr id="19" name="cardtext-90"/>
+          <p:cNvPr id="20" name="cardtext-90"/>
           <p:cNvSpPr txBox="1"/>
           <p:nvPr/>
         </p:nvSpPr>
@@ -10816,7 +10816,7 @@
       </p:sp>
       <p:sp>
         <p:nvSpPr>
-          <p:cNvPr id="20" name="card-91"/>
+          <p:cNvPr id="21" name="card-91"/>
           <p:cNvSpPr/>
           <p:nvPr/>
         </p:nvSpPr>
@@ -10838,7 +10838,7 @@
       </p:sp>
       <p:sp>
         <p:nvSpPr>
-          <p:cNvPr id="21" name="dot-92"/>
+          <p:cNvPr id="22" name="dot-92"/>
           <p:cNvSpPr/>
           <p:nvPr/>
         </p:nvSpPr>
@@ -10858,7 +10858,7 @@
       </p:sp>
       <p:pic>
         <p:nvPicPr>
-          <p:cNvPr id="22" name="icon-93" descr="/tmp/tmp.Shm5PlvpZ0/icons/x-office-calendar.png">    </p:cNvPr>
+          <p:cNvPr id="23" name="icon-93" descr="/tmp/tmp.WjEaqILH74/icons/x-office-calendar.png">    </p:cNvPr>
           <p:cNvPicPr>
             <a:picLocks noChangeAspect="1"/>
           </p:cNvPicPr>
@@ -10882,7 +10882,7 @@
       </p:pic>
       <p:sp>
         <p:nvSpPr>
-          <p:cNvPr id="23" name="cardtext-94"/>
+          <p:cNvPr id="24" name="cardtext-94"/>
           <p:cNvSpPr txBox="1"/>
           <p:nvPr/>
         </p:nvSpPr>
@@ -10938,7 +10938,7 @@
       </p:sp>
       <p:sp>
         <p:nvSpPr>
-          <p:cNvPr id="24" name="card-95"/>
+          <p:cNvPr id="25" name="card-95"/>
           <p:cNvSpPr/>
           <p:nvPr/>
         </p:nvSpPr>
@@ -10960,7 +10960,7 @@
       </p:sp>
       <p:sp>
         <p:nvSpPr>
-          <p:cNvPr id="25" name="dot-96"/>
+          <p:cNvPr id="26" name="dot-96"/>
           <p:cNvSpPr/>
           <p:nvPr/>
         </p:nvSpPr>
@@ -10980,7 +10980,7 @@
       </p:sp>
       <p:pic>
         <p:nvPicPr>
-          <p:cNvPr id="26" name="icon-97" descr="/tmp/tmp.Shm5PlvpZ0/icons/checkbox-checked.png">    </p:cNvPr>
+          <p:cNvPr id="27" name="icon-97" descr="/tmp/tmp.WjEaqILH74/icons/checkbox-checked.png">    </p:cNvPr>
           <p:cNvPicPr>
             <a:picLocks noChangeAspect="1"/>
           </p:cNvPicPr>
@@ -11004,7 +11004,7 @@
       </p:pic>
       <p:sp>
         <p:nvSpPr>
-          <p:cNvPr id="27" name="cardtext-98"/>
+          <p:cNvPr id="28" name="cardtext-98"/>
           <p:cNvSpPr txBox="1"/>
           <p:nvPr/>
         </p:nvSpPr>
@@ -11060,7 +11060,7 @@
       </p:sp>
       <p:sp>
         <p:nvSpPr>
-          <p:cNvPr id="28" name="card-99"/>
+          <p:cNvPr id="29" name="card-99"/>
           <p:cNvSpPr/>
           <p:nvPr/>
         </p:nvSpPr>
@@ -11082,7 +11082,7 @@
       </p:sp>
       <p:sp>
         <p:nvSpPr>
-          <p:cNvPr id="29" name="dot-100"/>
+          <p:cNvPr id="30" name="dot-100"/>
           <p:cNvSpPr/>
           <p:nvPr/>
         </p:nvSpPr>
@@ -11102,7 +11102,7 @@
       </p:sp>
       <p:pic>
         <p:nvPicPr>
-          <p:cNvPr id="30" name="icon-101" descr="/tmp/tmp.Shm5PlvpZ0/icons/view-reveal.png">    </p:cNvPr>
+          <p:cNvPr id="31" name="icon-101" descr="/tmp/tmp.WjEaqILH74/icons/view-reveal.png">    </p:cNvPr>
           <p:cNvPicPr>
             <a:picLocks noChangeAspect="1"/>
           </p:cNvPicPr>
@@ -11126,7 +11126,7 @@
       </p:pic>
       <p:sp>
         <p:nvSpPr>
-          <p:cNvPr id="31" name="cardtext-102"/>
+          <p:cNvPr id="32" name="cardtext-102"/>
           <p:cNvSpPr txBox="1"/>
           <p:nvPr/>
         </p:nvSpPr>
@@ -11182,7 +11182,7 @@
       </p:sp>
       <p:sp>
         <p:nvSpPr>
-          <p:cNvPr id="32" name="card-103"/>
+          <p:cNvPr id="33" name="card-103"/>
           <p:cNvSpPr/>
           <p:nvPr/>
         </p:nvSpPr>
@@ -11204,7 +11204,7 @@
       </p:sp>
       <p:sp>
         <p:nvSpPr>
-          <p:cNvPr id="33" name="dot-104"/>
+          <p:cNvPr id="34" name="dot-104"/>
           <p:cNvSpPr/>
           <p:nvPr/>
         </p:nvSpPr>
@@ -11224,7 +11224,7 @@
       </p:sp>
       <p:pic>
         <p:nvPicPr>
-          <p:cNvPr id="34" name="icon-105" descr="/tmp/tmp.Shm5PlvpZ0/icons/preferences-color.png">    </p:cNvPr>
+          <p:cNvPr id="35" name="icon-105" descr="/tmp/tmp.WjEaqILH74/icons/preferences-color.png">    </p:cNvPr>
           <p:cNvPicPr>
             <a:picLocks noChangeAspect="1"/>
           </p:cNvPicPr>
@@ -11248,7 +11248,7 @@
       </p:pic>
       <p:sp>
         <p:nvSpPr>
-          <p:cNvPr id="35" name="cardtext-106"/>
+          <p:cNvPr id="36" name="cardtext-106"/>
           <p:cNvSpPr txBox="1"/>
           <p:nvPr/>
         </p:nvSpPr>
@@ -11450,7 +11450,7 @@
       </p:sp>
       <p:pic>
         <p:nvPicPr>
-          <p:cNvPr id="4" name="saver-bubbles-107" descr="/tmp/tmp.Shm5PlvpZ0/img/saver-bubbles.jpg">    </p:cNvPr>
+          <p:cNvPr id="5" name="saver-bubbles-107" descr="/tmp/tmp.WjEaqILH74/img/saver-bubbles.jpg">    </p:cNvPr>
           <p:cNvPicPr>
             <a:picLocks noChangeAspect="1"/>
           </p:cNvPicPr>
@@ -11481,7 +11481,7 @@
       </p:pic>
       <p:pic>
         <p:nvPicPr>
-          <p:cNvPr id="5" name="saver-starfield-108" descr="/tmp/tmp.Shm5PlvpZ0/img/saver-starfield.jpg">    </p:cNvPr>
+          <p:cNvPr id="6" name="saver-starfield-108" descr="/tmp/tmp.WjEaqILH74/img/saver-starfield.jpg">    </p:cNvPr>
           <p:cNvPicPr>
             <a:picLocks noChangeAspect="1"/>
           </p:cNvPicPr>
@@ -11512,7 +11512,7 @@
       </p:pic>
       <p:sp>
         <p:nvSpPr>
-          <p:cNvPr id="6" name="caption-109"/>
+          <p:cNvPr id="7" name="caption-109"/>
           <p:cNvSpPr txBox="1"/>
           <p:nvPr/>
         </p:nvSpPr>
@@ -11548,7 +11548,7 @@
       </p:sp>
       <p:sp>
         <p:nvSpPr>
-          <p:cNvPr id="7" name="dot-110"/>
+          <p:cNvPr id="8" name="dot-110"/>
           <p:cNvSpPr/>
           <p:nvPr/>
         </p:nvSpPr>
@@ -11568,7 +11568,7 @@
       </p:sp>
       <p:pic>
         <p:nvPicPr>
-          <p:cNvPr id="8" name="icon-111" descr="/tmp/tmp.Shm5PlvpZ0/icons/alarm.png">    </p:cNvPr>
+          <p:cNvPr id="9" name="icon-111" descr="/tmp/tmp.WjEaqILH74/icons/alarm.png">    </p:cNvPr>
           <p:cNvPicPr>
             <a:picLocks noChangeAspect="1"/>
           </p:cNvPicPr>
@@ -11592,7 +11592,7 @@
       </p:pic>
       <p:sp>
         <p:nvSpPr>
-          <p:cNvPr id="9" name="row-112"/>
+          <p:cNvPr id="10" name="row-112"/>
           <p:cNvSpPr txBox="1"/>
           <p:nvPr/>
         </p:nvSpPr>
@@ -11648,7 +11648,7 @@
       </p:sp>
       <p:sp>
         <p:nvSpPr>
-          <p:cNvPr id="10" name="dot-113"/>
+          <p:cNvPr id="11" name="dot-113"/>
           <p:cNvSpPr/>
           <p:nvPr/>
         </p:nvSpPr>
@@ -11668,7 +11668,7 @@
       </p:sp>
       <p:pic>
         <p:nvPicPr>
-          <p:cNvPr id="11" name="icon-114" descr="/tmp/tmp.Shm5PlvpZ0/icons/face-smile.png">    </p:cNvPr>
+          <p:cNvPr id="12" name="icon-114" descr="/tmp/tmp.WjEaqILH74/icons/face-smile.png">    </p:cNvPr>
           <p:cNvPicPr>
             <a:picLocks noChangeAspect="1"/>
           </p:cNvPicPr>
@@ -11692,7 +11692,7 @@
       </p:pic>
       <p:sp>
         <p:nvSpPr>
-          <p:cNvPr id="12" name="row-115"/>
+          <p:cNvPr id="13" name="row-115"/>
           <p:cNvSpPr txBox="1"/>
           <p:nvPr/>
         </p:nvSpPr>
@@ -11894,7 +11894,7 @@
       </p:sp>
       <p:pic>
         <p:nvPicPr>
-          <p:cNvPr id="4" name="monitor" descr="/tmp/tmp.Shm5PlvpZ0/img/monitor.jpg">    </p:cNvPr>
+          <p:cNvPr id="5" name="monitor" descr="/tmp/tmp.WjEaqILH74/img/monitor.jpg">    </p:cNvPr>
           <p:cNvPicPr>
             <a:picLocks noChangeAspect="1"/>
           </p:cNvPicPr>
@@ -11925,7 +11925,7 @@
       </p:pic>
       <p:pic>
         <p:nvPicPr>
-          <p:cNvPr id="5" name="quick" descr="/tmp/tmp.Shm5PlvpZ0/img/quick.jpg">    </p:cNvPr>
+          <p:cNvPr id="6" name="quick" descr="/tmp/tmp.WjEaqILH74/img/quick.jpg">    </p:cNvPr>
           <p:cNvPicPr>
             <a:picLocks noChangeAspect="1"/>
           </p:cNvPicPr>
@@ -11956,7 +11956,7 @@
       </p:pic>
       <p:sp>
         <p:nvSpPr>
-          <p:cNvPr id="6" name="caption-116"/>
+          <p:cNvPr id="7" name="caption-116"/>
           <p:cNvSpPr txBox="1"/>
           <p:nvPr/>
         </p:nvSpPr>
@@ -11992,7 +11992,7 @@
       </p:sp>
       <p:sp>
         <p:nvSpPr>
-          <p:cNvPr id="7" name="dot-117"/>
+          <p:cNvPr id="8" name="dot-117"/>
           <p:cNvSpPr/>
           <p:nvPr/>
         </p:nvSpPr>
@@ -12012,7 +12012,7 @@
       </p:sp>
       <p:pic>
         <p:nvPicPr>
-          <p:cNvPr id="8" name="icon-118" descr="/tmp/tmp.Shm5PlvpZ0/icons/video-display.png">    </p:cNvPr>
+          <p:cNvPr id="9" name="icon-118" descr="/tmp/tmp.WjEaqILH74/icons/video-display.png">    </p:cNvPr>
           <p:cNvPicPr>
             <a:picLocks noChangeAspect="1"/>
           </p:cNvPicPr>
@@ -12036,7 +12036,7 @@
       </p:pic>
       <p:sp>
         <p:nvSpPr>
-          <p:cNvPr id="9" name="row-119"/>
+          <p:cNvPr id="10" name="row-119"/>
           <p:cNvSpPr txBox="1"/>
           <p:nvPr/>
         </p:nvSpPr>
@@ -12092,7 +12092,7 @@
       </p:sp>
       <p:sp>
         <p:nvSpPr>
-          <p:cNvPr id="10" name="dot-120"/>
+          <p:cNvPr id="11" name="dot-120"/>
           <p:cNvSpPr/>
           <p:nvPr/>
         </p:nvSpPr>
@@ -12112,7 +12112,7 @@
       </p:sp>
       <p:pic>
         <p:nvPicPr>
-          <p:cNvPr id="11" name="icon-121" descr="/tmp/tmp.Shm5PlvpZ0/icons/edit-paste.png">    </p:cNvPr>
+          <p:cNvPr id="12" name="icon-121" descr="/tmp/tmp.WjEaqILH74/icons/edit-paste.png">    </p:cNvPr>
           <p:cNvPicPr>
             <a:picLocks noChangeAspect="1"/>
           </p:cNvPicPr>
@@ -12136,7 +12136,7 @@
       </p:pic>
       <p:sp>
         <p:nvSpPr>
-          <p:cNvPr id="12" name="row-122"/>
+          <p:cNvPr id="13" name="row-122"/>
           <p:cNvSpPr txBox="1"/>
           <p:nvPr/>
         </p:nvSpPr>
@@ -12192,7 +12192,7 @@
       </p:sp>
       <p:sp>
         <p:nvSpPr>
-          <p:cNvPr id="13" name="dot-123"/>
+          <p:cNvPr id="14" name="dot-123"/>
           <p:cNvSpPr/>
           <p:nvPr/>
         </p:nvSpPr>
@@ -12212,7 +12212,7 @@
       </p:sp>
       <p:pic>
         <p:nvPicPr>
-          <p:cNvPr id="14" name="icon-124" descr="/tmp/tmp.Shm5PlvpZ0/icons/weather-clear-night.png">    </p:cNvPr>
+          <p:cNvPr id="15" name="icon-124" descr="/tmp/tmp.WjEaqILH74/icons/weather-clear-night.png">    </p:cNvPr>
           <p:cNvPicPr>
             <a:picLocks noChangeAspect="1"/>
           </p:cNvPicPr>
@@ -12236,7 +12236,7 @@
       </p:pic>
       <p:sp>
         <p:nvSpPr>
-          <p:cNvPr id="15" name="row-125"/>
+          <p:cNvPr id="16" name="row-125"/>
           <p:cNvSpPr txBox="1"/>
           <p:nvPr/>
         </p:nvSpPr>
@@ -12292,7 +12292,7 @@
       </p:sp>
       <p:sp>
         <p:nvSpPr>
-          <p:cNvPr id="16" name="dot-126"/>
+          <p:cNvPr id="17" name="dot-126"/>
           <p:cNvSpPr/>
           <p:nvPr/>
         </p:nvSpPr>
@@ -12312,7 +12312,7 @@
       </p:sp>
       <p:pic>
         <p:nvPicPr>
-          <p:cNvPr id="17" name="icon-127" descr="/tmp/tmp.Shm5PlvpZ0/icons/view-grid.png">    </p:cNvPr>
+          <p:cNvPr id="18" name="icon-127" descr="/tmp/tmp.WjEaqILH74/icons/view-grid.png">    </p:cNvPr>
           <p:cNvPicPr>
             <a:picLocks noChangeAspect="1"/>
           </p:cNvPicPr>
@@ -12336,7 +12336,7 @@
       </p:pic>
       <p:sp>
         <p:nvSpPr>
-          <p:cNvPr id="18" name="row-128"/>
+          <p:cNvPr id="19" name="row-128"/>
           <p:cNvSpPr txBox="1"/>
           <p:nvPr/>
         </p:nvSpPr>

</xml_diff>

<commit_message>
docs(overview): PDF and deck for the new switcher, scenes, speed test, media
New screenshots (headless, Fedora wallpaper, sample data): the window grid,
the speed test, the media tile, and the three screensaver scenes rendered
straight from the scene code. Switcher, welcome, MK Notes, screensaver and
top-bar pages and slides rewritten; README gallery refreshed.

Co-Authored-By: Claude Opus 5.5 <noreply@anthropic.com>
</commit_message>
<xml_diff>
--- a/docs/MK-Workstation-Overview.pptx
+++ b/docs/MK-Workstation-Overview.pptx
@@ -120,40 +120,40 @@
   <p:extLst>
     <p:ext uri="{521415D9-36F7-43E2-AB2F-B90AF26B5E84}">
       <p14:sectionLst xmlns:p14="http://schemas.microsoft.com/office/powerpoint/2010/main">
-        <p14:section name="Introduction" id="{c7eab502-350c-e47f-9b86-8e6a6f4995b9}">
+        <p14:section name="Introduction" id="{52ca5413-2dfa-cd5d-0c8d-be92f910ac46}">
           <p14:sldIdLst>
             <p14:sldId id="256"/>
             <p14:sldId id="257"/>
           </p14:sldIdLst>
         </p14:section>
-        <p14:section name="Your desktop" id="{ed974c15-597a-bcfe-c83a-8774bd858e2b}">
+        <p14:section name="Your desktop" id="{b9d78052-1eba-bb09-cbc2-8e5c85570add}">
           <p14:sldIdLst>
             <p14:sldId id="258"/>
             <p14:sldId id="259"/>
             <p14:sldId id="260"/>
           </p14:sldIdLst>
         </p14:section>
-        <p14:section name="MK Notes" id="{65de2850-f9fa-44d9-852f-c3bb52d4bd1b}">
+        <p14:section name="MK Notes" id="{2faceb9c-f1d5-105a-b6c1-740a7cfdb75c}">
           <p14:sldIdLst>
             <p14:sldId id="261"/>
             <p14:sldId id="262"/>
           </p14:sldIdLst>
         </p14:section>
-        <p14:section name="Focus and tools" id="{1e00c473-e657-deea-23a0-4c5f7495f06b}">
+        <p14:section name="Focus and tools" id="{5512acea-d797-bb8f-3a1c-d2ff3ac58596}">
           <p14:sldIdLst>
             <p14:sldId id="263"/>
             <p14:sldId id="264"/>
             <p14:sldId id="265"/>
           </p14:sldIdLst>
         </p14:section>
-        <p14:section name="Your computer" id="{18d463dc-6249-b302-56d1-7d31d3447606}">
+        <p14:section name="Your computer" id="{0ec44a41-7137-7d40-99a0-a5c9dea5f3c2}">
           <p14:sldIdLst>
             <p14:sldId id="266"/>
             <p14:sldId id="267"/>
             <p14:sldId id="268"/>
           </p14:sldIdLst>
         </p14:section>
-        <p14:section name="Get started" id="{8abba257-a351-6ef1-4ac3-2f7f5e14aab8}">
+        <p14:section name="Get started" id="{862fe0b0-1f02-c420-9703-53223861fae4}">
           <p14:sldIdLst>
             <p14:sldId id="269"/>
           </p14:sldIdLst>
@@ -1178,7 +1178,7 @@
           <a:p>
             <a:r>
               <a:rPr lang="en-US" dirty="0"/>
-              <a:t>Alt+Tab and the three-finger swipe show one switcher with a ring that follows your fingers. Each window takes the same finger travel however many are open, so fast swipes land where you expect.</a:t>
+              <a:t>Alt+Tab and the three-finger swipe open a frosted grid of live windows. Each window takes the same finger travel, the mouse works too, and 1 to 9 sends the selected window to that desktop.Alt+Tab and the three-finger swipe show one switcher with a ring that follows your fingers. Each window takes the same finger travel however many are open, so fast swipes land where you expect.</a:t>
             </a:r>
             <a:endParaRPr lang="en-US" dirty="0"/>
           </a:p>
@@ -1618,7 +1618,7 @@
           <a:p>
             <a:r>
               <a:rPr lang="en-US" dirty="0"/>
-              <a:t>The focus timer counts down in the top bar. Step away and a screensaver plays over your work; when time's up there's a small celebration instead of an alarm.</a:t>
+              <a:t>Step away for a few minutes and a scene plays: a masked hero swinging from a web over the city, a caped figure in the rain, or code rain that decodes the time. A video or call keeps it away; any touch brings you back.</a:t>
             </a:r>
             <a:endParaRPr lang="en-US" dirty="0"/>
           </a:p>
@@ -1706,7 +1706,7 @@
           <a:p>
             <a:r>
               <a:rPr lang="en-US" dirty="0"/>
-              <a:t>A light system monitor in the top bar with honest numbers, clipboard history on Super+V, a keep-awake switch and the usual tray icons.</a:t>
+              <a:t>The top bar has a light system monitor with a speed test, a media tile for Spotify or any player with seek and speaker choice, and clipboard history on Super+V.</a:t>
             </a:r>
             <a:endParaRPr lang="en-US" dirty="0"/>
           </a:p>
@@ -2533,7 +2533,7 @@
       </p:grpSpPr>
       <p:pic>
         <p:nvPicPr>
-          <p:cNvPr id="2" name="hero" descr="/tmp/tmp.WjEaqILH74/img/welcome.jpg">    </p:cNvPr>
+          <p:cNvPr id="2" name="hero" descr="/tmp/tmp.wNxcSLvjxS/img/welcome.jpg">    </p:cNvPr>
           <p:cNvPicPr>
             <a:picLocks noChangeAspect="1"/>
           </p:cNvPicPr>
@@ -2805,7 +2805,7 @@
       </p:sp>
       <p:pic>
         <p:nvPicPr>
-          <p:cNvPr id="5" name="app-129" descr="/tmp/tmp.WjEaqILH74/apps/app.zen_browser.zen.png">    </p:cNvPr>
+          <p:cNvPr id="5" name="app-136" descr="/tmp/tmp.wNxcSLvjxS/apps/app.zen_browser.zen.png">    </p:cNvPr>
           <p:cNvPicPr>
             <a:picLocks noChangeAspect="1"/>
           </p:cNvPicPr>
@@ -2829,7 +2829,7 @@
       </p:pic>
       <p:sp>
         <p:nvSpPr>
-          <p:cNvPr id="6" name="applabel-130"/>
+          <p:cNvPr id="6" name="applabel-137"/>
           <p:cNvSpPr txBox="1"/>
           <p:nvPr/>
         </p:nvSpPr>
@@ -2865,7 +2865,7 @@
       </p:sp>
       <p:pic>
         <p:nvPicPr>
-          <p:cNvPr id="7" name="app-131" descr="/tmp/tmp.WjEaqILH74/apps/net.cozic.joplin_desktop.png">    </p:cNvPr>
+          <p:cNvPr id="7" name="app-138" descr="/tmp/tmp.wNxcSLvjxS/apps/net.cozic.joplin_desktop.png">    </p:cNvPr>
           <p:cNvPicPr>
             <a:picLocks noChangeAspect="1"/>
           </p:cNvPicPr>
@@ -2889,7 +2889,7 @@
       </p:pic>
       <p:sp>
         <p:nvSpPr>
-          <p:cNvPr id="8" name="applabel-132"/>
+          <p:cNvPr id="8" name="applabel-139"/>
           <p:cNvSpPr txBox="1"/>
           <p:nvPr/>
         </p:nvSpPr>
@@ -2925,7 +2925,7 @@
       </p:sp>
       <p:pic>
         <p:nvPicPr>
-          <p:cNvPr id="9" name="app-133" descr="/tmp/tmp.WjEaqILH74/apps/org.onlyoffice.desktopeditors.png">    </p:cNvPr>
+          <p:cNvPr id="9" name="app-140" descr="/tmp/tmp.wNxcSLvjxS/apps/org.onlyoffice.desktopeditors.png">    </p:cNvPr>
           <p:cNvPicPr>
             <a:picLocks noChangeAspect="1"/>
           </p:cNvPicPr>
@@ -2949,7 +2949,7 @@
       </p:pic>
       <p:sp>
         <p:nvSpPr>
-          <p:cNvPr id="10" name="applabel-134"/>
+          <p:cNvPr id="10" name="applabel-141"/>
           <p:cNvSpPr txBox="1"/>
           <p:nvPr/>
         </p:nvSpPr>
@@ -2985,7 +2985,7 @@
       </p:sp>
       <p:pic>
         <p:nvPicPr>
-          <p:cNvPr id="11" name="app-135" descr="/tmp/tmp.WjEaqILH74/apps/vscode.png">    </p:cNvPr>
+          <p:cNvPr id="11" name="app-142" descr="/tmp/tmp.wNxcSLvjxS/apps/vscode.png">    </p:cNvPr>
           <p:cNvPicPr>
             <a:picLocks noChangeAspect="1"/>
           </p:cNvPicPr>
@@ -3009,7 +3009,7 @@
       </p:pic>
       <p:sp>
         <p:nvSpPr>
-          <p:cNvPr id="12" name="applabel-136"/>
+          <p:cNvPr id="12" name="applabel-143"/>
           <p:cNvSpPr txBox="1"/>
           <p:nvPr/>
         </p:nvSpPr>
@@ -3045,7 +3045,7 @@
       </p:sp>
       <p:pic>
         <p:nvPicPr>
-          <p:cNvPr id="13" name="app-137" descr="/tmp/tmp.WjEaqILH74/apps/com.spotify.Client.png">    </p:cNvPr>
+          <p:cNvPr id="13" name="app-144" descr="/tmp/tmp.wNxcSLvjxS/apps/com.spotify.Client.png">    </p:cNvPr>
           <p:cNvPicPr>
             <a:picLocks noChangeAspect="1"/>
           </p:cNvPicPr>
@@ -3069,7 +3069,7 @@
       </p:pic>
       <p:sp>
         <p:nvSpPr>
-          <p:cNvPr id="14" name="applabel-138"/>
+          <p:cNvPr id="14" name="applabel-145"/>
           <p:cNvSpPr txBox="1"/>
           <p:nvPr/>
         </p:nvSpPr>
@@ -3105,7 +3105,7 @@
       </p:sp>
       <p:pic>
         <p:nvPicPr>
-          <p:cNvPr id="15" name="app-139" descr="/tmp/tmp.WjEaqILH74/apps/net.lutris.Lutris.png">    </p:cNvPr>
+          <p:cNvPr id="15" name="app-146" descr="/tmp/tmp.wNxcSLvjxS/apps/net.lutris.Lutris.png">    </p:cNvPr>
           <p:cNvPicPr>
             <a:picLocks noChangeAspect="1"/>
           </p:cNvPicPr>
@@ -3129,7 +3129,7 @@
       </p:pic>
       <p:sp>
         <p:nvSpPr>
-          <p:cNvPr id="16" name="applabel-140"/>
+          <p:cNvPr id="16" name="applabel-147"/>
           <p:cNvSpPr txBox="1"/>
           <p:nvPr/>
         </p:nvSpPr>
@@ -3165,7 +3165,7 @@
       </p:sp>
       <p:pic>
         <p:nvPicPr>
-          <p:cNvPr id="17" name="app-141" descr="/tmp/tmp.WjEaqILH74/apps/com.mattjakeman.ExtensionManager.png">    </p:cNvPr>
+          <p:cNvPr id="17" name="app-148" descr="/tmp/tmp.wNxcSLvjxS/apps/com.mattjakeman.ExtensionManager.png">    </p:cNvPr>
           <p:cNvPicPr>
             <a:picLocks noChangeAspect="1"/>
           </p:cNvPicPr>
@@ -3189,7 +3189,7 @@
       </p:pic>
       <p:sp>
         <p:nvSpPr>
-          <p:cNvPr id="18" name="applabel-142"/>
+          <p:cNvPr id="18" name="applabel-149"/>
           <p:cNvSpPr txBox="1"/>
           <p:nvPr/>
         </p:nvSpPr>
@@ -3225,7 +3225,7 @@
       </p:sp>
       <p:pic>
         <p:nvPicPr>
-          <p:cNvPr id="19" name="app-143" descr="/tmp/tmp.WjEaqILH74/apps/net.sonobus.SonoBus.png">    </p:cNvPr>
+          <p:cNvPr id="19" name="app-150" descr="/tmp/tmp.wNxcSLvjxS/apps/net.sonobus.SonoBus.png">    </p:cNvPr>
           <p:cNvPicPr>
             <a:picLocks noChangeAspect="1"/>
           </p:cNvPicPr>
@@ -3249,7 +3249,7 @@
       </p:pic>
       <p:sp>
         <p:nvSpPr>
-          <p:cNvPr id="20" name="applabel-144"/>
+          <p:cNvPr id="20" name="applabel-151"/>
           <p:cNvSpPr txBox="1"/>
           <p:nvPr/>
         </p:nvSpPr>
@@ -3285,7 +3285,7 @@
       </p:sp>
       <p:pic>
         <p:nvPicPr>
-          <p:cNvPr id="21" name="app-145" descr="/tmp/tmp.WjEaqILH74/apps/com.github.tenderowl.frog.png">    </p:cNvPr>
+          <p:cNvPr id="21" name="app-152" descr="/tmp/tmp.wNxcSLvjxS/apps/com.github.tenderowl.frog.png">    </p:cNvPr>
           <p:cNvPicPr>
             <a:picLocks noChangeAspect="1"/>
           </p:cNvPicPr>
@@ -3309,7 +3309,7 @@
       </p:pic>
       <p:sp>
         <p:nvSpPr>
-          <p:cNvPr id="22" name="applabel-146"/>
+          <p:cNvPr id="22" name="applabel-153"/>
           <p:cNvSpPr txBox="1"/>
           <p:nvPr/>
         </p:nvSpPr>
@@ -3345,7 +3345,7 @@
       </p:sp>
       <p:pic>
         <p:nvPicPr>
-          <p:cNvPr id="23" name="app-147" descr="/tmp/tmp.WjEaqILH74/apps/one.alynx.FlipClock.png">    </p:cNvPr>
+          <p:cNvPr id="23" name="app-154" descr="/tmp/tmp.wNxcSLvjxS/apps/one.alynx.FlipClock.png">    </p:cNvPr>
           <p:cNvPicPr>
             <a:picLocks noChangeAspect="1"/>
           </p:cNvPicPr>
@@ -3369,7 +3369,7 @@
       </p:pic>
       <p:sp>
         <p:nvSpPr>
-          <p:cNvPr id="24" name="applabel-148"/>
+          <p:cNvPr id="24" name="applabel-155"/>
           <p:cNvSpPr txBox="1"/>
           <p:nvPr/>
         </p:nvSpPr>
@@ -3405,7 +3405,7 @@
       </p:sp>
       <p:pic>
         <p:nvPicPr>
-          <p:cNvPr id="25" name="app-149" descr="/tmp/tmp.WjEaqILH74/apps/io.github.mehulk.MkNotes.png">    </p:cNvPr>
+          <p:cNvPr id="25" name="app-156" descr="/tmp/tmp.wNxcSLvjxS/apps/io.github.mehulk.MkNotes.png">    </p:cNvPr>
           <p:cNvPicPr>
             <a:picLocks noChangeAspect="1"/>
           </p:cNvPicPr>
@@ -3429,7 +3429,7 @@
       </p:pic>
       <p:sp>
         <p:nvSpPr>
-          <p:cNvPr id="26" name="applabel-150"/>
+          <p:cNvPr id="26" name="applabel-157"/>
           <p:cNvSpPr txBox="1"/>
           <p:nvPr/>
         </p:nvSpPr>
@@ -3465,7 +3465,7 @@
       </p:sp>
       <p:pic>
         <p:nvPicPr>
-          <p:cNvPr id="27" name="app-151" descr="/tmp/tmp.WjEaqILH74/apps/io.github.mehulk.MkCompanion.png">    </p:cNvPr>
+          <p:cNvPr id="27" name="app-158" descr="/tmp/tmp.wNxcSLvjxS/apps/io.github.mehulk.MkCompanion.png">    </p:cNvPr>
           <p:cNvPicPr>
             <a:picLocks noChangeAspect="1"/>
           </p:cNvPicPr>
@@ -3489,7 +3489,7 @@
       </p:pic>
       <p:sp>
         <p:nvSpPr>
-          <p:cNvPr id="28" name="applabel-152"/>
+          <p:cNvPr id="28" name="applabel-159"/>
           <p:cNvSpPr txBox="1"/>
           <p:nvPr/>
         </p:nvSpPr>
@@ -3525,7 +3525,7 @@
       </p:sp>
       <p:pic>
         <p:nvPicPr>
-          <p:cNvPr id="29" name="app-153" descr="/tmp/tmp.WjEaqILH74/apps/io.github.mehulk.MkTimer.png">    </p:cNvPr>
+          <p:cNvPr id="29" name="app-160" descr="/tmp/tmp.wNxcSLvjxS/apps/io.github.mehulk.MkTimer.png">    </p:cNvPr>
           <p:cNvPicPr>
             <a:picLocks noChangeAspect="1"/>
           </p:cNvPicPr>
@@ -3549,7 +3549,7 @@
       </p:pic>
       <p:sp>
         <p:nvSpPr>
-          <p:cNvPr id="30" name="applabel-154"/>
+          <p:cNvPr id="30" name="applabel-161"/>
           <p:cNvSpPr txBox="1"/>
           <p:nvPr/>
         </p:nvSpPr>
@@ -3585,7 +3585,7 @@
       </p:sp>
       <p:pic>
         <p:nvPicPr>
-          <p:cNvPr id="31" name="app-155" descr="/tmp/tmp.WjEaqILH74/apps/io.github.mehulk.MkShortcuts.png">    </p:cNvPr>
+          <p:cNvPr id="31" name="app-162" descr="/tmp/tmp.wNxcSLvjxS/apps/io.github.mehulk.MkShortcuts.png">    </p:cNvPr>
           <p:cNvPicPr>
             <a:picLocks noChangeAspect="1"/>
           </p:cNvPicPr>
@@ -3609,7 +3609,7 @@
       </p:pic>
       <p:sp>
         <p:nvSpPr>
-          <p:cNvPr id="32" name="applabel-156"/>
+          <p:cNvPr id="32" name="applabel-163"/>
           <p:cNvSpPr txBox="1"/>
           <p:nvPr/>
         </p:nvSpPr>
@@ -3827,7 +3827,7 @@
       </p:sp>
       <p:sp>
         <p:nvSpPr>
-          <p:cNvPr id="5" name="card-157"/>
+          <p:cNvPr id="5" name="card-164"/>
           <p:cNvSpPr/>
           <p:nvPr/>
         </p:nvSpPr>
@@ -3849,7 +3849,7 @@
       </p:sp>
       <p:sp>
         <p:nvSpPr>
-          <p:cNvPr id="6" name="dot-158"/>
+          <p:cNvPr id="6" name="dot-165"/>
           <p:cNvSpPr/>
           <p:nvPr/>
         </p:nvSpPr>
@@ -3869,7 +3869,7 @@
       </p:sp>
       <p:pic>
         <p:nvPicPr>
-          <p:cNvPr id="7" name="icon-159" descr="/tmp/tmp.WjEaqILH74/icons/auth-fingerprint.png">    </p:cNvPr>
+          <p:cNvPr id="7" name="icon-166" descr="/tmp/tmp.wNxcSLvjxS/icons/auth-fingerprint.png">    </p:cNvPr>
           <p:cNvPicPr>
             <a:picLocks noChangeAspect="1"/>
           </p:cNvPicPr>
@@ -3893,7 +3893,7 @@
       </p:pic>
       <p:sp>
         <p:nvSpPr>
-          <p:cNvPr id="8" name="cardtext-160"/>
+          <p:cNvPr id="8" name="cardtext-167"/>
           <p:cNvSpPr txBox="1"/>
           <p:nvPr/>
         </p:nvSpPr>
@@ -3949,7 +3949,7 @@
       </p:sp>
       <p:sp>
         <p:nvSpPr>
-          <p:cNvPr id="9" name="card-161"/>
+          <p:cNvPr id="9" name="card-168"/>
           <p:cNvSpPr/>
           <p:nvPr/>
         </p:nvSpPr>
@@ -3971,7 +3971,7 @@
       </p:sp>
       <p:sp>
         <p:nvSpPr>
-          <p:cNvPr id="10" name="dot-162"/>
+          <p:cNvPr id="10" name="dot-169"/>
           <p:cNvSpPr/>
           <p:nvPr/>
         </p:nvSpPr>
@@ -3991,7 +3991,7 @@
       </p:sp>
       <p:pic>
         <p:nvPicPr>
-          <p:cNvPr id="11" name="icon-163" descr="/tmp/tmp.WjEaqILH74/icons/battery-full.png">    </p:cNvPr>
+          <p:cNvPr id="11" name="icon-170" descr="/tmp/tmp.wNxcSLvjxS/icons/battery-full.png">    </p:cNvPr>
           <p:cNvPicPr>
             <a:picLocks noChangeAspect="1"/>
           </p:cNvPicPr>
@@ -4015,7 +4015,7 @@
       </p:pic>
       <p:sp>
         <p:nvSpPr>
-          <p:cNvPr id="12" name="cardtext-164"/>
+          <p:cNvPr id="12" name="cardtext-171"/>
           <p:cNvSpPr txBox="1"/>
           <p:nvPr/>
         </p:nvSpPr>
@@ -4071,7 +4071,7 @@
       </p:sp>
       <p:sp>
         <p:nvSpPr>
-          <p:cNvPr id="13" name="card-165"/>
+          <p:cNvPr id="13" name="card-172"/>
           <p:cNvSpPr/>
           <p:nvPr/>
         </p:nvSpPr>
@@ -4093,7 +4093,7 @@
       </p:sp>
       <p:sp>
         <p:nvSpPr>
-          <p:cNvPr id="14" name="dot-166"/>
+          <p:cNvPr id="14" name="dot-173"/>
           <p:cNvSpPr/>
           <p:nvPr/>
         </p:nvSpPr>
@@ -4113,7 +4113,7 @@
       </p:sp>
       <p:pic>
         <p:nvPicPr>
-          <p:cNvPr id="15" name="icon-167" descr="/tmp/tmp.WjEaqILH74/icons/audio-speakers.png">    </p:cNvPr>
+          <p:cNvPr id="15" name="icon-174" descr="/tmp/tmp.wNxcSLvjxS/icons/audio-speakers.png">    </p:cNvPr>
           <p:cNvPicPr>
             <a:picLocks noChangeAspect="1"/>
           </p:cNvPicPr>
@@ -4137,7 +4137,7 @@
       </p:pic>
       <p:sp>
         <p:nvSpPr>
-          <p:cNvPr id="16" name="cardtext-168"/>
+          <p:cNvPr id="16" name="cardtext-175"/>
           <p:cNvSpPr txBox="1"/>
           <p:nvPr/>
         </p:nvSpPr>
@@ -4193,7 +4193,7 @@
       </p:sp>
       <p:sp>
         <p:nvSpPr>
-          <p:cNvPr id="17" name="card-169"/>
+          <p:cNvPr id="17" name="card-176"/>
           <p:cNvSpPr/>
           <p:nvPr/>
         </p:nvSpPr>
@@ -4215,7 +4215,7 @@
       </p:sp>
       <p:sp>
         <p:nvSpPr>
-          <p:cNvPr id="18" name="dot-170"/>
+          <p:cNvPr id="18" name="dot-177"/>
           <p:cNvSpPr/>
           <p:nvPr/>
         </p:nvSpPr>
@@ -4235,7 +4235,7 @@
       </p:sp>
       <p:pic>
         <p:nvPicPr>
-          <p:cNvPr id="19" name="icon-171" descr="/tmp/tmp.WjEaqILH74/icons/input-tablet.png">    </p:cNvPr>
+          <p:cNvPr id="19" name="icon-178" descr="/tmp/tmp.wNxcSLvjxS/icons/input-tablet.png">    </p:cNvPr>
           <p:cNvPicPr>
             <a:picLocks noChangeAspect="1"/>
           </p:cNvPicPr>
@@ -4259,7 +4259,7 @@
       </p:pic>
       <p:sp>
         <p:nvSpPr>
-          <p:cNvPr id="20" name="cardtext-172"/>
+          <p:cNvPr id="20" name="cardtext-179"/>
           <p:cNvSpPr txBox="1"/>
           <p:nvPr/>
         </p:nvSpPr>
@@ -4315,7 +4315,7 @@
       </p:sp>
       <p:sp>
         <p:nvSpPr>
-          <p:cNvPr id="21" name="card-173"/>
+          <p:cNvPr id="21" name="card-180"/>
           <p:cNvSpPr/>
           <p:nvPr/>
         </p:nvSpPr>
@@ -4337,7 +4337,7 @@
       </p:sp>
       <p:sp>
         <p:nvSpPr>
-          <p:cNvPr id="22" name="dot-174"/>
+          <p:cNvPr id="22" name="dot-181"/>
           <p:cNvSpPr/>
           <p:nvPr/>
         </p:nvSpPr>
@@ -4357,7 +4357,7 @@
       </p:sp>
       <p:pic>
         <p:nvPicPr>
-          <p:cNvPr id="23" name="icon-175" descr="/tmp/tmp.WjEaqILH74/icons/video-display.png">    </p:cNvPr>
+          <p:cNvPr id="23" name="icon-182" descr="/tmp/tmp.wNxcSLvjxS/icons/video-display.png">    </p:cNvPr>
           <p:cNvPicPr>
             <a:picLocks noChangeAspect="1"/>
           </p:cNvPicPr>
@@ -4381,7 +4381,7 @@
       </p:pic>
       <p:sp>
         <p:nvSpPr>
-          <p:cNvPr id="24" name="cardtext-176"/>
+          <p:cNvPr id="24" name="cardtext-183"/>
           <p:cNvSpPr txBox="1"/>
           <p:nvPr/>
         </p:nvSpPr>
@@ -4437,7 +4437,7 @@
       </p:sp>
       <p:sp>
         <p:nvSpPr>
-          <p:cNvPr id="25" name="card-177"/>
+          <p:cNvPr id="25" name="card-184"/>
           <p:cNvSpPr/>
           <p:nvPr/>
         </p:nvSpPr>
@@ -4459,7 +4459,7 @@
       </p:sp>
       <p:sp>
         <p:nvSpPr>
-          <p:cNvPr id="26" name="dot-178"/>
+          <p:cNvPr id="26" name="dot-185"/>
           <p:cNvSpPr/>
           <p:nvPr/>
         </p:nvSpPr>
@@ -4479,7 +4479,7 @@
       </p:sp>
       <p:pic>
         <p:nvPicPr>
-          <p:cNvPr id="27" name="icon-179" descr="/tmp/tmp.WjEaqILH74/icons/system-run.png">    </p:cNvPr>
+          <p:cNvPr id="27" name="icon-186" descr="/tmp/tmp.wNxcSLvjxS/icons/system-run.png">    </p:cNvPr>
           <p:cNvPicPr>
             <a:picLocks noChangeAspect="1"/>
           </p:cNvPicPr>
@@ -4503,7 +4503,7 @@
       </p:pic>
       <p:sp>
         <p:nvSpPr>
-          <p:cNvPr id="28" name="cardtext-180"/>
+          <p:cNvPr id="28" name="cardtext-187"/>
           <p:cNvSpPr txBox="1"/>
           <p:nvPr/>
         </p:nvSpPr>
@@ -4705,7 +4705,7 @@
       </p:sp>
       <p:sp>
         <p:nvSpPr>
-          <p:cNvPr id="5" name="key-181"/>
+          <p:cNvPr id="5" name="key-188"/>
           <p:cNvSpPr/>
           <p:nvPr/>
         </p:nvSpPr>
@@ -4727,7 +4727,7 @@
       </p:sp>
       <p:sp>
         <p:nvSpPr>
-          <p:cNvPr id="6" name="keytext-182"/>
+          <p:cNvPr id="6" name="keytext-189"/>
           <p:cNvSpPr txBox="1"/>
           <p:nvPr/>
         </p:nvSpPr>
@@ -4763,7 +4763,7 @@
       </p:sp>
       <p:sp>
         <p:nvSpPr>
-          <p:cNvPr id="7" name="keylabel-183"/>
+          <p:cNvPr id="7" name="keylabel-190"/>
           <p:cNvSpPr txBox="1"/>
           <p:nvPr/>
         </p:nvSpPr>
@@ -4799,7 +4799,7 @@
       </p:sp>
       <p:sp>
         <p:nvSpPr>
-          <p:cNvPr id="8" name="key-184"/>
+          <p:cNvPr id="8" name="key-191"/>
           <p:cNvSpPr/>
           <p:nvPr/>
         </p:nvSpPr>
@@ -4821,7 +4821,7 @@
       </p:sp>
       <p:sp>
         <p:nvSpPr>
-          <p:cNvPr id="9" name="keytext-185"/>
+          <p:cNvPr id="9" name="keytext-192"/>
           <p:cNvSpPr txBox="1"/>
           <p:nvPr/>
         </p:nvSpPr>
@@ -4857,7 +4857,7 @@
       </p:sp>
       <p:sp>
         <p:nvSpPr>
-          <p:cNvPr id="10" name="keylabel-186"/>
+          <p:cNvPr id="10" name="keylabel-193"/>
           <p:cNvSpPr txBox="1"/>
           <p:nvPr/>
         </p:nvSpPr>
@@ -4893,7 +4893,7 @@
       </p:sp>
       <p:sp>
         <p:nvSpPr>
-          <p:cNvPr id="11" name="key-187"/>
+          <p:cNvPr id="11" name="key-194"/>
           <p:cNvSpPr/>
           <p:nvPr/>
         </p:nvSpPr>
@@ -4915,7 +4915,7 @@
       </p:sp>
       <p:sp>
         <p:nvSpPr>
-          <p:cNvPr id="12" name="keytext-188"/>
+          <p:cNvPr id="12" name="keytext-195"/>
           <p:cNvSpPr txBox="1"/>
           <p:nvPr/>
         </p:nvSpPr>
@@ -4951,7 +4951,7 @@
       </p:sp>
       <p:sp>
         <p:nvSpPr>
-          <p:cNvPr id="13" name="keylabel-189"/>
+          <p:cNvPr id="13" name="keylabel-196"/>
           <p:cNvSpPr txBox="1"/>
           <p:nvPr/>
         </p:nvSpPr>
@@ -4987,7 +4987,7 @@
       </p:sp>
       <p:sp>
         <p:nvSpPr>
-          <p:cNvPr id="14" name="key-190"/>
+          <p:cNvPr id="14" name="key-197"/>
           <p:cNvSpPr/>
           <p:nvPr/>
         </p:nvSpPr>
@@ -5009,7 +5009,7 @@
       </p:sp>
       <p:sp>
         <p:nvSpPr>
-          <p:cNvPr id="15" name="keytext-191"/>
+          <p:cNvPr id="15" name="keytext-198"/>
           <p:cNvSpPr txBox="1"/>
           <p:nvPr/>
         </p:nvSpPr>
@@ -5045,7 +5045,7 @@
       </p:sp>
       <p:sp>
         <p:nvSpPr>
-          <p:cNvPr id="16" name="keylabel-192"/>
+          <p:cNvPr id="16" name="keylabel-199"/>
           <p:cNvSpPr txBox="1"/>
           <p:nvPr/>
         </p:nvSpPr>
@@ -5081,7 +5081,7 @@
       </p:sp>
       <p:sp>
         <p:nvSpPr>
-          <p:cNvPr id="17" name="key-193"/>
+          <p:cNvPr id="17" name="key-200"/>
           <p:cNvSpPr/>
           <p:nvPr/>
         </p:nvSpPr>
@@ -5103,7 +5103,7 @@
       </p:sp>
       <p:sp>
         <p:nvSpPr>
-          <p:cNvPr id="18" name="keytext-194"/>
+          <p:cNvPr id="18" name="keytext-201"/>
           <p:cNvSpPr txBox="1"/>
           <p:nvPr/>
         </p:nvSpPr>
@@ -5139,7 +5139,7 @@
       </p:sp>
       <p:sp>
         <p:nvSpPr>
-          <p:cNvPr id="19" name="keylabel-195"/>
+          <p:cNvPr id="19" name="keylabel-202"/>
           <p:cNvSpPr txBox="1"/>
           <p:nvPr/>
         </p:nvSpPr>
@@ -5175,7 +5175,7 @@
       </p:sp>
       <p:sp>
         <p:nvSpPr>
-          <p:cNvPr id="20" name="key-196"/>
+          <p:cNvPr id="20" name="key-203"/>
           <p:cNvSpPr/>
           <p:nvPr/>
         </p:nvSpPr>
@@ -5197,7 +5197,7 @@
       </p:sp>
       <p:sp>
         <p:nvSpPr>
-          <p:cNvPr id="21" name="keytext-197"/>
+          <p:cNvPr id="21" name="keytext-204"/>
           <p:cNvSpPr txBox="1"/>
           <p:nvPr/>
         </p:nvSpPr>
@@ -5233,7 +5233,7 @@
       </p:sp>
       <p:sp>
         <p:nvSpPr>
-          <p:cNvPr id="22" name="keylabel-198"/>
+          <p:cNvPr id="22" name="keylabel-205"/>
           <p:cNvSpPr txBox="1"/>
           <p:nvPr/>
         </p:nvSpPr>
@@ -5269,7 +5269,7 @@
       </p:sp>
       <p:sp>
         <p:nvSpPr>
-          <p:cNvPr id="23" name="key-199"/>
+          <p:cNvPr id="23" name="key-206"/>
           <p:cNvSpPr/>
           <p:nvPr/>
         </p:nvSpPr>
@@ -5291,7 +5291,7 @@
       </p:sp>
       <p:sp>
         <p:nvSpPr>
-          <p:cNvPr id="24" name="keytext-200"/>
+          <p:cNvPr id="24" name="keytext-207"/>
           <p:cNvSpPr txBox="1"/>
           <p:nvPr/>
         </p:nvSpPr>
@@ -5327,7 +5327,7 @@
       </p:sp>
       <p:sp>
         <p:nvSpPr>
-          <p:cNvPr id="25" name="keylabel-201"/>
+          <p:cNvPr id="25" name="keylabel-208"/>
           <p:cNvSpPr txBox="1"/>
           <p:nvPr/>
         </p:nvSpPr>
@@ -5363,7 +5363,7 @@
       </p:sp>
       <p:sp>
         <p:nvSpPr>
-          <p:cNvPr id="26" name="key-202"/>
+          <p:cNvPr id="26" name="key-209"/>
           <p:cNvSpPr/>
           <p:nvPr/>
         </p:nvSpPr>
@@ -5385,7 +5385,7 @@
       </p:sp>
       <p:sp>
         <p:nvSpPr>
-          <p:cNvPr id="27" name="keytext-203"/>
+          <p:cNvPr id="27" name="keytext-210"/>
           <p:cNvSpPr txBox="1"/>
           <p:nvPr/>
         </p:nvSpPr>
@@ -5421,7 +5421,7 @@
       </p:sp>
       <p:sp>
         <p:nvSpPr>
-          <p:cNvPr id="28" name="keylabel-204"/>
+          <p:cNvPr id="28" name="keylabel-211"/>
           <p:cNvSpPr txBox="1"/>
           <p:nvPr/>
         </p:nvSpPr>
@@ -5457,7 +5457,7 @@
       </p:sp>
       <p:sp>
         <p:nvSpPr>
-          <p:cNvPr id="29" name="key-205"/>
+          <p:cNvPr id="29" name="key-212"/>
           <p:cNvSpPr/>
           <p:nvPr/>
         </p:nvSpPr>
@@ -5479,7 +5479,7 @@
       </p:sp>
       <p:sp>
         <p:nvSpPr>
-          <p:cNvPr id="30" name="keytext-206"/>
+          <p:cNvPr id="30" name="keytext-213"/>
           <p:cNvSpPr txBox="1"/>
           <p:nvPr/>
         </p:nvSpPr>
@@ -5515,7 +5515,7 @@
       </p:sp>
       <p:sp>
         <p:nvSpPr>
-          <p:cNvPr id="31" name="keylabel-207"/>
+          <p:cNvPr id="31" name="keylabel-214"/>
           <p:cNvSpPr txBox="1"/>
           <p:nvPr/>
         </p:nvSpPr>
@@ -5551,7 +5551,7 @@
       </p:sp>
       <p:sp>
         <p:nvSpPr>
-          <p:cNvPr id="32" name="key-208"/>
+          <p:cNvPr id="32" name="key-215"/>
           <p:cNvSpPr/>
           <p:nvPr/>
         </p:nvSpPr>
@@ -5573,7 +5573,7 @@
       </p:sp>
       <p:sp>
         <p:nvSpPr>
-          <p:cNvPr id="33" name="keytext-209"/>
+          <p:cNvPr id="33" name="keytext-216"/>
           <p:cNvSpPr txBox="1"/>
           <p:nvPr/>
         </p:nvSpPr>
@@ -5609,7 +5609,7 @@
       </p:sp>
       <p:sp>
         <p:nvSpPr>
-          <p:cNvPr id="34" name="keylabel-210"/>
+          <p:cNvPr id="34" name="keylabel-217"/>
           <p:cNvSpPr txBox="1"/>
           <p:nvPr/>
         </p:nvSpPr>
@@ -5645,7 +5645,7 @@
       </p:sp>
       <p:pic>
         <p:nvPicPr>
-          <p:cNvPr id="35" name="shortcuts" descr="/tmp/tmp.WjEaqILH74/img/shortcuts.jpg">    </p:cNvPr>
+          <p:cNvPr id="35" name="shortcuts" descr="/tmp/tmp.wNxcSLvjxS/img/shortcuts.jpg">    </p:cNvPr>
           <p:cNvPicPr>
             <a:picLocks noChangeAspect="1"/>
           </p:cNvPicPr>
@@ -5676,7 +5676,7 @@
       </p:pic>
       <p:sp>
         <p:nvSpPr>
-          <p:cNvPr id="36" name="caption-211"/>
+          <p:cNvPr id="36" name="caption-218"/>
           <p:cNvSpPr txBox="1"/>
           <p:nvPr/>
         </p:nvSpPr>
@@ -5858,7 +5858,7 @@
       </p:sp>
       <p:sp>
         <p:nvSpPr>
-          <p:cNvPr id="5" name="dot-212"/>
+          <p:cNvPr id="5" name="dot-219"/>
           <p:cNvSpPr/>
           <p:nvPr/>
         </p:nvSpPr>
@@ -5878,7 +5878,7 @@
       </p:sp>
       <p:pic>
         <p:nvPicPr>
-          <p:cNvPr id="6" name="icon-213" descr="/tmp/tmp.WjEaqILH74/icons/document-open-recent.png">    </p:cNvPr>
+          <p:cNvPr id="6" name="icon-220" descr="/tmp/tmp.wNxcSLvjxS/icons/document-open-recent.png">    </p:cNvPr>
           <p:cNvPicPr>
             <a:picLocks noChangeAspect="1"/>
           </p:cNvPicPr>
@@ -5902,7 +5902,7 @@
       </p:pic>
       <p:sp>
         <p:nvSpPr>
-          <p:cNvPr id="7" name="row-214"/>
+          <p:cNvPr id="7" name="row-221"/>
           <p:cNvSpPr txBox="1"/>
           <p:nvPr/>
         </p:nvSpPr>
@@ -5958,7 +5958,7 @@
       </p:sp>
       <p:sp>
         <p:nvSpPr>
-          <p:cNvPr id="8" name="dot-215"/>
+          <p:cNvPr id="8" name="dot-222"/>
           <p:cNvSpPr/>
           <p:nvPr/>
         </p:nvSpPr>
@@ -5978,7 +5978,7 @@
       </p:sp>
       <p:pic>
         <p:nvPicPr>
-          <p:cNvPr id="9" name="icon-216" descr="/tmp/tmp.WjEaqILH74/icons/user-trash.png">    </p:cNvPr>
+          <p:cNvPr id="9" name="icon-223" descr="/tmp/tmp.wNxcSLvjxS/icons/user-trash.png">    </p:cNvPr>
           <p:cNvPicPr>
             <a:picLocks noChangeAspect="1"/>
           </p:cNvPicPr>
@@ -6002,7 +6002,7 @@
       </p:pic>
       <p:sp>
         <p:nvSpPr>
-          <p:cNvPr id="10" name="row-217"/>
+          <p:cNvPr id="10" name="row-224"/>
           <p:cNvSpPr txBox="1"/>
           <p:nvPr/>
         </p:nvSpPr>
@@ -6058,7 +6058,7 @@
       </p:sp>
       <p:sp>
         <p:nvSpPr>
-          <p:cNvPr id="11" name="dot-218"/>
+          <p:cNvPr id="11" name="dot-225"/>
           <p:cNvSpPr/>
           <p:nvPr/>
         </p:nvSpPr>
@@ -6078,7 +6078,7 @@
       </p:sp>
       <p:pic>
         <p:nvPicPr>
-          <p:cNvPr id="12" name="icon-219" descr="/tmp/tmp.WjEaqILH74/icons/checkbox-checked.png">    </p:cNvPr>
+          <p:cNvPr id="12" name="icon-226" descr="/tmp/tmp.wNxcSLvjxS/icons/checkbox-checked.png">    </p:cNvPr>
           <p:cNvPicPr>
             <a:picLocks noChangeAspect="1"/>
           </p:cNvPicPr>
@@ -6102,7 +6102,7 @@
       </p:pic>
       <p:sp>
         <p:nvSpPr>
-          <p:cNvPr id="13" name="row-220"/>
+          <p:cNvPr id="13" name="row-227"/>
           <p:cNvSpPr txBox="1"/>
           <p:nvPr/>
         </p:nvSpPr>
@@ -6158,7 +6158,7 @@
       </p:sp>
       <p:sp>
         <p:nvSpPr>
-          <p:cNvPr id="14" name="dot-221"/>
+          <p:cNvPr id="14" name="dot-228"/>
           <p:cNvSpPr/>
           <p:nvPr/>
         </p:nvSpPr>
@@ -6178,7 +6178,7 @@
       </p:sp>
       <p:pic>
         <p:nvPicPr>
-          <p:cNvPr id="15" name="icon-222" descr="/tmp/tmp.WjEaqILH74/icons/x-office-document.png">    </p:cNvPr>
+          <p:cNvPr id="15" name="icon-229" descr="/tmp/tmp.wNxcSLvjxS/icons/x-office-document.png">    </p:cNvPr>
           <p:cNvPicPr>
             <a:picLocks noChangeAspect="1"/>
           </p:cNvPicPr>
@@ -6202,7 +6202,7 @@
       </p:pic>
       <p:sp>
         <p:nvSpPr>
-          <p:cNvPr id="16" name="row-223"/>
+          <p:cNvPr id="16" name="row-230"/>
           <p:cNvSpPr txBox="1"/>
           <p:nvPr/>
         </p:nvSpPr>
@@ -6258,7 +6258,7 @@
       </p:sp>
       <p:sp>
         <p:nvSpPr>
-          <p:cNvPr id="17" name="dot-224"/>
+          <p:cNvPr id="17" name="dot-231"/>
           <p:cNvSpPr/>
           <p:nvPr/>
         </p:nvSpPr>
@@ -6278,7 +6278,7 @@
       </p:sp>
       <p:pic>
         <p:nvPicPr>
-          <p:cNvPr id="18" name="icon-225" descr="/tmp/tmp.WjEaqILH74/icons/software-update-available.png">    </p:cNvPr>
+          <p:cNvPr id="18" name="icon-232" descr="/tmp/tmp.wNxcSLvjxS/icons/software-update-available.png">    </p:cNvPr>
           <p:cNvPicPr>
             <a:picLocks noChangeAspect="1"/>
           </p:cNvPicPr>
@@ -6302,7 +6302,7 @@
       </p:pic>
       <p:sp>
         <p:nvSpPr>
-          <p:cNvPr id="19" name="row-226"/>
+          <p:cNvPr id="19" name="row-233"/>
           <p:cNvSpPr txBox="1"/>
           <p:nvPr/>
         </p:nvSpPr>
@@ -6358,7 +6358,7 @@
       </p:sp>
       <p:pic>
         <p:nvPicPr>
-          <p:cNvPr id="20" name="companion" descr="/tmp/tmp.WjEaqILH74/img/companion.jpg">    </p:cNvPr>
+          <p:cNvPr id="20" name="companion" descr="/tmp/tmp.wNxcSLvjxS/img/companion.jpg">    </p:cNvPr>
           <p:cNvPicPr>
             <a:picLocks noChangeAspect="1"/>
           </p:cNvPicPr>
@@ -6389,7 +6389,7 @@
       </p:pic>
       <p:sp>
         <p:nvSpPr>
-          <p:cNvPr id="21" name="caption-227"/>
+          <p:cNvPr id="21" name="caption-234"/>
           <p:cNvSpPr txBox="1"/>
           <p:nvPr/>
         </p:nvSpPr>
@@ -6571,7 +6571,7 @@
       </p:sp>
       <p:sp>
         <p:nvSpPr>
-          <p:cNvPr id="4" name="cmdbox-228"/>
+          <p:cNvPr id="4" name="cmdbox-235"/>
           <p:cNvSpPr/>
           <p:nvPr/>
         </p:nvSpPr>
@@ -6595,7 +6595,7 @@
       </p:sp>
       <p:sp>
         <p:nvSpPr>
-          <p:cNvPr id="5" name="cmd-229"/>
+          <p:cNvPr id="5" name="cmd-236"/>
           <p:cNvSpPr txBox="1"/>
           <p:nvPr/>
         </p:nvSpPr>
@@ -6645,7 +6645,7 @@
       </p:sp>
       <p:sp>
         <p:nvSpPr>
-          <p:cNvPr id="6" name="cmdbox-230"/>
+          <p:cNvPr id="6" name="cmdbox-237"/>
           <p:cNvSpPr/>
           <p:nvPr/>
         </p:nvSpPr>
@@ -6669,7 +6669,7 @@
       </p:sp>
       <p:sp>
         <p:nvSpPr>
-          <p:cNvPr id="7" name="cmd-231"/>
+          <p:cNvPr id="7" name="cmd-238"/>
           <p:cNvSpPr txBox="1"/>
           <p:nvPr/>
         </p:nvSpPr>
@@ -6719,7 +6719,7 @@
       </p:sp>
       <p:sp>
         <p:nvSpPr>
-          <p:cNvPr id="8" name="cmdbox-232"/>
+          <p:cNvPr id="8" name="cmdbox-239"/>
           <p:cNvSpPr/>
           <p:nvPr/>
         </p:nvSpPr>
@@ -6743,7 +6743,7 @@
       </p:sp>
       <p:sp>
         <p:nvSpPr>
-          <p:cNvPr id="9" name="cmd-233"/>
+          <p:cNvPr id="9" name="cmd-240"/>
           <p:cNvSpPr txBox="1"/>
           <p:nvPr/>
         </p:nvSpPr>
@@ -7087,7 +7087,7 @@
       </p:sp>
       <p:pic>
         <p:nvPicPr>
-          <p:cNvPr id="7" name="icon-2" descr="/tmp/tmp.WjEaqILH74/icons/edit-undo.png">    </p:cNvPr>
+          <p:cNvPr id="7" name="icon-2" descr="/tmp/tmp.wNxcSLvjxS/icons/edit-undo.png">    </p:cNvPr>
           <p:cNvPicPr>
             <a:picLocks noChangeAspect="1"/>
           </p:cNvPicPr>
@@ -7187,7 +7187,7 @@
       </p:sp>
       <p:pic>
         <p:nvPicPr>
-          <p:cNvPr id="10" name="icon-5" descr="/tmp/tmp.WjEaqILH74/icons/software-update-available.png">    </p:cNvPr>
+          <p:cNvPr id="10" name="icon-5" descr="/tmp/tmp.wNxcSLvjxS/icons/software-update-available.png">    </p:cNvPr>
           <p:cNvPicPr>
             <a:picLocks noChangeAspect="1"/>
           </p:cNvPicPr>
@@ -7837,7 +7837,7 @@
                   <a:schemeClr val="tx1"/>
                 </a:solidFill>
               </a:rPr>
-              <a:t>Swipe through your windows</a:t>
+              <a:t>Every window, live, one swipe away</a:t>
             </a:r>
             <a:endParaRPr lang="en-US" sz="3000" dirty="0"/>
           </a:p>
@@ -7845,7 +7845,7 @@
       </p:sp>
       <p:pic>
         <p:nvPicPr>
-          <p:cNvPr id="4" name="alttab-19" descr="/tmp/tmp.WjEaqILH74/img/alttab.jpg">    </p:cNvPr>
+          <p:cNvPr id="5" name="alttab-19" descr="/tmp/tmp.wNxcSLvjxS/img/alttab.jpg">    </p:cNvPr>
           <p:cNvPicPr>
             <a:picLocks noChangeAspect="1"/>
           </p:cNvPicPr>
@@ -7876,7 +7876,7 @@
       </p:pic>
       <p:sp>
         <p:nvSpPr>
-          <p:cNvPr id="5" name="caption-20"/>
+          <p:cNvPr id="6" name="caption-20"/>
           <p:cNvSpPr txBox="1"/>
           <p:nvPr/>
         </p:nvSpPr>
@@ -7904,7 +7904,7 @@
                   <a:schemeClr val="tx2"/>
                 </a:solidFill>
               </a:rPr>
-              <a:t>One glowing ring glides to the window you want</a:t>
+              <a:t>A frosted grid of live windows; the ring glides to your pick</a:t>
             </a:r>
             <a:endParaRPr lang="en-US" sz="1000" dirty="0"/>
           </a:p>
@@ -7912,7 +7912,7 @@
       </p:sp>
       <p:sp>
         <p:nvSpPr>
-          <p:cNvPr id="6" name="dot-21"/>
+          <p:cNvPr id="7" name="dot-21"/>
           <p:cNvSpPr/>
           <p:nvPr/>
         </p:nvSpPr>
@@ -7932,7 +7932,7 @@
       </p:sp>
       <p:pic>
         <p:nvPicPr>
-          <p:cNvPr id="7" name="icon-22" descr="/tmp/tmp.WjEaqILH74/icons/input-touchpad.png">    </p:cNvPr>
+          <p:cNvPr id="8" name="icon-22" descr="/tmp/tmp.wNxcSLvjxS/icons/view-grid.png">    </p:cNvPr>
           <p:cNvPicPr>
             <a:picLocks noChangeAspect="1"/>
           </p:cNvPicPr>
@@ -7956,7 +7956,7 @@
       </p:pic>
       <p:sp>
         <p:nvSpPr>
-          <p:cNvPr id="8" name="row-23"/>
+          <p:cNvPr id="9" name="row-23"/>
           <p:cNvSpPr txBox="1"/>
           <p:nvPr/>
         </p:nvSpPr>
@@ -7987,7 +7987,7 @@
                   <a:schemeClr val="tx1"/>
                 </a:solidFill>
               </a:rPr>
-              <a:t>Three fingers</a:t>
+              <a:t>A grid, not a strip</a:t>
             </a:r>
             <a:endParaRPr lang="en-US" sz="1400" dirty="0"/>
           </a:p>
@@ -8004,7 +8004,7 @@
                   <a:schemeClr val="tx2"/>
                 </a:solidFill>
               </a:rPr>
-              <a:t>every window, every workspace</a:t>
+              <a:t>previews, titles, which desktop</a:t>
             </a:r>
             <a:endParaRPr lang="en-US" sz="1400" dirty="0"/>
           </a:p>
@@ -8012,7 +8012,7 @@
       </p:sp>
       <p:sp>
         <p:nvSpPr>
-          <p:cNvPr id="9" name="dot-24"/>
+          <p:cNvPr id="10" name="dot-24"/>
           <p:cNvSpPr/>
           <p:nvPr/>
         </p:nvSpPr>
@@ -8032,7 +8032,7 @@
       </p:sp>
       <p:pic>
         <p:nvPicPr>
-          <p:cNvPr id="10" name="icon-25" descr="/tmp/tmp.WjEaqILH74/icons/view-grid.png">    </p:cNvPr>
+          <p:cNvPr id="11" name="icon-25" descr="/tmp/tmp.wNxcSLvjxS/icons/input-touchpad.png">    </p:cNvPr>
           <p:cNvPicPr>
             <a:picLocks noChangeAspect="1"/>
           </p:cNvPicPr>
@@ -8056,7 +8056,7 @@
       </p:pic>
       <p:sp>
         <p:nvSpPr>
-          <p:cNvPr id="11" name="row-26"/>
+          <p:cNvPr id="12" name="row-26"/>
           <p:cNvSpPr txBox="1"/>
           <p:nvPr/>
         </p:nvSpPr>
@@ -8087,7 +8087,7 @@
                   <a:schemeClr val="tx1"/>
                 </a:solidFill>
               </a:rPr>
-              <a:t>Four fingers</a:t>
+              <a:t>Three fingers</a:t>
             </a:r>
             <a:endParaRPr lang="en-US" sz="1400" dirty="0"/>
           </a:p>
@@ -8104,7 +8104,7 @@
                   <a:schemeClr val="tx2"/>
                 </a:solidFill>
               </a:rPr>
-              <a:t>workspaces; up for an overview</a:t>
+              <a:t>same finger travel per window</a:t>
             </a:r>
             <a:endParaRPr lang="en-US" sz="1400" dirty="0"/>
           </a:p>
@@ -8112,7 +8112,7 @@
       </p:sp>
       <p:sp>
         <p:nvSpPr>
-          <p:cNvPr id="12" name="dot-27"/>
+          <p:cNvPr id="13" name="dot-27"/>
           <p:cNvSpPr/>
           <p:nvPr/>
         </p:nvSpPr>
@@ -8132,7 +8132,7 @@
       </p:sp>
       <p:pic>
         <p:nvPicPr>
-          <p:cNvPr id="13" name="icon-28" descr="/tmp/tmp.WjEaqILH74/icons/system-run.png">    </p:cNvPr>
+          <p:cNvPr id="14" name="icon-28" descr="/tmp/tmp.wNxcSLvjxS/icons/view-dual.png">    </p:cNvPr>
           <p:cNvPicPr>
             <a:picLocks noChangeAspect="1"/>
           </p:cNvPicPr>
@@ -8156,7 +8156,7 @@
       </p:pic>
       <p:sp>
         <p:nvSpPr>
-          <p:cNvPr id="14" name="row-29"/>
+          <p:cNvPr id="15" name="row-29"/>
           <p:cNvSpPr txBox="1"/>
           <p:nvPr/>
         </p:nvSpPr>
@@ -8187,7 +8187,7 @@
                   <a:schemeClr val="tx1"/>
                 </a:solidFill>
               </a:rPr>
-              <a:t>As fast as GNOME</a:t>
+              <a:t>Move as you go</a:t>
             </a:r>
             <a:endParaRPr lang="en-US" sz="1400" dirty="0"/>
           </a:p>
@@ -8204,7 +8204,7 @@
                   <a:schemeClr val="tx2"/>
                 </a:solidFill>
               </a:rPr>
-              <a:t>measured, frame for frame</a:t>
+              <a:t>1–9 sends it to that desktop</a:t>
             </a:r>
             <a:endParaRPr lang="en-US" sz="1400" dirty="0"/>
           </a:p>
@@ -8212,7 +8212,7 @@
       </p:sp>
       <p:sp>
         <p:nvSpPr>
-          <p:cNvPr id="15" name="dot-30"/>
+          <p:cNvPr id="16" name="dot-30"/>
           <p:cNvSpPr/>
           <p:nvPr/>
         </p:nvSpPr>
@@ -8232,7 +8232,7 @@
       </p:sp>
       <p:pic>
         <p:nvPicPr>
-          <p:cNvPr id="16" name="icon-31" descr="/tmp/tmp.WjEaqILH74/icons/view-reveal.png">    </p:cNvPr>
+          <p:cNvPr id="17" name="icon-31" descr="/tmp/tmp.wNxcSLvjxS/icons/system-run.png">    </p:cNvPr>
           <p:cNvPicPr>
             <a:picLocks noChangeAspect="1"/>
           </p:cNvPicPr>
@@ -8256,7 +8256,7 @@
       </p:pic>
       <p:sp>
         <p:nvSpPr>
-          <p:cNvPr id="17" name="row-32"/>
+          <p:cNvPr id="18" name="row-32"/>
           <p:cNvSpPr txBox="1"/>
           <p:nvPr/>
         </p:nvSpPr>
@@ -8287,7 +8287,7 @@
                   <a:schemeClr val="tx1"/>
                 </a:solidFill>
               </a:rPr>
-              <a:t>Steady</a:t>
+              <a:t>As fast as GNOME</a:t>
             </a:r>
             <a:endParaRPr lang="en-US" sz="1400" dirty="0"/>
           </a:p>
@@ -8304,7 +8304,7 @@
                   <a:schemeClr val="tx2"/>
                 </a:solidFill>
               </a:rPr>
-              <a:t>same finger travel per window</a:t>
+              <a:t>measured, frame for frame</a:t>
             </a:r>
             <a:endParaRPr lang="en-US" sz="1400" dirty="0"/>
           </a:p>
@@ -8458,7 +8458,7 @@
       </p:sp>
       <p:pic>
         <p:nvPicPr>
-          <p:cNvPr id="5" name="tiled-33" descr="/tmp/tmp.WjEaqILH74/img/tiled.jpg">    </p:cNvPr>
+          <p:cNvPr id="5" name="tiled-33" descr="/tmp/tmp.wNxcSLvjxS/img/tiled.jpg">    </p:cNvPr>
           <p:cNvPicPr>
             <a:picLocks noChangeAspect="1"/>
           </p:cNvPicPr>
@@ -8545,7 +8545,7 @@
       </p:sp>
       <p:pic>
         <p:nvPicPr>
-          <p:cNvPr id="8" name="icon-36" descr="/tmp/tmp.WjEaqILH74/icons/view-dual.png">    </p:cNvPr>
+          <p:cNvPr id="8" name="icon-36" descr="/tmp/tmp.wNxcSLvjxS/icons/view-dual.png">    </p:cNvPr>
           <p:cNvPicPr>
             <a:picLocks noChangeAspect="1"/>
           </p:cNvPicPr>
@@ -8645,7 +8645,7 @@
       </p:sp>
       <p:pic>
         <p:nvPicPr>
-          <p:cNvPr id="11" name="icon-39" descr="/tmp/tmp.WjEaqILH74/icons/window-new.png">    </p:cNvPr>
+          <p:cNvPr id="11" name="icon-39" descr="/tmp/tmp.wNxcSLvjxS/icons/window-new.png">    </p:cNvPr>
           <p:cNvPicPr>
             <a:picLocks noChangeAspect="1"/>
           </p:cNvPicPr>
@@ -8745,7 +8745,7 @@
       </p:sp>
       <p:pic>
         <p:nvPicPr>
-          <p:cNvPr id="14" name="icon-42" descr="/tmp/tmp.WjEaqILH74/icons/view-pin.png">    </p:cNvPr>
+          <p:cNvPr id="14" name="icon-42" descr="/tmp/tmp.wNxcSLvjxS/icons/view-pin.png">    </p:cNvPr>
           <p:cNvPicPr>
             <a:picLocks noChangeAspect="1"/>
           </p:cNvPicPr>
@@ -8845,7 +8845,7 @@
       </p:sp>
       <p:pic>
         <p:nvPicPr>
-          <p:cNvPr id="17" name="icon-45" descr="/tmp/tmp.WjEaqILH74/icons/view-grid.png">    </p:cNvPr>
+          <p:cNvPr id="17" name="icon-45" descr="/tmp/tmp.wNxcSLvjxS/icons/view-grid.png">    </p:cNvPr>
           <p:cNvPicPr>
             <a:picLocks noChangeAspect="1"/>
           </p:cNvPicPr>
@@ -9071,7 +9071,7 @@
       </p:sp>
       <p:pic>
         <p:nvPicPr>
-          <p:cNvPr id="5" name="welcome-47" descr="/tmp/tmp.WjEaqILH74/img/welcome.jpg">    </p:cNvPr>
+          <p:cNvPr id="5" name="welcome-47" descr="/tmp/tmp.wNxcSLvjxS/img/welcome.jpg">    </p:cNvPr>
           <p:cNvPicPr>
             <a:picLocks noChangeAspect="1"/>
           </p:cNvPicPr>
@@ -9158,7 +9158,7 @@
       </p:sp>
       <p:pic>
         <p:nvPicPr>
-          <p:cNvPr id="8" name="icon-50" descr="/tmp/tmp.WjEaqILH74/icons/weather-clear-night.png">    </p:cNvPr>
+          <p:cNvPr id="8" name="icon-50" descr="/tmp/tmp.wNxcSLvjxS/icons/weather-clear-night.png">    </p:cNvPr>
           <p:cNvPicPr>
             <a:picLocks noChangeAspect="1"/>
           </p:cNvPicPr>
@@ -9258,7 +9258,7 @@
       </p:sp>
       <p:pic>
         <p:nvPicPr>
-          <p:cNvPr id="11" name="icon-53" descr="/tmp/tmp.WjEaqILH74/icons/view-pin.png">    </p:cNvPr>
+          <p:cNvPr id="11" name="icon-53" descr="/tmp/tmp.wNxcSLvjxS/icons/view-pin.png">    </p:cNvPr>
           <p:cNvPicPr>
             <a:picLocks noChangeAspect="1"/>
           </p:cNvPicPr>
@@ -9358,7 +9358,7 @@
       </p:sp>
       <p:pic>
         <p:nvPicPr>
-          <p:cNvPr id="14" name="icon-56" descr="/tmp/tmp.WjEaqILH74/icons/face-smile.png">    </p:cNvPr>
+          <p:cNvPr id="14" name="icon-56" descr="/tmp/tmp.wNxcSLvjxS/icons/face-smile.png">    </p:cNvPr>
           <p:cNvPicPr>
             <a:picLocks noChangeAspect="1"/>
           </p:cNvPicPr>
@@ -9413,7 +9413,7 @@
                   <a:schemeClr val="tx1"/>
                 </a:solidFill>
               </a:rPr>
-              <a:t>Your way</a:t>
+              <a:t>Never the same twice</a:t>
             </a:r>
             <a:endParaRPr lang="en-US" sz="1400" dirty="0"/>
           </a:p>
@@ -9430,7 +9430,7 @@
                   <a:schemeClr val="tx2"/>
                 </a:solidFill>
               </a:rPr>
-              <a:t>your name or your own line, spoken if you like</a:t>
+              <a:t>morning, Friday, birthday, or your lines</a:t>
             </a:r>
             <a:endParaRPr lang="en-US" sz="1400" dirty="0"/>
           </a:p>
@@ -9458,7 +9458,7 @@
       </p:sp>
       <p:pic>
         <p:nvPicPr>
-          <p:cNvPr id="17" name="icon-59" descr="/tmp/tmp.WjEaqILH74/icons/preferences-color.png">    </p:cNvPr>
+          <p:cNvPr id="17" name="icon-59" descr="/tmp/tmp.wNxcSLvjxS/icons/preferences-color.png">    </p:cNvPr>
           <p:cNvPicPr>
             <a:picLocks noChangeAspect="1"/>
           </p:cNvPicPr>
@@ -9684,7 +9684,7 @@
       </p:sp>
       <p:pic>
         <p:nvPicPr>
-          <p:cNvPr id="5" name="notes-split-61" descr="/tmp/tmp.WjEaqILH74/img/notes-split.jpg">    </p:cNvPr>
+          <p:cNvPr id="5" name="notes-split-61" descr="/tmp/tmp.wNxcSLvjxS/img/notes-split.jpg">    </p:cNvPr>
           <p:cNvPicPr>
             <a:picLocks noChangeAspect="1"/>
           </p:cNvPicPr>
@@ -9715,7 +9715,7 @@
       </p:pic>
       <p:pic>
         <p:nvPicPr>
-          <p:cNvPr id="6" name="phone" descr="/tmp/tmp.WjEaqILH74/img/phone-note.jpg">    </p:cNvPr>
+          <p:cNvPr id="6" name="phone" descr="/tmp/tmp.wNxcSLvjxS/img/phone-note.jpg">    </p:cNvPr>
           <p:cNvPicPr>
             <a:picLocks noChangeAspect="1"/>
           </p:cNvPicPr>
@@ -9802,7 +9802,7 @@
       </p:sp>
       <p:pic>
         <p:nvPicPr>
-          <p:cNvPr id="9" name="icon-64" descr="/tmp/tmp.WjEaqILH74/icons/x-office-document.png">    </p:cNvPr>
+          <p:cNvPr id="9" name="icon-64" descr="/tmp/tmp.wNxcSLvjxS/icons/x-office-document.png">    </p:cNvPr>
           <p:cNvPicPr>
             <a:picLocks noChangeAspect="1"/>
           </p:cNvPicPr>
@@ -9902,7 +9902,7 @@
       </p:sp>
       <p:pic>
         <p:nvPicPr>
-          <p:cNvPr id="12" name="icon-67" descr="/tmp/tmp.WjEaqILH74/icons/network-workgroup.png">    </p:cNvPr>
+          <p:cNvPr id="12" name="icon-67" descr="/tmp/tmp.wNxcSLvjxS/icons/network-workgroup.png">    </p:cNvPr>
           <p:cNvPicPr>
             <a:picLocks noChangeAspect="1"/>
           </p:cNvPicPr>
@@ -10002,7 +10002,7 @@
       </p:sp>
       <p:pic>
         <p:nvPicPr>
-          <p:cNvPr id="15" name="icon-70" descr="/tmp/tmp.WjEaqILH74/icons/applications-graphics.png">    </p:cNvPr>
+          <p:cNvPr id="15" name="icon-70" descr="/tmp/tmp.wNxcSLvjxS/icons/applications-graphics.png">    </p:cNvPr>
           <p:cNvPicPr>
             <a:picLocks noChangeAspect="1"/>
           </p:cNvPicPr>
@@ -10102,7 +10102,7 @@
       </p:sp>
       <p:pic>
         <p:nvPicPr>
-          <p:cNvPr id="18" name="icon-73" descr="/tmp/tmp.WjEaqILH74/icons/edit-paste.png">    </p:cNvPr>
+          <p:cNvPr id="18" name="icon-73" descr="/tmp/tmp.wNxcSLvjxS/icons/edit-paste.png">    </p:cNvPr>
           <p:cNvPicPr>
             <a:picLocks noChangeAspect="1"/>
           </p:cNvPicPr>
@@ -10370,7 +10370,7 @@
       </p:sp>
       <p:pic>
         <p:nvPicPr>
-          <p:cNvPr id="7" name="icon-77" descr="/tmp/tmp.WjEaqILH74/icons/emblem-system.png">    </p:cNvPr>
+          <p:cNvPr id="7" name="icon-77" descr="/tmp/tmp.wNxcSLvjxS/icons/emblem-system.png">    </p:cNvPr>
           <p:cNvPicPr>
             <a:picLocks noChangeAspect="1"/>
           </p:cNvPicPr>
@@ -10442,7 +10442,7 @@
                   <a:schemeClr val="tx2"/>
                 </a:solidFill>
               </a:rPr>
-              <a:t>browser or Android, offline, over Wi-Fi</a:t>
+              <a:t>browser or Android, offline, encrypted</a:t>
             </a:r>
             <a:endParaRPr lang="en-US" sz="1500" dirty="0"/>
           </a:p>
@@ -10492,7 +10492,7 @@
       </p:sp>
       <p:pic>
         <p:nvPicPr>
-          <p:cNvPr id="11" name="icon-81" descr="/tmp/tmp.WjEaqILH74/icons/x-office-document.png">    </p:cNvPr>
+          <p:cNvPr id="11" name="icon-81" descr="/tmp/tmp.wNxcSLvjxS/icons/x-office-document.png">    </p:cNvPr>
           <p:cNvPicPr>
             <a:picLocks noChangeAspect="1"/>
           </p:cNvPicPr>
@@ -10614,7 +10614,7 @@
       </p:sp>
       <p:pic>
         <p:nvPicPr>
-          <p:cNvPr id="15" name="icon-85" descr="/tmp/tmp.WjEaqILH74/icons/network-workgroup.png">    </p:cNvPr>
+          <p:cNvPr id="15" name="icon-85" descr="/tmp/tmp.wNxcSLvjxS/icons/network-workgroup.png">    </p:cNvPr>
           <p:cNvPicPr>
             <a:picLocks noChangeAspect="1"/>
           </p:cNvPicPr>
@@ -10736,7 +10736,7 @@
       </p:sp>
       <p:pic>
         <p:nvPicPr>
-          <p:cNvPr id="19" name="icon-89" descr="/tmp/tmp.WjEaqILH74/icons/document-open-recent.png">    </p:cNvPr>
+          <p:cNvPr id="19" name="icon-89" descr="/tmp/tmp.wNxcSLvjxS/icons/document-open-recent.png">    </p:cNvPr>
           <p:cNvPicPr>
             <a:picLocks noChangeAspect="1"/>
           </p:cNvPicPr>
@@ -10858,7 +10858,7 @@
       </p:sp>
       <p:pic>
         <p:nvPicPr>
-          <p:cNvPr id="23" name="icon-93" descr="/tmp/tmp.WjEaqILH74/icons/x-office-calendar.png">    </p:cNvPr>
+          <p:cNvPr id="23" name="icon-93" descr="/tmp/tmp.wNxcSLvjxS/icons/x-office-calendar.png">    </p:cNvPr>
           <p:cNvPicPr>
             <a:picLocks noChangeAspect="1"/>
           </p:cNvPicPr>
@@ -10980,7 +10980,7 @@
       </p:sp>
       <p:pic>
         <p:nvPicPr>
-          <p:cNvPr id="27" name="icon-97" descr="/tmp/tmp.WjEaqILH74/icons/checkbox-checked.png">    </p:cNvPr>
+          <p:cNvPr id="27" name="icon-97" descr="/tmp/tmp.wNxcSLvjxS/icons/checkbox-checked.png">    </p:cNvPr>
           <p:cNvPicPr>
             <a:picLocks noChangeAspect="1"/>
           </p:cNvPicPr>
@@ -11102,7 +11102,7 @@
       </p:sp>
       <p:pic>
         <p:nvPicPr>
-          <p:cNvPr id="31" name="icon-101" descr="/tmp/tmp.WjEaqILH74/icons/view-reveal.png">    </p:cNvPr>
+          <p:cNvPr id="31" name="icon-101" descr="/tmp/tmp.wNxcSLvjxS/icons/edit-paste.png">    </p:cNvPr>
           <p:cNvPicPr>
             <a:picLocks noChangeAspect="1"/>
           </p:cNvPicPr>
@@ -11157,7 +11157,7 @@
                   <a:schemeClr val="tx1"/>
                 </a:solidFill>
               </a:rPr>
-              <a:t>Focus mode</a:t>
+              <a:t>Quick capture</a:t>
             </a:r>
             <a:endParaRPr lang="en-US" sz="1500" dirty="0"/>
           </a:p>
@@ -11174,7 +11174,7 @@
                   <a:schemeClr val="tx2"/>
                 </a:solidFill>
               </a:rPr>
-              <a:t>F11: nothing but the words</a:t>
+              <a:t>Super+Ctrl+N from anywhere</a:t>
             </a:r>
             <a:endParaRPr lang="en-US" sz="1500" dirty="0"/>
           </a:p>
@@ -11224,7 +11224,7 @@
       </p:sp>
       <p:pic>
         <p:nvPicPr>
-          <p:cNvPr id="35" name="icon-105" descr="/tmp/tmp.WjEaqILH74/icons/preferences-color.png">    </p:cNvPr>
+          <p:cNvPr id="35" name="icon-105" descr="/tmp/tmp.wNxcSLvjxS/icons/preferences-color.png">    </p:cNvPr>
           <p:cNvPicPr>
             <a:picLocks noChangeAspect="1"/>
           </p:cNvPicPr>
@@ -11404,7 +11404,7 @@
                   <a:schemeClr val="accent1"/>
                 </a:solidFill>
               </a:rPr>
-              <a:t>FOCUS TIMER</a:t>
+              <a:t>STEP AWAY</a:t>
             </a:r>
             <a:endParaRPr lang="en-US" sz="1100" dirty="0"/>
           </a:p>
@@ -11442,7 +11442,7 @@
                   <a:schemeClr val="tx1"/>
                 </a:solidFill>
               </a:rPr>
-              <a:t>Step away. It notices.</a:t>
+              <a:t>Screensavers worth stepping away for</a:t>
             </a:r>
             <a:endParaRPr lang="en-US" sz="3000" dirty="0"/>
           </a:p>
@@ -11450,7 +11450,7 @@
       </p:sp>
       <p:pic>
         <p:nvPicPr>
-          <p:cNvPr id="5" name="saver-bubbles-107" descr="/tmp/tmp.WjEaqILH74/img/saver-bubbles.jpg">    </p:cNvPr>
+          <p:cNvPr id="5" name="scene-web-107" descr="/tmp/tmp.wNxcSLvjxS/img/scene-web.jpg">    </p:cNvPr>
           <p:cNvPicPr>
             <a:picLocks noChangeAspect="1"/>
           </p:cNvPicPr>
@@ -11465,7 +11465,7 @@
         <p:spPr>
           <a:xfrm>
             <a:off x="457200" y="1280160"/>
-            <a:ext cx="4023360" cy="2263140"/>
+            <a:ext cx="2651760" cy="1490472"/>
           </a:xfrm>
           <a:prstGeom prst="rect">
             <a:avLst/>
@@ -11481,7 +11481,7 @@
       </p:pic>
       <p:pic>
         <p:nvPicPr>
-          <p:cNvPr id="6" name="saver-starfield-108" descr="/tmp/tmp.WjEaqILH74/img/saver-starfield.jpg">    </p:cNvPr>
+          <p:cNvPr id="6" name="scene-knight-108" descr="/tmp/tmp.wNxcSLvjxS/img/scene-knight.jpg">    </p:cNvPr>
           <p:cNvPicPr>
             <a:picLocks noChangeAspect="1"/>
           </p:cNvPicPr>
@@ -11495,8 +11495,8 @@
         </p:blipFill>
         <p:spPr>
           <a:xfrm>
-            <a:off x="4663440" y="1280160"/>
-            <a:ext cx="4023360" cy="2263140"/>
+            <a:off x="3246120" y="1280160"/>
+            <a:ext cx="2651760" cy="1490472"/>
           </a:xfrm>
           <a:prstGeom prst="rect">
             <a:avLst/>
@@ -11510,65 +11510,9 @@
           </a:effectLst>
         </p:spPr>
       </p:pic>
-      <p:sp>
-        <p:nvSpPr>
-          <p:cNvPr id="7" name="caption-109"/>
-          <p:cNvSpPr txBox="1"/>
-          <p:nvPr/>
-        </p:nvSpPr>
-        <p:spPr>
-          <a:xfrm>
-            <a:off x="457200" y="3611880"/>
-            <a:ext cx="8229600" cy="274320"/>
-          </a:xfrm>
-          <a:prstGeom prst="rect">
-            <a:avLst/>
-          </a:prstGeom>
-          <a:noFill/>
-          <a:ln/>
-        </p:spPr>
-        <p:txBody>
-          <a:bodyPr wrap="square" lIns="0" tIns="0" rIns="0" bIns="0" rtlCol="0" anchor="ctr"/>
-          <a:lstStyle/>
-          <a:p>
-            <a:pPr indent="0" marL="0">
-              <a:buNone/>
-            </a:pPr>
-            <a:r>
-              <a:rPr lang="en-US" sz="1000" i="1" dirty="0">
-                <a:solidFill>
-                  <a:schemeClr val="tx2"/>
-                </a:solidFill>
-              </a:rPr>
-              <a:t>Bubbles or a starfield over your work; any touch and you're back</a:t>
-            </a:r>
-            <a:endParaRPr lang="en-US" sz="1000" dirty="0"/>
-          </a:p>
-        </p:txBody>
-      </p:sp>
-      <p:sp>
-        <p:nvSpPr>
-          <p:cNvPr id="8" name="dot-110"/>
-          <p:cNvSpPr/>
-          <p:nvPr/>
-        </p:nvSpPr>
-        <p:spPr>
-          <a:xfrm>
-            <a:off x="457200" y="3995928"/>
-            <a:ext cx="384048" cy="384048"/>
-          </a:xfrm>
-          <a:prstGeom prst="ellipse">
-            <a:avLst/>
-          </a:prstGeom>
-          <a:solidFill>
-            <a:schemeClr val="accent1"/>
-          </a:solidFill>
-          <a:ln/>
-        </p:spPr>
-      </p:sp>
       <p:pic>
         <p:nvPicPr>
-          <p:cNvPr id="9" name="icon-111" descr="/tmp/tmp.WjEaqILH74/icons/alarm.png">    </p:cNvPr>
+          <p:cNvPr id="7" name="scene-matrix-109" descr="/tmp/tmp.wNxcSLvjxS/img/scene-matrix.jpg">    </p:cNvPr>
           <p:cNvPicPr>
             <a:picLocks noChangeAspect="1"/>
           </p:cNvPicPr>
@@ -11582,79 +11526,66 @@
         </p:blipFill>
         <p:spPr>
           <a:xfrm>
-            <a:off x="548640" y="4087368"/>
-            <a:ext cx="201168" cy="201168"/>
-          </a:xfrm>
-          <a:prstGeom prst="rect">
-            <a:avLst/>
-          </a:prstGeom>
+            <a:off x="6035040" y="1280160"/>
+            <a:ext cx="2651760" cy="1490472"/>
+          </a:xfrm>
+          <a:prstGeom prst="rect">
+            <a:avLst/>
+          </a:prstGeom>
+          <a:effectLst>
+            <a:outerShdw sx="100000" sy="100000" kx="0" ky="0" algn="bl" rotWithShape="0" blurRad="127000" dist="38100" dir="5400000">
+              <a:srgbClr val="0B1430">
+                <a:alpha val="18000"/>
+              </a:srgbClr>
+            </a:outerShdw>
+          </a:effectLst>
         </p:spPr>
       </p:pic>
       <p:sp>
         <p:nvSpPr>
-          <p:cNvPr id="10" name="row-112"/>
+          <p:cNvPr id="8" name="caption-110"/>
           <p:cNvSpPr txBox="1"/>
           <p:nvPr/>
         </p:nvSpPr>
         <p:spPr>
           <a:xfrm>
-            <a:off x="960120" y="3941064"/>
-            <a:ext cx="3520440" cy="566928"/>
-          </a:xfrm>
-          <a:prstGeom prst="rect">
-            <a:avLst/>
-          </a:prstGeom>
-          <a:noFill/>
-          <a:ln/>
-        </p:spPr>
-        <p:txBody>
-          <a:bodyPr wrap="square" lIns="0" tIns="0" rIns="0" bIns="0" rtlCol="0" anchor="t"/>
-          <a:lstStyle/>
-          <a:p>
-            <a:pPr indent="0" marL="0">
-              <a:spcAft>
-                <a:spcPts val="100"/>
-              </a:spcAft>
-              <a:buNone/>
-            </a:pPr>
-            <a:r>
-              <a:rPr lang="en-US" sz="1400" b="1" dirty="0">
-                <a:solidFill>
-                  <a:schemeClr val="tx1"/>
-                </a:solidFill>
-              </a:rPr>
-              <a:t>Counts down in the top bar</a:t>
-            </a:r>
-            <a:endParaRPr lang="en-US" sz="1400" dirty="0"/>
-          </a:p>
-          <a:p>
-            <a:pPr indent="0" marL="0">
-              <a:spcAft>
-                <a:spcPts val="100"/>
-              </a:spcAft>
-              <a:buNone/>
-            </a:pPr>
-            <a:r>
-              <a:rPr lang="en-US" sz="1400" dirty="0">
+            <a:off x="457200" y="2852928"/>
+            <a:ext cx="8229600" cy="274320"/>
+          </a:xfrm>
+          <a:prstGeom prst="rect">
+            <a:avLst/>
+          </a:prstGeom>
+          <a:noFill/>
+          <a:ln/>
+        </p:spPr>
+        <p:txBody>
+          <a:bodyPr wrap="square" lIns="0" tIns="0" rIns="0" bIns="0" rtlCol="0" anchor="ctr"/>
+          <a:lstStyle/>
+          <a:p>
+            <a:pPr indent="0" marL="0">
+              <a:buNone/>
+            </a:pPr>
+            <a:r>
+              <a:rPr lang="en-US" sz="1000" i="1" dirty="0">
                 <a:solidFill>
                   <a:schemeClr val="tx2"/>
                 </a:solidFill>
               </a:rPr>
-              <a:t>the window gets out of your way</a:t>
-            </a:r>
-            <a:endParaRPr lang="en-US" sz="1400" dirty="0"/>
-          </a:p>
-        </p:txBody>
-      </p:sp>
-      <p:sp>
-        <p:nvSpPr>
-          <p:cNvPr id="11" name="dot-113"/>
+              <a:t>Web Hang · Night Watch · Neon Cascade</a:t>
+            </a:r>
+            <a:endParaRPr lang="en-US" sz="1000" dirty="0"/>
+          </a:p>
+        </p:txBody>
+      </p:sp>
+      <p:sp>
+        <p:nvSpPr>
+          <p:cNvPr id="9" name="dot-111"/>
           <p:cNvSpPr/>
           <p:nvPr/>
         </p:nvSpPr>
         <p:spPr>
           <a:xfrm>
-            <a:off x="4663440" y="3995928"/>
+            <a:off x="457200" y="3310128"/>
             <a:ext cx="384048" cy="384048"/>
           </a:xfrm>
           <a:prstGeom prst="ellipse">
@@ -11668,7 +11599,7 @@
       </p:sp>
       <p:pic>
         <p:nvPicPr>
-          <p:cNvPr id="12" name="icon-114" descr="/tmp/tmp.WjEaqILH74/icons/face-smile.png">    </p:cNvPr>
+          <p:cNvPr id="10" name="icon-112" descr="/tmp/tmp.wNxcSLvjxS/icons/weather-clear-night.png">    </p:cNvPr>
           <p:cNvPicPr>
             <a:picLocks noChangeAspect="1"/>
           </p:cNvPicPr>
@@ -11682,7 +11613,7 @@
         </p:blipFill>
         <p:spPr>
           <a:xfrm>
-            <a:off x="4754880" y="4087368"/>
+            <a:off x="548640" y="3401568"/>
             <a:ext cx="201168" cy="201168"/>
           </a:xfrm>
           <a:prstGeom prst="rect">
@@ -11692,13 +11623,13 @@
       </p:pic>
       <p:sp>
         <p:nvSpPr>
-          <p:cNvPr id="13" name="row-115"/>
+          <p:cNvPr id="11" name="row-113"/>
           <p:cNvSpPr txBox="1"/>
           <p:nvPr/>
         </p:nvSpPr>
         <p:spPr>
           <a:xfrm>
-            <a:off x="5166360" y="3941064"/>
+            <a:off x="960120" y="3255264"/>
             <a:ext cx="3520440" cy="566928"/>
           </a:xfrm>
           <a:prstGeom prst="rect">
@@ -11723,7 +11654,7 @@
                   <a:schemeClr val="tx1"/>
                 </a:solidFill>
               </a:rPr>
-              <a:t>A celebration, not an alarm</a:t>
+              <a:t>When you step away</a:t>
             </a:r>
             <a:endParaRPr lang="en-US" sz="1400" dirty="0"/>
           </a:p>
@@ -11740,7 +11671,307 @@
                   <a:schemeClr val="tx2"/>
                 </a:solidFill>
               </a:rPr>
-              <a:t>a little party when time's up</a:t>
+              <a:t>after a few idle minutes; any touch ends it</a:t>
+            </a:r>
+            <a:endParaRPr lang="en-US" sz="1400" dirty="0"/>
+          </a:p>
+        </p:txBody>
+      </p:sp>
+      <p:sp>
+        <p:nvSpPr>
+          <p:cNvPr id="12" name="dot-114"/>
+          <p:cNvSpPr/>
+          <p:nvPr/>
+        </p:nvSpPr>
+        <p:spPr>
+          <a:xfrm>
+            <a:off x="4663440" y="3310128"/>
+            <a:ext cx="384048" cy="384048"/>
+          </a:xfrm>
+          <a:prstGeom prst="ellipse">
+            <a:avLst/>
+          </a:prstGeom>
+          <a:solidFill>
+            <a:schemeClr val="accent1"/>
+          </a:solidFill>
+          <a:ln/>
+        </p:spPr>
+      </p:sp>
+      <p:pic>
+        <p:nvPicPr>
+          <p:cNvPr id="13" name="icon-115" descr="/tmp/tmp.wNxcSLvjxS/icons/video-display.png">    </p:cNvPr>
+          <p:cNvPicPr>
+            <a:picLocks noChangeAspect="1"/>
+          </p:cNvPicPr>
+          <p:nvPr/>
+        </p:nvPicPr>
+        <p:blipFill>
+          <a:blip r:embed="rId5"/>
+          <a:stretch>
+            <a:fillRect/>
+          </a:stretch>
+        </p:blipFill>
+        <p:spPr>
+          <a:xfrm>
+            <a:off x="4754880" y="3401568"/>
+            <a:ext cx="201168" cy="201168"/>
+          </a:xfrm>
+          <a:prstGeom prst="rect">
+            <a:avLst/>
+          </a:prstGeom>
+        </p:spPr>
+      </p:pic>
+      <p:sp>
+        <p:nvSpPr>
+          <p:cNvPr id="14" name="row-116"/>
+          <p:cNvSpPr txBox="1"/>
+          <p:nvPr/>
+        </p:nvSpPr>
+        <p:spPr>
+          <a:xfrm>
+            <a:off x="5166360" y="3255264"/>
+            <a:ext cx="3520440" cy="566928"/>
+          </a:xfrm>
+          <a:prstGeom prst="rect">
+            <a:avLst/>
+          </a:prstGeom>
+          <a:noFill/>
+          <a:ln/>
+        </p:spPr>
+        <p:txBody>
+          <a:bodyPr wrap="square" lIns="0" tIns="0" rIns="0" bIns="0" rtlCol="0" anchor="t"/>
+          <a:lstStyle/>
+          <a:p>
+            <a:pPr indent="0" marL="0">
+              <a:spcAft>
+                <a:spcPts val="100"/>
+              </a:spcAft>
+              <a:buNone/>
+            </a:pPr>
+            <a:r>
+              <a:rPr lang="en-US" sz="1400" b="1" dirty="0">
+                <a:solidFill>
+                  <a:schemeClr val="tx1"/>
+                </a:solidFill>
+              </a:rPr>
+              <a:t>Never over a film</a:t>
+            </a:r>
+            <a:endParaRPr lang="en-US" sz="1400" dirty="0"/>
+          </a:p>
+          <a:p>
+            <a:pPr indent="0" marL="0">
+              <a:spcAft>
+                <a:spcPts val="100"/>
+              </a:spcAft>
+              <a:buNone/>
+            </a:pPr>
+            <a:r>
+              <a:rPr lang="en-US" sz="1400" dirty="0">
+                <a:solidFill>
+                  <a:schemeClr val="tx2"/>
+                </a:solidFill>
+              </a:rPr>
+              <a:t>videos and calls keep it away</a:t>
+            </a:r>
+            <a:endParaRPr lang="en-US" sz="1400" dirty="0"/>
+          </a:p>
+        </p:txBody>
+      </p:sp>
+      <p:sp>
+        <p:nvSpPr>
+          <p:cNvPr id="15" name="dot-117"/>
+          <p:cNvSpPr/>
+          <p:nvPr/>
+        </p:nvSpPr>
+        <p:spPr>
+          <a:xfrm>
+            <a:off x="457200" y="3995928"/>
+            <a:ext cx="384048" cy="384048"/>
+          </a:xfrm>
+          <a:prstGeom prst="ellipse">
+            <a:avLst/>
+          </a:prstGeom>
+          <a:solidFill>
+            <a:schemeClr val="accent1"/>
+          </a:solidFill>
+          <a:ln/>
+        </p:spPr>
+      </p:sp>
+      <p:pic>
+        <p:nvPicPr>
+          <p:cNvPr id="16" name="icon-118" descr="/tmp/tmp.wNxcSLvjxS/icons/alarm.png">    </p:cNvPr>
+          <p:cNvPicPr>
+            <a:picLocks noChangeAspect="1"/>
+          </p:cNvPicPr>
+          <p:nvPr/>
+        </p:nvPicPr>
+        <p:blipFill>
+          <a:blip r:embed="rId6"/>
+          <a:stretch>
+            <a:fillRect/>
+          </a:stretch>
+        </p:blipFill>
+        <p:spPr>
+          <a:xfrm>
+            <a:off x="548640" y="4087368"/>
+            <a:ext cx="201168" cy="201168"/>
+          </a:xfrm>
+          <a:prstGeom prst="rect">
+            <a:avLst/>
+          </a:prstGeom>
+        </p:spPr>
+      </p:pic>
+      <p:sp>
+        <p:nvSpPr>
+          <p:cNvPr id="17" name="row-119"/>
+          <p:cNvSpPr txBox="1"/>
+          <p:nvPr/>
+        </p:nvSpPr>
+        <p:spPr>
+          <a:xfrm>
+            <a:off x="960120" y="3941064"/>
+            <a:ext cx="3520440" cy="566928"/>
+          </a:xfrm>
+          <a:prstGeom prst="rect">
+            <a:avLst/>
+          </a:prstGeom>
+          <a:noFill/>
+          <a:ln/>
+        </p:spPr>
+        <p:txBody>
+          <a:bodyPr wrap="square" lIns="0" tIns="0" rIns="0" bIns="0" rtlCol="0" anchor="t"/>
+          <a:lstStyle/>
+          <a:p>
+            <a:pPr indent="0" marL="0">
+              <a:spcAft>
+                <a:spcPts val="100"/>
+              </a:spcAft>
+              <a:buNone/>
+            </a:pPr>
+            <a:r>
+              <a:rPr lang="en-US" sz="1400" b="1" dirty="0">
+                <a:solidFill>
+                  <a:schemeClr val="tx1"/>
+                </a:solidFill>
+              </a:rPr>
+              <a:t>Focus timer</a:t>
+            </a:r>
+            <a:endParaRPr lang="en-US" sz="1400" dirty="0"/>
+          </a:p>
+          <a:p>
+            <a:pPr indent="0" marL="0">
+              <a:spcAft>
+                <a:spcPts val="100"/>
+              </a:spcAft>
+              <a:buNone/>
+            </a:pPr>
+            <a:r>
+              <a:rPr lang="en-US" sz="1400" dirty="0">
+                <a:solidFill>
+                  <a:schemeClr val="tx2"/>
+                </a:solidFill>
+              </a:rPr>
+              <a:t>countdown in the top bar, then a little party</a:t>
+            </a:r>
+            <a:endParaRPr lang="en-US" sz="1400" dirty="0"/>
+          </a:p>
+        </p:txBody>
+      </p:sp>
+      <p:sp>
+        <p:nvSpPr>
+          <p:cNvPr id="18" name="dot-120"/>
+          <p:cNvSpPr/>
+          <p:nvPr/>
+        </p:nvSpPr>
+        <p:spPr>
+          <a:xfrm>
+            <a:off x="4663440" y="3995928"/>
+            <a:ext cx="384048" cy="384048"/>
+          </a:xfrm>
+          <a:prstGeom prst="ellipse">
+            <a:avLst/>
+          </a:prstGeom>
+          <a:solidFill>
+            <a:schemeClr val="accent1"/>
+          </a:solidFill>
+          <a:ln/>
+        </p:spPr>
+      </p:sp>
+      <p:pic>
+        <p:nvPicPr>
+          <p:cNvPr id="19" name="icon-121" descr="/tmp/tmp.wNxcSLvjxS/icons/system-run.png">    </p:cNvPr>
+          <p:cNvPicPr>
+            <a:picLocks noChangeAspect="1"/>
+          </p:cNvPicPr>
+          <p:nvPr/>
+        </p:nvPicPr>
+        <p:blipFill>
+          <a:blip r:embed="rId7"/>
+          <a:stretch>
+            <a:fillRect/>
+          </a:stretch>
+        </p:blipFill>
+        <p:spPr>
+          <a:xfrm>
+            <a:off x="4754880" y="4087368"/>
+            <a:ext cx="201168" cy="201168"/>
+          </a:xfrm>
+          <a:prstGeom prst="rect">
+            <a:avLst/>
+          </a:prstGeom>
+        </p:spPr>
+      </p:pic>
+      <p:sp>
+        <p:nvSpPr>
+          <p:cNvPr id="20" name="row-122"/>
+          <p:cNvSpPr txBox="1"/>
+          <p:nvPr/>
+        </p:nvSpPr>
+        <p:spPr>
+          <a:xfrm>
+            <a:off x="5166360" y="3941064"/>
+            <a:ext cx="3520440" cy="566928"/>
+          </a:xfrm>
+          <a:prstGeom prst="rect">
+            <a:avLst/>
+          </a:prstGeom>
+          <a:noFill/>
+          <a:ln/>
+        </p:spPr>
+        <p:txBody>
+          <a:bodyPr wrap="square" lIns="0" tIns="0" rIns="0" bIns="0" rtlCol="0" anchor="t"/>
+          <a:lstStyle/>
+          <a:p>
+            <a:pPr indent="0" marL="0">
+              <a:spcAft>
+                <a:spcPts val="100"/>
+              </a:spcAft>
+              <a:buNone/>
+            </a:pPr>
+            <a:r>
+              <a:rPr lang="en-US" sz="1400" b="1" dirty="0">
+                <a:solidFill>
+                  <a:schemeClr val="tx1"/>
+                </a:solidFill>
+              </a:rPr>
+              <a:t>Light on the machine</a:t>
+            </a:r>
+            <a:endParaRPr lang="en-US" sz="1400" dirty="0"/>
+          </a:p>
+          <a:p>
+            <a:pPr indent="0" marL="0">
+              <a:spcAft>
+                <a:spcPts val="100"/>
+              </a:spcAft>
+              <a:buNone/>
+            </a:pPr>
+            <a:r>
+              <a:rPr lang="en-US" sz="1400" dirty="0">
+                <a:solidFill>
+                  <a:schemeClr val="tx2"/>
+                </a:solidFill>
+              </a:rPr>
+              <a:t>30 fps, still parts drawn once</a:t>
             </a:r>
             <a:endParaRPr lang="en-US" sz="1400" dirty="0"/>
           </a:p>
@@ -11894,7 +12125,7 @@
       </p:sp>
       <p:pic>
         <p:nvPicPr>
-          <p:cNvPr id="5" name="monitor" descr="/tmp/tmp.WjEaqILH74/img/monitor.jpg">    </p:cNvPr>
+          <p:cNvPr id="5" name="monitor" descr="/tmp/tmp.wNxcSLvjxS/img/speedtest.jpg">    </p:cNvPr>
           <p:cNvPicPr>
             <a:picLocks noChangeAspect="1"/>
           </p:cNvPicPr>
@@ -11909,7 +12140,7 @@
         <p:spPr>
           <a:xfrm>
             <a:off x="457200" y="1280160"/>
-            <a:ext cx="2651760" cy="2377440"/>
+            <a:ext cx="1700784" cy="2926080"/>
           </a:xfrm>
           <a:prstGeom prst="rect">
             <a:avLst/>
@@ -11925,7 +12156,7 @@
       </p:pic>
       <p:pic>
         <p:nvPicPr>
-          <p:cNvPr id="6" name="quick" descr="/tmp/tmp.WjEaqILH74/img/quick.jpg">    </p:cNvPr>
+          <p:cNvPr id="6" name="media" descr="/tmp/tmp.wNxcSLvjxS/img/media.jpg">    </p:cNvPr>
           <p:cNvPicPr>
             <a:picLocks noChangeAspect="1"/>
           </p:cNvPicPr>
@@ -11939,8 +12170,8 @@
         </p:blipFill>
         <p:spPr>
           <a:xfrm>
-            <a:off x="3291840" y="1280160"/>
-            <a:ext cx="2075688" cy="2377440"/>
+            <a:off x="2331720" y="1280160"/>
+            <a:ext cx="2221992" cy="2926080"/>
           </a:xfrm>
           <a:prstGeom prst="rect">
             <a:avLst/>
@@ -11956,14 +12187,14 @@
       </p:pic>
       <p:sp>
         <p:nvSpPr>
-          <p:cNvPr id="7" name="caption-116"/>
+          <p:cNvPr id="7" name="caption-123"/>
           <p:cNvSpPr txBox="1"/>
           <p:nvPr/>
         </p:nvSpPr>
         <p:spPr>
           <a:xfrm>
-            <a:off x="457200" y="3749040"/>
-            <a:ext cx="4937760" cy="274320"/>
+            <a:off x="457200" y="4297680"/>
+            <a:ext cx="4114800" cy="274320"/>
           </a:xfrm>
           <a:prstGeom prst="rect">
             <a:avLst/>
@@ -11984,7 +12215,7 @@
                   <a:schemeClr val="tx2"/>
                 </a:solidFill>
               </a:rPr>
-              <a:t>System monitor and Quick Settings</a:t>
+              <a:t>Speed test and your music</a:t>
             </a:r>
             <a:endParaRPr lang="en-US" sz="1000" dirty="0"/>
           </a:p>
@@ -11992,13 +12223,13 @@
       </p:sp>
       <p:sp>
         <p:nvSpPr>
-          <p:cNvPr id="8" name="dot-117"/>
+          <p:cNvPr id="8" name="dot-124"/>
           <p:cNvSpPr/>
           <p:nvPr/>
         </p:nvSpPr>
         <p:spPr>
           <a:xfrm>
-            <a:off x="5669280" y="1344168"/>
+            <a:off x="4937760" y="1344168"/>
             <a:ext cx="384048" cy="384048"/>
           </a:xfrm>
           <a:prstGeom prst="ellipse">
@@ -12012,7 +12243,7 @@
       </p:sp>
       <p:pic>
         <p:nvPicPr>
-          <p:cNvPr id="9" name="icon-118" descr="/tmp/tmp.WjEaqILH74/icons/video-display.png">    </p:cNvPr>
+          <p:cNvPr id="9" name="icon-125" descr="/tmp/tmp.wNxcSLvjxS/icons/video-display.png">    </p:cNvPr>
           <p:cNvPicPr>
             <a:picLocks noChangeAspect="1"/>
           </p:cNvPicPr>
@@ -12026,7 +12257,7 @@
         </p:blipFill>
         <p:spPr>
           <a:xfrm>
-            <a:off x="5760720" y="1435608"/>
+            <a:off x="5029200" y="1435608"/>
             <a:ext cx="201168" cy="201168"/>
           </a:xfrm>
           <a:prstGeom prst="rect">
@@ -12036,14 +12267,14 @@
       </p:pic>
       <p:sp>
         <p:nvSpPr>
-          <p:cNvPr id="10" name="row-119"/>
+          <p:cNvPr id="10" name="row-126"/>
           <p:cNvSpPr txBox="1"/>
           <p:nvPr/>
         </p:nvSpPr>
         <p:spPr>
           <a:xfrm>
-            <a:off x="6172200" y="1289304"/>
-            <a:ext cx="2514600" cy="566928"/>
+            <a:off x="5440680" y="1289304"/>
+            <a:ext cx="3246120" cy="566928"/>
           </a:xfrm>
           <a:prstGeom prst="rect">
             <a:avLst/>
@@ -12084,7 +12315,7 @@
                   <a:schemeClr val="tx2"/>
                 </a:solidFill>
               </a:rPr>
-              <a:t>CPU, memory, temperatures, battery draw</a:t>
+              <a:t>CPU, memory, temperatures, battery</a:t>
             </a:r>
             <a:endParaRPr lang="en-US" sz="1400" dirty="0"/>
           </a:p>
@@ -12092,13 +12323,13 @@
       </p:sp>
       <p:sp>
         <p:nvSpPr>
-          <p:cNvPr id="11" name="dot-120"/>
+          <p:cNvPr id="11" name="dot-127"/>
           <p:cNvSpPr/>
           <p:nvPr/>
         </p:nvSpPr>
         <p:spPr>
           <a:xfrm>
-            <a:off x="5669280" y="2121408"/>
+            <a:off x="4937760" y="2121408"/>
             <a:ext cx="384048" cy="384048"/>
           </a:xfrm>
           <a:prstGeom prst="ellipse">
@@ -12112,7 +12343,7 @@
       </p:sp>
       <p:pic>
         <p:nvPicPr>
-          <p:cNvPr id="12" name="icon-121" descr="/tmp/tmp.WjEaqILH74/icons/edit-paste.png">    </p:cNvPr>
+          <p:cNvPr id="12" name="icon-128" descr="/tmp/tmp.wNxcSLvjxS/icons/network-workgroup.png">    </p:cNvPr>
           <p:cNvPicPr>
             <a:picLocks noChangeAspect="1"/>
           </p:cNvPicPr>
@@ -12126,7 +12357,7 @@
         </p:blipFill>
         <p:spPr>
           <a:xfrm>
-            <a:off x="5760720" y="2212848"/>
+            <a:off x="5029200" y="2212848"/>
             <a:ext cx="201168" cy="201168"/>
           </a:xfrm>
           <a:prstGeom prst="rect">
@@ -12136,14 +12367,14 @@
       </p:pic>
       <p:sp>
         <p:nvSpPr>
-          <p:cNvPr id="13" name="row-122"/>
+          <p:cNvPr id="13" name="row-129"/>
           <p:cNvSpPr txBox="1"/>
           <p:nvPr/>
         </p:nvSpPr>
         <p:spPr>
           <a:xfrm>
-            <a:off x="6172200" y="2066544"/>
-            <a:ext cx="2514600" cy="566928"/>
+            <a:off x="5440680" y="2066544"/>
+            <a:ext cx="3246120" cy="566928"/>
           </a:xfrm>
           <a:prstGeom prst="rect">
             <a:avLst/>
@@ -12167,7 +12398,7 @@
                   <a:schemeClr val="tx1"/>
                 </a:solidFill>
               </a:rPr>
-              <a:t>Clipboard history</a:t>
+              <a:t>Speed test</a:t>
             </a:r>
             <a:endParaRPr lang="en-US" sz="1400" dirty="0"/>
           </a:p>
@@ -12184,7 +12415,7 @@
                   <a:schemeClr val="tx2"/>
                 </a:solidFill>
               </a:rPr>
-              <a:t>Super+V brings back what you copied</a:t>
+              <a:t>ping, download, upload on a gauge</a:t>
             </a:r>
             <a:endParaRPr lang="en-US" sz="1400" dirty="0"/>
           </a:p>
@@ -12192,13 +12423,13 @@
       </p:sp>
       <p:sp>
         <p:nvSpPr>
-          <p:cNvPr id="14" name="dot-123"/>
+          <p:cNvPr id="14" name="dot-130"/>
           <p:cNvSpPr/>
           <p:nvPr/>
         </p:nvSpPr>
         <p:spPr>
           <a:xfrm>
-            <a:off x="5669280" y="2898648"/>
+            <a:off x="4937760" y="2898648"/>
             <a:ext cx="384048" cy="384048"/>
           </a:xfrm>
           <a:prstGeom prst="ellipse">
@@ -12212,7 +12443,7 @@
       </p:sp>
       <p:pic>
         <p:nvPicPr>
-          <p:cNvPr id="15" name="icon-124" descr="/tmp/tmp.WjEaqILH74/icons/weather-clear-night.png">    </p:cNvPr>
+          <p:cNvPr id="15" name="icon-131" descr="/tmp/tmp.wNxcSLvjxS/icons/audio-speakers.png">    </p:cNvPr>
           <p:cNvPicPr>
             <a:picLocks noChangeAspect="1"/>
           </p:cNvPicPr>
@@ -12226,7 +12457,7 @@
         </p:blipFill>
         <p:spPr>
           <a:xfrm>
-            <a:off x="5760720" y="2990088"/>
+            <a:off x="5029200" y="2990088"/>
             <a:ext cx="201168" cy="201168"/>
           </a:xfrm>
           <a:prstGeom prst="rect">
@@ -12236,14 +12467,14 @@
       </p:pic>
       <p:sp>
         <p:nvSpPr>
-          <p:cNvPr id="16" name="row-125"/>
+          <p:cNvPr id="16" name="row-132"/>
           <p:cNvSpPr txBox="1"/>
           <p:nvPr/>
         </p:nvSpPr>
         <p:spPr>
           <a:xfrm>
-            <a:off x="6172200" y="2843784"/>
-            <a:ext cx="2514600" cy="566928"/>
+            <a:off x="5440680" y="2843784"/>
+            <a:ext cx="3246120" cy="566928"/>
           </a:xfrm>
           <a:prstGeom prst="rect">
             <a:avLst/>
@@ -12267,7 +12498,7 @@
                   <a:schemeClr val="tx1"/>
                 </a:solidFill>
               </a:rPr>
-              <a:t>Keep awake</a:t>
+              <a:t>Your music</a:t>
             </a:r>
             <a:endParaRPr lang="en-US" sz="1400" dirty="0"/>
           </a:p>
@@ -12284,7 +12515,7 @@
                   <a:schemeClr val="tx2"/>
                 </a:solidFill>
               </a:rPr>
-              <a:t>one switch for films and downloads</a:t>
+              <a:t>art, seek, skip, choose speakers</a:t>
             </a:r>
             <a:endParaRPr lang="en-US" sz="1400" dirty="0"/>
           </a:p>
@@ -12292,13 +12523,13 @@
       </p:sp>
       <p:sp>
         <p:nvSpPr>
-          <p:cNvPr id="17" name="dot-126"/>
+          <p:cNvPr id="17" name="dot-133"/>
           <p:cNvSpPr/>
           <p:nvPr/>
         </p:nvSpPr>
         <p:spPr>
           <a:xfrm>
-            <a:off x="5669280" y="3675888"/>
+            <a:off x="4937760" y="3675888"/>
             <a:ext cx="384048" cy="384048"/>
           </a:xfrm>
           <a:prstGeom prst="ellipse">
@@ -12312,7 +12543,7 @@
       </p:sp>
       <p:pic>
         <p:nvPicPr>
-          <p:cNvPr id="18" name="icon-127" descr="/tmp/tmp.WjEaqILH74/icons/view-grid.png">    </p:cNvPr>
+          <p:cNvPr id="18" name="icon-134" descr="/tmp/tmp.wNxcSLvjxS/icons/edit-paste.png">    </p:cNvPr>
           <p:cNvPicPr>
             <a:picLocks noChangeAspect="1"/>
           </p:cNvPicPr>
@@ -12326,7 +12557,7 @@
         </p:blipFill>
         <p:spPr>
           <a:xfrm>
-            <a:off x="5760720" y="3767328"/>
+            <a:off x="5029200" y="3767328"/>
             <a:ext cx="201168" cy="201168"/>
           </a:xfrm>
           <a:prstGeom prst="rect">
@@ -12336,14 +12567,14 @@
       </p:pic>
       <p:sp>
         <p:nvSpPr>
-          <p:cNvPr id="19" name="row-128"/>
+          <p:cNvPr id="19" name="row-135"/>
           <p:cNvSpPr txBox="1"/>
           <p:nvPr/>
         </p:nvSpPr>
         <p:spPr>
           <a:xfrm>
-            <a:off x="6172200" y="3621024"/>
-            <a:ext cx="2514600" cy="566928"/>
+            <a:off x="5440680" y="3621024"/>
+            <a:ext cx="3246120" cy="566928"/>
           </a:xfrm>
           <a:prstGeom prst="rect">
             <a:avLst/>
@@ -12367,7 +12598,7 @@
                   <a:schemeClr val="tx1"/>
                 </a:solidFill>
               </a:rPr>
-              <a:t>Tray icons</a:t>
+              <a:t>Clipboard history</a:t>
             </a:r>
             <a:endParaRPr lang="en-US" sz="1400" dirty="0"/>
           </a:p>
@@ -12384,7 +12615,7 @@
                   <a:schemeClr val="tx2"/>
                 </a:solidFill>
               </a:rPr>
-              <a:t>chat apps and launchers, like anywhere</a:t>
+              <a:t>Super+V brings back what you copied</a:t>
             </a:r>
             <a:endParaRPr lang="en-US" sz="1400" dirty="0"/>
           </a:p>

</xml_diff>

<commit_message>
docs(overview): compact switcher screenshot and captions; PDF and deck rebuilt
Co-Authored-By: Claude Opus 5.5 <noreply@anthropic.com>
</commit_message>
<xml_diff>
--- a/docs/MK-Workstation-Overview.pptx
+++ b/docs/MK-Workstation-Overview.pptx
@@ -120,40 +120,40 @@
   <p:extLst>
     <p:ext uri="{521415D9-36F7-43E2-AB2F-B90AF26B5E84}">
       <p14:sectionLst xmlns:p14="http://schemas.microsoft.com/office/powerpoint/2010/main">
-        <p14:section name="Introduction" id="{52ca5413-2dfa-cd5d-0c8d-be92f910ac46}">
+        <p14:section name="Introduction" id="{0e785fd8-a218-bc84-3c7f-b8960e6268c3}">
           <p14:sldIdLst>
             <p14:sldId id="256"/>
             <p14:sldId id="257"/>
           </p14:sldIdLst>
         </p14:section>
-        <p14:section name="Your desktop" id="{b9d78052-1eba-bb09-cbc2-8e5c85570add}">
+        <p14:section name="Your desktop" id="{64e087b9-0ba3-d9a9-f126-d05f2e85b626}">
           <p14:sldIdLst>
             <p14:sldId id="258"/>
             <p14:sldId id="259"/>
             <p14:sldId id="260"/>
           </p14:sldIdLst>
         </p14:section>
-        <p14:section name="MK Notes" id="{2faceb9c-f1d5-105a-b6c1-740a7cfdb75c}">
+        <p14:section name="MK Notes" id="{4a620948-6559-fde8-b871-d4cf9ca56c53}">
           <p14:sldIdLst>
             <p14:sldId id="261"/>
             <p14:sldId id="262"/>
           </p14:sldIdLst>
         </p14:section>
-        <p14:section name="Focus and tools" id="{5512acea-d797-bb8f-3a1c-d2ff3ac58596}">
+        <p14:section name="Focus and tools" id="{0df5ba72-46e3-c6f1-f057-9cc25475db10}">
           <p14:sldIdLst>
             <p14:sldId id="263"/>
             <p14:sldId id="264"/>
             <p14:sldId id="265"/>
           </p14:sldIdLst>
         </p14:section>
-        <p14:section name="Your computer" id="{0ec44a41-7137-7d40-99a0-a5c9dea5f3c2}">
+        <p14:section name="Your computer" id="{c1d451d3-7d32-a4ba-e141-3794b0a438da}">
           <p14:sldIdLst>
             <p14:sldId id="266"/>
             <p14:sldId id="267"/>
             <p14:sldId id="268"/>
           </p14:sldIdLst>
         </p14:section>
-        <p14:section name="Get started" id="{862fe0b0-1f02-c420-9703-53223861fae4}">
+        <p14:section name="Get started" id="{0bbf6386-643a-cda9-8a0e-a543024079d6}">
           <p14:sldIdLst>
             <p14:sldId id="269"/>
           </p14:sldIdLst>
@@ -1178,7 +1178,7 @@
           <a:p>
             <a:r>
               <a:rPr lang="en-US" dirty="0"/>
-              <a:t>Alt+Tab and the three-finger swipe open a frosted grid of live windows. Each window takes the same finger travel, the mouse works too, and 1 to 9 sends the selected window to that desktop.Alt+Tab and the three-finger swipe show one switcher with a ring that follows your fingers. Each window takes the same finger travel however many are open, so fast swipes land where you expect.</a:t>
+              <a:t>Alt+Tab and the three-finger swipe open a compact card of live windows, at once. Each window takes the same finger travel, the mouse works too, and 1 to 9 sends the selected window to that desktop.Alt+Tab and the three-finger swipe show one switcher with a ring that follows your fingers. Each window takes the same finger travel however many are open, so fast swipes land where you expect.</a:t>
             </a:r>
             <a:endParaRPr lang="en-US" dirty="0"/>
           </a:p>
@@ -2533,7 +2533,7 @@
       </p:grpSpPr>
       <p:pic>
         <p:nvPicPr>
-          <p:cNvPr id="2" name="hero" descr="/tmp/tmp.wNxcSLvjxS/img/welcome.jpg">    </p:cNvPr>
+          <p:cNvPr id="2" name="hero" descr="/tmp/tmp.fflfJbYgbW/img/welcome.jpg">    </p:cNvPr>
           <p:cNvPicPr>
             <a:picLocks noChangeAspect="1"/>
           </p:cNvPicPr>
@@ -2805,7 +2805,7 @@
       </p:sp>
       <p:pic>
         <p:nvPicPr>
-          <p:cNvPr id="5" name="app-136" descr="/tmp/tmp.wNxcSLvjxS/apps/app.zen_browser.zen.png">    </p:cNvPr>
+          <p:cNvPr id="5" name="app-136" descr="/tmp/tmp.fflfJbYgbW/apps/app.zen_browser.zen.png">    </p:cNvPr>
           <p:cNvPicPr>
             <a:picLocks noChangeAspect="1"/>
           </p:cNvPicPr>
@@ -2865,7 +2865,7 @@
       </p:sp>
       <p:pic>
         <p:nvPicPr>
-          <p:cNvPr id="7" name="app-138" descr="/tmp/tmp.wNxcSLvjxS/apps/net.cozic.joplin_desktop.png">    </p:cNvPr>
+          <p:cNvPr id="7" name="app-138" descr="/tmp/tmp.fflfJbYgbW/apps/net.cozic.joplin_desktop.png">    </p:cNvPr>
           <p:cNvPicPr>
             <a:picLocks noChangeAspect="1"/>
           </p:cNvPicPr>
@@ -2925,7 +2925,7 @@
       </p:sp>
       <p:pic>
         <p:nvPicPr>
-          <p:cNvPr id="9" name="app-140" descr="/tmp/tmp.wNxcSLvjxS/apps/org.onlyoffice.desktopeditors.png">    </p:cNvPr>
+          <p:cNvPr id="9" name="app-140" descr="/tmp/tmp.fflfJbYgbW/apps/org.onlyoffice.desktopeditors.png">    </p:cNvPr>
           <p:cNvPicPr>
             <a:picLocks noChangeAspect="1"/>
           </p:cNvPicPr>
@@ -2985,7 +2985,7 @@
       </p:sp>
       <p:pic>
         <p:nvPicPr>
-          <p:cNvPr id="11" name="app-142" descr="/tmp/tmp.wNxcSLvjxS/apps/vscode.png">    </p:cNvPr>
+          <p:cNvPr id="11" name="app-142" descr="/tmp/tmp.fflfJbYgbW/apps/vscode.png">    </p:cNvPr>
           <p:cNvPicPr>
             <a:picLocks noChangeAspect="1"/>
           </p:cNvPicPr>
@@ -3045,7 +3045,7 @@
       </p:sp>
       <p:pic>
         <p:nvPicPr>
-          <p:cNvPr id="13" name="app-144" descr="/tmp/tmp.wNxcSLvjxS/apps/com.spotify.Client.png">    </p:cNvPr>
+          <p:cNvPr id="13" name="app-144" descr="/tmp/tmp.fflfJbYgbW/apps/com.spotify.Client.png">    </p:cNvPr>
           <p:cNvPicPr>
             <a:picLocks noChangeAspect="1"/>
           </p:cNvPicPr>
@@ -3105,7 +3105,7 @@
       </p:sp>
       <p:pic>
         <p:nvPicPr>
-          <p:cNvPr id="15" name="app-146" descr="/tmp/tmp.wNxcSLvjxS/apps/net.lutris.Lutris.png">    </p:cNvPr>
+          <p:cNvPr id="15" name="app-146" descr="/tmp/tmp.fflfJbYgbW/apps/net.lutris.Lutris.png">    </p:cNvPr>
           <p:cNvPicPr>
             <a:picLocks noChangeAspect="1"/>
           </p:cNvPicPr>
@@ -3165,7 +3165,7 @@
       </p:sp>
       <p:pic>
         <p:nvPicPr>
-          <p:cNvPr id="17" name="app-148" descr="/tmp/tmp.wNxcSLvjxS/apps/com.mattjakeman.ExtensionManager.png">    </p:cNvPr>
+          <p:cNvPr id="17" name="app-148" descr="/tmp/tmp.fflfJbYgbW/apps/com.mattjakeman.ExtensionManager.png">    </p:cNvPr>
           <p:cNvPicPr>
             <a:picLocks noChangeAspect="1"/>
           </p:cNvPicPr>
@@ -3225,7 +3225,7 @@
       </p:sp>
       <p:pic>
         <p:nvPicPr>
-          <p:cNvPr id="19" name="app-150" descr="/tmp/tmp.wNxcSLvjxS/apps/net.sonobus.SonoBus.png">    </p:cNvPr>
+          <p:cNvPr id="19" name="app-150" descr="/tmp/tmp.fflfJbYgbW/apps/net.sonobus.SonoBus.png">    </p:cNvPr>
           <p:cNvPicPr>
             <a:picLocks noChangeAspect="1"/>
           </p:cNvPicPr>
@@ -3285,7 +3285,7 @@
       </p:sp>
       <p:pic>
         <p:nvPicPr>
-          <p:cNvPr id="21" name="app-152" descr="/tmp/tmp.wNxcSLvjxS/apps/com.github.tenderowl.frog.png">    </p:cNvPr>
+          <p:cNvPr id="21" name="app-152" descr="/tmp/tmp.fflfJbYgbW/apps/com.github.tenderowl.frog.png">    </p:cNvPr>
           <p:cNvPicPr>
             <a:picLocks noChangeAspect="1"/>
           </p:cNvPicPr>
@@ -3345,7 +3345,7 @@
       </p:sp>
       <p:pic>
         <p:nvPicPr>
-          <p:cNvPr id="23" name="app-154" descr="/tmp/tmp.wNxcSLvjxS/apps/one.alynx.FlipClock.png">    </p:cNvPr>
+          <p:cNvPr id="23" name="app-154" descr="/tmp/tmp.fflfJbYgbW/apps/one.alynx.FlipClock.png">    </p:cNvPr>
           <p:cNvPicPr>
             <a:picLocks noChangeAspect="1"/>
           </p:cNvPicPr>
@@ -3405,7 +3405,7 @@
       </p:sp>
       <p:pic>
         <p:nvPicPr>
-          <p:cNvPr id="25" name="app-156" descr="/tmp/tmp.wNxcSLvjxS/apps/io.github.mehulk.MkNotes.png">    </p:cNvPr>
+          <p:cNvPr id="25" name="app-156" descr="/tmp/tmp.fflfJbYgbW/apps/io.github.mehulk.MkNotes.png">    </p:cNvPr>
           <p:cNvPicPr>
             <a:picLocks noChangeAspect="1"/>
           </p:cNvPicPr>
@@ -3465,7 +3465,7 @@
       </p:sp>
       <p:pic>
         <p:nvPicPr>
-          <p:cNvPr id="27" name="app-158" descr="/tmp/tmp.wNxcSLvjxS/apps/io.github.mehulk.MkCompanion.png">    </p:cNvPr>
+          <p:cNvPr id="27" name="app-158" descr="/tmp/tmp.fflfJbYgbW/apps/io.github.mehulk.MkCompanion.png">    </p:cNvPr>
           <p:cNvPicPr>
             <a:picLocks noChangeAspect="1"/>
           </p:cNvPicPr>
@@ -3525,7 +3525,7 @@
       </p:sp>
       <p:pic>
         <p:nvPicPr>
-          <p:cNvPr id="29" name="app-160" descr="/tmp/tmp.wNxcSLvjxS/apps/io.github.mehulk.MkTimer.png">    </p:cNvPr>
+          <p:cNvPr id="29" name="app-160" descr="/tmp/tmp.fflfJbYgbW/apps/io.github.mehulk.MkTimer.png">    </p:cNvPr>
           <p:cNvPicPr>
             <a:picLocks noChangeAspect="1"/>
           </p:cNvPicPr>
@@ -3585,7 +3585,7 @@
       </p:sp>
       <p:pic>
         <p:nvPicPr>
-          <p:cNvPr id="31" name="app-162" descr="/tmp/tmp.wNxcSLvjxS/apps/io.github.mehulk.MkShortcuts.png">    </p:cNvPr>
+          <p:cNvPr id="31" name="app-162" descr="/tmp/tmp.fflfJbYgbW/apps/io.github.mehulk.MkShortcuts.png">    </p:cNvPr>
           <p:cNvPicPr>
             <a:picLocks noChangeAspect="1"/>
           </p:cNvPicPr>
@@ -3869,7 +3869,7 @@
       </p:sp>
       <p:pic>
         <p:nvPicPr>
-          <p:cNvPr id="7" name="icon-166" descr="/tmp/tmp.wNxcSLvjxS/icons/auth-fingerprint.png">    </p:cNvPr>
+          <p:cNvPr id="7" name="icon-166" descr="/tmp/tmp.fflfJbYgbW/icons/auth-fingerprint.png">    </p:cNvPr>
           <p:cNvPicPr>
             <a:picLocks noChangeAspect="1"/>
           </p:cNvPicPr>
@@ -3991,7 +3991,7 @@
       </p:sp>
       <p:pic>
         <p:nvPicPr>
-          <p:cNvPr id="11" name="icon-170" descr="/tmp/tmp.wNxcSLvjxS/icons/battery-full.png">    </p:cNvPr>
+          <p:cNvPr id="11" name="icon-170" descr="/tmp/tmp.fflfJbYgbW/icons/battery-full.png">    </p:cNvPr>
           <p:cNvPicPr>
             <a:picLocks noChangeAspect="1"/>
           </p:cNvPicPr>
@@ -4113,7 +4113,7 @@
       </p:sp>
       <p:pic>
         <p:nvPicPr>
-          <p:cNvPr id="15" name="icon-174" descr="/tmp/tmp.wNxcSLvjxS/icons/audio-speakers.png">    </p:cNvPr>
+          <p:cNvPr id="15" name="icon-174" descr="/tmp/tmp.fflfJbYgbW/icons/audio-speakers.png">    </p:cNvPr>
           <p:cNvPicPr>
             <a:picLocks noChangeAspect="1"/>
           </p:cNvPicPr>
@@ -4235,7 +4235,7 @@
       </p:sp>
       <p:pic>
         <p:nvPicPr>
-          <p:cNvPr id="19" name="icon-178" descr="/tmp/tmp.wNxcSLvjxS/icons/input-tablet.png">    </p:cNvPr>
+          <p:cNvPr id="19" name="icon-178" descr="/tmp/tmp.fflfJbYgbW/icons/input-tablet.png">    </p:cNvPr>
           <p:cNvPicPr>
             <a:picLocks noChangeAspect="1"/>
           </p:cNvPicPr>
@@ -4357,7 +4357,7 @@
       </p:sp>
       <p:pic>
         <p:nvPicPr>
-          <p:cNvPr id="23" name="icon-182" descr="/tmp/tmp.wNxcSLvjxS/icons/video-display.png">    </p:cNvPr>
+          <p:cNvPr id="23" name="icon-182" descr="/tmp/tmp.fflfJbYgbW/icons/video-display.png">    </p:cNvPr>
           <p:cNvPicPr>
             <a:picLocks noChangeAspect="1"/>
           </p:cNvPicPr>
@@ -4479,7 +4479,7 @@
       </p:sp>
       <p:pic>
         <p:nvPicPr>
-          <p:cNvPr id="27" name="icon-186" descr="/tmp/tmp.wNxcSLvjxS/icons/system-run.png">    </p:cNvPr>
+          <p:cNvPr id="27" name="icon-186" descr="/tmp/tmp.fflfJbYgbW/icons/system-run.png">    </p:cNvPr>
           <p:cNvPicPr>
             <a:picLocks noChangeAspect="1"/>
           </p:cNvPicPr>
@@ -5645,7 +5645,7 @@
       </p:sp>
       <p:pic>
         <p:nvPicPr>
-          <p:cNvPr id="35" name="shortcuts" descr="/tmp/tmp.wNxcSLvjxS/img/shortcuts.jpg">    </p:cNvPr>
+          <p:cNvPr id="35" name="shortcuts" descr="/tmp/tmp.fflfJbYgbW/img/shortcuts.jpg">    </p:cNvPr>
           <p:cNvPicPr>
             <a:picLocks noChangeAspect="1"/>
           </p:cNvPicPr>
@@ -5878,7 +5878,7 @@
       </p:sp>
       <p:pic>
         <p:nvPicPr>
-          <p:cNvPr id="6" name="icon-220" descr="/tmp/tmp.wNxcSLvjxS/icons/document-open-recent.png">    </p:cNvPr>
+          <p:cNvPr id="6" name="icon-220" descr="/tmp/tmp.fflfJbYgbW/icons/document-open-recent.png">    </p:cNvPr>
           <p:cNvPicPr>
             <a:picLocks noChangeAspect="1"/>
           </p:cNvPicPr>
@@ -5978,7 +5978,7 @@
       </p:sp>
       <p:pic>
         <p:nvPicPr>
-          <p:cNvPr id="9" name="icon-223" descr="/tmp/tmp.wNxcSLvjxS/icons/user-trash.png">    </p:cNvPr>
+          <p:cNvPr id="9" name="icon-223" descr="/tmp/tmp.fflfJbYgbW/icons/user-trash.png">    </p:cNvPr>
           <p:cNvPicPr>
             <a:picLocks noChangeAspect="1"/>
           </p:cNvPicPr>
@@ -6078,7 +6078,7 @@
       </p:sp>
       <p:pic>
         <p:nvPicPr>
-          <p:cNvPr id="12" name="icon-226" descr="/tmp/tmp.wNxcSLvjxS/icons/checkbox-checked.png">    </p:cNvPr>
+          <p:cNvPr id="12" name="icon-226" descr="/tmp/tmp.fflfJbYgbW/icons/checkbox-checked.png">    </p:cNvPr>
           <p:cNvPicPr>
             <a:picLocks noChangeAspect="1"/>
           </p:cNvPicPr>
@@ -6178,7 +6178,7 @@
       </p:sp>
       <p:pic>
         <p:nvPicPr>
-          <p:cNvPr id="15" name="icon-229" descr="/tmp/tmp.wNxcSLvjxS/icons/x-office-document.png">    </p:cNvPr>
+          <p:cNvPr id="15" name="icon-229" descr="/tmp/tmp.fflfJbYgbW/icons/x-office-document.png">    </p:cNvPr>
           <p:cNvPicPr>
             <a:picLocks noChangeAspect="1"/>
           </p:cNvPicPr>
@@ -6278,7 +6278,7 @@
       </p:sp>
       <p:pic>
         <p:nvPicPr>
-          <p:cNvPr id="18" name="icon-232" descr="/tmp/tmp.wNxcSLvjxS/icons/software-update-available.png">    </p:cNvPr>
+          <p:cNvPr id="18" name="icon-232" descr="/tmp/tmp.fflfJbYgbW/icons/software-update-available.png">    </p:cNvPr>
           <p:cNvPicPr>
             <a:picLocks noChangeAspect="1"/>
           </p:cNvPicPr>
@@ -6358,7 +6358,7 @@
       </p:sp>
       <p:pic>
         <p:nvPicPr>
-          <p:cNvPr id="20" name="companion" descr="/tmp/tmp.wNxcSLvjxS/img/companion.jpg">    </p:cNvPr>
+          <p:cNvPr id="20" name="companion" descr="/tmp/tmp.fflfJbYgbW/img/companion.jpg">    </p:cNvPr>
           <p:cNvPicPr>
             <a:picLocks noChangeAspect="1"/>
           </p:cNvPicPr>
@@ -7087,7 +7087,7 @@
       </p:sp>
       <p:pic>
         <p:nvPicPr>
-          <p:cNvPr id="7" name="icon-2" descr="/tmp/tmp.wNxcSLvjxS/icons/edit-undo.png">    </p:cNvPr>
+          <p:cNvPr id="7" name="icon-2" descr="/tmp/tmp.fflfJbYgbW/icons/edit-undo.png">    </p:cNvPr>
           <p:cNvPicPr>
             <a:picLocks noChangeAspect="1"/>
           </p:cNvPicPr>
@@ -7187,7 +7187,7 @@
       </p:sp>
       <p:pic>
         <p:nvPicPr>
-          <p:cNvPr id="10" name="icon-5" descr="/tmp/tmp.wNxcSLvjxS/icons/software-update-available.png">    </p:cNvPr>
+          <p:cNvPr id="10" name="icon-5" descr="/tmp/tmp.fflfJbYgbW/icons/software-update-available.png">    </p:cNvPr>
           <p:cNvPicPr>
             <a:picLocks noChangeAspect="1"/>
           </p:cNvPicPr>
@@ -7845,7 +7845,7 @@
       </p:sp>
       <p:pic>
         <p:nvPicPr>
-          <p:cNvPr id="5" name="alttab-19" descr="/tmp/tmp.wNxcSLvjxS/img/alttab.jpg">    </p:cNvPr>
+          <p:cNvPr id="5" name="alttab-19" descr="/tmp/tmp.fflfJbYgbW/img/alttab.jpg">    </p:cNvPr>
           <p:cNvPicPr>
             <a:picLocks noChangeAspect="1"/>
           </p:cNvPicPr>
@@ -7904,7 +7904,7 @@
                   <a:schemeClr val="tx2"/>
                 </a:solidFill>
               </a:rPr>
-              <a:t>A frosted grid of live windows; the ring glides to your pick</a:t>
+              <a:t>A compact card of live windows that appears at once</a:t>
             </a:r>
             <a:endParaRPr lang="en-US" sz="1000" dirty="0"/>
           </a:p>
@@ -7932,7 +7932,7 @@
       </p:sp>
       <p:pic>
         <p:nvPicPr>
-          <p:cNvPr id="8" name="icon-22" descr="/tmp/tmp.wNxcSLvjxS/icons/view-grid.png">    </p:cNvPr>
+          <p:cNvPr id="8" name="icon-22" descr="/tmp/tmp.fflfJbYgbW/icons/view-grid.png">    </p:cNvPr>
           <p:cNvPicPr>
             <a:picLocks noChangeAspect="1"/>
           </p:cNvPicPr>
@@ -7987,7 +7987,7 @@
                   <a:schemeClr val="tx1"/>
                 </a:solidFill>
               </a:rPr>
-              <a:t>A grid, not a strip</a:t>
+              <a:t>Live previews</a:t>
             </a:r>
             <a:endParaRPr lang="en-US" sz="1400" dirty="0"/>
           </a:p>
@@ -8004,7 +8004,7 @@
                   <a:schemeClr val="tx2"/>
                 </a:solidFill>
               </a:rPr>
-              <a:t>previews, titles, which desktop</a:t>
+              <a:t>titles, icons, which desktop</a:t>
             </a:r>
             <a:endParaRPr lang="en-US" sz="1400" dirty="0"/>
           </a:p>
@@ -8032,7 +8032,7 @@
       </p:sp>
       <p:pic>
         <p:nvPicPr>
-          <p:cNvPr id="11" name="icon-25" descr="/tmp/tmp.wNxcSLvjxS/icons/input-touchpad.png">    </p:cNvPr>
+          <p:cNvPr id="11" name="icon-25" descr="/tmp/tmp.fflfJbYgbW/icons/input-touchpad.png">    </p:cNvPr>
           <p:cNvPicPr>
             <a:picLocks noChangeAspect="1"/>
           </p:cNvPicPr>
@@ -8132,7 +8132,7 @@
       </p:sp>
       <p:pic>
         <p:nvPicPr>
-          <p:cNvPr id="14" name="icon-28" descr="/tmp/tmp.wNxcSLvjxS/icons/view-dual.png">    </p:cNvPr>
+          <p:cNvPr id="14" name="icon-28" descr="/tmp/tmp.fflfJbYgbW/icons/view-dual.png">    </p:cNvPr>
           <p:cNvPicPr>
             <a:picLocks noChangeAspect="1"/>
           </p:cNvPicPr>
@@ -8232,7 +8232,7 @@
       </p:sp>
       <p:pic>
         <p:nvPicPr>
-          <p:cNvPr id="17" name="icon-31" descr="/tmp/tmp.wNxcSLvjxS/icons/system-run.png">    </p:cNvPr>
+          <p:cNvPr id="17" name="icon-31" descr="/tmp/tmp.fflfJbYgbW/icons/system-run.png">    </p:cNvPr>
           <p:cNvPicPr>
             <a:picLocks noChangeAspect="1"/>
           </p:cNvPicPr>
@@ -8458,7 +8458,7 @@
       </p:sp>
       <p:pic>
         <p:nvPicPr>
-          <p:cNvPr id="5" name="tiled-33" descr="/tmp/tmp.wNxcSLvjxS/img/tiled.jpg">    </p:cNvPr>
+          <p:cNvPr id="5" name="tiled-33" descr="/tmp/tmp.fflfJbYgbW/img/tiled.jpg">    </p:cNvPr>
           <p:cNvPicPr>
             <a:picLocks noChangeAspect="1"/>
           </p:cNvPicPr>
@@ -8545,7 +8545,7 @@
       </p:sp>
       <p:pic>
         <p:nvPicPr>
-          <p:cNvPr id="8" name="icon-36" descr="/tmp/tmp.wNxcSLvjxS/icons/view-dual.png">    </p:cNvPr>
+          <p:cNvPr id="8" name="icon-36" descr="/tmp/tmp.fflfJbYgbW/icons/view-dual.png">    </p:cNvPr>
           <p:cNvPicPr>
             <a:picLocks noChangeAspect="1"/>
           </p:cNvPicPr>
@@ -8645,7 +8645,7 @@
       </p:sp>
       <p:pic>
         <p:nvPicPr>
-          <p:cNvPr id="11" name="icon-39" descr="/tmp/tmp.wNxcSLvjxS/icons/window-new.png">    </p:cNvPr>
+          <p:cNvPr id="11" name="icon-39" descr="/tmp/tmp.fflfJbYgbW/icons/window-new.png">    </p:cNvPr>
           <p:cNvPicPr>
             <a:picLocks noChangeAspect="1"/>
           </p:cNvPicPr>
@@ -8745,7 +8745,7 @@
       </p:sp>
       <p:pic>
         <p:nvPicPr>
-          <p:cNvPr id="14" name="icon-42" descr="/tmp/tmp.wNxcSLvjxS/icons/view-pin.png">    </p:cNvPr>
+          <p:cNvPr id="14" name="icon-42" descr="/tmp/tmp.fflfJbYgbW/icons/view-pin.png">    </p:cNvPr>
           <p:cNvPicPr>
             <a:picLocks noChangeAspect="1"/>
           </p:cNvPicPr>
@@ -8845,7 +8845,7 @@
       </p:sp>
       <p:pic>
         <p:nvPicPr>
-          <p:cNvPr id="17" name="icon-45" descr="/tmp/tmp.wNxcSLvjxS/icons/view-grid.png">    </p:cNvPr>
+          <p:cNvPr id="17" name="icon-45" descr="/tmp/tmp.fflfJbYgbW/icons/view-grid.png">    </p:cNvPr>
           <p:cNvPicPr>
             <a:picLocks noChangeAspect="1"/>
           </p:cNvPicPr>
@@ -9071,7 +9071,7 @@
       </p:sp>
       <p:pic>
         <p:nvPicPr>
-          <p:cNvPr id="5" name="welcome-47" descr="/tmp/tmp.wNxcSLvjxS/img/welcome.jpg">    </p:cNvPr>
+          <p:cNvPr id="5" name="welcome-47" descr="/tmp/tmp.fflfJbYgbW/img/welcome.jpg">    </p:cNvPr>
           <p:cNvPicPr>
             <a:picLocks noChangeAspect="1"/>
           </p:cNvPicPr>
@@ -9158,7 +9158,7 @@
       </p:sp>
       <p:pic>
         <p:nvPicPr>
-          <p:cNvPr id="8" name="icon-50" descr="/tmp/tmp.wNxcSLvjxS/icons/weather-clear-night.png">    </p:cNvPr>
+          <p:cNvPr id="8" name="icon-50" descr="/tmp/tmp.fflfJbYgbW/icons/weather-clear-night.png">    </p:cNvPr>
           <p:cNvPicPr>
             <a:picLocks noChangeAspect="1"/>
           </p:cNvPicPr>
@@ -9258,7 +9258,7 @@
       </p:sp>
       <p:pic>
         <p:nvPicPr>
-          <p:cNvPr id="11" name="icon-53" descr="/tmp/tmp.wNxcSLvjxS/icons/view-pin.png">    </p:cNvPr>
+          <p:cNvPr id="11" name="icon-53" descr="/tmp/tmp.fflfJbYgbW/icons/view-pin.png">    </p:cNvPr>
           <p:cNvPicPr>
             <a:picLocks noChangeAspect="1"/>
           </p:cNvPicPr>
@@ -9358,7 +9358,7 @@
       </p:sp>
       <p:pic>
         <p:nvPicPr>
-          <p:cNvPr id="14" name="icon-56" descr="/tmp/tmp.wNxcSLvjxS/icons/face-smile.png">    </p:cNvPr>
+          <p:cNvPr id="14" name="icon-56" descr="/tmp/tmp.fflfJbYgbW/icons/face-smile.png">    </p:cNvPr>
           <p:cNvPicPr>
             <a:picLocks noChangeAspect="1"/>
           </p:cNvPicPr>
@@ -9458,7 +9458,7 @@
       </p:sp>
       <p:pic>
         <p:nvPicPr>
-          <p:cNvPr id="17" name="icon-59" descr="/tmp/tmp.wNxcSLvjxS/icons/preferences-color.png">    </p:cNvPr>
+          <p:cNvPr id="17" name="icon-59" descr="/tmp/tmp.fflfJbYgbW/icons/preferences-color.png">    </p:cNvPr>
           <p:cNvPicPr>
             <a:picLocks noChangeAspect="1"/>
           </p:cNvPicPr>
@@ -9684,7 +9684,7 @@
       </p:sp>
       <p:pic>
         <p:nvPicPr>
-          <p:cNvPr id="5" name="notes-split-61" descr="/tmp/tmp.wNxcSLvjxS/img/notes-split.jpg">    </p:cNvPr>
+          <p:cNvPr id="5" name="notes-split-61" descr="/tmp/tmp.fflfJbYgbW/img/notes-split.jpg">    </p:cNvPr>
           <p:cNvPicPr>
             <a:picLocks noChangeAspect="1"/>
           </p:cNvPicPr>
@@ -9715,7 +9715,7 @@
       </p:pic>
       <p:pic>
         <p:nvPicPr>
-          <p:cNvPr id="6" name="phone" descr="/tmp/tmp.wNxcSLvjxS/img/phone-note.jpg">    </p:cNvPr>
+          <p:cNvPr id="6" name="phone" descr="/tmp/tmp.fflfJbYgbW/img/phone-note.jpg">    </p:cNvPr>
           <p:cNvPicPr>
             <a:picLocks noChangeAspect="1"/>
           </p:cNvPicPr>
@@ -9802,7 +9802,7 @@
       </p:sp>
       <p:pic>
         <p:nvPicPr>
-          <p:cNvPr id="9" name="icon-64" descr="/tmp/tmp.wNxcSLvjxS/icons/x-office-document.png">    </p:cNvPr>
+          <p:cNvPr id="9" name="icon-64" descr="/tmp/tmp.fflfJbYgbW/icons/x-office-document.png">    </p:cNvPr>
           <p:cNvPicPr>
             <a:picLocks noChangeAspect="1"/>
           </p:cNvPicPr>
@@ -9902,7 +9902,7 @@
       </p:sp>
       <p:pic>
         <p:nvPicPr>
-          <p:cNvPr id="12" name="icon-67" descr="/tmp/tmp.wNxcSLvjxS/icons/network-workgroup.png">    </p:cNvPr>
+          <p:cNvPr id="12" name="icon-67" descr="/tmp/tmp.fflfJbYgbW/icons/network-workgroup.png">    </p:cNvPr>
           <p:cNvPicPr>
             <a:picLocks noChangeAspect="1"/>
           </p:cNvPicPr>
@@ -10002,7 +10002,7 @@
       </p:sp>
       <p:pic>
         <p:nvPicPr>
-          <p:cNvPr id="15" name="icon-70" descr="/tmp/tmp.wNxcSLvjxS/icons/applications-graphics.png">    </p:cNvPr>
+          <p:cNvPr id="15" name="icon-70" descr="/tmp/tmp.fflfJbYgbW/icons/applications-graphics.png">    </p:cNvPr>
           <p:cNvPicPr>
             <a:picLocks noChangeAspect="1"/>
           </p:cNvPicPr>
@@ -10102,7 +10102,7 @@
       </p:sp>
       <p:pic>
         <p:nvPicPr>
-          <p:cNvPr id="18" name="icon-73" descr="/tmp/tmp.wNxcSLvjxS/icons/edit-paste.png">    </p:cNvPr>
+          <p:cNvPr id="18" name="icon-73" descr="/tmp/tmp.fflfJbYgbW/icons/edit-paste.png">    </p:cNvPr>
           <p:cNvPicPr>
             <a:picLocks noChangeAspect="1"/>
           </p:cNvPicPr>
@@ -10370,7 +10370,7 @@
       </p:sp>
       <p:pic>
         <p:nvPicPr>
-          <p:cNvPr id="7" name="icon-77" descr="/tmp/tmp.wNxcSLvjxS/icons/emblem-system.png">    </p:cNvPr>
+          <p:cNvPr id="7" name="icon-77" descr="/tmp/tmp.fflfJbYgbW/icons/emblem-system.png">    </p:cNvPr>
           <p:cNvPicPr>
             <a:picLocks noChangeAspect="1"/>
           </p:cNvPicPr>
@@ -10492,7 +10492,7 @@
       </p:sp>
       <p:pic>
         <p:nvPicPr>
-          <p:cNvPr id="11" name="icon-81" descr="/tmp/tmp.wNxcSLvjxS/icons/x-office-document.png">    </p:cNvPr>
+          <p:cNvPr id="11" name="icon-81" descr="/tmp/tmp.fflfJbYgbW/icons/x-office-document.png">    </p:cNvPr>
           <p:cNvPicPr>
             <a:picLocks noChangeAspect="1"/>
           </p:cNvPicPr>
@@ -10614,7 +10614,7 @@
       </p:sp>
       <p:pic>
         <p:nvPicPr>
-          <p:cNvPr id="15" name="icon-85" descr="/tmp/tmp.wNxcSLvjxS/icons/network-workgroup.png">    </p:cNvPr>
+          <p:cNvPr id="15" name="icon-85" descr="/tmp/tmp.fflfJbYgbW/icons/network-workgroup.png">    </p:cNvPr>
           <p:cNvPicPr>
             <a:picLocks noChangeAspect="1"/>
           </p:cNvPicPr>
@@ -10736,7 +10736,7 @@
       </p:sp>
       <p:pic>
         <p:nvPicPr>
-          <p:cNvPr id="19" name="icon-89" descr="/tmp/tmp.wNxcSLvjxS/icons/document-open-recent.png">    </p:cNvPr>
+          <p:cNvPr id="19" name="icon-89" descr="/tmp/tmp.fflfJbYgbW/icons/document-open-recent.png">    </p:cNvPr>
           <p:cNvPicPr>
             <a:picLocks noChangeAspect="1"/>
           </p:cNvPicPr>
@@ -10858,7 +10858,7 @@
       </p:sp>
       <p:pic>
         <p:nvPicPr>
-          <p:cNvPr id="23" name="icon-93" descr="/tmp/tmp.wNxcSLvjxS/icons/x-office-calendar.png">    </p:cNvPr>
+          <p:cNvPr id="23" name="icon-93" descr="/tmp/tmp.fflfJbYgbW/icons/x-office-calendar.png">    </p:cNvPr>
           <p:cNvPicPr>
             <a:picLocks noChangeAspect="1"/>
           </p:cNvPicPr>
@@ -10980,7 +10980,7 @@
       </p:sp>
       <p:pic>
         <p:nvPicPr>
-          <p:cNvPr id="27" name="icon-97" descr="/tmp/tmp.wNxcSLvjxS/icons/checkbox-checked.png">    </p:cNvPr>
+          <p:cNvPr id="27" name="icon-97" descr="/tmp/tmp.fflfJbYgbW/icons/checkbox-checked.png">    </p:cNvPr>
           <p:cNvPicPr>
             <a:picLocks noChangeAspect="1"/>
           </p:cNvPicPr>
@@ -11102,7 +11102,7 @@
       </p:sp>
       <p:pic>
         <p:nvPicPr>
-          <p:cNvPr id="31" name="icon-101" descr="/tmp/tmp.wNxcSLvjxS/icons/edit-paste.png">    </p:cNvPr>
+          <p:cNvPr id="31" name="icon-101" descr="/tmp/tmp.fflfJbYgbW/icons/edit-paste.png">    </p:cNvPr>
           <p:cNvPicPr>
             <a:picLocks noChangeAspect="1"/>
           </p:cNvPicPr>
@@ -11224,7 +11224,7 @@
       </p:sp>
       <p:pic>
         <p:nvPicPr>
-          <p:cNvPr id="35" name="icon-105" descr="/tmp/tmp.wNxcSLvjxS/icons/preferences-color.png">    </p:cNvPr>
+          <p:cNvPr id="35" name="icon-105" descr="/tmp/tmp.fflfJbYgbW/icons/preferences-color.png">    </p:cNvPr>
           <p:cNvPicPr>
             <a:picLocks noChangeAspect="1"/>
           </p:cNvPicPr>
@@ -11450,7 +11450,7 @@
       </p:sp>
       <p:pic>
         <p:nvPicPr>
-          <p:cNvPr id="5" name="scene-web-107" descr="/tmp/tmp.wNxcSLvjxS/img/scene-web.jpg">    </p:cNvPr>
+          <p:cNvPr id="5" name="scene-web-107" descr="/tmp/tmp.fflfJbYgbW/img/scene-web.jpg">    </p:cNvPr>
           <p:cNvPicPr>
             <a:picLocks noChangeAspect="1"/>
           </p:cNvPicPr>
@@ -11481,7 +11481,7 @@
       </p:pic>
       <p:pic>
         <p:nvPicPr>
-          <p:cNvPr id="6" name="scene-knight-108" descr="/tmp/tmp.wNxcSLvjxS/img/scene-knight.jpg">    </p:cNvPr>
+          <p:cNvPr id="6" name="scene-knight-108" descr="/tmp/tmp.fflfJbYgbW/img/scene-knight.jpg">    </p:cNvPr>
           <p:cNvPicPr>
             <a:picLocks noChangeAspect="1"/>
           </p:cNvPicPr>
@@ -11512,7 +11512,7 @@
       </p:pic>
       <p:pic>
         <p:nvPicPr>
-          <p:cNvPr id="7" name="scene-matrix-109" descr="/tmp/tmp.wNxcSLvjxS/img/scene-matrix.jpg">    </p:cNvPr>
+          <p:cNvPr id="7" name="scene-matrix-109" descr="/tmp/tmp.fflfJbYgbW/img/scene-matrix.jpg">    </p:cNvPr>
           <p:cNvPicPr>
             <a:picLocks noChangeAspect="1"/>
           </p:cNvPicPr>
@@ -11599,7 +11599,7 @@
       </p:sp>
       <p:pic>
         <p:nvPicPr>
-          <p:cNvPr id="10" name="icon-112" descr="/tmp/tmp.wNxcSLvjxS/icons/weather-clear-night.png">    </p:cNvPr>
+          <p:cNvPr id="10" name="icon-112" descr="/tmp/tmp.fflfJbYgbW/icons/weather-clear-night.png">    </p:cNvPr>
           <p:cNvPicPr>
             <a:picLocks noChangeAspect="1"/>
           </p:cNvPicPr>
@@ -11699,7 +11699,7 @@
       </p:sp>
       <p:pic>
         <p:nvPicPr>
-          <p:cNvPr id="13" name="icon-115" descr="/tmp/tmp.wNxcSLvjxS/icons/video-display.png">    </p:cNvPr>
+          <p:cNvPr id="13" name="icon-115" descr="/tmp/tmp.fflfJbYgbW/icons/video-display.png">    </p:cNvPr>
           <p:cNvPicPr>
             <a:picLocks noChangeAspect="1"/>
           </p:cNvPicPr>
@@ -11799,7 +11799,7 @@
       </p:sp>
       <p:pic>
         <p:nvPicPr>
-          <p:cNvPr id="16" name="icon-118" descr="/tmp/tmp.wNxcSLvjxS/icons/alarm.png">    </p:cNvPr>
+          <p:cNvPr id="16" name="icon-118" descr="/tmp/tmp.fflfJbYgbW/icons/alarm.png">    </p:cNvPr>
           <p:cNvPicPr>
             <a:picLocks noChangeAspect="1"/>
           </p:cNvPicPr>
@@ -11899,7 +11899,7 @@
       </p:sp>
       <p:pic>
         <p:nvPicPr>
-          <p:cNvPr id="19" name="icon-121" descr="/tmp/tmp.wNxcSLvjxS/icons/system-run.png">    </p:cNvPr>
+          <p:cNvPr id="19" name="icon-121" descr="/tmp/tmp.fflfJbYgbW/icons/system-run.png">    </p:cNvPr>
           <p:cNvPicPr>
             <a:picLocks noChangeAspect="1"/>
           </p:cNvPicPr>
@@ -12125,7 +12125,7 @@
       </p:sp>
       <p:pic>
         <p:nvPicPr>
-          <p:cNvPr id="5" name="monitor" descr="/tmp/tmp.wNxcSLvjxS/img/speedtest.jpg">    </p:cNvPr>
+          <p:cNvPr id="5" name="monitor" descr="/tmp/tmp.fflfJbYgbW/img/speedtest.jpg">    </p:cNvPr>
           <p:cNvPicPr>
             <a:picLocks noChangeAspect="1"/>
           </p:cNvPicPr>
@@ -12156,7 +12156,7 @@
       </p:pic>
       <p:pic>
         <p:nvPicPr>
-          <p:cNvPr id="6" name="media" descr="/tmp/tmp.wNxcSLvjxS/img/media.jpg">    </p:cNvPr>
+          <p:cNvPr id="6" name="media" descr="/tmp/tmp.fflfJbYgbW/img/media.jpg">    </p:cNvPr>
           <p:cNvPicPr>
             <a:picLocks noChangeAspect="1"/>
           </p:cNvPicPr>
@@ -12243,7 +12243,7 @@
       </p:sp>
       <p:pic>
         <p:nvPicPr>
-          <p:cNvPr id="9" name="icon-125" descr="/tmp/tmp.wNxcSLvjxS/icons/video-display.png">    </p:cNvPr>
+          <p:cNvPr id="9" name="icon-125" descr="/tmp/tmp.fflfJbYgbW/icons/video-display.png">    </p:cNvPr>
           <p:cNvPicPr>
             <a:picLocks noChangeAspect="1"/>
           </p:cNvPicPr>
@@ -12343,7 +12343,7 @@
       </p:sp>
       <p:pic>
         <p:nvPicPr>
-          <p:cNvPr id="12" name="icon-128" descr="/tmp/tmp.wNxcSLvjxS/icons/network-workgroup.png">    </p:cNvPr>
+          <p:cNvPr id="12" name="icon-128" descr="/tmp/tmp.fflfJbYgbW/icons/network-workgroup.png">    </p:cNvPr>
           <p:cNvPicPr>
             <a:picLocks noChangeAspect="1"/>
           </p:cNvPicPr>
@@ -12443,7 +12443,7 @@
       </p:sp>
       <p:pic>
         <p:nvPicPr>
-          <p:cNvPr id="15" name="icon-131" descr="/tmp/tmp.wNxcSLvjxS/icons/audio-speakers.png">    </p:cNvPr>
+          <p:cNvPr id="15" name="icon-131" descr="/tmp/tmp.fflfJbYgbW/icons/audio-speakers.png">    </p:cNvPr>
           <p:cNvPicPr>
             <a:picLocks noChangeAspect="1"/>
           </p:cNvPicPr>
@@ -12543,7 +12543,7 @@
       </p:sp>
       <p:pic>
         <p:nvPicPr>
-          <p:cNvPr id="18" name="icon-134" descr="/tmp/tmp.wNxcSLvjxS/icons/edit-paste.png">    </p:cNvPr>
+          <p:cNvPr id="18" name="icon-134" descr="/tmp/tmp.fflfJbYgbW/icons/edit-paste.png">    </p:cNvPr>
           <p:cNvPicPr>
             <a:picLocks noChangeAspect="1"/>
           </p:cNvPicPr>

</xml_diff>

<commit_message>
docs: Screensaver app, brick-built Web Hang scene; overview rebuilt
Co-Authored-By: Claude Opus 5.5 <noreply@anthropic.com>
</commit_message>
<xml_diff>
--- a/docs/MK-Workstation-Overview.pptx
+++ b/docs/MK-Workstation-Overview.pptx
@@ -120,40 +120,40 @@
   <p:extLst>
     <p:ext uri="{521415D9-36F7-43E2-AB2F-B90AF26B5E84}">
       <p14:sectionLst xmlns:p14="http://schemas.microsoft.com/office/powerpoint/2010/main">
-        <p14:section name="Introduction" id="{0e785fd8-a218-bc84-3c7f-b8960e6268c3}">
+        <p14:section name="Introduction" id="{011f2dee-a1ec-630a-9503-4ade67bc0597}">
           <p14:sldIdLst>
             <p14:sldId id="256"/>
             <p14:sldId id="257"/>
           </p14:sldIdLst>
         </p14:section>
-        <p14:section name="Your desktop" id="{64e087b9-0ba3-d9a9-f126-d05f2e85b626}">
+        <p14:section name="Your desktop" id="{be35597c-00fe-1077-b796-b5ec821d552d}">
           <p14:sldIdLst>
             <p14:sldId id="258"/>
             <p14:sldId id="259"/>
             <p14:sldId id="260"/>
           </p14:sldIdLst>
         </p14:section>
-        <p14:section name="MK Notes" id="{4a620948-6559-fde8-b871-d4cf9ca56c53}">
+        <p14:section name="MK Notes" id="{5250244a-89a2-8995-7fe9-eb168fe5d35f}">
           <p14:sldIdLst>
             <p14:sldId id="261"/>
             <p14:sldId id="262"/>
           </p14:sldIdLst>
         </p14:section>
-        <p14:section name="Focus and tools" id="{0df5ba72-46e3-c6f1-f057-9cc25475db10}">
+        <p14:section name="Focus and tools" id="{c02c75e1-e377-5a14-3648-09cd21c4156b}">
           <p14:sldIdLst>
             <p14:sldId id="263"/>
             <p14:sldId id="264"/>
             <p14:sldId id="265"/>
           </p14:sldIdLst>
         </p14:section>
-        <p14:section name="Your computer" id="{c1d451d3-7d32-a4ba-e141-3794b0a438da}">
+        <p14:section name="Your computer" id="{62231eb8-6540-a687-aa4a-f0c579118892}">
           <p14:sldIdLst>
             <p14:sldId id="266"/>
             <p14:sldId id="267"/>
             <p14:sldId id="268"/>
           </p14:sldIdLst>
         </p14:section>
-        <p14:section name="Get started" id="{0bbf6386-643a-cda9-8a0e-a543024079d6}">
+        <p14:section name="Get started" id="{84ed3e3a-91d4-20f5-d458-c971ce5fb2dc}">
           <p14:sldIdLst>
             <p14:sldId id="269"/>
           </p14:sldIdLst>
@@ -2533,7 +2533,7 @@
       </p:grpSpPr>
       <p:pic>
         <p:nvPicPr>
-          <p:cNvPr id="2" name="hero" descr="/tmp/tmp.fflfJbYgbW/img/welcome.jpg">    </p:cNvPr>
+          <p:cNvPr id="2" name="hero" descr="/tmp/tmp.6gMuyieSku/img/welcome.jpg">    </p:cNvPr>
           <p:cNvPicPr>
             <a:picLocks noChangeAspect="1"/>
           </p:cNvPicPr>
@@ -2805,7 +2805,7 @@
       </p:sp>
       <p:pic>
         <p:nvPicPr>
-          <p:cNvPr id="5" name="app-136" descr="/tmp/tmp.fflfJbYgbW/apps/app.zen_browser.zen.png">    </p:cNvPr>
+          <p:cNvPr id="5" name="app-136" descr="/tmp/tmp.6gMuyieSku/apps/app.zen_browser.zen.png">    </p:cNvPr>
           <p:cNvPicPr>
             <a:picLocks noChangeAspect="1"/>
           </p:cNvPicPr>
@@ -2865,7 +2865,7 @@
       </p:sp>
       <p:pic>
         <p:nvPicPr>
-          <p:cNvPr id="7" name="app-138" descr="/tmp/tmp.fflfJbYgbW/apps/net.cozic.joplin_desktop.png">    </p:cNvPr>
+          <p:cNvPr id="7" name="app-138" descr="/tmp/tmp.6gMuyieSku/apps/net.cozic.joplin_desktop.png">    </p:cNvPr>
           <p:cNvPicPr>
             <a:picLocks noChangeAspect="1"/>
           </p:cNvPicPr>
@@ -2925,7 +2925,7 @@
       </p:sp>
       <p:pic>
         <p:nvPicPr>
-          <p:cNvPr id="9" name="app-140" descr="/tmp/tmp.fflfJbYgbW/apps/org.onlyoffice.desktopeditors.png">    </p:cNvPr>
+          <p:cNvPr id="9" name="app-140" descr="/tmp/tmp.6gMuyieSku/apps/org.onlyoffice.desktopeditors.png">    </p:cNvPr>
           <p:cNvPicPr>
             <a:picLocks noChangeAspect="1"/>
           </p:cNvPicPr>
@@ -2985,7 +2985,7 @@
       </p:sp>
       <p:pic>
         <p:nvPicPr>
-          <p:cNvPr id="11" name="app-142" descr="/tmp/tmp.fflfJbYgbW/apps/vscode.png">    </p:cNvPr>
+          <p:cNvPr id="11" name="app-142" descr="/tmp/tmp.6gMuyieSku/apps/vscode.png">    </p:cNvPr>
           <p:cNvPicPr>
             <a:picLocks noChangeAspect="1"/>
           </p:cNvPicPr>
@@ -3045,7 +3045,7 @@
       </p:sp>
       <p:pic>
         <p:nvPicPr>
-          <p:cNvPr id="13" name="app-144" descr="/tmp/tmp.fflfJbYgbW/apps/com.spotify.Client.png">    </p:cNvPr>
+          <p:cNvPr id="13" name="app-144" descr="/tmp/tmp.6gMuyieSku/apps/com.spotify.Client.png">    </p:cNvPr>
           <p:cNvPicPr>
             <a:picLocks noChangeAspect="1"/>
           </p:cNvPicPr>
@@ -3105,7 +3105,7 @@
       </p:sp>
       <p:pic>
         <p:nvPicPr>
-          <p:cNvPr id="15" name="app-146" descr="/tmp/tmp.fflfJbYgbW/apps/net.lutris.Lutris.png">    </p:cNvPr>
+          <p:cNvPr id="15" name="app-146" descr="/tmp/tmp.6gMuyieSku/apps/net.lutris.Lutris.png">    </p:cNvPr>
           <p:cNvPicPr>
             <a:picLocks noChangeAspect="1"/>
           </p:cNvPicPr>
@@ -3165,7 +3165,7 @@
       </p:sp>
       <p:pic>
         <p:nvPicPr>
-          <p:cNvPr id="17" name="app-148" descr="/tmp/tmp.fflfJbYgbW/apps/com.mattjakeman.ExtensionManager.png">    </p:cNvPr>
+          <p:cNvPr id="17" name="app-148" descr="/tmp/tmp.6gMuyieSku/apps/com.mattjakeman.ExtensionManager.png">    </p:cNvPr>
           <p:cNvPicPr>
             <a:picLocks noChangeAspect="1"/>
           </p:cNvPicPr>
@@ -3225,7 +3225,7 @@
       </p:sp>
       <p:pic>
         <p:nvPicPr>
-          <p:cNvPr id="19" name="app-150" descr="/tmp/tmp.fflfJbYgbW/apps/net.sonobus.SonoBus.png">    </p:cNvPr>
+          <p:cNvPr id="19" name="app-150" descr="/tmp/tmp.6gMuyieSku/apps/net.sonobus.SonoBus.png">    </p:cNvPr>
           <p:cNvPicPr>
             <a:picLocks noChangeAspect="1"/>
           </p:cNvPicPr>
@@ -3285,7 +3285,7 @@
       </p:sp>
       <p:pic>
         <p:nvPicPr>
-          <p:cNvPr id="21" name="app-152" descr="/tmp/tmp.fflfJbYgbW/apps/com.github.tenderowl.frog.png">    </p:cNvPr>
+          <p:cNvPr id="21" name="app-152" descr="/tmp/tmp.6gMuyieSku/apps/com.github.tenderowl.frog.png">    </p:cNvPr>
           <p:cNvPicPr>
             <a:picLocks noChangeAspect="1"/>
           </p:cNvPicPr>
@@ -3345,7 +3345,7 @@
       </p:sp>
       <p:pic>
         <p:nvPicPr>
-          <p:cNvPr id="23" name="app-154" descr="/tmp/tmp.fflfJbYgbW/apps/one.alynx.FlipClock.png">    </p:cNvPr>
+          <p:cNvPr id="23" name="app-154" descr="/tmp/tmp.6gMuyieSku/apps/one.alynx.FlipClock.png">    </p:cNvPr>
           <p:cNvPicPr>
             <a:picLocks noChangeAspect="1"/>
           </p:cNvPicPr>
@@ -3405,7 +3405,7 @@
       </p:sp>
       <p:pic>
         <p:nvPicPr>
-          <p:cNvPr id="25" name="app-156" descr="/tmp/tmp.fflfJbYgbW/apps/io.github.mehulk.MkNotes.png">    </p:cNvPr>
+          <p:cNvPr id="25" name="app-156" descr="/tmp/tmp.6gMuyieSku/apps/io.github.mehulk.MkNotes.png">    </p:cNvPr>
           <p:cNvPicPr>
             <a:picLocks noChangeAspect="1"/>
           </p:cNvPicPr>
@@ -3465,7 +3465,7 @@
       </p:sp>
       <p:pic>
         <p:nvPicPr>
-          <p:cNvPr id="27" name="app-158" descr="/tmp/tmp.fflfJbYgbW/apps/io.github.mehulk.MkCompanion.png">    </p:cNvPr>
+          <p:cNvPr id="27" name="app-158" descr="/tmp/tmp.6gMuyieSku/apps/io.github.mehulk.MkCompanion.png">    </p:cNvPr>
           <p:cNvPicPr>
             <a:picLocks noChangeAspect="1"/>
           </p:cNvPicPr>
@@ -3525,7 +3525,7 @@
       </p:sp>
       <p:pic>
         <p:nvPicPr>
-          <p:cNvPr id="29" name="app-160" descr="/tmp/tmp.fflfJbYgbW/apps/io.github.mehulk.MkTimer.png">    </p:cNvPr>
+          <p:cNvPr id="29" name="app-160" descr="/tmp/tmp.6gMuyieSku/apps/io.github.mehulk.MkTimer.png">    </p:cNvPr>
           <p:cNvPicPr>
             <a:picLocks noChangeAspect="1"/>
           </p:cNvPicPr>
@@ -3585,7 +3585,7 @@
       </p:sp>
       <p:pic>
         <p:nvPicPr>
-          <p:cNvPr id="31" name="app-162" descr="/tmp/tmp.fflfJbYgbW/apps/io.github.mehulk.MkShortcuts.png">    </p:cNvPr>
+          <p:cNvPr id="31" name="app-162" descr="/tmp/tmp.6gMuyieSku/apps/io.github.mehulk.MkShortcuts.png">    </p:cNvPr>
           <p:cNvPicPr>
             <a:picLocks noChangeAspect="1"/>
           </p:cNvPicPr>
@@ -3869,7 +3869,7 @@
       </p:sp>
       <p:pic>
         <p:nvPicPr>
-          <p:cNvPr id="7" name="icon-166" descr="/tmp/tmp.fflfJbYgbW/icons/auth-fingerprint.png">    </p:cNvPr>
+          <p:cNvPr id="7" name="icon-166" descr="/tmp/tmp.6gMuyieSku/icons/auth-fingerprint.png">    </p:cNvPr>
           <p:cNvPicPr>
             <a:picLocks noChangeAspect="1"/>
           </p:cNvPicPr>
@@ -3991,7 +3991,7 @@
       </p:sp>
       <p:pic>
         <p:nvPicPr>
-          <p:cNvPr id="11" name="icon-170" descr="/tmp/tmp.fflfJbYgbW/icons/battery-full.png">    </p:cNvPr>
+          <p:cNvPr id="11" name="icon-170" descr="/tmp/tmp.6gMuyieSku/icons/battery-full.png">    </p:cNvPr>
           <p:cNvPicPr>
             <a:picLocks noChangeAspect="1"/>
           </p:cNvPicPr>
@@ -4113,7 +4113,7 @@
       </p:sp>
       <p:pic>
         <p:nvPicPr>
-          <p:cNvPr id="15" name="icon-174" descr="/tmp/tmp.fflfJbYgbW/icons/audio-speakers.png">    </p:cNvPr>
+          <p:cNvPr id="15" name="icon-174" descr="/tmp/tmp.6gMuyieSku/icons/audio-speakers.png">    </p:cNvPr>
           <p:cNvPicPr>
             <a:picLocks noChangeAspect="1"/>
           </p:cNvPicPr>
@@ -4235,7 +4235,7 @@
       </p:sp>
       <p:pic>
         <p:nvPicPr>
-          <p:cNvPr id="19" name="icon-178" descr="/tmp/tmp.fflfJbYgbW/icons/input-tablet.png">    </p:cNvPr>
+          <p:cNvPr id="19" name="icon-178" descr="/tmp/tmp.6gMuyieSku/icons/input-tablet.png">    </p:cNvPr>
           <p:cNvPicPr>
             <a:picLocks noChangeAspect="1"/>
           </p:cNvPicPr>
@@ -4357,7 +4357,7 @@
       </p:sp>
       <p:pic>
         <p:nvPicPr>
-          <p:cNvPr id="23" name="icon-182" descr="/tmp/tmp.fflfJbYgbW/icons/video-display.png">    </p:cNvPr>
+          <p:cNvPr id="23" name="icon-182" descr="/tmp/tmp.6gMuyieSku/icons/video-display.png">    </p:cNvPr>
           <p:cNvPicPr>
             <a:picLocks noChangeAspect="1"/>
           </p:cNvPicPr>
@@ -4479,7 +4479,7 @@
       </p:sp>
       <p:pic>
         <p:nvPicPr>
-          <p:cNvPr id="27" name="icon-186" descr="/tmp/tmp.fflfJbYgbW/icons/system-run.png">    </p:cNvPr>
+          <p:cNvPr id="27" name="icon-186" descr="/tmp/tmp.6gMuyieSku/icons/system-run.png">    </p:cNvPr>
           <p:cNvPicPr>
             <a:picLocks noChangeAspect="1"/>
           </p:cNvPicPr>
@@ -5645,7 +5645,7 @@
       </p:sp>
       <p:pic>
         <p:nvPicPr>
-          <p:cNvPr id="35" name="shortcuts" descr="/tmp/tmp.fflfJbYgbW/img/shortcuts.jpg">    </p:cNvPr>
+          <p:cNvPr id="35" name="shortcuts" descr="/tmp/tmp.6gMuyieSku/img/shortcuts.jpg">    </p:cNvPr>
           <p:cNvPicPr>
             <a:picLocks noChangeAspect="1"/>
           </p:cNvPicPr>
@@ -5878,7 +5878,7 @@
       </p:sp>
       <p:pic>
         <p:nvPicPr>
-          <p:cNvPr id="6" name="icon-220" descr="/tmp/tmp.fflfJbYgbW/icons/document-open-recent.png">    </p:cNvPr>
+          <p:cNvPr id="6" name="icon-220" descr="/tmp/tmp.6gMuyieSku/icons/document-open-recent.png">    </p:cNvPr>
           <p:cNvPicPr>
             <a:picLocks noChangeAspect="1"/>
           </p:cNvPicPr>
@@ -5978,7 +5978,7 @@
       </p:sp>
       <p:pic>
         <p:nvPicPr>
-          <p:cNvPr id="9" name="icon-223" descr="/tmp/tmp.fflfJbYgbW/icons/user-trash.png">    </p:cNvPr>
+          <p:cNvPr id="9" name="icon-223" descr="/tmp/tmp.6gMuyieSku/icons/user-trash.png">    </p:cNvPr>
           <p:cNvPicPr>
             <a:picLocks noChangeAspect="1"/>
           </p:cNvPicPr>
@@ -6078,7 +6078,7 @@
       </p:sp>
       <p:pic>
         <p:nvPicPr>
-          <p:cNvPr id="12" name="icon-226" descr="/tmp/tmp.fflfJbYgbW/icons/checkbox-checked.png">    </p:cNvPr>
+          <p:cNvPr id="12" name="icon-226" descr="/tmp/tmp.6gMuyieSku/icons/checkbox-checked.png">    </p:cNvPr>
           <p:cNvPicPr>
             <a:picLocks noChangeAspect="1"/>
           </p:cNvPicPr>
@@ -6178,7 +6178,7 @@
       </p:sp>
       <p:pic>
         <p:nvPicPr>
-          <p:cNvPr id="15" name="icon-229" descr="/tmp/tmp.fflfJbYgbW/icons/x-office-document.png">    </p:cNvPr>
+          <p:cNvPr id="15" name="icon-229" descr="/tmp/tmp.6gMuyieSku/icons/x-office-document.png">    </p:cNvPr>
           <p:cNvPicPr>
             <a:picLocks noChangeAspect="1"/>
           </p:cNvPicPr>
@@ -6278,7 +6278,7 @@
       </p:sp>
       <p:pic>
         <p:nvPicPr>
-          <p:cNvPr id="18" name="icon-232" descr="/tmp/tmp.fflfJbYgbW/icons/software-update-available.png">    </p:cNvPr>
+          <p:cNvPr id="18" name="icon-232" descr="/tmp/tmp.6gMuyieSku/icons/software-update-available.png">    </p:cNvPr>
           <p:cNvPicPr>
             <a:picLocks noChangeAspect="1"/>
           </p:cNvPicPr>
@@ -6358,7 +6358,7 @@
       </p:sp>
       <p:pic>
         <p:nvPicPr>
-          <p:cNvPr id="20" name="companion" descr="/tmp/tmp.fflfJbYgbW/img/companion.jpg">    </p:cNvPr>
+          <p:cNvPr id="20" name="companion" descr="/tmp/tmp.6gMuyieSku/img/companion.jpg">    </p:cNvPr>
           <p:cNvPicPr>
             <a:picLocks noChangeAspect="1"/>
           </p:cNvPicPr>
@@ -7087,7 +7087,7 @@
       </p:sp>
       <p:pic>
         <p:nvPicPr>
-          <p:cNvPr id="7" name="icon-2" descr="/tmp/tmp.fflfJbYgbW/icons/edit-undo.png">    </p:cNvPr>
+          <p:cNvPr id="7" name="icon-2" descr="/tmp/tmp.6gMuyieSku/icons/edit-undo.png">    </p:cNvPr>
           <p:cNvPicPr>
             <a:picLocks noChangeAspect="1"/>
           </p:cNvPicPr>
@@ -7187,7 +7187,7 @@
       </p:sp>
       <p:pic>
         <p:nvPicPr>
-          <p:cNvPr id="10" name="icon-5" descr="/tmp/tmp.fflfJbYgbW/icons/software-update-available.png">    </p:cNvPr>
+          <p:cNvPr id="10" name="icon-5" descr="/tmp/tmp.6gMuyieSku/icons/software-update-available.png">    </p:cNvPr>
           <p:cNvPicPr>
             <a:picLocks noChangeAspect="1"/>
           </p:cNvPicPr>
@@ -7845,7 +7845,7 @@
       </p:sp>
       <p:pic>
         <p:nvPicPr>
-          <p:cNvPr id="5" name="alttab-19" descr="/tmp/tmp.fflfJbYgbW/img/alttab.jpg">    </p:cNvPr>
+          <p:cNvPr id="5" name="alttab-19" descr="/tmp/tmp.6gMuyieSku/img/alttab.jpg">    </p:cNvPr>
           <p:cNvPicPr>
             <a:picLocks noChangeAspect="1"/>
           </p:cNvPicPr>
@@ -7932,7 +7932,7 @@
       </p:sp>
       <p:pic>
         <p:nvPicPr>
-          <p:cNvPr id="8" name="icon-22" descr="/tmp/tmp.fflfJbYgbW/icons/view-grid.png">    </p:cNvPr>
+          <p:cNvPr id="8" name="icon-22" descr="/tmp/tmp.6gMuyieSku/icons/view-grid.png">    </p:cNvPr>
           <p:cNvPicPr>
             <a:picLocks noChangeAspect="1"/>
           </p:cNvPicPr>
@@ -8032,7 +8032,7 @@
       </p:sp>
       <p:pic>
         <p:nvPicPr>
-          <p:cNvPr id="11" name="icon-25" descr="/tmp/tmp.fflfJbYgbW/icons/input-touchpad.png">    </p:cNvPr>
+          <p:cNvPr id="11" name="icon-25" descr="/tmp/tmp.6gMuyieSku/icons/input-touchpad.png">    </p:cNvPr>
           <p:cNvPicPr>
             <a:picLocks noChangeAspect="1"/>
           </p:cNvPicPr>
@@ -8132,7 +8132,7 @@
       </p:sp>
       <p:pic>
         <p:nvPicPr>
-          <p:cNvPr id="14" name="icon-28" descr="/tmp/tmp.fflfJbYgbW/icons/view-dual.png">    </p:cNvPr>
+          <p:cNvPr id="14" name="icon-28" descr="/tmp/tmp.6gMuyieSku/icons/view-dual.png">    </p:cNvPr>
           <p:cNvPicPr>
             <a:picLocks noChangeAspect="1"/>
           </p:cNvPicPr>
@@ -8232,7 +8232,7 @@
       </p:sp>
       <p:pic>
         <p:nvPicPr>
-          <p:cNvPr id="17" name="icon-31" descr="/tmp/tmp.fflfJbYgbW/icons/system-run.png">    </p:cNvPr>
+          <p:cNvPr id="17" name="icon-31" descr="/tmp/tmp.6gMuyieSku/icons/system-run.png">    </p:cNvPr>
           <p:cNvPicPr>
             <a:picLocks noChangeAspect="1"/>
           </p:cNvPicPr>
@@ -8458,7 +8458,7 @@
       </p:sp>
       <p:pic>
         <p:nvPicPr>
-          <p:cNvPr id="5" name="tiled-33" descr="/tmp/tmp.fflfJbYgbW/img/tiled.jpg">    </p:cNvPr>
+          <p:cNvPr id="5" name="tiled-33" descr="/tmp/tmp.6gMuyieSku/img/tiled.jpg">    </p:cNvPr>
           <p:cNvPicPr>
             <a:picLocks noChangeAspect="1"/>
           </p:cNvPicPr>
@@ -8545,7 +8545,7 @@
       </p:sp>
       <p:pic>
         <p:nvPicPr>
-          <p:cNvPr id="8" name="icon-36" descr="/tmp/tmp.fflfJbYgbW/icons/view-dual.png">    </p:cNvPr>
+          <p:cNvPr id="8" name="icon-36" descr="/tmp/tmp.6gMuyieSku/icons/view-dual.png">    </p:cNvPr>
           <p:cNvPicPr>
             <a:picLocks noChangeAspect="1"/>
           </p:cNvPicPr>
@@ -8645,7 +8645,7 @@
       </p:sp>
       <p:pic>
         <p:nvPicPr>
-          <p:cNvPr id="11" name="icon-39" descr="/tmp/tmp.fflfJbYgbW/icons/window-new.png">    </p:cNvPr>
+          <p:cNvPr id="11" name="icon-39" descr="/tmp/tmp.6gMuyieSku/icons/window-new.png">    </p:cNvPr>
           <p:cNvPicPr>
             <a:picLocks noChangeAspect="1"/>
           </p:cNvPicPr>
@@ -8745,7 +8745,7 @@
       </p:sp>
       <p:pic>
         <p:nvPicPr>
-          <p:cNvPr id="14" name="icon-42" descr="/tmp/tmp.fflfJbYgbW/icons/view-pin.png">    </p:cNvPr>
+          <p:cNvPr id="14" name="icon-42" descr="/tmp/tmp.6gMuyieSku/icons/view-pin.png">    </p:cNvPr>
           <p:cNvPicPr>
             <a:picLocks noChangeAspect="1"/>
           </p:cNvPicPr>
@@ -8845,7 +8845,7 @@
       </p:sp>
       <p:pic>
         <p:nvPicPr>
-          <p:cNvPr id="17" name="icon-45" descr="/tmp/tmp.fflfJbYgbW/icons/view-grid.png">    </p:cNvPr>
+          <p:cNvPr id="17" name="icon-45" descr="/tmp/tmp.6gMuyieSku/icons/view-grid.png">    </p:cNvPr>
           <p:cNvPicPr>
             <a:picLocks noChangeAspect="1"/>
           </p:cNvPicPr>
@@ -9071,7 +9071,7 @@
       </p:sp>
       <p:pic>
         <p:nvPicPr>
-          <p:cNvPr id="5" name="welcome-47" descr="/tmp/tmp.fflfJbYgbW/img/welcome.jpg">    </p:cNvPr>
+          <p:cNvPr id="5" name="welcome-47" descr="/tmp/tmp.6gMuyieSku/img/welcome.jpg">    </p:cNvPr>
           <p:cNvPicPr>
             <a:picLocks noChangeAspect="1"/>
           </p:cNvPicPr>
@@ -9158,7 +9158,7 @@
       </p:sp>
       <p:pic>
         <p:nvPicPr>
-          <p:cNvPr id="8" name="icon-50" descr="/tmp/tmp.fflfJbYgbW/icons/weather-clear-night.png">    </p:cNvPr>
+          <p:cNvPr id="8" name="icon-50" descr="/tmp/tmp.6gMuyieSku/icons/weather-clear-night.png">    </p:cNvPr>
           <p:cNvPicPr>
             <a:picLocks noChangeAspect="1"/>
           </p:cNvPicPr>
@@ -9258,7 +9258,7 @@
       </p:sp>
       <p:pic>
         <p:nvPicPr>
-          <p:cNvPr id="11" name="icon-53" descr="/tmp/tmp.fflfJbYgbW/icons/view-pin.png">    </p:cNvPr>
+          <p:cNvPr id="11" name="icon-53" descr="/tmp/tmp.6gMuyieSku/icons/view-pin.png">    </p:cNvPr>
           <p:cNvPicPr>
             <a:picLocks noChangeAspect="1"/>
           </p:cNvPicPr>
@@ -9358,7 +9358,7 @@
       </p:sp>
       <p:pic>
         <p:nvPicPr>
-          <p:cNvPr id="14" name="icon-56" descr="/tmp/tmp.fflfJbYgbW/icons/face-smile.png">    </p:cNvPr>
+          <p:cNvPr id="14" name="icon-56" descr="/tmp/tmp.6gMuyieSku/icons/face-smile.png">    </p:cNvPr>
           <p:cNvPicPr>
             <a:picLocks noChangeAspect="1"/>
           </p:cNvPicPr>
@@ -9458,7 +9458,7 @@
       </p:sp>
       <p:pic>
         <p:nvPicPr>
-          <p:cNvPr id="17" name="icon-59" descr="/tmp/tmp.fflfJbYgbW/icons/preferences-color.png">    </p:cNvPr>
+          <p:cNvPr id="17" name="icon-59" descr="/tmp/tmp.6gMuyieSku/icons/preferences-color.png">    </p:cNvPr>
           <p:cNvPicPr>
             <a:picLocks noChangeAspect="1"/>
           </p:cNvPicPr>
@@ -9684,7 +9684,7 @@
       </p:sp>
       <p:pic>
         <p:nvPicPr>
-          <p:cNvPr id="5" name="notes-split-61" descr="/tmp/tmp.fflfJbYgbW/img/notes-split.jpg">    </p:cNvPr>
+          <p:cNvPr id="5" name="notes-split-61" descr="/tmp/tmp.6gMuyieSku/img/notes-split.jpg">    </p:cNvPr>
           <p:cNvPicPr>
             <a:picLocks noChangeAspect="1"/>
           </p:cNvPicPr>
@@ -9715,7 +9715,7 @@
       </p:pic>
       <p:pic>
         <p:nvPicPr>
-          <p:cNvPr id="6" name="phone" descr="/tmp/tmp.fflfJbYgbW/img/phone-note.jpg">    </p:cNvPr>
+          <p:cNvPr id="6" name="phone" descr="/tmp/tmp.6gMuyieSku/img/phone-note.jpg">    </p:cNvPr>
           <p:cNvPicPr>
             <a:picLocks noChangeAspect="1"/>
           </p:cNvPicPr>
@@ -9802,7 +9802,7 @@
       </p:sp>
       <p:pic>
         <p:nvPicPr>
-          <p:cNvPr id="9" name="icon-64" descr="/tmp/tmp.fflfJbYgbW/icons/x-office-document.png">    </p:cNvPr>
+          <p:cNvPr id="9" name="icon-64" descr="/tmp/tmp.6gMuyieSku/icons/x-office-document.png">    </p:cNvPr>
           <p:cNvPicPr>
             <a:picLocks noChangeAspect="1"/>
           </p:cNvPicPr>
@@ -9902,7 +9902,7 @@
       </p:sp>
       <p:pic>
         <p:nvPicPr>
-          <p:cNvPr id="12" name="icon-67" descr="/tmp/tmp.fflfJbYgbW/icons/network-workgroup.png">    </p:cNvPr>
+          <p:cNvPr id="12" name="icon-67" descr="/tmp/tmp.6gMuyieSku/icons/network-workgroup.png">    </p:cNvPr>
           <p:cNvPicPr>
             <a:picLocks noChangeAspect="1"/>
           </p:cNvPicPr>
@@ -10002,7 +10002,7 @@
       </p:sp>
       <p:pic>
         <p:nvPicPr>
-          <p:cNvPr id="15" name="icon-70" descr="/tmp/tmp.fflfJbYgbW/icons/applications-graphics.png">    </p:cNvPr>
+          <p:cNvPr id="15" name="icon-70" descr="/tmp/tmp.6gMuyieSku/icons/applications-graphics.png">    </p:cNvPr>
           <p:cNvPicPr>
             <a:picLocks noChangeAspect="1"/>
           </p:cNvPicPr>
@@ -10102,7 +10102,7 @@
       </p:sp>
       <p:pic>
         <p:nvPicPr>
-          <p:cNvPr id="18" name="icon-73" descr="/tmp/tmp.fflfJbYgbW/icons/edit-paste.png">    </p:cNvPr>
+          <p:cNvPr id="18" name="icon-73" descr="/tmp/tmp.6gMuyieSku/icons/edit-paste.png">    </p:cNvPr>
           <p:cNvPicPr>
             <a:picLocks noChangeAspect="1"/>
           </p:cNvPicPr>
@@ -10370,7 +10370,7 @@
       </p:sp>
       <p:pic>
         <p:nvPicPr>
-          <p:cNvPr id="7" name="icon-77" descr="/tmp/tmp.fflfJbYgbW/icons/emblem-system.png">    </p:cNvPr>
+          <p:cNvPr id="7" name="icon-77" descr="/tmp/tmp.6gMuyieSku/icons/emblem-system.png">    </p:cNvPr>
           <p:cNvPicPr>
             <a:picLocks noChangeAspect="1"/>
           </p:cNvPicPr>
@@ -10492,7 +10492,7 @@
       </p:sp>
       <p:pic>
         <p:nvPicPr>
-          <p:cNvPr id="11" name="icon-81" descr="/tmp/tmp.fflfJbYgbW/icons/x-office-document.png">    </p:cNvPr>
+          <p:cNvPr id="11" name="icon-81" descr="/tmp/tmp.6gMuyieSku/icons/x-office-document.png">    </p:cNvPr>
           <p:cNvPicPr>
             <a:picLocks noChangeAspect="1"/>
           </p:cNvPicPr>
@@ -10614,7 +10614,7 @@
       </p:sp>
       <p:pic>
         <p:nvPicPr>
-          <p:cNvPr id="15" name="icon-85" descr="/tmp/tmp.fflfJbYgbW/icons/network-workgroup.png">    </p:cNvPr>
+          <p:cNvPr id="15" name="icon-85" descr="/tmp/tmp.6gMuyieSku/icons/network-workgroup.png">    </p:cNvPr>
           <p:cNvPicPr>
             <a:picLocks noChangeAspect="1"/>
           </p:cNvPicPr>
@@ -10736,7 +10736,7 @@
       </p:sp>
       <p:pic>
         <p:nvPicPr>
-          <p:cNvPr id="19" name="icon-89" descr="/tmp/tmp.fflfJbYgbW/icons/document-open-recent.png">    </p:cNvPr>
+          <p:cNvPr id="19" name="icon-89" descr="/tmp/tmp.6gMuyieSku/icons/document-open-recent.png">    </p:cNvPr>
           <p:cNvPicPr>
             <a:picLocks noChangeAspect="1"/>
           </p:cNvPicPr>
@@ -10858,7 +10858,7 @@
       </p:sp>
       <p:pic>
         <p:nvPicPr>
-          <p:cNvPr id="23" name="icon-93" descr="/tmp/tmp.fflfJbYgbW/icons/x-office-calendar.png">    </p:cNvPr>
+          <p:cNvPr id="23" name="icon-93" descr="/tmp/tmp.6gMuyieSku/icons/x-office-calendar.png">    </p:cNvPr>
           <p:cNvPicPr>
             <a:picLocks noChangeAspect="1"/>
           </p:cNvPicPr>
@@ -10980,7 +10980,7 @@
       </p:sp>
       <p:pic>
         <p:nvPicPr>
-          <p:cNvPr id="27" name="icon-97" descr="/tmp/tmp.fflfJbYgbW/icons/checkbox-checked.png">    </p:cNvPr>
+          <p:cNvPr id="27" name="icon-97" descr="/tmp/tmp.6gMuyieSku/icons/checkbox-checked.png">    </p:cNvPr>
           <p:cNvPicPr>
             <a:picLocks noChangeAspect="1"/>
           </p:cNvPicPr>
@@ -11102,7 +11102,7 @@
       </p:sp>
       <p:pic>
         <p:nvPicPr>
-          <p:cNvPr id="31" name="icon-101" descr="/tmp/tmp.fflfJbYgbW/icons/edit-paste.png">    </p:cNvPr>
+          <p:cNvPr id="31" name="icon-101" descr="/tmp/tmp.6gMuyieSku/icons/edit-paste.png">    </p:cNvPr>
           <p:cNvPicPr>
             <a:picLocks noChangeAspect="1"/>
           </p:cNvPicPr>
@@ -11224,7 +11224,7 @@
       </p:sp>
       <p:pic>
         <p:nvPicPr>
-          <p:cNvPr id="35" name="icon-105" descr="/tmp/tmp.fflfJbYgbW/icons/preferences-color.png">    </p:cNvPr>
+          <p:cNvPr id="35" name="icon-105" descr="/tmp/tmp.6gMuyieSku/icons/preferences-color.png">    </p:cNvPr>
           <p:cNvPicPr>
             <a:picLocks noChangeAspect="1"/>
           </p:cNvPicPr>
@@ -11450,7 +11450,7 @@
       </p:sp>
       <p:pic>
         <p:nvPicPr>
-          <p:cNvPr id="5" name="scene-web-107" descr="/tmp/tmp.fflfJbYgbW/img/scene-web.jpg">    </p:cNvPr>
+          <p:cNvPr id="5" name="scene-web-107" descr="/tmp/tmp.6gMuyieSku/img/scene-web.jpg">    </p:cNvPr>
           <p:cNvPicPr>
             <a:picLocks noChangeAspect="1"/>
           </p:cNvPicPr>
@@ -11481,7 +11481,7 @@
       </p:pic>
       <p:pic>
         <p:nvPicPr>
-          <p:cNvPr id="6" name="scene-knight-108" descr="/tmp/tmp.fflfJbYgbW/img/scene-knight.jpg">    </p:cNvPr>
+          <p:cNvPr id="6" name="scene-knight-108" descr="/tmp/tmp.6gMuyieSku/img/scene-knight.jpg">    </p:cNvPr>
           <p:cNvPicPr>
             <a:picLocks noChangeAspect="1"/>
           </p:cNvPicPr>
@@ -11512,7 +11512,7 @@
       </p:pic>
       <p:pic>
         <p:nvPicPr>
-          <p:cNvPr id="7" name="scene-matrix-109" descr="/tmp/tmp.fflfJbYgbW/img/scene-matrix.jpg">    </p:cNvPr>
+          <p:cNvPr id="7" name="scene-matrix-109" descr="/tmp/tmp.6gMuyieSku/img/scene-matrix.jpg">    </p:cNvPr>
           <p:cNvPicPr>
             <a:picLocks noChangeAspect="1"/>
           </p:cNvPicPr>
@@ -11599,7 +11599,7 @@
       </p:sp>
       <p:pic>
         <p:nvPicPr>
-          <p:cNvPr id="10" name="icon-112" descr="/tmp/tmp.fflfJbYgbW/icons/weather-clear-night.png">    </p:cNvPr>
+          <p:cNvPr id="10" name="icon-112" descr="/tmp/tmp.6gMuyieSku/icons/weather-clear-night.png">    </p:cNvPr>
           <p:cNvPicPr>
             <a:picLocks noChangeAspect="1"/>
           </p:cNvPicPr>
@@ -11699,7 +11699,7 @@
       </p:sp>
       <p:pic>
         <p:nvPicPr>
-          <p:cNvPr id="13" name="icon-115" descr="/tmp/tmp.fflfJbYgbW/icons/video-display.png">    </p:cNvPr>
+          <p:cNvPr id="13" name="icon-115" descr="/tmp/tmp.6gMuyieSku/icons/video-display.png">    </p:cNvPr>
           <p:cNvPicPr>
             <a:picLocks noChangeAspect="1"/>
           </p:cNvPicPr>
@@ -11799,7 +11799,7 @@
       </p:sp>
       <p:pic>
         <p:nvPicPr>
-          <p:cNvPr id="16" name="icon-118" descr="/tmp/tmp.fflfJbYgbW/icons/alarm.png">    </p:cNvPr>
+          <p:cNvPr id="16" name="icon-118" descr="/tmp/tmp.6gMuyieSku/icons/alarm.png">    </p:cNvPr>
           <p:cNvPicPr>
             <a:picLocks noChangeAspect="1"/>
           </p:cNvPicPr>
@@ -11899,7 +11899,7 @@
       </p:sp>
       <p:pic>
         <p:nvPicPr>
-          <p:cNvPr id="19" name="icon-121" descr="/tmp/tmp.fflfJbYgbW/icons/system-run.png">    </p:cNvPr>
+          <p:cNvPr id="19" name="icon-121" descr="/tmp/tmp.6gMuyieSku/icons/system-run.png">    </p:cNvPr>
           <p:cNvPicPr>
             <a:picLocks noChangeAspect="1"/>
           </p:cNvPicPr>
@@ -12125,7 +12125,7 @@
       </p:sp>
       <p:pic>
         <p:nvPicPr>
-          <p:cNvPr id="5" name="monitor" descr="/tmp/tmp.fflfJbYgbW/img/speedtest.jpg">    </p:cNvPr>
+          <p:cNvPr id="5" name="monitor" descr="/tmp/tmp.6gMuyieSku/img/speedtest.jpg">    </p:cNvPr>
           <p:cNvPicPr>
             <a:picLocks noChangeAspect="1"/>
           </p:cNvPicPr>
@@ -12156,7 +12156,7 @@
       </p:pic>
       <p:pic>
         <p:nvPicPr>
-          <p:cNvPr id="6" name="media" descr="/tmp/tmp.fflfJbYgbW/img/media.jpg">    </p:cNvPr>
+          <p:cNvPr id="6" name="media" descr="/tmp/tmp.6gMuyieSku/img/media.jpg">    </p:cNvPr>
           <p:cNvPicPr>
             <a:picLocks noChangeAspect="1"/>
           </p:cNvPicPr>
@@ -12243,7 +12243,7 @@
       </p:sp>
       <p:pic>
         <p:nvPicPr>
-          <p:cNvPr id="9" name="icon-125" descr="/tmp/tmp.fflfJbYgbW/icons/video-display.png">    </p:cNvPr>
+          <p:cNvPr id="9" name="icon-125" descr="/tmp/tmp.6gMuyieSku/icons/video-display.png">    </p:cNvPr>
           <p:cNvPicPr>
             <a:picLocks noChangeAspect="1"/>
           </p:cNvPicPr>
@@ -12343,7 +12343,7 @@
       </p:sp>
       <p:pic>
         <p:nvPicPr>
-          <p:cNvPr id="12" name="icon-128" descr="/tmp/tmp.fflfJbYgbW/icons/network-workgroup.png">    </p:cNvPr>
+          <p:cNvPr id="12" name="icon-128" descr="/tmp/tmp.6gMuyieSku/icons/network-workgroup.png">    </p:cNvPr>
           <p:cNvPicPr>
             <a:picLocks noChangeAspect="1"/>
           </p:cNvPicPr>
@@ -12443,7 +12443,7 @@
       </p:sp>
       <p:pic>
         <p:nvPicPr>
-          <p:cNvPr id="15" name="icon-131" descr="/tmp/tmp.fflfJbYgbW/icons/audio-speakers.png">    </p:cNvPr>
+          <p:cNvPr id="15" name="icon-131" descr="/tmp/tmp.6gMuyieSku/icons/audio-speakers.png">    </p:cNvPr>
           <p:cNvPicPr>
             <a:picLocks noChangeAspect="1"/>
           </p:cNvPicPr>
@@ -12543,7 +12543,7 @@
       </p:sp>
       <p:pic>
         <p:nvPicPr>
-          <p:cNvPr id="18" name="icon-134" descr="/tmp/tmp.fflfJbYgbW/icons/edit-paste.png">    </p:cNvPr>
+          <p:cNvPr id="18" name="icon-134" descr="/tmp/tmp.6gMuyieSku/icons/edit-paste.png">    </p:cNvPr>
           <p:cNvPicPr>
             <a:picLocks noChangeAspect="1"/>
           </p:cNvPicPr>

</xml_diff>

<commit_message>
feat(scenes): brick-built caped knight, skyscraper Web Hang, hex terminal stream
- Night Watch: the crouched silhouette is now a brick-built caped
  knight: plastic blocks, cowl with ears, rippling cape, yellow belt
  and chest emblem, rim-lit by the searchlight.
- Web Hang: no moon; the hero hangs beside a skyscraper with setbacks,
  a spire beacon and lit windows.
- Terminal Stream (was Neon Cascade): hexadecimal rain in cyan with
  amber columns, glowing heads, faint scanlines.

Co-Authored-By: Claude Opus 5.5 <noreply@anthropic.com>
</commit_message>
<xml_diff>
--- a/docs/MK-Workstation-Overview.pptx
+++ b/docs/MK-Workstation-Overview.pptx
@@ -120,40 +120,40 @@
   <p:extLst>
     <p:ext uri="{521415D9-36F7-43E2-AB2F-B90AF26B5E84}">
       <p14:sectionLst xmlns:p14="http://schemas.microsoft.com/office/powerpoint/2010/main">
-        <p14:section name="Introduction" id="{011f2dee-a1ec-630a-9503-4ade67bc0597}">
+        <p14:section name="Introduction" id="{e3385471-325c-8d67-b654-6364441ec19c}">
           <p14:sldIdLst>
             <p14:sldId id="256"/>
             <p14:sldId id="257"/>
           </p14:sldIdLst>
         </p14:section>
-        <p14:section name="Your desktop" id="{be35597c-00fe-1077-b796-b5ec821d552d}">
+        <p14:section name="Your desktop" id="{8c0400c4-0880-ee2e-6621-cc2a3d98a047}">
           <p14:sldIdLst>
             <p14:sldId id="258"/>
             <p14:sldId id="259"/>
             <p14:sldId id="260"/>
           </p14:sldIdLst>
         </p14:section>
-        <p14:section name="MK Notes" id="{5250244a-89a2-8995-7fe9-eb168fe5d35f}">
+        <p14:section name="MK Notes" id="{3500a1fa-320d-b034-39ec-ab7bdb423838}">
           <p14:sldIdLst>
             <p14:sldId id="261"/>
             <p14:sldId id="262"/>
           </p14:sldIdLst>
         </p14:section>
-        <p14:section name="Focus and tools" id="{c02c75e1-e377-5a14-3648-09cd21c4156b}">
+        <p14:section name="Focus and tools" id="{28ff21e4-545a-1a57-4628-cf4fc7b7338a}">
           <p14:sldIdLst>
             <p14:sldId id="263"/>
             <p14:sldId id="264"/>
             <p14:sldId id="265"/>
           </p14:sldIdLst>
         </p14:section>
-        <p14:section name="Your computer" id="{62231eb8-6540-a687-aa4a-f0c579118892}">
+        <p14:section name="Your computer" id="{36f144a2-31e9-67a0-554a-d2a48d7c57fd}">
           <p14:sldIdLst>
             <p14:sldId id="266"/>
             <p14:sldId id="267"/>
             <p14:sldId id="268"/>
           </p14:sldIdLst>
         </p14:section>
-        <p14:section name="Get started" id="{84ed3e3a-91d4-20f5-d458-c971ce5fb2dc}">
+        <p14:section name="Get started" id="{d440eb97-198e-6a9b-3119-0e31e8c25122}">
           <p14:sldIdLst>
             <p14:sldId id="269"/>
           </p14:sldIdLst>
@@ -1618,7 +1618,7 @@
           <a:p>
             <a:r>
               <a:rPr lang="en-US" dirty="0"/>
-              <a:t>Step away for a few minutes and a scene plays: a masked hero swinging from a web over the city, a caped figure in the rain, or code rain that decodes the time. A video or call keeps it away; any touch brings you back.</a:t>
+              <a:t>Step away for a few minutes and a scene plays: a brick-built masked hero hanging beside a skyscraper, a brick-built caped knight in the rain, or hexadecimal rain that decodes the time. A video or call keeps it away; any touch brings you back.</a:t>
             </a:r>
             <a:endParaRPr lang="en-US" dirty="0"/>
           </a:p>
@@ -2533,7 +2533,7 @@
       </p:grpSpPr>
       <p:pic>
         <p:nvPicPr>
-          <p:cNvPr id="2" name="hero" descr="/tmp/tmp.6gMuyieSku/img/welcome.jpg">    </p:cNvPr>
+          <p:cNvPr id="2" name="hero" descr="/tmp/tmp.eH5VcKLLim/img/welcome.jpg">    </p:cNvPr>
           <p:cNvPicPr>
             <a:picLocks noChangeAspect="1"/>
           </p:cNvPicPr>
@@ -2805,7 +2805,7 @@
       </p:sp>
       <p:pic>
         <p:nvPicPr>
-          <p:cNvPr id="5" name="app-136" descr="/tmp/tmp.6gMuyieSku/apps/app.zen_browser.zen.png">    </p:cNvPr>
+          <p:cNvPr id="5" name="app-136" descr="/tmp/tmp.eH5VcKLLim/apps/app.zen_browser.zen.png">    </p:cNvPr>
           <p:cNvPicPr>
             <a:picLocks noChangeAspect="1"/>
           </p:cNvPicPr>
@@ -2865,7 +2865,7 @@
       </p:sp>
       <p:pic>
         <p:nvPicPr>
-          <p:cNvPr id="7" name="app-138" descr="/tmp/tmp.6gMuyieSku/apps/net.cozic.joplin_desktop.png">    </p:cNvPr>
+          <p:cNvPr id="7" name="app-138" descr="/tmp/tmp.eH5VcKLLim/apps/net.cozic.joplin_desktop.png">    </p:cNvPr>
           <p:cNvPicPr>
             <a:picLocks noChangeAspect="1"/>
           </p:cNvPicPr>
@@ -2925,7 +2925,7 @@
       </p:sp>
       <p:pic>
         <p:nvPicPr>
-          <p:cNvPr id="9" name="app-140" descr="/tmp/tmp.6gMuyieSku/apps/org.onlyoffice.desktopeditors.png">    </p:cNvPr>
+          <p:cNvPr id="9" name="app-140" descr="/tmp/tmp.eH5VcKLLim/apps/org.onlyoffice.desktopeditors.png">    </p:cNvPr>
           <p:cNvPicPr>
             <a:picLocks noChangeAspect="1"/>
           </p:cNvPicPr>
@@ -2985,7 +2985,7 @@
       </p:sp>
       <p:pic>
         <p:nvPicPr>
-          <p:cNvPr id="11" name="app-142" descr="/tmp/tmp.6gMuyieSku/apps/vscode.png">    </p:cNvPr>
+          <p:cNvPr id="11" name="app-142" descr="/tmp/tmp.eH5VcKLLim/apps/vscode.png">    </p:cNvPr>
           <p:cNvPicPr>
             <a:picLocks noChangeAspect="1"/>
           </p:cNvPicPr>
@@ -3045,7 +3045,7 @@
       </p:sp>
       <p:pic>
         <p:nvPicPr>
-          <p:cNvPr id="13" name="app-144" descr="/tmp/tmp.6gMuyieSku/apps/com.spotify.Client.png">    </p:cNvPr>
+          <p:cNvPr id="13" name="app-144" descr="/tmp/tmp.eH5VcKLLim/apps/com.spotify.Client.png">    </p:cNvPr>
           <p:cNvPicPr>
             <a:picLocks noChangeAspect="1"/>
           </p:cNvPicPr>
@@ -3105,7 +3105,7 @@
       </p:sp>
       <p:pic>
         <p:nvPicPr>
-          <p:cNvPr id="15" name="app-146" descr="/tmp/tmp.6gMuyieSku/apps/net.lutris.Lutris.png">    </p:cNvPr>
+          <p:cNvPr id="15" name="app-146" descr="/tmp/tmp.eH5VcKLLim/apps/net.lutris.Lutris.png">    </p:cNvPr>
           <p:cNvPicPr>
             <a:picLocks noChangeAspect="1"/>
           </p:cNvPicPr>
@@ -3165,7 +3165,7 @@
       </p:sp>
       <p:pic>
         <p:nvPicPr>
-          <p:cNvPr id="17" name="app-148" descr="/tmp/tmp.6gMuyieSku/apps/com.mattjakeman.ExtensionManager.png">    </p:cNvPr>
+          <p:cNvPr id="17" name="app-148" descr="/tmp/tmp.eH5VcKLLim/apps/com.mattjakeman.ExtensionManager.png">    </p:cNvPr>
           <p:cNvPicPr>
             <a:picLocks noChangeAspect="1"/>
           </p:cNvPicPr>
@@ -3225,7 +3225,7 @@
       </p:sp>
       <p:pic>
         <p:nvPicPr>
-          <p:cNvPr id="19" name="app-150" descr="/tmp/tmp.6gMuyieSku/apps/net.sonobus.SonoBus.png">    </p:cNvPr>
+          <p:cNvPr id="19" name="app-150" descr="/tmp/tmp.eH5VcKLLim/apps/net.sonobus.SonoBus.png">    </p:cNvPr>
           <p:cNvPicPr>
             <a:picLocks noChangeAspect="1"/>
           </p:cNvPicPr>
@@ -3285,7 +3285,7 @@
       </p:sp>
       <p:pic>
         <p:nvPicPr>
-          <p:cNvPr id="21" name="app-152" descr="/tmp/tmp.6gMuyieSku/apps/com.github.tenderowl.frog.png">    </p:cNvPr>
+          <p:cNvPr id="21" name="app-152" descr="/tmp/tmp.eH5VcKLLim/apps/com.github.tenderowl.frog.png">    </p:cNvPr>
           <p:cNvPicPr>
             <a:picLocks noChangeAspect="1"/>
           </p:cNvPicPr>
@@ -3345,7 +3345,7 @@
       </p:sp>
       <p:pic>
         <p:nvPicPr>
-          <p:cNvPr id="23" name="app-154" descr="/tmp/tmp.6gMuyieSku/apps/one.alynx.FlipClock.png">    </p:cNvPr>
+          <p:cNvPr id="23" name="app-154" descr="/tmp/tmp.eH5VcKLLim/apps/one.alynx.FlipClock.png">    </p:cNvPr>
           <p:cNvPicPr>
             <a:picLocks noChangeAspect="1"/>
           </p:cNvPicPr>
@@ -3405,7 +3405,7 @@
       </p:sp>
       <p:pic>
         <p:nvPicPr>
-          <p:cNvPr id="25" name="app-156" descr="/tmp/tmp.6gMuyieSku/apps/io.github.mehulk.MkNotes.png">    </p:cNvPr>
+          <p:cNvPr id="25" name="app-156" descr="/tmp/tmp.eH5VcKLLim/apps/io.github.mehulk.MkNotes.png">    </p:cNvPr>
           <p:cNvPicPr>
             <a:picLocks noChangeAspect="1"/>
           </p:cNvPicPr>
@@ -3465,7 +3465,7 @@
       </p:sp>
       <p:pic>
         <p:nvPicPr>
-          <p:cNvPr id="27" name="app-158" descr="/tmp/tmp.6gMuyieSku/apps/io.github.mehulk.MkCompanion.png">    </p:cNvPr>
+          <p:cNvPr id="27" name="app-158" descr="/tmp/tmp.eH5VcKLLim/apps/io.github.mehulk.MkCompanion.png">    </p:cNvPr>
           <p:cNvPicPr>
             <a:picLocks noChangeAspect="1"/>
           </p:cNvPicPr>
@@ -3525,7 +3525,7 @@
       </p:sp>
       <p:pic>
         <p:nvPicPr>
-          <p:cNvPr id="29" name="app-160" descr="/tmp/tmp.6gMuyieSku/apps/io.github.mehulk.MkTimer.png">    </p:cNvPr>
+          <p:cNvPr id="29" name="app-160" descr="/tmp/tmp.eH5VcKLLim/apps/io.github.mehulk.MkTimer.png">    </p:cNvPr>
           <p:cNvPicPr>
             <a:picLocks noChangeAspect="1"/>
           </p:cNvPicPr>
@@ -3585,7 +3585,7 @@
       </p:sp>
       <p:pic>
         <p:nvPicPr>
-          <p:cNvPr id="31" name="app-162" descr="/tmp/tmp.6gMuyieSku/apps/io.github.mehulk.MkShortcuts.png">    </p:cNvPr>
+          <p:cNvPr id="31" name="app-162" descr="/tmp/tmp.eH5VcKLLim/apps/io.github.mehulk.MkShortcuts.png">    </p:cNvPr>
           <p:cNvPicPr>
             <a:picLocks noChangeAspect="1"/>
           </p:cNvPicPr>
@@ -3869,7 +3869,7 @@
       </p:sp>
       <p:pic>
         <p:nvPicPr>
-          <p:cNvPr id="7" name="icon-166" descr="/tmp/tmp.6gMuyieSku/icons/auth-fingerprint.png">    </p:cNvPr>
+          <p:cNvPr id="7" name="icon-166" descr="/tmp/tmp.eH5VcKLLim/icons/auth-fingerprint.png">    </p:cNvPr>
           <p:cNvPicPr>
             <a:picLocks noChangeAspect="1"/>
           </p:cNvPicPr>
@@ -3991,7 +3991,7 @@
       </p:sp>
       <p:pic>
         <p:nvPicPr>
-          <p:cNvPr id="11" name="icon-170" descr="/tmp/tmp.6gMuyieSku/icons/battery-full.png">    </p:cNvPr>
+          <p:cNvPr id="11" name="icon-170" descr="/tmp/tmp.eH5VcKLLim/icons/battery-full.png">    </p:cNvPr>
           <p:cNvPicPr>
             <a:picLocks noChangeAspect="1"/>
           </p:cNvPicPr>
@@ -4113,7 +4113,7 @@
       </p:sp>
       <p:pic>
         <p:nvPicPr>
-          <p:cNvPr id="15" name="icon-174" descr="/tmp/tmp.6gMuyieSku/icons/audio-speakers.png">    </p:cNvPr>
+          <p:cNvPr id="15" name="icon-174" descr="/tmp/tmp.eH5VcKLLim/icons/audio-speakers.png">    </p:cNvPr>
           <p:cNvPicPr>
             <a:picLocks noChangeAspect="1"/>
           </p:cNvPicPr>
@@ -4235,7 +4235,7 @@
       </p:sp>
       <p:pic>
         <p:nvPicPr>
-          <p:cNvPr id="19" name="icon-178" descr="/tmp/tmp.6gMuyieSku/icons/input-tablet.png">    </p:cNvPr>
+          <p:cNvPr id="19" name="icon-178" descr="/tmp/tmp.eH5VcKLLim/icons/input-tablet.png">    </p:cNvPr>
           <p:cNvPicPr>
             <a:picLocks noChangeAspect="1"/>
           </p:cNvPicPr>
@@ -4357,7 +4357,7 @@
       </p:sp>
       <p:pic>
         <p:nvPicPr>
-          <p:cNvPr id="23" name="icon-182" descr="/tmp/tmp.6gMuyieSku/icons/video-display.png">    </p:cNvPr>
+          <p:cNvPr id="23" name="icon-182" descr="/tmp/tmp.eH5VcKLLim/icons/video-display.png">    </p:cNvPr>
           <p:cNvPicPr>
             <a:picLocks noChangeAspect="1"/>
           </p:cNvPicPr>
@@ -4479,7 +4479,7 @@
       </p:sp>
       <p:pic>
         <p:nvPicPr>
-          <p:cNvPr id="27" name="icon-186" descr="/tmp/tmp.6gMuyieSku/icons/system-run.png">    </p:cNvPr>
+          <p:cNvPr id="27" name="icon-186" descr="/tmp/tmp.eH5VcKLLim/icons/system-run.png">    </p:cNvPr>
           <p:cNvPicPr>
             <a:picLocks noChangeAspect="1"/>
           </p:cNvPicPr>
@@ -5645,7 +5645,7 @@
       </p:sp>
       <p:pic>
         <p:nvPicPr>
-          <p:cNvPr id="35" name="shortcuts" descr="/tmp/tmp.6gMuyieSku/img/shortcuts.jpg">    </p:cNvPr>
+          <p:cNvPr id="35" name="shortcuts" descr="/tmp/tmp.eH5VcKLLim/img/shortcuts.jpg">    </p:cNvPr>
           <p:cNvPicPr>
             <a:picLocks noChangeAspect="1"/>
           </p:cNvPicPr>
@@ -5878,7 +5878,7 @@
       </p:sp>
       <p:pic>
         <p:nvPicPr>
-          <p:cNvPr id="6" name="icon-220" descr="/tmp/tmp.6gMuyieSku/icons/document-open-recent.png">    </p:cNvPr>
+          <p:cNvPr id="6" name="icon-220" descr="/tmp/tmp.eH5VcKLLim/icons/document-open-recent.png">    </p:cNvPr>
           <p:cNvPicPr>
             <a:picLocks noChangeAspect="1"/>
           </p:cNvPicPr>
@@ -5978,7 +5978,7 @@
       </p:sp>
       <p:pic>
         <p:nvPicPr>
-          <p:cNvPr id="9" name="icon-223" descr="/tmp/tmp.6gMuyieSku/icons/user-trash.png">    </p:cNvPr>
+          <p:cNvPr id="9" name="icon-223" descr="/tmp/tmp.eH5VcKLLim/icons/user-trash.png">    </p:cNvPr>
           <p:cNvPicPr>
             <a:picLocks noChangeAspect="1"/>
           </p:cNvPicPr>
@@ -6078,7 +6078,7 @@
       </p:sp>
       <p:pic>
         <p:nvPicPr>
-          <p:cNvPr id="12" name="icon-226" descr="/tmp/tmp.6gMuyieSku/icons/checkbox-checked.png">    </p:cNvPr>
+          <p:cNvPr id="12" name="icon-226" descr="/tmp/tmp.eH5VcKLLim/icons/checkbox-checked.png">    </p:cNvPr>
           <p:cNvPicPr>
             <a:picLocks noChangeAspect="1"/>
           </p:cNvPicPr>
@@ -6178,7 +6178,7 @@
       </p:sp>
       <p:pic>
         <p:nvPicPr>
-          <p:cNvPr id="15" name="icon-229" descr="/tmp/tmp.6gMuyieSku/icons/x-office-document.png">    </p:cNvPr>
+          <p:cNvPr id="15" name="icon-229" descr="/tmp/tmp.eH5VcKLLim/icons/x-office-document.png">    </p:cNvPr>
           <p:cNvPicPr>
             <a:picLocks noChangeAspect="1"/>
           </p:cNvPicPr>
@@ -6278,7 +6278,7 @@
       </p:sp>
       <p:pic>
         <p:nvPicPr>
-          <p:cNvPr id="18" name="icon-232" descr="/tmp/tmp.6gMuyieSku/icons/software-update-available.png">    </p:cNvPr>
+          <p:cNvPr id="18" name="icon-232" descr="/tmp/tmp.eH5VcKLLim/icons/software-update-available.png">    </p:cNvPr>
           <p:cNvPicPr>
             <a:picLocks noChangeAspect="1"/>
           </p:cNvPicPr>
@@ -6358,7 +6358,7 @@
       </p:sp>
       <p:pic>
         <p:nvPicPr>
-          <p:cNvPr id="20" name="companion" descr="/tmp/tmp.6gMuyieSku/img/companion.jpg">    </p:cNvPr>
+          <p:cNvPr id="20" name="companion" descr="/tmp/tmp.eH5VcKLLim/img/companion.jpg">    </p:cNvPr>
           <p:cNvPicPr>
             <a:picLocks noChangeAspect="1"/>
           </p:cNvPicPr>
@@ -7087,7 +7087,7 @@
       </p:sp>
       <p:pic>
         <p:nvPicPr>
-          <p:cNvPr id="7" name="icon-2" descr="/tmp/tmp.6gMuyieSku/icons/edit-undo.png">    </p:cNvPr>
+          <p:cNvPr id="7" name="icon-2" descr="/tmp/tmp.eH5VcKLLim/icons/edit-undo.png">    </p:cNvPr>
           <p:cNvPicPr>
             <a:picLocks noChangeAspect="1"/>
           </p:cNvPicPr>
@@ -7187,7 +7187,7 @@
       </p:sp>
       <p:pic>
         <p:nvPicPr>
-          <p:cNvPr id="10" name="icon-5" descr="/tmp/tmp.6gMuyieSku/icons/software-update-available.png">    </p:cNvPr>
+          <p:cNvPr id="10" name="icon-5" descr="/tmp/tmp.eH5VcKLLim/icons/software-update-available.png">    </p:cNvPr>
           <p:cNvPicPr>
             <a:picLocks noChangeAspect="1"/>
           </p:cNvPicPr>
@@ -7845,7 +7845,7 @@
       </p:sp>
       <p:pic>
         <p:nvPicPr>
-          <p:cNvPr id="5" name="alttab-19" descr="/tmp/tmp.6gMuyieSku/img/alttab.jpg">    </p:cNvPr>
+          <p:cNvPr id="5" name="alttab-19" descr="/tmp/tmp.eH5VcKLLim/img/alttab.jpg">    </p:cNvPr>
           <p:cNvPicPr>
             <a:picLocks noChangeAspect="1"/>
           </p:cNvPicPr>
@@ -7932,7 +7932,7 @@
       </p:sp>
       <p:pic>
         <p:nvPicPr>
-          <p:cNvPr id="8" name="icon-22" descr="/tmp/tmp.6gMuyieSku/icons/view-grid.png">    </p:cNvPr>
+          <p:cNvPr id="8" name="icon-22" descr="/tmp/tmp.eH5VcKLLim/icons/view-grid.png">    </p:cNvPr>
           <p:cNvPicPr>
             <a:picLocks noChangeAspect="1"/>
           </p:cNvPicPr>
@@ -8032,7 +8032,7 @@
       </p:sp>
       <p:pic>
         <p:nvPicPr>
-          <p:cNvPr id="11" name="icon-25" descr="/tmp/tmp.6gMuyieSku/icons/input-touchpad.png">    </p:cNvPr>
+          <p:cNvPr id="11" name="icon-25" descr="/tmp/tmp.eH5VcKLLim/icons/input-touchpad.png">    </p:cNvPr>
           <p:cNvPicPr>
             <a:picLocks noChangeAspect="1"/>
           </p:cNvPicPr>
@@ -8132,7 +8132,7 @@
       </p:sp>
       <p:pic>
         <p:nvPicPr>
-          <p:cNvPr id="14" name="icon-28" descr="/tmp/tmp.6gMuyieSku/icons/view-dual.png">    </p:cNvPr>
+          <p:cNvPr id="14" name="icon-28" descr="/tmp/tmp.eH5VcKLLim/icons/view-dual.png">    </p:cNvPr>
           <p:cNvPicPr>
             <a:picLocks noChangeAspect="1"/>
           </p:cNvPicPr>
@@ -8232,7 +8232,7 @@
       </p:sp>
       <p:pic>
         <p:nvPicPr>
-          <p:cNvPr id="17" name="icon-31" descr="/tmp/tmp.6gMuyieSku/icons/system-run.png">    </p:cNvPr>
+          <p:cNvPr id="17" name="icon-31" descr="/tmp/tmp.eH5VcKLLim/icons/system-run.png">    </p:cNvPr>
           <p:cNvPicPr>
             <a:picLocks noChangeAspect="1"/>
           </p:cNvPicPr>
@@ -8458,7 +8458,7 @@
       </p:sp>
       <p:pic>
         <p:nvPicPr>
-          <p:cNvPr id="5" name="tiled-33" descr="/tmp/tmp.6gMuyieSku/img/tiled.jpg">    </p:cNvPr>
+          <p:cNvPr id="5" name="tiled-33" descr="/tmp/tmp.eH5VcKLLim/img/tiled.jpg">    </p:cNvPr>
           <p:cNvPicPr>
             <a:picLocks noChangeAspect="1"/>
           </p:cNvPicPr>
@@ -8545,7 +8545,7 @@
       </p:sp>
       <p:pic>
         <p:nvPicPr>
-          <p:cNvPr id="8" name="icon-36" descr="/tmp/tmp.6gMuyieSku/icons/view-dual.png">    </p:cNvPr>
+          <p:cNvPr id="8" name="icon-36" descr="/tmp/tmp.eH5VcKLLim/icons/view-dual.png">    </p:cNvPr>
           <p:cNvPicPr>
             <a:picLocks noChangeAspect="1"/>
           </p:cNvPicPr>
@@ -8645,7 +8645,7 @@
       </p:sp>
       <p:pic>
         <p:nvPicPr>
-          <p:cNvPr id="11" name="icon-39" descr="/tmp/tmp.6gMuyieSku/icons/window-new.png">    </p:cNvPr>
+          <p:cNvPr id="11" name="icon-39" descr="/tmp/tmp.eH5VcKLLim/icons/window-new.png">    </p:cNvPr>
           <p:cNvPicPr>
             <a:picLocks noChangeAspect="1"/>
           </p:cNvPicPr>
@@ -8745,7 +8745,7 @@
       </p:sp>
       <p:pic>
         <p:nvPicPr>
-          <p:cNvPr id="14" name="icon-42" descr="/tmp/tmp.6gMuyieSku/icons/view-pin.png">    </p:cNvPr>
+          <p:cNvPr id="14" name="icon-42" descr="/tmp/tmp.eH5VcKLLim/icons/view-pin.png">    </p:cNvPr>
           <p:cNvPicPr>
             <a:picLocks noChangeAspect="1"/>
           </p:cNvPicPr>
@@ -8845,7 +8845,7 @@
       </p:sp>
       <p:pic>
         <p:nvPicPr>
-          <p:cNvPr id="17" name="icon-45" descr="/tmp/tmp.6gMuyieSku/icons/view-grid.png">    </p:cNvPr>
+          <p:cNvPr id="17" name="icon-45" descr="/tmp/tmp.eH5VcKLLim/icons/view-grid.png">    </p:cNvPr>
           <p:cNvPicPr>
             <a:picLocks noChangeAspect="1"/>
           </p:cNvPicPr>
@@ -9071,7 +9071,7 @@
       </p:sp>
       <p:pic>
         <p:nvPicPr>
-          <p:cNvPr id="5" name="welcome-47" descr="/tmp/tmp.6gMuyieSku/img/welcome.jpg">    </p:cNvPr>
+          <p:cNvPr id="5" name="welcome-47" descr="/tmp/tmp.eH5VcKLLim/img/welcome.jpg">    </p:cNvPr>
           <p:cNvPicPr>
             <a:picLocks noChangeAspect="1"/>
           </p:cNvPicPr>
@@ -9158,7 +9158,7 @@
       </p:sp>
       <p:pic>
         <p:nvPicPr>
-          <p:cNvPr id="8" name="icon-50" descr="/tmp/tmp.6gMuyieSku/icons/weather-clear-night.png">    </p:cNvPr>
+          <p:cNvPr id="8" name="icon-50" descr="/tmp/tmp.eH5VcKLLim/icons/weather-clear-night.png">    </p:cNvPr>
           <p:cNvPicPr>
             <a:picLocks noChangeAspect="1"/>
           </p:cNvPicPr>
@@ -9258,7 +9258,7 @@
       </p:sp>
       <p:pic>
         <p:nvPicPr>
-          <p:cNvPr id="11" name="icon-53" descr="/tmp/tmp.6gMuyieSku/icons/view-pin.png">    </p:cNvPr>
+          <p:cNvPr id="11" name="icon-53" descr="/tmp/tmp.eH5VcKLLim/icons/view-pin.png">    </p:cNvPr>
           <p:cNvPicPr>
             <a:picLocks noChangeAspect="1"/>
           </p:cNvPicPr>
@@ -9358,7 +9358,7 @@
       </p:sp>
       <p:pic>
         <p:nvPicPr>
-          <p:cNvPr id="14" name="icon-56" descr="/tmp/tmp.6gMuyieSku/icons/face-smile.png">    </p:cNvPr>
+          <p:cNvPr id="14" name="icon-56" descr="/tmp/tmp.eH5VcKLLim/icons/face-smile.png">    </p:cNvPr>
           <p:cNvPicPr>
             <a:picLocks noChangeAspect="1"/>
           </p:cNvPicPr>
@@ -9458,7 +9458,7 @@
       </p:sp>
       <p:pic>
         <p:nvPicPr>
-          <p:cNvPr id="17" name="icon-59" descr="/tmp/tmp.6gMuyieSku/icons/preferences-color.png">    </p:cNvPr>
+          <p:cNvPr id="17" name="icon-59" descr="/tmp/tmp.eH5VcKLLim/icons/preferences-color.png">    </p:cNvPr>
           <p:cNvPicPr>
             <a:picLocks noChangeAspect="1"/>
           </p:cNvPicPr>
@@ -9684,7 +9684,7 @@
       </p:sp>
       <p:pic>
         <p:nvPicPr>
-          <p:cNvPr id="5" name="notes-split-61" descr="/tmp/tmp.6gMuyieSku/img/notes-split.jpg">    </p:cNvPr>
+          <p:cNvPr id="5" name="notes-split-61" descr="/tmp/tmp.eH5VcKLLim/img/notes-split.jpg">    </p:cNvPr>
           <p:cNvPicPr>
             <a:picLocks noChangeAspect="1"/>
           </p:cNvPicPr>
@@ -9715,7 +9715,7 @@
       </p:pic>
       <p:pic>
         <p:nvPicPr>
-          <p:cNvPr id="6" name="phone" descr="/tmp/tmp.6gMuyieSku/img/phone-note.jpg">    </p:cNvPr>
+          <p:cNvPr id="6" name="phone" descr="/tmp/tmp.eH5VcKLLim/img/phone-note.jpg">    </p:cNvPr>
           <p:cNvPicPr>
             <a:picLocks noChangeAspect="1"/>
           </p:cNvPicPr>
@@ -9802,7 +9802,7 @@
       </p:sp>
       <p:pic>
         <p:nvPicPr>
-          <p:cNvPr id="9" name="icon-64" descr="/tmp/tmp.6gMuyieSku/icons/x-office-document.png">    </p:cNvPr>
+          <p:cNvPr id="9" name="icon-64" descr="/tmp/tmp.eH5VcKLLim/icons/x-office-document.png">    </p:cNvPr>
           <p:cNvPicPr>
             <a:picLocks noChangeAspect="1"/>
           </p:cNvPicPr>
@@ -9902,7 +9902,7 @@
       </p:sp>
       <p:pic>
         <p:nvPicPr>
-          <p:cNvPr id="12" name="icon-67" descr="/tmp/tmp.6gMuyieSku/icons/network-workgroup.png">    </p:cNvPr>
+          <p:cNvPr id="12" name="icon-67" descr="/tmp/tmp.eH5VcKLLim/icons/network-workgroup.png">    </p:cNvPr>
           <p:cNvPicPr>
             <a:picLocks noChangeAspect="1"/>
           </p:cNvPicPr>
@@ -10002,7 +10002,7 @@
       </p:sp>
       <p:pic>
         <p:nvPicPr>
-          <p:cNvPr id="15" name="icon-70" descr="/tmp/tmp.6gMuyieSku/icons/applications-graphics.png">    </p:cNvPr>
+          <p:cNvPr id="15" name="icon-70" descr="/tmp/tmp.eH5VcKLLim/icons/applications-graphics.png">    </p:cNvPr>
           <p:cNvPicPr>
             <a:picLocks noChangeAspect="1"/>
           </p:cNvPicPr>
@@ -10102,7 +10102,7 @@
       </p:sp>
       <p:pic>
         <p:nvPicPr>
-          <p:cNvPr id="18" name="icon-73" descr="/tmp/tmp.6gMuyieSku/icons/edit-paste.png">    </p:cNvPr>
+          <p:cNvPr id="18" name="icon-73" descr="/tmp/tmp.eH5VcKLLim/icons/edit-paste.png">    </p:cNvPr>
           <p:cNvPicPr>
             <a:picLocks noChangeAspect="1"/>
           </p:cNvPicPr>
@@ -10370,7 +10370,7 @@
       </p:sp>
       <p:pic>
         <p:nvPicPr>
-          <p:cNvPr id="7" name="icon-77" descr="/tmp/tmp.6gMuyieSku/icons/emblem-system.png">    </p:cNvPr>
+          <p:cNvPr id="7" name="icon-77" descr="/tmp/tmp.eH5VcKLLim/icons/emblem-system.png">    </p:cNvPr>
           <p:cNvPicPr>
             <a:picLocks noChangeAspect="1"/>
           </p:cNvPicPr>
@@ -10492,7 +10492,7 @@
       </p:sp>
       <p:pic>
         <p:nvPicPr>
-          <p:cNvPr id="11" name="icon-81" descr="/tmp/tmp.6gMuyieSku/icons/x-office-document.png">    </p:cNvPr>
+          <p:cNvPr id="11" name="icon-81" descr="/tmp/tmp.eH5VcKLLim/icons/x-office-document.png">    </p:cNvPr>
           <p:cNvPicPr>
             <a:picLocks noChangeAspect="1"/>
           </p:cNvPicPr>
@@ -10614,7 +10614,7 @@
       </p:sp>
       <p:pic>
         <p:nvPicPr>
-          <p:cNvPr id="15" name="icon-85" descr="/tmp/tmp.6gMuyieSku/icons/network-workgroup.png">    </p:cNvPr>
+          <p:cNvPr id="15" name="icon-85" descr="/tmp/tmp.eH5VcKLLim/icons/network-workgroup.png">    </p:cNvPr>
           <p:cNvPicPr>
             <a:picLocks noChangeAspect="1"/>
           </p:cNvPicPr>
@@ -10736,7 +10736,7 @@
       </p:sp>
       <p:pic>
         <p:nvPicPr>
-          <p:cNvPr id="19" name="icon-89" descr="/tmp/tmp.6gMuyieSku/icons/document-open-recent.png">    </p:cNvPr>
+          <p:cNvPr id="19" name="icon-89" descr="/tmp/tmp.eH5VcKLLim/icons/document-open-recent.png">    </p:cNvPr>
           <p:cNvPicPr>
             <a:picLocks noChangeAspect="1"/>
           </p:cNvPicPr>
@@ -10858,7 +10858,7 @@
       </p:sp>
       <p:pic>
         <p:nvPicPr>
-          <p:cNvPr id="23" name="icon-93" descr="/tmp/tmp.6gMuyieSku/icons/x-office-calendar.png">    </p:cNvPr>
+          <p:cNvPr id="23" name="icon-93" descr="/tmp/tmp.eH5VcKLLim/icons/x-office-calendar.png">    </p:cNvPr>
           <p:cNvPicPr>
             <a:picLocks noChangeAspect="1"/>
           </p:cNvPicPr>
@@ -10980,7 +10980,7 @@
       </p:sp>
       <p:pic>
         <p:nvPicPr>
-          <p:cNvPr id="27" name="icon-97" descr="/tmp/tmp.6gMuyieSku/icons/checkbox-checked.png">    </p:cNvPr>
+          <p:cNvPr id="27" name="icon-97" descr="/tmp/tmp.eH5VcKLLim/icons/checkbox-checked.png">    </p:cNvPr>
           <p:cNvPicPr>
             <a:picLocks noChangeAspect="1"/>
           </p:cNvPicPr>
@@ -11102,7 +11102,7 @@
       </p:sp>
       <p:pic>
         <p:nvPicPr>
-          <p:cNvPr id="31" name="icon-101" descr="/tmp/tmp.6gMuyieSku/icons/edit-paste.png">    </p:cNvPr>
+          <p:cNvPr id="31" name="icon-101" descr="/tmp/tmp.eH5VcKLLim/icons/edit-paste.png">    </p:cNvPr>
           <p:cNvPicPr>
             <a:picLocks noChangeAspect="1"/>
           </p:cNvPicPr>
@@ -11224,7 +11224,7 @@
       </p:sp>
       <p:pic>
         <p:nvPicPr>
-          <p:cNvPr id="35" name="icon-105" descr="/tmp/tmp.6gMuyieSku/icons/preferences-color.png">    </p:cNvPr>
+          <p:cNvPr id="35" name="icon-105" descr="/tmp/tmp.eH5VcKLLim/icons/preferences-color.png">    </p:cNvPr>
           <p:cNvPicPr>
             <a:picLocks noChangeAspect="1"/>
           </p:cNvPicPr>
@@ -11450,7 +11450,7 @@
       </p:sp>
       <p:pic>
         <p:nvPicPr>
-          <p:cNvPr id="5" name="scene-web-107" descr="/tmp/tmp.6gMuyieSku/img/scene-web.jpg">    </p:cNvPr>
+          <p:cNvPr id="5" name="scene-web-107" descr="/tmp/tmp.eH5VcKLLim/img/scene-web.jpg">    </p:cNvPr>
           <p:cNvPicPr>
             <a:picLocks noChangeAspect="1"/>
           </p:cNvPicPr>
@@ -11481,7 +11481,7 @@
       </p:pic>
       <p:pic>
         <p:nvPicPr>
-          <p:cNvPr id="6" name="scene-knight-108" descr="/tmp/tmp.6gMuyieSku/img/scene-knight.jpg">    </p:cNvPr>
+          <p:cNvPr id="6" name="scene-knight-108" descr="/tmp/tmp.eH5VcKLLim/img/scene-knight.jpg">    </p:cNvPr>
           <p:cNvPicPr>
             <a:picLocks noChangeAspect="1"/>
           </p:cNvPicPr>
@@ -11512,7 +11512,7 @@
       </p:pic>
       <p:pic>
         <p:nvPicPr>
-          <p:cNvPr id="7" name="scene-matrix-109" descr="/tmp/tmp.6gMuyieSku/img/scene-matrix.jpg">    </p:cNvPr>
+          <p:cNvPr id="7" name="scene-matrix-109" descr="/tmp/tmp.eH5VcKLLim/img/scene-matrix.jpg">    </p:cNvPr>
           <p:cNvPicPr>
             <a:picLocks noChangeAspect="1"/>
           </p:cNvPicPr>
@@ -11571,7 +11571,7 @@
                   <a:schemeClr val="tx2"/>
                 </a:solidFill>
               </a:rPr>
-              <a:t>Web Hang · Night Watch · Neon Cascade</a:t>
+              <a:t>Web Hang · Night Watch · Terminal Stream</a:t>
             </a:r>
             <a:endParaRPr lang="en-US" sz="1000" dirty="0"/>
           </a:p>
@@ -11599,7 +11599,7 @@
       </p:sp>
       <p:pic>
         <p:nvPicPr>
-          <p:cNvPr id="10" name="icon-112" descr="/tmp/tmp.6gMuyieSku/icons/weather-clear-night.png">    </p:cNvPr>
+          <p:cNvPr id="10" name="icon-112" descr="/tmp/tmp.eH5VcKLLim/icons/weather-clear-night.png">    </p:cNvPr>
           <p:cNvPicPr>
             <a:picLocks noChangeAspect="1"/>
           </p:cNvPicPr>
@@ -11699,7 +11699,7 @@
       </p:sp>
       <p:pic>
         <p:nvPicPr>
-          <p:cNvPr id="13" name="icon-115" descr="/tmp/tmp.6gMuyieSku/icons/video-display.png">    </p:cNvPr>
+          <p:cNvPr id="13" name="icon-115" descr="/tmp/tmp.eH5VcKLLim/icons/video-display.png">    </p:cNvPr>
           <p:cNvPicPr>
             <a:picLocks noChangeAspect="1"/>
           </p:cNvPicPr>
@@ -11799,7 +11799,7 @@
       </p:sp>
       <p:pic>
         <p:nvPicPr>
-          <p:cNvPr id="16" name="icon-118" descr="/tmp/tmp.6gMuyieSku/icons/alarm.png">    </p:cNvPr>
+          <p:cNvPr id="16" name="icon-118" descr="/tmp/tmp.eH5VcKLLim/icons/alarm.png">    </p:cNvPr>
           <p:cNvPicPr>
             <a:picLocks noChangeAspect="1"/>
           </p:cNvPicPr>
@@ -11899,7 +11899,7 @@
       </p:sp>
       <p:pic>
         <p:nvPicPr>
-          <p:cNvPr id="19" name="icon-121" descr="/tmp/tmp.6gMuyieSku/icons/system-run.png">    </p:cNvPr>
+          <p:cNvPr id="19" name="icon-121" descr="/tmp/tmp.eH5VcKLLim/icons/system-run.png">    </p:cNvPr>
           <p:cNvPicPr>
             <a:picLocks noChangeAspect="1"/>
           </p:cNvPicPr>
@@ -12125,7 +12125,7 @@
       </p:sp>
       <p:pic>
         <p:nvPicPr>
-          <p:cNvPr id="5" name="monitor" descr="/tmp/tmp.6gMuyieSku/img/speedtest.jpg">    </p:cNvPr>
+          <p:cNvPr id="5" name="monitor" descr="/tmp/tmp.eH5VcKLLim/img/speedtest.jpg">    </p:cNvPr>
           <p:cNvPicPr>
             <a:picLocks noChangeAspect="1"/>
           </p:cNvPicPr>
@@ -12156,7 +12156,7 @@
       </p:pic>
       <p:pic>
         <p:nvPicPr>
-          <p:cNvPr id="6" name="media" descr="/tmp/tmp.6gMuyieSku/img/media.jpg">    </p:cNvPr>
+          <p:cNvPr id="6" name="media" descr="/tmp/tmp.eH5VcKLLim/img/media.jpg">    </p:cNvPr>
           <p:cNvPicPr>
             <a:picLocks noChangeAspect="1"/>
           </p:cNvPicPr>
@@ -12243,7 +12243,7 @@
       </p:sp>
       <p:pic>
         <p:nvPicPr>
-          <p:cNvPr id="9" name="icon-125" descr="/tmp/tmp.6gMuyieSku/icons/video-display.png">    </p:cNvPr>
+          <p:cNvPr id="9" name="icon-125" descr="/tmp/tmp.eH5VcKLLim/icons/video-display.png">    </p:cNvPr>
           <p:cNvPicPr>
             <a:picLocks noChangeAspect="1"/>
           </p:cNvPicPr>
@@ -12343,7 +12343,7 @@
       </p:sp>
       <p:pic>
         <p:nvPicPr>
-          <p:cNvPr id="12" name="icon-128" descr="/tmp/tmp.6gMuyieSku/icons/network-workgroup.png">    </p:cNvPr>
+          <p:cNvPr id="12" name="icon-128" descr="/tmp/tmp.eH5VcKLLim/icons/network-workgroup.png">    </p:cNvPr>
           <p:cNvPicPr>
             <a:picLocks noChangeAspect="1"/>
           </p:cNvPicPr>
@@ -12443,7 +12443,7 @@
       </p:sp>
       <p:pic>
         <p:nvPicPr>
-          <p:cNvPr id="15" name="icon-131" descr="/tmp/tmp.6gMuyieSku/icons/audio-speakers.png">    </p:cNvPr>
+          <p:cNvPr id="15" name="icon-131" descr="/tmp/tmp.eH5VcKLLim/icons/audio-speakers.png">    </p:cNvPr>
           <p:cNvPicPr>
             <a:picLocks noChangeAspect="1"/>
           </p:cNvPicPr>
@@ -12543,7 +12543,7 @@
       </p:sp>
       <p:pic>
         <p:nvPicPr>
-          <p:cNvPr id="18" name="icon-134" descr="/tmp/tmp.6gMuyieSku/icons/edit-paste.png">    </p:cNvPr>
+          <p:cNvPr id="18" name="icon-134" descr="/tmp/tmp.eH5VcKLLim/icons/edit-paste.png">    </p:cNvPr>
           <p:cNvPicPr>
             <a:picLocks noChangeAspect="1"/>
           </p:cNvPicPr>

</xml_diff>

<commit_message>
docs(overview): rebuilt with the new scenes
Co-Authored-By: Claude Opus 5.5 <noreply@anthropic.com>
</commit_message>
<xml_diff>
--- a/docs/MK-Workstation-Overview.pptx
+++ b/docs/MK-Workstation-Overview.pptx
@@ -120,40 +120,40 @@
   <p:extLst>
     <p:ext uri="{521415D9-36F7-43E2-AB2F-B90AF26B5E84}">
       <p14:sectionLst xmlns:p14="http://schemas.microsoft.com/office/powerpoint/2010/main">
-        <p14:section name="Introduction" id="{e3385471-325c-8d67-b654-6364441ec19c}">
+        <p14:section name="Introduction" id="{d0c28f12-fd1b-47b9-147a-85a3787846ab}">
           <p14:sldIdLst>
             <p14:sldId id="256"/>
             <p14:sldId id="257"/>
           </p14:sldIdLst>
         </p14:section>
-        <p14:section name="Your desktop" id="{8c0400c4-0880-ee2e-6621-cc2a3d98a047}">
+        <p14:section name="Your desktop" id="{cf2e1826-4059-ac21-a216-4a7a74dec242}">
           <p14:sldIdLst>
             <p14:sldId id="258"/>
             <p14:sldId id="259"/>
             <p14:sldId id="260"/>
           </p14:sldIdLst>
         </p14:section>
-        <p14:section name="MK Notes" id="{3500a1fa-320d-b034-39ec-ab7bdb423838}">
+        <p14:section name="MK Notes" id="{2fb061a0-04f0-cad2-35d7-d40e4e954b13}">
           <p14:sldIdLst>
             <p14:sldId id="261"/>
             <p14:sldId id="262"/>
           </p14:sldIdLst>
         </p14:section>
-        <p14:section name="Focus and tools" id="{28ff21e4-545a-1a57-4628-cf4fc7b7338a}">
+        <p14:section name="Focus and tools" id="{00d293c6-e6b2-a4b9-6acd-33f0ffbdb07f}">
           <p14:sldIdLst>
             <p14:sldId id="263"/>
             <p14:sldId id="264"/>
             <p14:sldId id="265"/>
           </p14:sldIdLst>
         </p14:section>
-        <p14:section name="Your computer" id="{36f144a2-31e9-67a0-554a-d2a48d7c57fd}">
+        <p14:section name="Your computer" id="{c1dd1d32-45e2-8bc2-1933-2d9d92df88e5}">
           <p14:sldIdLst>
             <p14:sldId id="266"/>
             <p14:sldId id="267"/>
             <p14:sldId id="268"/>
           </p14:sldIdLst>
         </p14:section>
-        <p14:section name="Get started" id="{d440eb97-198e-6a9b-3119-0e31e8c25122}">
+        <p14:section name="Get started" id="{a43d4c65-8ab1-56c3-884a-44c40d7161aa}">
           <p14:sldIdLst>
             <p14:sldId id="269"/>
           </p14:sldIdLst>
@@ -2533,7 +2533,7 @@
       </p:grpSpPr>
       <p:pic>
         <p:nvPicPr>
-          <p:cNvPr id="2" name="hero" descr="/tmp/tmp.eH5VcKLLim/img/welcome.jpg">    </p:cNvPr>
+          <p:cNvPr id="2" name="hero" descr="/tmp/tmp.U4D0us9tfa/img/welcome.jpg">    </p:cNvPr>
           <p:cNvPicPr>
             <a:picLocks noChangeAspect="1"/>
           </p:cNvPicPr>
@@ -2805,7 +2805,7 @@
       </p:sp>
       <p:pic>
         <p:nvPicPr>
-          <p:cNvPr id="5" name="app-136" descr="/tmp/tmp.eH5VcKLLim/apps/app.zen_browser.zen.png">    </p:cNvPr>
+          <p:cNvPr id="5" name="app-136" descr="/tmp/tmp.U4D0us9tfa/apps/app.zen_browser.zen.png">    </p:cNvPr>
           <p:cNvPicPr>
             <a:picLocks noChangeAspect="1"/>
           </p:cNvPicPr>
@@ -2865,7 +2865,7 @@
       </p:sp>
       <p:pic>
         <p:nvPicPr>
-          <p:cNvPr id="7" name="app-138" descr="/tmp/tmp.eH5VcKLLim/apps/net.cozic.joplin_desktop.png">    </p:cNvPr>
+          <p:cNvPr id="7" name="app-138" descr="/tmp/tmp.U4D0us9tfa/apps/net.cozic.joplin_desktop.png">    </p:cNvPr>
           <p:cNvPicPr>
             <a:picLocks noChangeAspect="1"/>
           </p:cNvPicPr>
@@ -2925,7 +2925,7 @@
       </p:sp>
       <p:pic>
         <p:nvPicPr>
-          <p:cNvPr id="9" name="app-140" descr="/tmp/tmp.eH5VcKLLim/apps/org.onlyoffice.desktopeditors.png">    </p:cNvPr>
+          <p:cNvPr id="9" name="app-140" descr="/tmp/tmp.U4D0us9tfa/apps/org.onlyoffice.desktopeditors.png">    </p:cNvPr>
           <p:cNvPicPr>
             <a:picLocks noChangeAspect="1"/>
           </p:cNvPicPr>
@@ -2985,7 +2985,7 @@
       </p:sp>
       <p:pic>
         <p:nvPicPr>
-          <p:cNvPr id="11" name="app-142" descr="/tmp/tmp.eH5VcKLLim/apps/vscode.png">    </p:cNvPr>
+          <p:cNvPr id="11" name="app-142" descr="/tmp/tmp.U4D0us9tfa/apps/vscode.png">    </p:cNvPr>
           <p:cNvPicPr>
             <a:picLocks noChangeAspect="1"/>
           </p:cNvPicPr>
@@ -3045,7 +3045,7 @@
       </p:sp>
       <p:pic>
         <p:nvPicPr>
-          <p:cNvPr id="13" name="app-144" descr="/tmp/tmp.eH5VcKLLim/apps/com.spotify.Client.png">    </p:cNvPr>
+          <p:cNvPr id="13" name="app-144" descr="/tmp/tmp.U4D0us9tfa/apps/com.spotify.Client.png">    </p:cNvPr>
           <p:cNvPicPr>
             <a:picLocks noChangeAspect="1"/>
           </p:cNvPicPr>
@@ -3105,7 +3105,7 @@
       </p:sp>
       <p:pic>
         <p:nvPicPr>
-          <p:cNvPr id="15" name="app-146" descr="/tmp/tmp.eH5VcKLLim/apps/net.lutris.Lutris.png">    </p:cNvPr>
+          <p:cNvPr id="15" name="app-146" descr="/tmp/tmp.U4D0us9tfa/apps/net.lutris.Lutris.png">    </p:cNvPr>
           <p:cNvPicPr>
             <a:picLocks noChangeAspect="1"/>
           </p:cNvPicPr>
@@ -3165,7 +3165,7 @@
       </p:sp>
       <p:pic>
         <p:nvPicPr>
-          <p:cNvPr id="17" name="app-148" descr="/tmp/tmp.eH5VcKLLim/apps/com.mattjakeman.ExtensionManager.png">    </p:cNvPr>
+          <p:cNvPr id="17" name="app-148" descr="/tmp/tmp.U4D0us9tfa/apps/com.mattjakeman.ExtensionManager.png">    </p:cNvPr>
           <p:cNvPicPr>
             <a:picLocks noChangeAspect="1"/>
           </p:cNvPicPr>
@@ -3225,7 +3225,7 @@
       </p:sp>
       <p:pic>
         <p:nvPicPr>
-          <p:cNvPr id="19" name="app-150" descr="/tmp/tmp.eH5VcKLLim/apps/net.sonobus.SonoBus.png">    </p:cNvPr>
+          <p:cNvPr id="19" name="app-150" descr="/tmp/tmp.U4D0us9tfa/apps/net.sonobus.SonoBus.png">    </p:cNvPr>
           <p:cNvPicPr>
             <a:picLocks noChangeAspect="1"/>
           </p:cNvPicPr>
@@ -3285,7 +3285,7 @@
       </p:sp>
       <p:pic>
         <p:nvPicPr>
-          <p:cNvPr id="21" name="app-152" descr="/tmp/tmp.eH5VcKLLim/apps/com.github.tenderowl.frog.png">    </p:cNvPr>
+          <p:cNvPr id="21" name="app-152" descr="/tmp/tmp.U4D0us9tfa/apps/com.github.tenderowl.frog.png">    </p:cNvPr>
           <p:cNvPicPr>
             <a:picLocks noChangeAspect="1"/>
           </p:cNvPicPr>
@@ -3345,7 +3345,7 @@
       </p:sp>
       <p:pic>
         <p:nvPicPr>
-          <p:cNvPr id="23" name="app-154" descr="/tmp/tmp.eH5VcKLLim/apps/one.alynx.FlipClock.png">    </p:cNvPr>
+          <p:cNvPr id="23" name="app-154" descr="/tmp/tmp.U4D0us9tfa/apps/one.alynx.FlipClock.png">    </p:cNvPr>
           <p:cNvPicPr>
             <a:picLocks noChangeAspect="1"/>
           </p:cNvPicPr>
@@ -3405,7 +3405,7 @@
       </p:sp>
       <p:pic>
         <p:nvPicPr>
-          <p:cNvPr id="25" name="app-156" descr="/tmp/tmp.eH5VcKLLim/apps/io.github.mehulk.MkNotes.png">    </p:cNvPr>
+          <p:cNvPr id="25" name="app-156" descr="/tmp/tmp.U4D0us9tfa/apps/io.github.mehulk.MkNotes.png">    </p:cNvPr>
           <p:cNvPicPr>
             <a:picLocks noChangeAspect="1"/>
           </p:cNvPicPr>
@@ -3465,7 +3465,7 @@
       </p:sp>
       <p:pic>
         <p:nvPicPr>
-          <p:cNvPr id="27" name="app-158" descr="/tmp/tmp.eH5VcKLLim/apps/io.github.mehulk.MkCompanion.png">    </p:cNvPr>
+          <p:cNvPr id="27" name="app-158" descr="/tmp/tmp.U4D0us9tfa/apps/io.github.mehulk.MkCompanion.png">    </p:cNvPr>
           <p:cNvPicPr>
             <a:picLocks noChangeAspect="1"/>
           </p:cNvPicPr>
@@ -3525,7 +3525,7 @@
       </p:sp>
       <p:pic>
         <p:nvPicPr>
-          <p:cNvPr id="29" name="app-160" descr="/tmp/tmp.eH5VcKLLim/apps/io.github.mehulk.MkTimer.png">    </p:cNvPr>
+          <p:cNvPr id="29" name="app-160" descr="/tmp/tmp.U4D0us9tfa/apps/io.github.mehulk.MkTimer.png">    </p:cNvPr>
           <p:cNvPicPr>
             <a:picLocks noChangeAspect="1"/>
           </p:cNvPicPr>
@@ -3585,7 +3585,7 @@
       </p:sp>
       <p:pic>
         <p:nvPicPr>
-          <p:cNvPr id="31" name="app-162" descr="/tmp/tmp.eH5VcKLLim/apps/io.github.mehulk.MkShortcuts.png">    </p:cNvPr>
+          <p:cNvPr id="31" name="app-162" descr="/tmp/tmp.U4D0us9tfa/apps/io.github.mehulk.MkShortcuts.png">    </p:cNvPr>
           <p:cNvPicPr>
             <a:picLocks noChangeAspect="1"/>
           </p:cNvPicPr>
@@ -3869,7 +3869,7 @@
       </p:sp>
       <p:pic>
         <p:nvPicPr>
-          <p:cNvPr id="7" name="icon-166" descr="/tmp/tmp.eH5VcKLLim/icons/auth-fingerprint.png">    </p:cNvPr>
+          <p:cNvPr id="7" name="icon-166" descr="/tmp/tmp.U4D0us9tfa/icons/auth-fingerprint.png">    </p:cNvPr>
           <p:cNvPicPr>
             <a:picLocks noChangeAspect="1"/>
           </p:cNvPicPr>
@@ -3991,7 +3991,7 @@
       </p:sp>
       <p:pic>
         <p:nvPicPr>
-          <p:cNvPr id="11" name="icon-170" descr="/tmp/tmp.eH5VcKLLim/icons/battery-full.png">    </p:cNvPr>
+          <p:cNvPr id="11" name="icon-170" descr="/tmp/tmp.U4D0us9tfa/icons/battery-full.png">    </p:cNvPr>
           <p:cNvPicPr>
             <a:picLocks noChangeAspect="1"/>
           </p:cNvPicPr>
@@ -4113,7 +4113,7 @@
       </p:sp>
       <p:pic>
         <p:nvPicPr>
-          <p:cNvPr id="15" name="icon-174" descr="/tmp/tmp.eH5VcKLLim/icons/audio-speakers.png">    </p:cNvPr>
+          <p:cNvPr id="15" name="icon-174" descr="/tmp/tmp.U4D0us9tfa/icons/audio-speakers.png">    </p:cNvPr>
           <p:cNvPicPr>
             <a:picLocks noChangeAspect="1"/>
           </p:cNvPicPr>
@@ -4235,7 +4235,7 @@
       </p:sp>
       <p:pic>
         <p:nvPicPr>
-          <p:cNvPr id="19" name="icon-178" descr="/tmp/tmp.eH5VcKLLim/icons/input-tablet.png">    </p:cNvPr>
+          <p:cNvPr id="19" name="icon-178" descr="/tmp/tmp.U4D0us9tfa/icons/input-tablet.png">    </p:cNvPr>
           <p:cNvPicPr>
             <a:picLocks noChangeAspect="1"/>
           </p:cNvPicPr>
@@ -4357,7 +4357,7 @@
       </p:sp>
       <p:pic>
         <p:nvPicPr>
-          <p:cNvPr id="23" name="icon-182" descr="/tmp/tmp.eH5VcKLLim/icons/video-display.png">    </p:cNvPr>
+          <p:cNvPr id="23" name="icon-182" descr="/tmp/tmp.U4D0us9tfa/icons/video-display.png">    </p:cNvPr>
           <p:cNvPicPr>
             <a:picLocks noChangeAspect="1"/>
           </p:cNvPicPr>
@@ -4479,7 +4479,7 @@
       </p:sp>
       <p:pic>
         <p:nvPicPr>
-          <p:cNvPr id="27" name="icon-186" descr="/tmp/tmp.eH5VcKLLim/icons/system-run.png">    </p:cNvPr>
+          <p:cNvPr id="27" name="icon-186" descr="/tmp/tmp.U4D0us9tfa/icons/system-run.png">    </p:cNvPr>
           <p:cNvPicPr>
             <a:picLocks noChangeAspect="1"/>
           </p:cNvPicPr>
@@ -5645,7 +5645,7 @@
       </p:sp>
       <p:pic>
         <p:nvPicPr>
-          <p:cNvPr id="35" name="shortcuts" descr="/tmp/tmp.eH5VcKLLim/img/shortcuts.jpg">    </p:cNvPr>
+          <p:cNvPr id="35" name="shortcuts" descr="/tmp/tmp.U4D0us9tfa/img/shortcuts.jpg">    </p:cNvPr>
           <p:cNvPicPr>
             <a:picLocks noChangeAspect="1"/>
           </p:cNvPicPr>
@@ -5878,7 +5878,7 @@
       </p:sp>
       <p:pic>
         <p:nvPicPr>
-          <p:cNvPr id="6" name="icon-220" descr="/tmp/tmp.eH5VcKLLim/icons/document-open-recent.png">    </p:cNvPr>
+          <p:cNvPr id="6" name="icon-220" descr="/tmp/tmp.U4D0us9tfa/icons/document-open-recent.png">    </p:cNvPr>
           <p:cNvPicPr>
             <a:picLocks noChangeAspect="1"/>
           </p:cNvPicPr>
@@ -5978,7 +5978,7 @@
       </p:sp>
       <p:pic>
         <p:nvPicPr>
-          <p:cNvPr id="9" name="icon-223" descr="/tmp/tmp.eH5VcKLLim/icons/user-trash.png">    </p:cNvPr>
+          <p:cNvPr id="9" name="icon-223" descr="/tmp/tmp.U4D0us9tfa/icons/user-trash.png">    </p:cNvPr>
           <p:cNvPicPr>
             <a:picLocks noChangeAspect="1"/>
           </p:cNvPicPr>
@@ -6078,7 +6078,7 @@
       </p:sp>
       <p:pic>
         <p:nvPicPr>
-          <p:cNvPr id="12" name="icon-226" descr="/tmp/tmp.eH5VcKLLim/icons/checkbox-checked.png">    </p:cNvPr>
+          <p:cNvPr id="12" name="icon-226" descr="/tmp/tmp.U4D0us9tfa/icons/checkbox-checked.png">    </p:cNvPr>
           <p:cNvPicPr>
             <a:picLocks noChangeAspect="1"/>
           </p:cNvPicPr>
@@ -6178,7 +6178,7 @@
       </p:sp>
       <p:pic>
         <p:nvPicPr>
-          <p:cNvPr id="15" name="icon-229" descr="/tmp/tmp.eH5VcKLLim/icons/x-office-document.png">    </p:cNvPr>
+          <p:cNvPr id="15" name="icon-229" descr="/tmp/tmp.U4D0us9tfa/icons/x-office-document.png">    </p:cNvPr>
           <p:cNvPicPr>
             <a:picLocks noChangeAspect="1"/>
           </p:cNvPicPr>
@@ -6278,7 +6278,7 @@
       </p:sp>
       <p:pic>
         <p:nvPicPr>
-          <p:cNvPr id="18" name="icon-232" descr="/tmp/tmp.eH5VcKLLim/icons/software-update-available.png">    </p:cNvPr>
+          <p:cNvPr id="18" name="icon-232" descr="/tmp/tmp.U4D0us9tfa/icons/software-update-available.png">    </p:cNvPr>
           <p:cNvPicPr>
             <a:picLocks noChangeAspect="1"/>
           </p:cNvPicPr>
@@ -6358,7 +6358,7 @@
       </p:sp>
       <p:pic>
         <p:nvPicPr>
-          <p:cNvPr id="20" name="companion" descr="/tmp/tmp.eH5VcKLLim/img/companion.jpg">    </p:cNvPr>
+          <p:cNvPr id="20" name="companion" descr="/tmp/tmp.U4D0us9tfa/img/companion.jpg">    </p:cNvPr>
           <p:cNvPicPr>
             <a:picLocks noChangeAspect="1"/>
           </p:cNvPicPr>
@@ -7087,7 +7087,7 @@
       </p:sp>
       <p:pic>
         <p:nvPicPr>
-          <p:cNvPr id="7" name="icon-2" descr="/tmp/tmp.eH5VcKLLim/icons/edit-undo.png">    </p:cNvPr>
+          <p:cNvPr id="7" name="icon-2" descr="/tmp/tmp.U4D0us9tfa/icons/edit-undo.png">    </p:cNvPr>
           <p:cNvPicPr>
             <a:picLocks noChangeAspect="1"/>
           </p:cNvPicPr>
@@ -7187,7 +7187,7 @@
       </p:sp>
       <p:pic>
         <p:nvPicPr>
-          <p:cNvPr id="10" name="icon-5" descr="/tmp/tmp.eH5VcKLLim/icons/software-update-available.png">    </p:cNvPr>
+          <p:cNvPr id="10" name="icon-5" descr="/tmp/tmp.U4D0us9tfa/icons/software-update-available.png">    </p:cNvPr>
           <p:cNvPicPr>
             <a:picLocks noChangeAspect="1"/>
           </p:cNvPicPr>
@@ -7845,7 +7845,7 @@
       </p:sp>
       <p:pic>
         <p:nvPicPr>
-          <p:cNvPr id="5" name="alttab-19" descr="/tmp/tmp.eH5VcKLLim/img/alttab.jpg">    </p:cNvPr>
+          <p:cNvPr id="5" name="alttab-19" descr="/tmp/tmp.U4D0us9tfa/img/alttab.jpg">    </p:cNvPr>
           <p:cNvPicPr>
             <a:picLocks noChangeAspect="1"/>
           </p:cNvPicPr>
@@ -7932,7 +7932,7 @@
       </p:sp>
       <p:pic>
         <p:nvPicPr>
-          <p:cNvPr id="8" name="icon-22" descr="/tmp/tmp.eH5VcKLLim/icons/view-grid.png">    </p:cNvPr>
+          <p:cNvPr id="8" name="icon-22" descr="/tmp/tmp.U4D0us9tfa/icons/view-grid.png">    </p:cNvPr>
           <p:cNvPicPr>
             <a:picLocks noChangeAspect="1"/>
           </p:cNvPicPr>
@@ -8032,7 +8032,7 @@
       </p:sp>
       <p:pic>
         <p:nvPicPr>
-          <p:cNvPr id="11" name="icon-25" descr="/tmp/tmp.eH5VcKLLim/icons/input-touchpad.png">    </p:cNvPr>
+          <p:cNvPr id="11" name="icon-25" descr="/tmp/tmp.U4D0us9tfa/icons/input-touchpad.png">    </p:cNvPr>
           <p:cNvPicPr>
             <a:picLocks noChangeAspect="1"/>
           </p:cNvPicPr>
@@ -8132,7 +8132,7 @@
       </p:sp>
       <p:pic>
         <p:nvPicPr>
-          <p:cNvPr id="14" name="icon-28" descr="/tmp/tmp.eH5VcKLLim/icons/view-dual.png">    </p:cNvPr>
+          <p:cNvPr id="14" name="icon-28" descr="/tmp/tmp.U4D0us9tfa/icons/view-dual.png">    </p:cNvPr>
           <p:cNvPicPr>
             <a:picLocks noChangeAspect="1"/>
           </p:cNvPicPr>
@@ -8232,7 +8232,7 @@
       </p:sp>
       <p:pic>
         <p:nvPicPr>
-          <p:cNvPr id="17" name="icon-31" descr="/tmp/tmp.eH5VcKLLim/icons/system-run.png">    </p:cNvPr>
+          <p:cNvPr id="17" name="icon-31" descr="/tmp/tmp.U4D0us9tfa/icons/system-run.png">    </p:cNvPr>
           <p:cNvPicPr>
             <a:picLocks noChangeAspect="1"/>
           </p:cNvPicPr>
@@ -8458,7 +8458,7 @@
       </p:sp>
       <p:pic>
         <p:nvPicPr>
-          <p:cNvPr id="5" name="tiled-33" descr="/tmp/tmp.eH5VcKLLim/img/tiled.jpg">    </p:cNvPr>
+          <p:cNvPr id="5" name="tiled-33" descr="/tmp/tmp.U4D0us9tfa/img/tiled.jpg">    </p:cNvPr>
           <p:cNvPicPr>
             <a:picLocks noChangeAspect="1"/>
           </p:cNvPicPr>
@@ -8545,7 +8545,7 @@
       </p:sp>
       <p:pic>
         <p:nvPicPr>
-          <p:cNvPr id="8" name="icon-36" descr="/tmp/tmp.eH5VcKLLim/icons/view-dual.png">    </p:cNvPr>
+          <p:cNvPr id="8" name="icon-36" descr="/tmp/tmp.U4D0us9tfa/icons/view-dual.png">    </p:cNvPr>
           <p:cNvPicPr>
             <a:picLocks noChangeAspect="1"/>
           </p:cNvPicPr>
@@ -8645,7 +8645,7 @@
       </p:sp>
       <p:pic>
         <p:nvPicPr>
-          <p:cNvPr id="11" name="icon-39" descr="/tmp/tmp.eH5VcKLLim/icons/window-new.png">    </p:cNvPr>
+          <p:cNvPr id="11" name="icon-39" descr="/tmp/tmp.U4D0us9tfa/icons/window-new.png">    </p:cNvPr>
           <p:cNvPicPr>
             <a:picLocks noChangeAspect="1"/>
           </p:cNvPicPr>
@@ -8745,7 +8745,7 @@
       </p:sp>
       <p:pic>
         <p:nvPicPr>
-          <p:cNvPr id="14" name="icon-42" descr="/tmp/tmp.eH5VcKLLim/icons/view-pin.png">    </p:cNvPr>
+          <p:cNvPr id="14" name="icon-42" descr="/tmp/tmp.U4D0us9tfa/icons/view-pin.png">    </p:cNvPr>
           <p:cNvPicPr>
             <a:picLocks noChangeAspect="1"/>
           </p:cNvPicPr>
@@ -8845,7 +8845,7 @@
       </p:sp>
       <p:pic>
         <p:nvPicPr>
-          <p:cNvPr id="17" name="icon-45" descr="/tmp/tmp.eH5VcKLLim/icons/view-grid.png">    </p:cNvPr>
+          <p:cNvPr id="17" name="icon-45" descr="/tmp/tmp.U4D0us9tfa/icons/view-grid.png">    </p:cNvPr>
           <p:cNvPicPr>
             <a:picLocks noChangeAspect="1"/>
           </p:cNvPicPr>
@@ -9071,7 +9071,7 @@
       </p:sp>
       <p:pic>
         <p:nvPicPr>
-          <p:cNvPr id="5" name="welcome-47" descr="/tmp/tmp.eH5VcKLLim/img/welcome.jpg">    </p:cNvPr>
+          <p:cNvPr id="5" name="welcome-47" descr="/tmp/tmp.U4D0us9tfa/img/welcome.jpg">    </p:cNvPr>
           <p:cNvPicPr>
             <a:picLocks noChangeAspect="1"/>
           </p:cNvPicPr>
@@ -9158,7 +9158,7 @@
       </p:sp>
       <p:pic>
         <p:nvPicPr>
-          <p:cNvPr id="8" name="icon-50" descr="/tmp/tmp.eH5VcKLLim/icons/weather-clear-night.png">    </p:cNvPr>
+          <p:cNvPr id="8" name="icon-50" descr="/tmp/tmp.U4D0us9tfa/icons/weather-clear-night.png">    </p:cNvPr>
           <p:cNvPicPr>
             <a:picLocks noChangeAspect="1"/>
           </p:cNvPicPr>
@@ -9258,7 +9258,7 @@
       </p:sp>
       <p:pic>
         <p:nvPicPr>
-          <p:cNvPr id="11" name="icon-53" descr="/tmp/tmp.eH5VcKLLim/icons/view-pin.png">    </p:cNvPr>
+          <p:cNvPr id="11" name="icon-53" descr="/tmp/tmp.U4D0us9tfa/icons/view-pin.png">    </p:cNvPr>
           <p:cNvPicPr>
             <a:picLocks noChangeAspect="1"/>
           </p:cNvPicPr>
@@ -9358,7 +9358,7 @@
       </p:sp>
       <p:pic>
         <p:nvPicPr>
-          <p:cNvPr id="14" name="icon-56" descr="/tmp/tmp.eH5VcKLLim/icons/face-smile.png">    </p:cNvPr>
+          <p:cNvPr id="14" name="icon-56" descr="/tmp/tmp.U4D0us9tfa/icons/face-smile.png">    </p:cNvPr>
           <p:cNvPicPr>
             <a:picLocks noChangeAspect="1"/>
           </p:cNvPicPr>
@@ -9458,7 +9458,7 @@
       </p:sp>
       <p:pic>
         <p:nvPicPr>
-          <p:cNvPr id="17" name="icon-59" descr="/tmp/tmp.eH5VcKLLim/icons/preferences-color.png">    </p:cNvPr>
+          <p:cNvPr id="17" name="icon-59" descr="/tmp/tmp.U4D0us9tfa/icons/preferences-color.png">    </p:cNvPr>
           <p:cNvPicPr>
             <a:picLocks noChangeAspect="1"/>
           </p:cNvPicPr>
@@ -9684,7 +9684,7 @@
       </p:sp>
       <p:pic>
         <p:nvPicPr>
-          <p:cNvPr id="5" name="notes-split-61" descr="/tmp/tmp.eH5VcKLLim/img/notes-split.jpg">    </p:cNvPr>
+          <p:cNvPr id="5" name="notes-split-61" descr="/tmp/tmp.U4D0us9tfa/img/notes-split.jpg">    </p:cNvPr>
           <p:cNvPicPr>
             <a:picLocks noChangeAspect="1"/>
           </p:cNvPicPr>
@@ -9715,7 +9715,7 @@
       </p:pic>
       <p:pic>
         <p:nvPicPr>
-          <p:cNvPr id="6" name="phone" descr="/tmp/tmp.eH5VcKLLim/img/phone-note.jpg">    </p:cNvPr>
+          <p:cNvPr id="6" name="phone" descr="/tmp/tmp.U4D0us9tfa/img/phone-note.jpg">    </p:cNvPr>
           <p:cNvPicPr>
             <a:picLocks noChangeAspect="1"/>
           </p:cNvPicPr>
@@ -9802,7 +9802,7 @@
       </p:sp>
       <p:pic>
         <p:nvPicPr>
-          <p:cNvPr id="9" name="icon-64" descr="/tmp/tmp.eH5VcKLLim/icons/x-office-document.png">    </p:cNvPr>
+          <p:cNvPr id="9" name="icon-64" descr="/tmp/tmp.U4D0us9tfa/icons/x-office-document.png">    </p:cNvPr>
           <p:cNvPicPr>
             <a:picLocks noChangeAspect="1"/>
           </p:cNvPicPr>
@@ -9902,7 +9902,7 @@
       </p:sp>
       <p:pic>
         <p:nvPicPr>
-          <p:cNvPr id="12" name="icon-67" descr="/tmp/tmp.eH5VcKLLim/icons/network-workgroup.png">    </p:cNvPr>
+          <p:cNvPr id="12" name="icon-67" descr="/tmp/tmp.U4D0us9tfa/icons/network-workgroup.png">    </p:cNvPr>
           <p:cNvPicPr>
             <a:picLocks noChangeAspect="1"/>
           </p:cNvPicPr>
@@ -10002,7 +10002,7 @@
       </p:sp>
       <p:pic>
         <p:nvPicPr>
-          <p:cNvPr id="15" name="icon-70" descr="/tmp/tmp.eH5VcKLLim/icons/applications-graphics.png">    </p:cNvPr>
+          <p:cNvPr id="15" name="icon-70" descr="/tmp/tmp.U4D0us9tfa/icons/applications-graphics.png">    </p:cNvPr>
           <p:cNvPicPr>
             <a:picLocks noChangeAspect="1"/>
           </p:cNvPicPr>
@@ -10102,7 +10102,7 @@
       </p:sp>
       <p:pic>
         <p:nvPicPr>
-          <p:cNvPr id="18" name="icon-73" descr="/tmp/tmp.eH5VcKLLim/icons/edit-paste.png">    </p:cNvPr>
+          <p:cNvPr id="18" name="icon-73" descr="/tmp/tmp.U4D0us9tfa/icons/edit-paste.png">    </p:cNvPr>
           <p:cNvPicPr>
             <a:picLocks noChangeAspect="1"/>
           </p:cNvPicPr>
@@ -10370,7 +10370,7 @@
       </p:sp>
       <p:pic>
         <p:nvPicPr>
-          <p:cNvPr id="7" name="icon-77" descr="/tmp/tmp.eH5VcKLLim/icons/emblem-system.png">    </p:cNvPr>
+          <p:cNvPr id="7" name="icon-77" descr="/tmp/tmp.U4D0us9tfa/icons/emblem-system.png">    </p:cNvPr>
           <p:cNvPicPr>
             <a:picLocks noChangeAspect="1"/>
           </p:cNvPicPr>
@@ -10492,7 +10492,7 @@
       </p:sp>
       <p:pic>
         <p:nvPicPr>
-          <p:cNvPr id="11" name="icon-81" descr="/tmp/tmp.eH5VcKLLim/icons/x-office-document.png">    </p:cNvPr>
+          <p:cNvPr id="11" name="icon-81" descr="/tmp/tmp.U4D0us9tfa/icons/x-office-document.png">    </p:cNvPr>
           <p:cNvPicPr>
             <a:picLocks noChangeAspect="1"/>
           </p:cNvPicPr>
@@ -10614,7 +10614,7 @@
       </p:sp>
       <p:pic>
         <p:nvPicPr>
-          <p:cNvPr id="15" name="icon-85" descr="/tmp/tmp.eH5VcKLLim/icons/network-workgroup.png">    </p:cNvPr>
+          <p:cNvPr id="15" name="icon-85" descr="/tmp/tmp.U4D0us9tfa/icons/network-workgroup.png">    </p:cNvPr>
           <p:cNvPicPr>
             <a:picLocks noChangeAspect="1"/>
           </p:cNvPicPr>
@@ -10736,7 +10736,7 @@
       </p:sp>
       <p:pic>
         <p:nvPicPr>
-          <p:cNvPr id="19" name="icon-89" descr="/tmp/tmp.eH5VcKLLim/icons/document-open-recent.png">    </p:cNvPr>
+          <p:cNvPr id="19" name="icon-89" descr="/tmp/tmp.U4D0us9tfa/icons/document-open-recent.png">    </p:cNvPr>
           <p:cNvPicPr>
             <a:picLocks noChangeAspect="1"/>
           </p:cNvPicPr>
@@ -10858,7 +10858,7 @@
       </p:sp>
       <p:pic>
         <p:nvPicPr>
-          <p:cNvPr id="23" name="icon-93" descr="/tmp/tmp.eH5VcKLLim/icons/x-office-calendar.png">    </p:cNvPr>
+          <p:cNvPr id="23" name="icon-93" descr="/tmp/tmp.U4D0us9tfa/icons/x-office-calendar.png">    </p:cNvPr>
           <p:cNvPicPr>
             <a:picLocks noChangeAspect="1"/>
           </p:cNvPicPr>
@@ -10980,7 +10980,7 @@
       </p:sp>
       <p:pic>
         <p:nvPicPr>
-          <p:cNvPr id="27" name="icon-97" descr="/tmp/tmp.eH5VcKLLim/icons/checkbox-checked.png">    </p:cNvPr>
+          <p:cNvPr id="27" name="icon-97" descr="/tmp/tmp.U4D0us9tfa/icons/checkbox-checked.png">    </p:cNvPr>
           <p:cNvPicPr>
             <a:picLocks noChangeAspect="1"/>
           </p:cNvPicPr>
@@ -11102,7 +11102,7 @@
       </p:sp>
       <p:pic>
         <p:nvPicPr>
-          <p:cNvPr id="31" name="icon-101" descr="/tmp/tmp.eH5VcKLLim/icons/edit-paste.png">    </p:cNvPr>
+          <p:cNvPr id="31" name="icon-101" descr="/tmp/tmp.U4D0us9tfa/icons/edit-paste.png">    </p:cNvPr>
           <p:cNvPicPr>
             <a:picLocks noChangeAspect="1"/>
           </p:cNvPicPr>
@@ -11224,7 +11224,7 @@
       </p:sp>
       <p:pic>
         <p:nvPicPr>
-          <p:cNvPr id="35" name="icon-105" descr="/tmp/tmp.eH5VcKLLim/icons/preferences-color.png">    </p:cNvPr>
+          <p:cNvPr id="35" name="icon-105" descr="/tmp/tmp.U4D0us9tfa/icons/preferences-color.png">    </p:cNvPr>
           <p:cNvPicPr>
             <a:picLocks noChangeAspect="1"/>
           </p:cNvPicPr>
@@ -11450,7 +11450,7 @@
       </p:sp>
       <p:pic>
         <p:nvPicPr>
-          <p:cNvPr id="5" name="scene-web-107" descr="/tmp/tmp.eH5VcKLLim/img/scene-web.jpg">    </p:cNvPr>
+          <p:cNvPr id="5" name="scene-web-107" descr="/tmp/tmp.U4D0us9tfa/img/scene-web.jpg">    </p:cNvPr>
           <p:cNvPicPr>
             <a:picLocks noChangeAspect="1"/>
           </p:cNvPicPr>
@@ -11481,7 +11481,7 @@
       </p:pic>
       <p:pic>
         <p:nvPicPr>
-          <p:cNvPr id="6" name="scene-knight-108" descr="/tmp/tmp.eH5VcKLLim/img/scene-knight.jpg">    </p:cNvPr>
+          <p:cNvPr id="6" name="scene-knight-108" descr="/tmp/tmp.U4D0us9tfa/img/scene-knight.jpg">    </p:cNvPr>
           <p:cNvPicPr>
             <a:picLocks noChangeAspect="1"/>
           </p:cNvPicPr>
@@ -11512,7 +11512,7 @@
       </p:pic>
       <p:pic>
         <p:nvPicPr>
-          <p:cNvPr id="7" name="scene-matrix-109" descr="/tmp/tmp.eH5VcKLLim/img/scene-matrix.jpg">    </p:cNvPr>
+          <p:cNvPr id="7" name="scene-matrix-109" descr="/tmp/tmp.U4D0us9tfa/img/scene-matrix.jpg">    </p:cNvPr>
           <p:cNvPicPr>
             <a:picLocks noChangeAspect="1"/>
           </p:cNvPicPr>
@@ -11599,7 +11599,7 @@
       </p:sp>
       <p:pic>
         <p:nvPicPr>
-          <p:cNvPr id="10" name="icon-112" descr="/tmp/tmp.eH5VcKLLim/icons/weather-clear-night.png">    </p:cNvPr>
+          <p:cNvPr id="10" name="icon-112" descr="/tmp/tmp.U4D0us9tfa/icons/weather-clear-night.png">    </p:cNvPr>
           <p:cNvPicPr>
             <a:picLocks noChangeAspect="1"/>
           </p:cNvPicPr>
@@ -11699,7 +11699,7 @@
       </p:sp>
       <p:pic>
         <p:nvPicPr>
-          <p:cNvPr id="13" name="icon-115" descr="/tmp/tmp.eH5VcKLLim/icons/video-display.png">    </p:cNvPr>
+          <p:cNvPr id="13" name="icon-115" descr="/tmp/tmp.U4D0us9tfa/icons/video-display.png">    </p:cNvPr>
           <p:cNvPicPr>
             <a:picLocks noChangeAspect="1"/>
           </p:cNvPicPr>
@@ -11799,7 +11799,7 @@
       </p:sp>
       <p:pic>
         <p:nvPicPr>
-          <p:cNvPr id="16" name="icon-118" descr="/tmp/tmp.eH5VcKLLim/icons/alarm.png">    </p:cNvPr>
+          <p:cNvPr id="16" name="icon-118" descr="/tmp/tmp.U4D0us9tfa/icons/alarm.png">    </p:cNvPr>
           <p:cNvPicPr>
             <a:picLocks noChangeAspect="1"/>
           </p:cNvPicPr>
@@ -11899,7 +11899,7 @@
       </p:sp>
       <p:pic>
         <p:nvPicPr>
-          <p:cNvPr id="19" name="icon-121" descr="/tmp/tmp.eH5VcKLLim/icons/system-run.png">    </p:cNvPr>
+          <p:cNvPr id="19" name="icon-121" descr="/tmp/tmp.U4D0us9tfa/icons/system-run.png">    </p:cNvPr>
           <p:cNvPicPr>
             <a:picLocks noChangeAspect="1"/>
           </p:cNvPicPr>
@@ -12125,7 +12125,7 @@
       </p:sp>
       <p:pic>
         <p:nvPicPr>
-          <p:cNvPr id="5" name="monitor" descr="/tmp/tmp.eH5VcKLLim/img/speedtest.jpg">    </p:cNvPr>
+          <p:cNvPr id="5" name="monitor" descr="/tmp/tmp.U4D0us9tfa/img/speedtest.jpg">    </p:cNvPr>
           <p:cNvPicPr>
             <a:picLocks noChangeAspect="1"/>
           </p:cNvPicPr>
@@ -12156,7 +12156,7 @@
       </p:pic>
       <p:pic>
         <p:nvPicPr>
-          <p:cNvPr id="6" name="media" descr="/tmp/tmp.eH5VcKLLim/img/media.jpg">    </p:cNvPr>
+          <p:cNvPr id="6" name="media" descr="/tmp/tmp.U4D0us9tfa/img/media.jpg">    </p:cNvPr>
           <p:cNvPicPr>
             <a:picLocks noChangeAspect="1"/>
           </p:cNvPicPr>
@@ -12243,7 +12243,7 @@
       </p:sp>
       <p:pic>
         <p:nvPicPr>
-          <p:cNvPr id="9" name="icon-125" descr="/tmp/tmp.eH5VcKLLim/icons/video-display.png">    </p:cNvPr>
+          <p:cNvPr id="9" name="icon-125" descr="/tmp/tmp.U4D0us9tfa/icons/video-display.png">    </p:cNvPr>
           <p:cNvPicPr>
             <a:picLocks noChangeAspect="1"/>
           </p:cNvPicPr>
@@ -12343,7 +12343,7 @@
       </p:sp>
       <p:pic>
         <p:nvPicPr>
-          <p:cNvPr id="12" name="icon-128" descr="/tmp/tmp.eH5VcKLLim/icons/network-workgroup.png">    </p:cNvPr>
+          <p:cNvPr id="12" name="icon-128" descr="/tmp/tmp.U4D0us9tfa/icons/network-workgroup.png">    </p:cNvPr>
           <p:cNvPicPr>
             <a:picLocks noChangeAspect="1"/>
           </p:cNvPicPr>
@@ -12443,7 +12443,7 @@
       </p:sp>
       <p:pic>
         <p:nvPicPr>
-          <p:cNvPr id="15" name="icon-131" descr="/tmp/tmp.eH5VcKLLim/icons/audio-speakers.png">    </p:cNvPr>
+          <p:cNvPr id="15" name="icon-131" descr="/tmp/tmp.U4D0us9tfa/icons/audio-speakers.png">    </p:cNvPr>
           <p:cNvPicPr>
             <a:picLocks noChangeAspect="1"/>
           </p:cNvPicPr>
@@ -12543,7 +12543,7 @@
       </p:sp>
       <p:pic>
         <p:nvPicPr>
-          <p:cNvPr id="18" name="icon-134" descr="/tmp/tmp.eH5VcKLLim/icons/edit-paste.png">    </p:cNvPr>
+          <p:cNvPr id="18" name="icon-134" descr="/tmp/tmp.U4D0us9tfa/icons/edit-paste.png">    </p:cNvPr>
           <p:cNvPicPr>
             <a:picLocks noChangeAspect="1"/>
           </p:cNvPicPr>

</xml_diff>

<commit_message>
docs(overview): rebuild the PDF and deck with the new Web Hang scene
</commit_message>
<xml_diff>
--- a/docs/MK-Workstation-Overview.pptx
+++ b/docs/MK-Workstation-Overview.pptx
@@ -120,40 +120,40 @@
   <p:extLst>
     <p:ext uri="{521415D9-36F7-43E2-AB2F-B90AF26B5E84}">
       <p14:sectionLst xmlns:p14="http://schemas.microsoft.com/office/powerpoint/2010/main">
-        <p14:section name="Introduction" id="{d0c28f12-fd1b-47b9-147a-85a3787846ab}">
+        <p14:section name="Introduction" id="{99a4c4c7-91ff-61b9-03d7-6aa78c10da84}">
           <p14:sldIdLst>
             <p14:sldId id="256"/>
             <p14:sldId id="257"/>
           </p14:sldIdLst>
         </p14:section>
-        <p14:section name="Your desktop" id="{cf2e1826-4059-ac21-a216-4a7a74dec242}">
+        <p14:section name="Your desktop" id="{77a79bb4-991c-4d26-0091-6773a0dea2d6}">
           <p14:sldIdLst>
             <p14:sldId id="258"/>
             <p14:sldId id="259"/>
             <p14:sldId id="260"/>
           </p14:sldIdLst>
         </p14:section>
-        <p14:section name="MK Notes" id="{2fb061a0-04f0-cad2-35d7-d40e4e954b13}">
+        <p14:section name="MK Notes" id="{ae24ba3e-5da2-fd59-082d-5e1d53747fa7}">
           <p14:sldIdLst>
             <p14:sldId id="261"/>
             <p14:sldId id="262"/>
           </p14:sldIdLst>
         </p14:section>
-        <p14:section name="Focus and tools" id="{00d293c6-e6b2-a4b9-6acd-33f0ffbdb07f}">
+        <p14:section name="Focus and tools" id="{957cb424-db27-d45d-2e8a-aa783b68c330}">
           <p14:sldIdLst>
             <p14:sldId id="263"/>
             <p14:sldId id="264"/>
             <p14:sldId id="265"/>
           </p14:sldIdLst>
         </p14:section>
-        <p14:section name="Your computer" id="{c1dd1d32-45e2-8bc2-1933-2d9d92df88e5}">
+        <p14:section name="Your computer" id="{36e7bdf5-86dd-91f3-a1d1-a128ec3a2724}">
           <p14:sldIdLst>
             <p14:sldId id="266"/>
             <p14:sldId id="267"/>
             <p14:sldId id="268"/>
           </p14:sldIdLst>
         </p14:section>
-        <p14:section name="Get started" id="{a43d4c65-8ab1-56c3-884a-44c40d7161aa}">
+        <p14:section name="Get started" id="{7d5fcbad-c0be-e158-9ba7-9405f7a20f3a}">
           <p14:sldIdLst>
             <p14:sldId id="269"/>
           </p14:sldIdLst>
@@ -2533,7 +2533,7 @@
       </p:grpSpPr>
       <p:pic>
         <p:nvPicPr>
-          <p:cNvPr id="2" name="hero" descr="/tmp/tmp.U4D0us9tfa/img/welcome.jpg">    </p:cNvPr>
+          <p:cNvPr id="2" name="hero" descr="/tmp/tmp.cGG6SXUsEK/img/welcome.jpg">    </p:cNvPr>
           <p:cNvPicPr>
             <a:picLocks noChangeAspect="1"/>
           </p:cNvPicPr>
@@ -2805,7 +2805,7 @@
       </p:sp>
       <p:pic>
         <p:nvPicPr>
-          <p:cNvPr id="5" name="app-136" descr="/tmp/tmp.U4D0us9tfa/apps/app.zen_browser.zen.png">    </p:cNvPr>
+          <p:cNvPr id="5" name="app-136" descr="/tmp/tmp.cGG6SXUsEK/apps/app.zen_browser.zen.png">    </p:cNvPr>
           <p:cNvPicPr>
             <a:picLocks noChangeAspect="1"/>
           </p:cNvPicPr>
@@ -2865,7 +2865,7 @@
       </p:sp>
       <p:pic>
         <p:nvPicPr>
-          <p:cNvPr id="7" name="app-138" descr="/tmp/tmp.U4D0us9tfa/apps/net.cozic.joplin_desktop.png">    </p:cNvPr>
+          <p:cNvPr id="7" name="app-138" descr="/tmp/tmp.cGG6SXUsEK/apps/net.cozic.joplin_desktop.png">    </p:cNvPr>
           <p:cNvPicPr>
             <a:picLocks noChangeAspect="1"/>
           </p:cNvPicPr>
@@ -2925,7 +2925,7 @@
       </p:sp>
       <p:pic>
         <p:nvPicPr>
-          <p:cNvPr id="9" name="app-140" descr="/tmp/tmp.U4D0us9tfa/apps/org.onlyoffice.desktopeditors.png">    </p:cNvPr>
+          <p:cNvPr id="9" name="app-140" descr="/tmp/tmp.cGG6SXUsEK/apps/org.onlyoffice.desktopeditors.png">    </p:cNvPr>
           <p:cNvPicPr>
             <a:picLocks noChangeAspect="1"/>
           </p:cNvPicPr>
@@ -2985,7 +2985,7 @@
       </p:sp>
       <p:pic>
         <p:nvPicPr>
-          <p:cNvPr id="11" name="app-142" descr="/tmp/tmp.U4D0us9tfa/apps/vscode.png">    </p:cNvPr>
+          <p:cNvPr id="11" name="app-142" descr="/tmp/tmp.cGG6SXUsEK/apps/vscode.png">    </p:cNvPr>
           <p:cNvPicPr>
             <a:picLocks noChangeAspect="1"/>
           </p:cNvPicPr>
@@ -3045,7 +3045,7 @@
       </p:sp>
       <p:pic>
         <p:nvPicPr>
-          <p:cNvPr id="13" name="app-144" descr="/tmp/tmp.U4D0us9tfa/apps/com.spotify.Client.png">    </p:cNvPr>
+          <p:cNvPr id="13" name="app-144" descr="/tmp/tmp.cGG6SXUsEK/apps/com.spotify.Client.png">    </p:cNvPr>
           <p:cNvPicPr>
             <a:picLocks noChangeAspect="1"/>
           </p:cNvPicPr>
@@ -3105,7 +3105,7 @@
       </p:sp>
       <p:pic>
         <p:nvPicPr>
-          <p:cNvPr id="15" name="app-146" descr="/tmp/tmp.U4D0us9tfa/apps/net.lutris.Lutris.png">    </p:cNvPr>
+          <p:cNvPr id="15" name="app-146" descr="/tmp/tmp.cGG6SXUsEK/apps/net.lutris.Lutris.png">    </p:cNvPr>
           <p:cNvPicPr>
             <a:picLocks noChangeAspect="1"/>
           </p:cNvPicPr>
@@ -3165,7 +3165,7 @@
       </p:sp>
       <p:pic>
         <p:nvPicPr>
-          <p:cNvPr id="17" name="app-148" descr="/tmp/tmp.U4D0us9tfa/apps/com.mattjakeman.ExtensionManager.png">    </p:cNvPr>
+          <p:cNvPr id="17" name="app-148" descr="/tmp/tmp.cGG6SXUsEK/apps/com.mattjakeman.ExtensionManager.png">    </p:cNvPr>
           <p:cNvPicPr>
             <a:picLocks noChangeAspect="1"/>
           </p:cNvPicPr>
@@ -3225,7 +3225,7 @@
       </p:sp>
       <p:pic>
         <p:nvPicPr>
-          <p:cNvPr id="19" name="app-150" descr="/tmp/tmp.U4D0us9tfa/apps/net.sonobus.SonoBus.png">    </p:cNvPr>
+          <p:cNvPr id="19" name="app-150" descr="/tmp/tmp.cGG6SXUsEK/apps/net.sonobus.SonoBus.png">    </p:cNvPr>
           <p:cNvPicPr>
             <a:picLocks noChangeAspect="1"/>
           </p:cNvPicPr>
@@ -3285,7 +3285,7 @@
       </p:sp>
       <p:pic>
         <p:nvPicPr>
-          <p:cNvPr id="21" name="app-152" descr="/tmp/tmp.U4D0us9tfa/apps/com.github.tenderowl.frog.png">    </p:cNvPr>
+          <p:cNvPr id="21" name="app-152" descr="/tmp/tmp.cGG6SXUsEK/apps/com.github.tenderowl.frog.png">    </p:cNvPr>
           <p:cNvPicPr>
             <a:picLocks noChangeAspect="1"/>
           </p:cNvPicPr>
@@ -3345,7 +3345,7 @@
       </p:sp>
       <p:pic>
         <p:nvPicPr>
-          <p:cNvPr id="23" name="app-154" descr="/tmp/tmp.U4D0us9tfa/apps/one.alynx.FlipClock.png">    </p:cNvPr>
+          <p:cNvPr id="23" name="app-154" descr="/tmp/tmp.cGG6SXUsEK/apps/one.alynx.FlipClock.png">    </p:cNvPr>
           <p:cNvPicPr>
             <a:picLocks noChangeAspect="1"/>
           </p:cNvPicPr>
@@ -3405,7 +3405,7 @@
       </p:sp>
       <p:pic>
         <p:nvPicPr>
-          <p:cNvPr id="25" name="app-156" descr="/tmp/tmp.U4D0us9tfa/apps/io.github.mehulk.MkNotes.png">    </p:cNvPr>
+          <p:cNvPr id="25" name="app-156" descr="/tmp/tmp.cGG6SXUsEK/apps/io.github.mehulk.MkNotes.png">    </p:cNvPr>
           <p:cNvPicPr>
             <a:picLocks noChangeAspect="1"/>
           </p:cNvPicPr>
@@ -3465,7 +3465,7 @@
       </p:sp>
       <p:pic>
         <p:nvPicPr>
-          <p:cNvPr id="27" name="app-158" descr="/tmp/tmp.U4D0us9tfa/apps/io.github.mehulk.MkCompanion.png">    </p:cNvPr>
+          <p:cNvPr id="27" name="app-158" descr="/tmp/tmp.cGG6SXUsEK/apps/io.github.mehulk.MkCompanion.png">    </p:cNvPr>
           <p:cNvPicPr>
             <a:picLocks noChangeAspect="1"/>
           </p:cNvPicPr>
@@ -3525,7 +3525,7 @@
       </p:sp>
       <p:pic>
         <p:nvPicPr>
-          <p:cNvPr id="29" name="app-160" descr="/tmp/tmp.U4D0us9tfa/apps/io.github.mehulk.MkTimer.png">    </p:cNvPr>
+          <p:cNvPr id="29" name="app-160" descr="/tmp/tmp.cGG6SXUsEK/apps/io.github.mehulk.MkTimer.png">    </p:cNvPr>
           <p:cNvPicPr>
             <a:picLocks noChangeAspect="1"/>
           </p:cNvPicPr>
@@ -3585,7 +3585,7 @@
       </p:sp>
       <p:pic>
         <p:nvPicPr>
-          <p:cNvPr id="31" name="app-162" descr="/tmp/tmp.U4D0us9tfa/apps/io.github.mehulk.MkShortcuts.png">    </p:cNvPr>
+          <p:cNvPr id="31" name="app-162" descr="/tmp/tmp.cGG6SXUsEK/apps/io.github.mehulk.MkShortcuts.png">    </p:cNvPr>
           <p:cNvPicPr>
             <a:picLocks noChangeAspect="1"/>
           </p:cNvPicPr>
@@ -3869,7 +3869,7 @@
       </p:sp>
       <p:pic>
         <p:nvPicPr>
-          <p:cNvPr id="7" name="icon-166" descr="/tmp/tmp.U4D0us9tfa/icons/auth-fingerprint.png">    </p:cNvPr>
+          <p:cNvPr id="7" name="icon-166" descr="/tmp/tmp.cGG6SXUsEK/icons/auth-fingerprint.png">    </p:cNvPr>
           <p:cNvPicPr>
             <a:picLocks noChangeAspect="1"/>
           </p:cNvPicPr>
@@ -3991,7 +3991,7 @@
       </p:sp>
       <p:pic>
         <p:nvPicPr>
-          <p:cNvPr id="11" name="icon-170" descr="/tmp/tmp.U4D0us9tfa/icons/battery-full.png">    </p:cNvPr>
+          <p:cNvPr id="11" name="icon-170" descr="/tmp/tmp.cGG6SXUsEK/icons/battery-full.png">    </p:cNvPr>
           <p:cNvPicPr>
             <a:picLocks noChangeAspect="1"/>
           </p:cNvPicPr>
@@ -4113,7 +4113,7 @@
       </p:sp>
       <p:pic>
         <p:nvPicPr>
-          <p:cNvPr id="15" name="icon-174" descr="/tmp/tmp.U4D0us9tfa/icons/audio-speakers.png">    </p:cNvPr>
+          <p:cNvPr id="15" name="icon-174" descr="/tmp/tmp.cGG6SXUsEK/icons/audio-speakers.png">    </p:cNvPr>
           <p:cNvPicPr>
             <a:picLocks noChangeAspect="1"/>
           </p:cNvPicPr>
@@ -4235,7 +4235,7 @@
       </p:sp>
       <p:pic>
         <p:nvPicPr>
-          <p:cNvPr id="19" name="icon-178" descr="/tmp/tmp.U4D0us9tfa/icons/input-tablet.png">    </p:cNvPr>
+          <p:cNvPr id="19" name="icon-178" descr="/tmp/tmp.cGG6SXUsEK/icons/input-tablet.png">    </p:cNvPr>
           <p:cNvPicPr>
             <a:picLocks noChangeAspect="1"/>
           </p:cNvPicPr>
@@ -4357,7 +4357,7 @@
       </p:sp>
       <p:pic>
         <p:nvPicPr>
-          <p:cNvPr id="23" name="icon-182" descr="/tmp/tmp.U4D0us9tfa/icons/video-display.png">    </p:cNvPr>
+          <p:cNvPr id="23" name="icon-182" descr="/tmp/tmp.cGG6SXUsEK/icons/video-display.png">    </p:cNvPr>
           <p:cNvPicPr>
             <a:picLocks noChangeAspect="1"/>
           </p:cNvPicPr>
@@ -4479,7 +4479,7 @@
       </p:sp>
       <p:pic>
         <p:nvPicPr>
-          <p:cNvPr id="27" name="icon-186" descr="/tmp/tmp.U4D0us9tfa/icons/system-run.png">    </p:cNvPr>
+          <p:cNvPr id="27" name="icon-186" descr="/tmp/tmp.cGG6SXUsEK/icons/system-run.png">    </p:cNvPr>
           <p:cNvPicPr>
             <a:picLocks noChangeAspect="1"/>
           </p:cNvPicPr>
@@ -5645,7 +5645,7 @@
       </p:sp>
       <p:pic>
         <p:nvPicPr>
-          <p:cNvPr id="35" name="shortcuts" descr="/tmp/tmp.U4D0us9tfa/img/shortcuts.jpg">    </p:cNvPr>
+          <p:cNvPr id="35" name="shortcuts" descr="/tmp/tmp.cGG6SXUsEK/img/shortcuts.jpg">    </p:cNvPr>
           <p:cNvPicPr>
             <a:picLocks noChangeAspect="1"/>
           </p:cNvPicPr>
@@ -5878,7 +5878,7 @@
       </p:sp>
       <p:pic>
         <p:nvPicPr>
-          <p:cNvPr id="6" name="icon-220" descr="/tmp/tmp.U4D0us9tfa/icons/document-open-recent.png">    </p:cNvPr>
+          <p:cNvPr id="6" name="icon-220" descr="/tmp/tmp.cGG6SXUsEK/icons/document-open-recent.png">    </p:cNvPr>
           <p:cNvPicPr>
             <a:picLocks noChangeAspect="1"/>
           </p:cNvPicPr>
@@ -5978,7 +5978,7 @@
       </p:sp>
       <p:pic>
         <p:nvPicPr>
-          <p:cNvPr id="9" name="icon-223" descr="/tmp/tmp.U4D0us9tfa/icons/user-trash.png">    </p:cNvPr>
+          <p:cNvPr id="9" name="icon-223" descr="/tmp/tmp.cGG6SXUsEK/icons/user-trash.png">    </p:cNvPr>
           <p:cNvPicPr>
             <a:picLocks noChangeAspect="1"/>
           </p:cNvPicPr>
@@ -6078,7 +6078,7 @@
       </p:sp>
       <p:pic>
         <p:nvPicPr>
-          <p:cNvPr id="12" name="icon-226" descr="/tmp/tmp.U4D0us9tfa/icons/checkbox-checked.png">    </p:cNvPr>
+          <p:cNvPr id="12" name="icon-226" descr="/tmp/tmp.cGG6SXUsEK/icons/checkbox-checked.png">    </p:cNvPr>
           <p:cNvPicPr>
             <a:picLocks noChangeAspect="1"/>
           </p:cNvPicPr>
@@ -6178,7 +6178,7 @@
       </p:sp>
       <p:pic>
         <p:nvPicPr>
-          <p:cNvPr id="15" name="icon-229" descr="/tmp/tmp.U4D0us9tfa/icons/x-office-document.png">    </p:cNvPr>
+          <p:cNvPr id="15" name="icon-229" descr="/tmp/tmp.cGG6SXUsEK/icons/x-office-document.png">    </p:cNvPr>
           <p:cNvPicPr>
             <a:picLocks noChangeAspect="1"/>
           </p:cNvPicPr>
@@ -6278,7 +6278,7 @@
       </p:sp>
       <p:pic>
         <p:nvPicPr>
-          <p:cNvPr id="18" name="icon-232" descr="/tmp/tmp.U4D0us9tfa/icons/software-update-available.png">    </p:cNvPr>
+          <p:cNvPr id="18" name="icon-232" descr="/tmp/tmp.cGG6SXUsEK/icons/software-update-available.png">    </p:cNvPr>
           <p:cNvPicPr>
             <a:picLocks noChangeAspect="1"/>
           </p:cNvPicPr>
@@ -6358,7 +6358,7 @@
       </p:sp>
       <p:pic>
         <p:nvPicPr>
-          <p:cNvPr id="20" name="companion" descr="/tmp/tmp.U4D0us9tfa/img/companion.jpg">    </p:cNvPr>
+          <p:cNvPr id="20" name="companion" descr="/tmp/tmp.cGG6SXUsEK/img/companion.jpg">    </p:cNvPr>
           <p:cNvPicPr>
             <a:picLocks noChangeAspect="1"/>
           </p:cNvPicPr>
@@ -7087,7 +7087,7 @@
       </p:sp>
       <p:pic>
         <p:nvPicPr>
-          <p:cNvPr id="7" name="icon-2" descr="/tmp/tmp.U4D0us9tfa/icons/edit-undo.png">    </p:cNvPr>
+          <p:cNvPr id="7" name="icon-2" descr="/tmp/tmp.cGG6SXUsEK/icons/edit-undo.png">    </p:cNvPr>
           <p:cNvPicPr>
             <a:picLocks noChangeAspect="1"/>
           </p:cNvPicPr>
@@ -7187,7 +7187,7 @@
       </p:sp>
       <p:pic>
         <p:nvPicPr>
-          <p:cNvPr id="10" name="icon-5" descr="/tmp/tmp.U4D0us9tfa/icons/software-update-available.png">    </p:cNvPr>
+          <p:cNvPr id="10" name="icon-5" descr="/tmp/tmp.cGG6SXUsEK/icons/software-update-available.png">    </p:cNvPr>
           <p:cNvPicPr>
             <a:picLocks noChangeAspect="1"/>
           </p:cNvPicPr>
@@ -7845,7 +7845,7 @@
       </p:sp>
       <p:pic>
         <p:nvPicPr>
-          <p:cNvPr id="5" name="alttab-19" descr="/tmp/tmp.U4D0us9tfa/img/alttab.jpg">    </p:cNvPr>
+          <p:cNvPr id="5" name="alttab-19" descr="/tmp/tmp.cGG6SXUsEK/img/alttab.jpg">    </p:cNvPr>
           <p:cNvPicPr>
             <a:picLocks noChangeAspect="1"/>
           </p:cNvPicPr>
@@ -7932,7 +7932,7 @@
       </p:sp>
       <p:pic>
         <p:nvPicPr>
-          <p:cNvPr id="8" name="icon-22" descr="/tmp/tmp.U4D0us9tfa/icons/view-grid.png">    </p:cNvPr>
+          <p:cNvPr id="8" name="icon-22" descr="/tmp/tmp.cGG6SXUsEK/icons/view-grid.png">    </p:cNvPr>
           <p:cNvPicPr>
             <a:picLocks noChangeAspect="1"/>
           </p:cNvPicPr>
@@ -8032,7 +8032,7 @@
       </p:sp>
       <p:pic>
         <p:nvPicPr>
-          <p:cNvPr id="11" name="icon-25" descr="/tmp/tmp.U4D0us9tfa/icons/input-touchpad.png">    </p:cNvPr>
+          <p:cNvPr id="11" name="icon-25" descr="/tmp/tmp.cGG6SXUsEK/icons/input-touchpad.png">    </p:cNvPr>
           <p:cNvPicPr>
             <a:picLocks noChangeAspect="1"/>
           </p:cNvPicPr>
@@ -8132,7 +8132,7 @@
       </p:sp>
       <p:pic>
         <p:nvPicPr>
-          <p:cNvPr id="14" name="icon-28" descr="/tmp/tmp.U4D0us9tfa/icons/view-dual.png">    </p:cNvPr>
+          <p:cNvPr id="14" name="icon-28" descr="/tmp/tmp.cGG6SXUsEK/icons/view-dual.png">    </p:cNvPr>
           <p:cNvPicPr>
             <a:picLocks noChangeAspect="1"/>
           </p:cNvPicPr>
@@ -8232,7 +8232,7 @@
       </p:sp>
       <p:pic>
         <p:nvPicPr>
-          <p:cNvPr id="17" name="icon-31" descr="/tmp/tmp.U4D0us9tfa/icons/system-run.png">    </p:cNvPr>
+          <p:cNvPr id="17" name="icon-31" descr="/tmp/tmp.cGG6SXUsEK/icons/system-run.png">    </p:cNvPr>
           <p:cNvPicPr>
             <a:picLocks noChangeAspect="1"/>
           </p:cNvPicPr>
@@ -8458,7 +8458,7 @@
       </p:sp>
       <p:pic>
         <p:nvPicPr>
-          <p:cNvPr id="5" name="tiled-33" descr="/tmp/tmp.U4D0us9tfa/img/tiled.jpg">    </p:cNvPr>
+          <p:cNvPr id="5" name="tiled-33" descr="/tmp/tmp.cGG6SXUsEK/img/tiled.jpg">    </p:cNvPr>
           <p:cNvPicPr>
             <a:picLocks noChangeAspect="1"/>
           </p:cNvPicPr>
@@ -8545,7 +8545,7 @@
       </p:sp>
       <p:pic>
         <p:nvPicPr>
-          <p:cNvPr id="8" name="icon-36" descr="/tmp/tmp.U4D0us9tfa/icons/view-dual.png">    </p:cNvPr>
+          <p:cNvPr id="8" name="icon-36" descr="/tmp/tmp.cGG6SXUsEK/icons/view-dual.png">    </p:cNvPr>
           <p:cNvPicPr>
             <a:picLocks noChangeAspect="1"/>
           </p:cNvPicPr>
@@ -8645,7 +8645,7 @@
       </p:sp>
       <p:pic>
         <p:nvPicPr>
-          <p:cNvPr id="11" name="icon-39" descr="/tmp/tmp.U4D0us9tfa/icons/window-new.png">    </p:cNvPr>
+          <p:cNvPr id="11" name="icon-39" descr="/tmp/tmp.cGG6SXUsEK/icons/window-new.png">    </p:cNvPr>
           <p:cNvPicPr>
             <a:picLocks noChangeAspect="1"/>
           </p:cNvPicPr>
@@ -8745,7 +8745,7 @@
       </p:sp>
       <p:pic>
         <p:nvPicPr>
-          <p:cNvPr id="14" name="icon-42" descr="/tmp/tmp.U4D0us9tfa/icons/view-pin.png">    </p:cNvPr>
+          <p:cNvPr id="14" name="icon-42" descr="/tmp/tmp.cGG6SXUsEK/icons/view-pin.png">    </p:cNvPr>
           <p:cNvPicPr>
             <a:picLocks noChangeAspect="1"/>
           </p:cNvPicPr>
@@ -8845,7 +8845,7 @@
       </p:sp>
       <p:pic>
         <p:nvPicPr>
-          <p:cNvPr id="17" name="icon-45" descr="/tmp/tmp.U4D0us9tfa/icons/view-grid.png">    </p:cNvPr>
+          <p:cNvPr id="17" name="icon-45" descr="/tmp/tmp.cGG6SXUsEK/icons/view-grid.png">    </p:cNvPr>
           <p:cNvPicPr>
             <a:picLocks noChangeAspect="1"/>
           </p:cNvPicPr>
@@ -9071,7 +9071,7 @@
       </p:sp>
       <p:pic>
         <p:nvPicPr>
-          <p:cNvPr id="5" name="welcome-47" descr="/tmp/tmp.U4D0us9tfa/img/welcome.jpg">    </p:cNvPr>
+          <p:cNvPr id="5" name="welcome-47" descr="/tmp/tmp.cGG6SXUsEK/img/welcome.jpg">    </p:cNvPr>
           <p:cNvPicPr>
             <a:picLocks noChangeAspect="1"/>
           </p:cNvPicPr>
@@ -9158,7 +9158,7 @@
       </p:sp>
       <p:pic>
         <p:nvPicPr>
-          <p:cNvPr id="8" name="icon-50" descr="/tmp/tmp.U4D0us9tfa/icons/weather-clear-night.png">    </p:cNvPr>
+          <p:cNvPr id="8" name="icon-50" descr="/tmp/tmp.cGG6SXUsEK/icons/weather-clear-night.png">    </p:cNvPr>
           <p:cNvPicPr>
             <a:picLocks noChangeAspect="1"/>
           </p:cNvPicPr>
@@ -9258,7 +9258,7 @@
       </p:sp>
       <p:pic>
         <p:nvPicPr>
-          <p:cNvPr id="11" name="icon-53" descr="/tmp/tmp.U4D0us9tfa/icons/view-pin.png">    </p:cNvPr>
+          <p:cNvPr id="11" name="icon-53" descr="/tmp/tmp.cGG6SXUsEK/icons/view-pin.png">    </p:cNvPr>
           <p:cNvPicPr>
             <a:picLocks noChangeAspect="1"/>
           </p:cNvPicPr>
@@ -9358,7 +9358,7 @@
       </p:sp>
       <p:pic>
         <p:nvPicPr>
-          <p:cNvPr id="14" name="icon-56" descr="/tmp/tmp.U4D0us9tfa/icons/face-smile.png">    </p:cNvPr>
+          <p:cNvPr id="14" name="icon-56" descr="/tmp/tmp.cGG6SXUsEK/icons/face-smile.png">    </p:cNvPr>
           <p:cNvPicPr>
             <a:picLocks noChangeAspect="1"/>
           </p:cNvPicPr>
@@ -9458,7 +9458,7 @@
       </p:sp>
       <p:pic>
         <p:nvPicPr>
-          <p:cNvPr id="17" name="icon-59" descr="/tmp/tmp.U4D0us9tfa/icons/preferences-color.png">    </p:cNvPr>
+          <p:cNvPr id="17" name="icon-59" descr="/tmp/tmp.cGG6SXUsEK/icons/preferences-color.png">    </p:cNvPr>
           <p:cNvPicPr>
             <a:picLocks noChangeAspect="1"/>
           </p:cNvPicPr>
@@ -9684,7 +9684,7 @@
       </p:sp>
       <p:pic>
         <p:nvPicPr>
-          <p:cNvPr id="5" name="notes-split-61" descr="/tmp/tmp.U4D0us9tfa/img/notes-split.jpg">    </p:cNvPr>
+          <p:cNvPr id="5" name="notes-split-61" descr="/tmp/tmp.cGG6SXUsEK/img/notes-split.jpg">    </p:cNvPr>
           <p:cNvPicPr>
             <a:picLocks noChangeAspect="1"/>
           </p:cNvPicPr>
@@ -9715,7 +9715,7 @@
       </p:pic>
       <p:pic>
         <p:nvPicPr>
-          <p:cNvPr id="6" name="phone" descr="/tmp/tmp.U4D0us9tfa/img/phone-note.jpg">    </p:cNvPr>
+          <p:cNvPr id="6" name="phone" descr="/tmp/tmp.cGG6SXUsEK/img/phone-note.jpg">    </p:cNvPr>
           <p:cNvPicPr>
             <a:picLocks noChangeAspect="1"/>
           </p:cNvPicPr>
@@ -9802,7 +9802,7 @@
       </p:sp>
       <p:pic>
         <p:nvPicPr>
-          <p:cNvPr id="9" name="icon-64" descr="/tmp/tmp.U4D0us9tfa/icons/x-office-document.png">    </p:cNvPr>
+          <p:cNvPr id="9" name="icon-64" descr="/tmp/tmp.cGG6SXUsEK/icons/x-office-document.png">    </p:cNvPr>
           <p:cNvPicPr>
             <a:picLocks noChangeAspect="1"/>
           </p:cNvPicPr>
@@ -9902,7 +9902,7 @@
       </p:sp>
       <p:pic>
         <p:nvPicPr>
-          <p:cNvPr id="12" name="icon-67" descr="/tmp/tmp.U4D0us9tfa/icons/network-workgroup.png">    </p:cNvPr>
+          <p:cNvPr id="12" name="icon-67" descr="/tmp/tmp.cGG6SXUsEK/icons/network-workgroup.png">    </p:cNvPr>
           <p:cNvPicPr>
             <a:picLocks noChangeAspect="1"/>
           </p:cNvPicPr>
@@ -10002,7 +10002,7 @@
       </p:sp>
       <p:pic>
         <p:nvPicPr>
-          <p:cNvPr id="15" name="icon-70" descr="/tmp/tmp.U4D0us9tfa/icons/applications-graphics.png">    </p:cNvPr>
+          <p:cNvPr id="15" name="icon-70" descr="/tmp/tmp.cGG6SXUsEK/icons/applications-graphics.png">    </p:cNvPr>
           <p:cNvPicPr>
             <a:picLocks noChangeAspect="1"/>
           </p:cNvPicPr>
@@ -10102,7 +10102,7 @@
       </p:sp>
       <p:pic>
         <p:nvPicPr>
-          <p:cNvPr id="18" name="icon-73" descr="/tmp/tmp.U4D0us9tfa/icons/edit-paste.png">    </p:cNvPr>
+          <p:cNvPr id="18" name="icon-73" descr="/tmp/tmp.cGG6SXUsEK/icons/edit-paste.png">    </p:cNvPr>
           <p:cNvPicPr>
             <a:picLocks noChangeAspect="1"/>
           </p:cNvPicPr>
@@ -10370,7 +10370,7 @@
       </p:sp>
       <p:pic>
         <p:nvPicPr>
-          <p:cNvPr id="7" name="icon-77" descr="/tmp/tmp.U4D0us9tfa/icons/emblem-system.png">    </p:cNvPr>
+          <p:cNvPr id="7" name="icon-77" descr="/tmp/tmp.cGG6SXUsEK/icons/emblem-system.png">    </p:cNvPr>
           <p:cNvPicPr>
             <a:picLocks noChangeAspect="1"/>
           </p:cNvPicPr>
@@ -10492,7 +10492,7 @@
       </p:sp>
       <p:pic>
         <p:nvPicPr>
-          <p:cNvPr id="11" name="icon-81" descr="/tmp/tmp.U4D0us9tfa/icons/x-office-document.png">    </p:cNvPr>
+          <p:cNvPr id="11" name="icon-81" descr="/tmp/tmp.cGG6SXUsEK/icons/x-office-document.png">    </p:cNvPr>
           <p:cNvPicPr>
             <a:picLocks noChangeAspect="1"/>
           </p:cNvPicPr>
@@ -10614,7 +10614,7 @@
       </p:sp>
       <p:pic>
         <p:nvPicPr>
-          <p:cNvPr id="15" name="icon-85" descr="/tmp/tmp.U4D0us9tfa/icons/network-workgroup.png">    </p:cNvPr>
+          <p:cNvPr id="15" name="icon-85" descr="/tmp/tmp.cGG6SXUsEK/icons/network-workgroup.png">    </p:cNvPr>
           <p:cNvPicPr>
             <a:picLocks noChangeAspect="1"/>
           </p:cNvPicPr>
@@ -10736,7 +10736,7 @@
       </p:sp>
       <p:pic>
         <p:nvPicPr>
-          <p:cNvPr id="19" name="icon-89" descr="/tmp/tmp.U4D0us9tfa/icons/document-open-recent.png">    </p:cNvPr>
+          <p:cNvPr id="19" name="icon-89" descr="/tmp/tmp.cGG6SXUsEK/icons/document-open-recent.png">    </p:cNvPr>
           <p:cNvPicPr>
             <a:picLocks noChangeAspect="1"/>
           </p:cNvPicPr>
@@ -10858,7 +10858,7 @@
       </p:sp>
       <p:pic>
         <p:nvPicPr>
-          <p:cNvPr id="23" name="icon-93" descr="/tmp/tmp.U4D0us9tfa/icons/x-office-calendar.png">    </p:cNvPr>
+          <p:cNvPr id="23" name="icon-93" descr="/tmp/tmp.cGG6SXUsEK/icons/x-office-calendar.png">    </p:cNvPr>
           <p:cNvPicPr>
             <a:picLocks noChangeAspect="1"/>
           </p:cNvPicPr>
@@ -10980,7 +10980,7 @@
       </p:sp>
       <p:pic>
         <p:nvPicPr>
-          <p:cNvPr id="27" name="icon-97" descr="/tmp/tmp.U4D0us9tfa/icons/checkbox-checked.png">    </p:cNvPr>
+          <p:cNvPr id="27" name="icon-97" descr="/tmp/tmp.cGG6SXUsEK/icons/checkbox-checked.png">    </p:cNvPr>
           <p:cNvPicPr>
             <a:picLocks noChangeAspect="1"/>
           </p:cNvPicPr>
@@ -11102,7 +11102,7 @@
       </p:sp>
       <p:pic>
         <p:nvPicPr>
-          <p:cNvPr id="31" name="icon-101" descr="/tmp/tmp.U4D0us9tfa/icons/edit-paste.png">    </p:cNvPr>
+          <p:cNvPr id="31" name="icon-101" descr="/tmp/tmp.cGG6SXUsEK/icons/edit-paste.png">    </p:cNvPr>
           <p:cNvPicPr>
             <a:picLocks noChangeAspect="1"/>
           </p:cNvPicPr>
@@ -11224,7 +11224,7 @@
       </p:sp>
       <p:pic>
         <p:nvPicPr>
-          <p:cNvPr id="35" name="icon-105" descr="/tmp/tmp.U4D0us9tfa/icons/preferences-color.png">    </p:cNvPr>
+          <p:cNvPr id="35" name="icon-105" descr="/tmp/tmp.cGG6SXUsEK/icons/preferences-color.png">    </p:cNvPr>
           <p:cNvPicPr>
             <a:picLocks noChangeAspect="1"/>
           </p:cNvPicPr>
@@ -11450,7 +11450,7 @@
       </p:sp>
       <p:pic>
         <p:nvPicPr>
-          <p:cNvPr id="5" name="scene-web-107" descr="/tmp/tmp.U4D0us9tfa/img/scene-web.jpg">    </p:cNvPr>
+          <p:cNvPr id="5" name="scene-web-107" descr="/tmp/tmp.cGG6SXUsEK/img/scene-web.jpg">    </p:cNvPr>
           <p:cNvPicPr>
             <a:picLocks noChangeAspect="1"/>
           </p:cNvPicPr>
@@ -11481,7 +11481,7 @@
       </p:pic>
       <p:pic>
         <p:nvPicPr>
-          <p:cNvPr id="6" name="scene-knight-108" descr="/tmp/tmp.U4D0us9tfa/img/scene-knight.jpg">    </p:cNvPr>
+          <p:cNvPr id="6" name="scene-knight-108" descr="/tmp/tmp.cGG6SXUsEK/img/scene-knight.jpg">    </p:cNvPr>
           <p:cNvPicPr>
             <a:picLocks noChangeAspect="1"/>
           </p:cNvPicPr>
@@ -11512,7 +11512,7 @@
       </p:pic>
       <p:pic>
         <p:nvPicPr>
-          <p:cNvPr id="7" name="scene-matrix-109" descr="/tmp/tmp.U4D0us9tfa/img/scene-matrix.jpg">    </p:cNvPr>
+          <p:cNvPr id="7" name="scene-matrix-109" descr="/tmp/tmp.cGG6SXUsEK/img/scene-matrix.jpg">    </p:cNvPr>
           <p:cNvPicPr>
             <a:picLocks noChangeAspect="1"/>
           </p:cNvPicPr>
@@ -11599,7 +11599,7 @@
       </p:sp>
       <p:pic>
         <p:nvPicPr>
-          <p:cNvPr id="10" name="icon-112" descr="/tmp/tmp.U4D0us9tfa/icons/weather-clear-night.png">    </p:cNvPr>
+          <p:cNvPr id="10" name="icon-112" descr="/tmp/tmp.cGG6SXUsEK/icons/weather-clear-night.png">    </p:cNvPr>
           <p:cNvPicPr>
             <a:picLocks noChangeAspect="1"/>
           </p:cNvPicPr>
@@ -11699,7 +11699,7 @@
       </p:sp>
       <p:pic>
         <p:nvPicPr>
-          <p:cNvPr id="13" name="icon-115" descr="/tmp/tmp.U4D0us9tfa/icons/video-display.png">    </p:cNvPr>
+          <p:cNvPr id="13" name="icon-115" descr="/tmp/tmp.cGG6SXUsEK/icons/video-display.png">    </p:cNvPr>
           <p:cNvPicPr>
             <a:picLocks noChangeAspect="1"/>
           </p:cNvPicPr>
@@ -11799,7 +11799,7 @@
       </p:sp>
       <p:pic>
         <p:nvPicPr>
-          <p:cNvPr id="16" name="icon-118" descr="/tmp/tmp.U4D0us9tfa/icons/alarm.png">    </p:cNvPr>
+          <p:cNvPr id="16" name="icon-118" descr="/tmp/tmp.cGG6SXUsEK/icons/alarm.png">    </p:cNvPr>
           <p:cNvPicPr>
             <a:picLocks noChangeAspect="1"/>
           </p:cNvPicPr>
@@ -11899,7 +11899,7 @@
       </p:sp>
       <p:pic>
         <p:nvPicPr>
-          <p:cNvPr id="19" name="icon-121" descr="/tmp/tmp.U4D0us9tfa/icons/system-run.png">    </p:cNvPr>
+          <p:cNvPr id="19" name="icon-121" descr="/tmp/tmp.cGG6SXUsEK/icons/system-run.png">    </p:cNvPr>
           <p:cNvPicPr>
             <a:picLocks noChangeAspect="1"/>
           </p:cNvPicPr>
@@ -12125,7 +12125,7 @@
       </p:sp>
       <p:pic>
         <p:nvPicPr>
-          <p:cNvPr id="5" name="monitor" descr="/tmp/tmp.U4D0us9tfa/img/speedtest.jpg">    </p:cNvPr>
+          <p:cNvPr id="5" name="monitor" descr="/tmp/tmp.cGG6SXUsEK/img/speedtest.jpg">    </p:cNvPr>
           <p:cNvPicPr>
             <a:picLocks noChangeAspect="1"/>
           </p:cNvPicPr>
@@ -12156,7 +12156,7 @@
       </p:pic>
       <p:pic>
         <p:nvPicPr>
-          <p:cNvPr id="6" name="media" descr="/tmp/tmp.U4D0us9tfa/img/media.jpg">    </p:cNvPr>
+          <p:cNvPr id="6" name="media" descr="/tmp/tmp.cGG6SXUsEK/img/media.jpg">    </p:cNvPr>
           <p:cNvPicPr>
             <a:picLocks noChangeAspect="1"/>
           </p:cNvPicPr>
@@ -12243,7 +12243,7 @@
       </p:sp>
       <p:pic>
         <p:nvPicPr>
-          <p:cNvPr id="9" name="icon-125" descr="/tmp/tmp.U4D0us9tfa/icons/video-display.png">    </p:cNvPr>
+          <p:cNvPr id="9" name="icon-125" descr="/tmp/tmp.cGG6SXUsEK/icons/video-display.png">    </p:cNvPr>
           <p:cNvPicPr>
             <a:picLocks noChangeAspect="1"/>
           </p:cNvPicPr>
@@ -12343,7 +12343,7 @@
       </p:sp>
       <p:pic>
         <p:nvPicPr>
-          <p:cNvPr id="12" name="icon-128" descr="/tmp/tmp.U4D0us9tfa/icons/network-workgroup.png">    </p:cNvPr>
+          <p:cNvPr id="12" name="icon-128" descr="/tmp/tmp.cGG6SXUsEK/icons/network-workgroup.png">    </p:cNvPr>
           <p:cNvPicPr>
             <a:picLocks noChangeAspect="1"/>
           </p:cNvPicPr>
@@ -12443,7 +12443,7 @@
       </p:sp>
       <p:pic>
         <p:nvPicPr>
-          <p:cNvPr id="15" name="icon-131" descr="/tmp/tmp.U4D0us9tfa/icons/audio-speakers.png">    </p:cNvPr>
+          <p:cNvPr id="15" name="icon-131" descr="/tmp/tmp.cGG6SXUsEK/icons/audio-speakers.png">    </p:cNvPr>
           <p:cNvPicPr>
             <a:picLocks noChangeAspect="1"/>
           </p:cNvPicPr>
@@ -12543,7 +12543,7 @@
       </p:sp>
       <p:pic>
         <p:nvPicPr>
-          <p:cNvPr id="18" name="icon-134" descr="/tmp/tmp.U4D0us9tfa/icons/edit-paste.png">    </p:cNvPr>
+          <p:cNvPr id="18" name="icon-134" descr="/tmp/tmp.cGG6SXUsEK/icons/edit-paste.png">    </p:cNvPr>
           <p:cNvPicPr>
             <a:picLocks noChangeAspect="1"/>
           </p:cNvPicPr>

</xml_diff>

<commit_message>
docs(overview): rebuild with the new Web Hang scene
</commit_message>
<xml_diff>
--- a/docs/MK-Workstation-Overview.pptx
+++ b/docs/MK-Workstation-Overview.pptx
@@ -120,40 +120,40 @@
   <p:extLst>
     <p:ext uri="{521415D9-36F7-43E2-AB2F-B90AF26B5E84}">
       <p14:sectionLst xmlns:p14="http://schemas.microsoft.com/office/powerpoint/2010/main">
-        <p14:section name="Introduction" id="{99a4c4c7-91ff-61b9-03d7-6aa78c10da84}">
+        <p14:section name="Introduction" id="{c2896efb-69e5-53fa-8b50-aeab402b9b39}">
           <p14:sldIdLst>
             <p14:sldId id="256"/>
             <p14:sldId id="257"/>
           </p14:sldIdLst>
         </p14:section>
-        <p14:section name="Your desktop" id="{77a79bb4-991c-4d26-0091-6773a0dea2d6}">
+        <p14:section name="Your desktop" id="{eb507075-d200-26dd-9d41-ccba7c352e28}">
           <p14:sldIdLst>
             <p14:sldId id="258"/>
             <p14:sldId id="259"/>
             <p14:sldId id="260"/>
           </p14:sldIdLst>
         </p14:section>
-        <p14:section name="MK Notes" id="{ae24ba3e-5da2-fd59-082d-5e1d53747fa7}">
+        <p14:section name="MK Notes" id="{b0e3f689-7657-393f-4d31-60aed8437adb}">
           <p14:sldIdLst>
             <p14:sldId id="261"/>
             <p14:sldId id="262"/>
           </p14:sldIdLst>
         </p14:section>
-        <p14:section name="Focus and tools" id="{957cb424-db27-d45d-2e8a-aa783b68c330}">
+        <p14:section name="Focus and tools" id="{8eb6ddc9-ff00-0d34-7e83-7efb01f6b790}">
           <p14:sldIdLst>
             <p14:sldId id="263"/>
             <p14:sldId id="264"/>
             <p14:sldId id="265"/>
           </p14:sldIdLst>
         </p14:section>
-        <p14:section name="Your computer" id="{36e7bdf5-86dd-91f3-a1d1-a128ec3a2724}">
+        <p14:section name="Your computer" id="{785f1f8d-6134-dabb-541e-17beb67a25bb}">
           <p14:sldIdLst>
             <p14:sldId id="266"/>
             <p14:sldId id="267"/>
             <p14:sldId id="268"/>
           </p14:sldIdLst>
         </p14:section>
-        <p14:section name="Get started" id="{7d5fcbad-c0be-e158-9ba7-9405f7a20f3a}">
+        <p14:section name="Get started" id="{acda5f5a-32d8-484a-ed13-5ae8f7fbd154}">
           <p14:sldIdLst>
             <p14:sldId id="269"/>
           </p14:sldIdLst>
@@ -2533,7 +2533,7 @@
       </p:grpSpPr>
       <p:pic>
         <p:nvPicPr>
-          <p:cNvPr id="2" name="hero" descr="/tmp/tmp.cGG6SXUsEK/img/welcome.jpg">    </p:cNvPr>
+          <p:cNvPr id="2" name="hero" descr="/tmp/tmp.3zNu4FnGzV/img/welcome.jpg">    </p:cNvPr>
           <p:cNvPicPr>
             <a:picLocks noChangeAspect="1"/>
           </p:cNvPicPr>
@@ -2805,7 +2805,7 @@
       </p:sp>
       <p:pic>
         <p:nvPicPr>
-          <p:cNvPr id="5" name="app-136" descr="/tmp/tmp.cGG6SXUsEK/apps/app.zen_browser.zen.png">    </p:cNvPr>
+          <p:cNvPr id="5" name="app-136" descr="/tmp/tmp.3zNu4FnGzV/apps/app.zen_browser.zen.png">    </p:cNvPr>
           <p:cNvPicPr>
             <a:picLocks noChangeAspect="1"/>
           </p:cNvPicPr>
@@ -2865,7 +2865,7 @@
       </p:sp>
       <p:pic>
         <p:nvPicPr>
-          <p:cNvPr id="7" name="app-138" descr="/tmp/tmp.cGG6SXUsEK/apps/net.cozic.joplin_desktop.png">    </p:cNvPr>
+          <p:cNvPr id="7" name="app-138" descr="/tmp/tmp.3zNu4FnGzV/apps/net.cozic.joplin_desktop.png">    </p:cNvPr>
           <p:cNvPicPr>
             <a:picLocks noChangeAspect="1"/>
           </p:cNvPicPr>
@@ -2925,7 +2925,7 @@
       </p:sp>
       <p:pic>
         <p:nvPicPr>
-          <p:cNvPr id="9" name="app-140" descr="/tmp/tmp.cGG6SXUsEK/apps/org.onlyoffice.desktopeditors.png">    </p:cNvPr>
+          <p:cNvPr id="9" name="app-140" descr="/tmp/tmp.3zNu4FnGzV/apps/org.onlyoffice.desktopeditors.png">    </p:cNvPr>
           <p:cNvPicPr>
             <a:picLocks noChangeAspect="1"/>
           </p:cNvPicPr>
@@ -2985,7 +2985,7 @@
       </p:sp>
       <p:pic>
         <p:nvPicPr>
-          <p:cNvPr id="11" name="app-142" descr="/tmp/tmp.cGG6SXUsEK/apps/vscode.png">    </p:cNvPr>
+          <p:cNvPr id="11" name="app-142" descr="/tmp/tmp.3zNu4FnGzV/apps/vscode.png">    </p:cNvPr>
           <p:cNvPicPr>
             <a:picLocks noChangeAspect="1"/>
           </p:cNvPicPr>
@@ -3045,7 +3045,7 @@
       </p:sp>
       <p:pic>
         <p:nvPicPr>
-          <p:cNvPr id="13" name="app-144" descr="/tmp/tmp.cGG6SXUsEK/apps/com.spotify.Client.png">    </p:cNvPr>
+          <p:cNvPr id="13" name="app-144" descr="/tmp/tmp.3zNu4FnGzV/apps/com.spotify.Client.png">    </p:cNvPr>
           <p:cNvPicPr>
             <a:picLocks noChangeAspect="1"/>
           </p:cNvPicPr>
@@ -3105,7 +3105,7 @@
       </p:sp>
       <p:pic>
         <p:nvPicPr>
-          <p:cNvPr id="15" name="app-146" descr="/tmp/tmp.cGG6SXUsEK/apps/net.lutris.Lutris.png">    </p:cNvPr>
+          <p:cNvPr id="15" name="app-146" descr="/tmp/tmp.3zNu4FnGzV/apps/net.lutris.Lutris.png">    </p:cNvPr>
           <p:cNvPicPr>
             <a:picLocks noChangeAspect="1"/>
           </p:cNvPicPr>
@@ -3165,7 +3165,7 @@
       </p:sp>
       <p:pic>
         <p:nvPicPr>
-          <p:cNvPr id="17" name="app-148" descr="/tmp/tmp.cGG6SXUsEK/apps/com.mattjakeman.ExtensionManager.png">    </p:cNvPr>
+          <p:cNvPr id="17" name="app-148" descr="/tmp/tmp.3zNu4FnGzV/apps/com.mattjakeman.ExtensionManager.png">    </p:cNvPr>
           <p:cNvPicPr>
             <a:picLocks noChangeAspect="1"/>
           </p:cNvPicPr>
@@ -3225,7 +3225,7 @@
       </p:sp>
       <p:pic>
         <p:nvPicPr>
-          <p:cNvPr id="19" name="app-150" descr="/tmp/tmp.cGG6SXUsEK/apps/net.sonobus.SonoBus.png">    </p:cNvPr>
+          <p:cNvPr id="19" name="app-150" descr="/tmp/tmp.3zNu4FnGzV/apps/net.sonobus.SonoBus.png">    </p:cNvPr>
           <p:cNvPicPr>
             <a:picLocks noChangeAspect="1"/>
           </p:cNvPicPr>
@@ -3285,7 +3285,7 @@
       </p:sp>
       <p:pic>
         <p:nvPicPr>
-          <p:cNvPr id="21" name="app-152" descr="/tmp/tmp.cGG6SXUsEK/apps/com.github.tenderowl.frog.png">    </p:cNvPr>
+          <p:cNvPr id="21" name="app-152" descr="/tmp/tmp.3zNu4FnGzV/apps/com.github.tenderowl.frog.png">    </p:cNvPr>
           <p:cNvPicPr>
             <a:picLocks noChangeAspect="1"/>
           </p:cNvPicPr>
@@ -3345,7 +3345,7 @@
       </p:sp>
       <p:pic>
         <p:nvPicPr>
-          <p:cNvPr id="23" name="app-154" descr="/tmp/tmp.cGG6SXUsEK/apps/one.alynx.FlipClock.png">    </p:cNvPr>
+          <p:cNvPr id="23" name="app-154" descr="/tmp/tmp.3zNu4FnGzV/apps/one.alynx.FlipClock.png">    </p:cNvPr>
           <p:cNvPicPr>
             <a:picLocks noChangeAspect="1"/>
           </p:cNvPicPr>
@@ -3405,7 +3405,7 @@
       </p:sp>
       <p:pic>
         <p:nvPicPr>
-          <p:cNvPr id="25" name="app-156" descr="/tmp/tmp.cGG6SXUsEK/apps/io.github.mehulk.MkNotes.png">    </p:cNvPr>
+          <p:cNvPr id="25" name="app-156" descr="/tmp/tmp.3zNu4FnGzV/apps/io.github.mehulk.MkNotes.png">    </p:cNvPr>
           <p:cNvPicPr>
             <a:picLocks noChangeAspect="1"/>
           </p:cNvPicPr>
@@ -3465,7 +3465,7 @@
       </p:sp>
       <p:pic>
         <p:nvPicPr>
-          <p:cNvPr id="27" name="app-158" descr="/tmp/tmp.cGG6SXUsEK/apps/io.github.mehulk.MkCompanion.png">    </p:cNvPr>
+          <p:cNvPr id="27" name="app-158" descr="/tmp/tmp.3zNu4FnGzV/apps/io.github.mehulk.MkCompanion.png">    </p:cNvPr>
           <p:cNvPicPr>
             <a:picLocks noChangeAspect="1"/>
           </p:cNvPicPr>
@@ -3525,7 +3525,7 @@
       </p:sp>
       <p:pic>
         <p:nvPicPr>
-          <p:cNvPr id="29" name="app-160" descr="/tmp/tmp.cGG6SXUsEK/apps/io.github.mehulk.MkTimer.png">    </p:cNvPr>
+          <p:cNvPr id="29" name="app-160" descr="/tmp/tmp.3zNu4FnGzV/apps/io.github.mehulk.MkTimer.png">    </p:cNvPr>
           <p:cNvPicPr>
             <a:picLocks noChangeAspect="1"/>
           </p:cNvPicPr>
@@ -3585,7 +3585,7 @@
       </p:sp>
       <p:pic>
         <p:nvPicPr>
-          <p:cNvPr id="31" name="app-162" descr="/tmp/tmp.cGG6SXUsEK/apps/io.github.mehulk.MkShortcuts.png">    </p:cNvPr>
+          <p:cNvPr id="31" name="app-162" descr="/tmp/tmp.3zNu4FnGzV/apps/io.github.mehulk.MkShortcuts.png">    </p:cNvPr>
           <p:cNvPicPr>
             <a:picLocks noChangeAspect="1"/>
           </p:cNvPicPr>
@@ -3869,7 +3869,7 @@
       </p:sp>
       <p:pic>
         <p:nvPicPr>
-          <p:cNvPr id="7" name="icon-166" descr="/tmp/tmp.cGG6SXUsEK/icons/auth-fingerprint.png">    </p:cNvPr>
+          <p:cNvPr id="7" name="icon-166" descr="/tmp/tmp.3zNu4FnGzV/icons/auth-fingerprint.png">    </p:cNvPr>
           <p:cNvPicPr>
             <a:picLocks noChangeAspect="1"/>
           </p:cNvPicPr>
@@ -3991,7 +3991,7 @@
       </p:sp>
       <p:pic>
         <p:nvPicPr>
-          <p:cNvPr id="11" name="icon-170" descr="/tmp/tmp.cGG6SXUsEK/icons/battery-full.png">    </p:cNvPr>
+          <p:cNvPr id="11" name="icon-170" descr="/tmp/tmp.3zNu4FnGzV/icons/battery-full.png">    </p:cNvPr>
           <p:cNvPicPr>
             <a:picLocks noChangeAspect="1"/>
           </p:cNvPicPr>
@@ -4113,7 +4113,7 @@
       </p:sp>
       <p:pic>
         <p:nvPicPr>
-          <p:cNvPr id="15" name="icon-174" descr="/tmp/tmp.cGG6SXUsEK/icons/audio-speakers.png">    </p:cNvPr>
+          <p:cNvPr id="15" name="icon-174" descr="/tmp/tmp.3zNu4FnGzV/icons/audio-speakers.png">    </p:cNvPr>
           <p:cNvPicPr>
             <a:picLocks noChangeAspect="1"/>
           </p:cNvPicPr>
@@ -4235,7 +4235,7 @@
       </p:sp>
       <p:pic>
         <p:nvPicPr>
-          <p:cNvPr id="19" name="icon-178" descr="/tmp/tmp.cGG6SXUsEK/icons/input-tablet.png">    </p:cNvPr>
+          <p:cNvPr id="19" name="icon-178" descr="/tmp/tmp.3zNu4FnGzV/icons/input-tablet.png">    </p:cNvPr>
           <p:cNvPicPr>
             <a:picLocks noChangeAspect="1"/>
           </p:cNvPicPr>
@@ -4357,7 +4357,7 @@
       </p:sp>
       <p:pic>
         <p:nvPicPr>
-          <p:cNvPr id="23" name="icon-182" descr="/tmp/tmp.cGG6SXUsEK/icons/video-display.png">    </p:cNvPr>
+          <p:cNvPr id="23" name="icon-182" descr="/tmp/tmp.3zNu4FnGzV/icons/video-display.png">    </p:cNvPr>
           <p:cNvPicPr>
             <a:picLocks noChangeAspect="1"/>
           </p:cNvPicPr>
@@ -4479,7 +4479,7 @@
       </p:sp>
       <p:pic>
         <p:nvPicPr>
-          <p:cNvPr id="27" name="icon-186" descr="/tmp/tmp.cGG6SXUsEK/icons/system-run.png">    </p:cNvPr>
+          <p:cNvPr id="27" name="icon-186" descr="/tmp/tmp.3zNu4FnGzV/icons/system-run.png">    </p:cNvPr>
           <p:cNvPicPr>
             <a:picLocks noChangeAspect="1"/>
           </p:cNvPicPr>
@@ -5645,7 +5645,7 @@
       </p:sp>
       <p:pic>
         <p:nvPicPr>
-          <p:cNvPr id="35" name="shortcuts" descr="/tmp/tmp.cGG6SXUsEK/img/shortcuts.jpg">    </p:cNvPr>
+          <p:cNvPr id="35" name="shortcuts" descr="/tmp/tmp.3zNu4FnGzV/img/shortcuts.jpg">    </p:cNvPr>
           <p:cNvPicPr>
             <a:picLocks noChangeAspect="1"/>
           </p:cNvPicPr>
@@ -5878,7 +5878,7 @@
       </p:sp>
       <p:pic>
         <p:nvPicPr>
-          <p:cNvPr id="6" name="icon-220" descr="/tmp/tmp.cGG6SXUsEK/icons/document-open-recent.png">    </p:cNvPr>
+          <p:cNvPr id="6" name="icon-220" descr="/tmp/tmp.3zNu4FnGzV/icons/document-open-recent.png">    </p:cNvPr>
           <p:cNvPicPr>
             <a:picLocks noChangeAspect="1"/>
           </p:cNvPicPr>
@@ -5978,7 +5978,7 @@
       </p:sp>
       <p:pic>
         <p:nvPicPr>
-          <p:cNvPr id="9" name="icon-223" descr="/tmp/tmp.cGG6SXUsEK/icons/user-trash.png">    </p:cNvPr>
+          <p:cNvPr id="9" name="icon-223" descr="/tmp/tmp.3zNu4FnGzV/icons/user-trash.png">    </p:cNvPr>
           <p:cNvPicPr>
             <a:picLocks noChangeAspect="1"/>
           </p:cNvPicPr>
@@ -6078,7 +6078,7 @@
       </p:sp>
       <p:pic>
         <p:nvPicPr>
-          <p:cNvPr id="12" name="icon-226" descr="/tmp/tmp.cGG6SXUsEK/icons/checkbox-checked.png">    </p:cNvPr>
+          <p:cNvPr id="12" name="icon-226" descr="/tmp/tmp.3zNu4FnGzV/icons/checkbox-checked.png">    </p:cNvPr>
           <p:cNvPicPr>
             <a:picLocks noChangeAspect="1"/>
           </p:cNvPicPr>
@@ -6178,7 +6178,7 @@
       </p:sp>
       <p:pic>
         <p:nvPicPr>
-          <p:cNvPr id="15" name="icon-229" descr="/tmp/tmp.cGG6SXUsEK/icons/x-office-document.png">    </p:cNvPr>
+          <p:cNvPr id="15" name="icon-229" descr="/tmp/tmp.3zNu4FnGzV/icons/x-office-document.png">    </p:cNvPr>
           <p:cNvPicPr>
             <a:picLocks noChangeAspect="1"/>
           </p:cNvPicPr>
@@ -6278,7 +6278,7 @@
       </p:sp>
       <p:pic>
         <p:nvPicPr>
-          <p:cNvPr id="18" name="icon-232" descr="/tmp/tmp.cGG6SXUsEK/icons/software-update-available.png">    </p:cNvPr>
+          <p:cNvPr id="18" name="icon-232" descr="/tmp/tmp.3zNu4FnGzV/icons/software-update-available.png">    </p:cNvPr>
           <p:cNvPicPr>
             <a:picLocks noChangeAspect="1"/>
           </p:cNvPicPr>
@@ -6358,7 +6358,7 @@
       </p:sp>
       <p:pic>
         <p:nvPicPr>
-          <p:cNvPr id="20" name="companion" descr="/tmp/tmp.cGG6SXUsEK/img/companion.jpg">    </p:cNvPr>
+          <p:cNvPr id="20" name="companion" descr="/tmp/tmp.3zNu4FnGzV/img/companion.jpg">    </p:cNvPr>
           <p:cNvPicPr>
             <a:picLocks noChangeAspect="1"/>
           </p:cNvPicPr>
@@ -7087,7 +7087,7 @@
       </p:sp>
       <p:pic>
         <p:nvPicPr>
-          <p:cNvPr id="7" name="icon-2" descr="/tmp/tmp.cGG6SXUsEK/icons/edit-undo.png">    </p:cNvPr>
+          <p:cNvPr id="7" name="icon-2" descr="/tmp/tmp.3zNu4FnGzV/icons/edit-undo.png">    </p:cNvPr>
           <p:cNvPicPr>
             <a:picLocks noChangeAspect="1"/>
           </p:cNvPicPr>
@@ -7187,7 +7187,7 @@
       </p:sp>
       <p:pic>
         <p:nvPicPr>
-          <p:cNvPr id="10" name="icon-5" descr="/tmp/tmp.cGG6SXUsEK/icons/software-update-available.png">    </p:cNvPr>
+          <p:cNvPr id="10" name="icon-5" descr="/tmp/tmp.3zNu4FnGzV/icons/software-update-available.png">    </p:cNvPr>
           <p:cNvPicPr>
             <a:picLocks noChangeAspect="1"/>
           </p:cNvPicPr>
@@ -7845,7 +7845,7 @@
       </p:sp>
       <p:pic>
         <p:nvPicPr>
-          <p:cNvPr id="5" name="alttab-19" descr="/tmp/tmp.cGG6SXUsEK/img/alttab.jpg">    </p:cNvPr>
+          <p:cNvPr id="5" name="alttab-19" descr="/tmp/tmp.3zNu4FnGzV/img/alttab.jpg">    </p:cNvPr>
           <p:cNvPicPr>
             <a:picLocks noChangeAspect="1"/>
           </p:cNvPicPr>
@@ -7932,7 +7932,7 @@
       </p:sp>
       <p:pic>
         <p:nvPicPr>
-          <p:cNvPr id="8" name="icon-22" descr="/tmp/tmp.cGG6SXUsEK/icons/view-grid.png">    </p:cNvPr>
+          <p:cNvPr id="8" name="icon-22" descr="/tmp/tmp.3zNu4FnGzV/icons/view-grid.png">    </p:cNvPr>
           <p:cNvPicPr>
             <a:picLocks noChangeAspect="1"/>
           </p:cNvPicPr>
@@ -8032,7 +8032,7 @@
       </p:sp>
       <p:pic>
         <p:nvPicPr>
-          <p:cNvPr id="11" name="icon-25" descr="/tmp/tmp.cGG6SXUsEK/icons/input-touchpad.png">    </p:cNvPr>
+          <p:cNvPr id="11" name="icon-25" descr="/tmp/tmp.3zNu4FnGzV/icons/input-touchpad.png">    </p:cNvPr>
           <p:cNvPicPr>
             <a:picLocks noChangeAspect="1"/>
           </p:cNvPicPr>
@@ -8132,7 +8132,7 @@
       </p:sp>
       <p:pic>
         <p:nvPicPr>
-          <p:cNvPr id="14" name="icon-28" descr="/tmp/tmp.cGG6SXUsEK/icons/view-dual.png">    </p:cNvPr>
+          <p:cNvPr id="14" name="icon-28" descr="/tmp/tmp.3zNu4FnGzV/icons/view-dual.png">    </p:cNvPr>
           <p:cNvPicPr>
             <a:picLocks noChangeAspect="1"/>
           </p:cNvPicPr>
@@ -8232,7 +8232,7 @@
       </p:sp>
       <p:pic>
         <p:nvPicPr>
-          <p:cNvPr id="17" name="icon-31" descr="/tmp/tmp.cGG6SXUsEK/icons/system-run.png">    </p:cNvPr>
+          <p:cNvPr id="17" name="icon-31" descr="/tmp/tmp.3zNu4FnGzV/icons/system-run.png">    </p:cNvPr>
           <p:cNvPicPr>
             <a:picLocks noChangeAspect="1"/>
           </p:cNvPicPr>
@@ -8458,7 +8458,7 @@
       </p:sp>
       <p:pic>
         <p:nvPicPr>
-          <p:cNvPr id="5" name="tiled-33" descr="/tmp/tmp.cGG6SXUsEK/img/tiled.jpg">    </p:cNvPr>
+          <p:cNvPr id="5" name="tiled-33" descr="/tmp/tmp.3zNu4FnGzV/img/tiled.jpg">    </p:cNvPr>
           <p:cNvPicPr>
             <a:picLocks noChangeAspect="1"/>
           </p:cNvPicPr>
@@ -8545,7 +8545,7 @@
       </p:sp>
       <p:pic>
         <p:nvPicPr>
-          <p:cNvPr id="8" name="icon-36" descr="/tmp/tmp.cGG6SXUsEK/icons/view-dual.png">    </p:cNvPr>
+          <p:cNvPr id="8" name="icon-36" descr="/tmp/tmp.3zNu4FnGzV/icons/view-dual.png">    </p:cNvPr>
           <p:cNvPicPr>
             <a:picLocks noChangeAspect="1"/>
           </p:cNvPicPr>
@@ -8645,7 +8645,7 @@
       </p:sp>
       <p:pic>
         <p:nvPicPr>
-          <p:cNvPr id="11" name="icon-39" descr="/tmp/tmp.cGG6SXUsEK/icons/window-new.png">    </p:cNvPr>
+          <p:cNvPr id="11" name="icon-39" descr="/tmp/tmp.3zNu4FnGzV/icons/window-new.png">    </p:cNvPr>
           <p:cNvPicPr>
             <a:picLocks noChangeAspect="1"/>
           </p:cNvPicPr>
@@ -8745,7 +8745,7 @@
       </p:sp>
       <p:pic>
         <p:nvPicPr>
-          <p:cNvPr id="14" name="icon-42" descr="/tmp/tmp.cGG6SXUsEK/icons/view-pin.png">    </p:cNvPr>
+          <p:cNvPr id="14" name="icon-42" descr="/tmp/tmp.3zNu4FnGzV/icons/view-pin.png">    </p:cNvPr>
           <p:cNvPicPr>
             <a:picLocks noChangeAspect="1"/>
           </p:cNvPicPr>
@@ -8845,7 +8845,7 @@
       </p:sp>
       <p:pic>
         <p:nvPicPr>
-          <p:cNvPr id="17" name="icon-45" descr="/tmp/tmp.cGG6SXUsEK/icons/view-grid.png">    </p:cNvPr>
+          <p:cNvPr id="17" name="icon-45" descr="/tmp/tmp.3zNu4FnGzV/icons/view-grid.png">    </p:cNvPr>
           <p:cNvPicPr>
             <a:picLocks noChangeAspect="1"/>
           </p:cNvPicPr>
@@ -9071,7 +9071,7 @@
       </p:sp>
       <p:pic>
         <p:nvPicPr>
-          <p:cNvPr id="5" name="welcome-47" descr="/tmp/tmp.cGG6SXUsEK/img/welcome.jpg">    </p:cNvPr>
+          <p:cNvPr id="5" name="welcome-47" descr="/tmp/tmp.3zNu4FnGzV/img/welcome.jpg">    </p:cNvPr>
           <p:cNvPicPr>
             <a:picLocks noChangeAspect="1"/>
           </p:cNvPicPr>
@@ -9158,7 +9158,7 @@
       </p:sp>
       <p:pic>
         <p:nvPicPr>
-          <p:cNvPr id="8" name="icon-50" descr="/tmp/tmp.cGG6SXUsEK/icons/weather-clear-night.png">    </p:cNvPr>
+          <p:cNvPr id="8" name="icon-50" descr="/tmp/tmp.3zNu4FnGzV/icons/weather-clear-night.png">    </p:cNvPr>
           <p:cNvPicPr>
             <a:picLocks noChangeAspect="1"/>
           </p:cNvPicPr>
@@ -9258,7 +9258,7 @@
       </p:sp>
       <p:pic>
         <p:nvPicPr>
-          <p:cNvPr id="11" name="icon-53" descr="/tmp/tmp.cGG6SXUsEK/icons/view-pin.png">    </p:cNvPr>
+          <p:cNvPr id="11" name="icon-53" descr="/tmp/tmp.3zNu4FnGzV/icons/view-pin.png">    </p:cNvPr>
           <p:cNvPicPr>
             <a:picLocks noChangeAspect="1"/>
           </p:cNvPicPr>
@@ -9358,7 +9358,7 @@
       </p:sp>
       <p:pic>
         <p:nvPicPr>
-          <p:cNvPr id="14" name="icon-56" descr="/tmp/tmp.cGG6SXUsEK/icons/face-smile.png">    </p:cNvPr>
+          <p:cNvPr id="14" name="icon-56" descr="/tmp/tmp.3zNu4FnGzV/icons/face-smile.png">    </p:cNvPr>
           <p:cNvPicPr>
             <a:picLocks noChangeAspect="1"/>
           </p:cNvPicPr>
@@ -9458,7 +9458,7 @@
       </p:sp>
       <p:pic>
         <p:nvPicPr>
-          <p:cNvPr id="17" name="icon-59" descr="/tmp/tmp.cGG6SXUsEK/icons/preferences-color.png">    </p:cNvPr>
+          <p:cNvPr id="17" name="icon-59" descr="/tmp/tmp.3zNu4FnGzV/icons/preferences-color.png">    </p:cNvPr>
           <p:cNvPicPr>
             <a:picLocks noChangeAspect="1"/>
           </p:cNvPicPr>
@@ -9684,7 +9684,7 @@
       </p:sp>
       <p:pic>
         <p:nvPicPr>
-          <p:cNvPr id="5" name="notes-split-61" descr="/tmp/tmp.cGG6SXUsEK/img/notes-split.jpg">    </p:cNvPr>
+          <p:cNvPr id="5" name="notes-split-61" descr="/tmp/tmp.3zNu4FnGzV/img/notes-split.jpg">    </p:cNvPr>
           <p:cNvPicPr>
             <a:picLocks noChangeAspect="1"/>
           </p:cNvPicPr>
@@ -9715,7 +9715,7 @@
       </p:pic>
       <p:pic>
         <p:nvPicPr>
-          <p:cNvPr id="6" name="phone" descr="/tmp/tmp.cGG6SXUsEK/img/phone-note.jpg">    </p:cNvPr>
+          <p:cNvPr id="6" name="phone" descr="/tmp/tmp.3zNu4FnGzV/img/phone-note.jpg">    </p:cNvPr>
           <p:cNvPicPr>
             <a:picLocks noChangeAspect="1"/>
           </p:cNvPicPr>
@@ -9802,7 +9802,7 @@
       </p:sp>
       <p:pic>
         <p:nvPicPr>
-          <p:cNvPr id="9" name="icon-64" descr="/tmp/tmp.cGG6SXUsEK/icons/x-office-document.png">    </p:cNvPr>
+          <p:cNvPr id="9" name="icon-64" descr="/tmp/tmp.3zNu4FnGzV/icons/x-office-document.png">    </p:cNvPr>
           <p:cNvPicPr>
             <a:picLocks noChangeAspect="1"/>
           </p:cNvPicPr>
@@ -9902,7 +9902,7 @@
       </p:sp>
       <p:pic>
         <p:nvPicPr>
-          <p:cNvPr id="12" name="icon-67" descr="/tmp/tmp.cGG6SXUsEK/icons/network-workgroup.png">    </p:cNvPr>
+          <p:cNvPr id="12" name="icon-67" descr="/tmp/tmp.3zNu4FnGzV/icons/network-workgroup.png">    </p:cNvPr>
           <p:cNvPicPr>
             <a:picLocks noChangeAspect="1"/>
           </p:cNvPicPr>
@@ -10002,7 +10002,7 @@
       </p:sp>
       <p:pic>
         <p:nvPicPr>
-          <p:cNvPr id="15" name="icon-70" descr="/tmp/tmp.cGG6SXUsEK/icons/applications-graphics.png">    </p:cNvPr>
+          <p:cNvPr id="15" name="icon-70" descr="/tmp/tmp.3zNu4FnGzV/icons/applications-graphics.png">    </p:cNvPr>
           <p:cNvPicPr>
             <a:picLocks noChangeAspect="1"/>
           </p:cNvPicPr>
@@ -10102,7 +10102,7 @@
       </p:sp>
       <p:pic>
         <p:nvPicPr>
-          <p:cNvPr id="18" name="icon-73" descr="/tmp/tmp.cGG6SXUsEK/icons/edit-paste.png">    </p:cNvPr>
+          <p:cNvPr id="18" name="icon-73" descr="/tmp/tmp.3zNu4FnGzV/icons/edit-paste.png">    </p:cNvPr>
           <p:cNvPicPr>
             <a:picLocks noChangeAspect="1"/>
           </p:cNvPicPr>
@@ -10370,7 +10370,7 @@
       </p:sp>
       <p:pic>
         <p:nvPicPr>
-          <p:cNvPr id="7" name="icon-77" descr="/tmp/tmp.cGG6SXUsEK/icons/emblem-system.png">    </p:cNvPr>
+          <p:cNvPr id="7" name="icon-77" descr="/tmp/tmp.3zNu4FnGzV/icons/emblem-system.png">    </p:cNvPr>
           <p:cNvPicPr>
             <a:picLocks noChangeAspect="1"/>
           </p:cNvPicPr>
@@ -10492,7 +10492,7 @@
       </p:sp>
       <p:pic>
         <p:nvPicPr>
-          <p:cNvPr id="11" name="icon-81" descr="/tmp/tmp.cGG6SXUsEK/icons/x-office-document.png">    </p:cNvPr>
+          <p:cNvPr id="11" name="icon-81" descr="/tmp/tmp.3zNu4FnGzV/icons/x-office-document.png">    </p:cNvPr>
           <p:cNvPicPr>
             <a:picLocks noChangeAspect="1"/>
           </p:cNvPicPr>
@@ -10614,7 +10614,7 @@
       </p:sp>
       <p:pic>
         <p:nvPicPr>
-          <p:cNvPr id="15" name="icon-85" descr="/tmp/tmp.cGG6SXUsEK/icons/network-workgroup.png">    </p:cNvPr>
+          <p:cNvPr id="15" name="icon-85" descr="/tmp/tmp.3zNu4FnGzV/icons/network-workgroup.png">    </p:cNvPr>
           <p:cNvPicPr>
             <a:picLocks noChangeAspect="1"/>
           </p:cNvPicPr>
@@ -10736,7 +10736,7 @@
       </p:sp>
       <p:pic>
         <p:nvPicPr>
-          <p:cNvPr id="19" name="icon-89" descr="/tmp/tmp.cGG6SXUsEK/icons/document-open-recent.png">    </p:cNvPr>
+          <p:cNvPr id="19" name="icon-89" descr="/tmp/tmp.3zNu4FnGzV/icons/document-open-recent.png">    </p:cNvPr>
           <p:cNvPicPr>
             <a:picLocks noChangeAspect="1"/>
           </p:cNvPicPr>
@@ -10858,7 +10858,7 @@
       </p:sp>
       <p:pic>
         <p:nvPicPr>
-          <p:cNvPr id="23" name="icon-93" descr="/tmp/tmp.cGG6SXUsEK/icons/x-office-calendar.png">    </p:cNvPr>
+          <p:cNvPr id="23" name="icon-93" descr="/tmp/tmp.3zNu4FnGzV/icons/x-office-calendar.png">    </p:cNvPr>
           <p:cNvPicPr>
             <a:picLocks noChangeAspect="1"/>
           </p:cNvPicPr>
@@ -10980,7 +10980,7 @@
       </p:sp>
       <p:pic>
         <p:nvPicPr>
-          <p:cNvPr id="27" name="icon-97" descr="/tmp/tmp.cGG6SXUsEK/icons/checkbox-checked.png">    </p:cNvPr>
+          <p:cNvPr id="27" name="icon-97" descr="/tmp/tmp.3zNu4FnGzV/icons/checkbox-checked.png">    </p:cNvPr>
           <p:cNvPicPr>
             <a:picLocks noChangeAspect="1"/>
           </p:cNvPicPr>
@@ -11102,7 +11102,7 @@
       </p:sp>
       <p:pic>
         <p:nvPicPr>
-          <p:cNvPr id="31" name="icon-101" descr="/tmp/tmp.cGG6SXUsEK/icons/edit-paste.png">    </p:cNvPr>
+          <p:cNvPr id="31" name="icon-101" descr="/tmp/tmp.3zNu4FnGzV/icons/edit-paste.png">    </p:cNvPr>
           <p:cNvPicPr>
             <a:picLocks noChangeAspect="1"/>
           </p:cNvPicPr>
@@ -11224,7 +11224,7 @@
       </p:sp>
       <p:pic>
         <p:nvPicPr>
-          <p:cNvPr id="35" name="icon-105" descr="/tmp/tmp.cGG6SXUsEK/icons/preferences-color.png">    </p:cNvPr>
+          <p:cNvPr id="35" name="icon-105" descr="/tmp/tmp.3zNu4FnGzV/icons/preferences-color.png">    </p:cNvPr>
           <p:cNvPicPr>
             <a:picLocks noChangeAspect="1"/>
           </p:cNvPicPr>
@@ -11450,7 +11450,7 @@
       </p:sp>
       <p:pic>
         <p:nvPicPr>
-          <p:cNvPr id="5" name="scene-web-107" descr="/tmp/tmp.cGG6SXUsEK/img/scene-web.jpg">    </p:cNvPr>
+          <p:cNvPr id="5" name="scene-web-107" descr="/tmp/tmp.3zNu4FnGzV/img/scene-web.jpg">    </p:cNvPr>
           <p:cNvPicPr>
             <a:picLocks noChangeAspect="1"/>
           </p:cNvPicPr>
@@ -11481,7 +11481,7 @@
       </p:pic>
       <p:pic>
         <p:nvPicPr>
-          <p:cNvPr id="6" name="scene-knight-108" descr="/tmp/tmp.cGG6SXUsEK/img/scene-knight.jpg">    </p:cNvPr>
+          <p:cNvPr id="6" name="scene-knight-108" descr="/tmp/tmp.3zNu4FnGzV/img/scene-knight.jpg">    </p:cNvPr>
           <p:cNvPicPr>
             <a:picLocks noChangeAspect="1"/>
           </p:cNvPicPr>
@@ -11512,7 +11512,7 @@
       </p:pic>
       <p:pic>
         <p:nvPicPr>
-          <p:cNvPr id="7" name="scene-matrix-109" descr="/tmp/tmp.cGG6SXUsEK/img/scene-matrix.jpg">    </p:cNvPr>
+          <p:cNvPr id="7" name="scene-matrix-109" descr="/tmp/tmp.3zNu4FnGzV/img/scene-matrix.jpg">    </p:cNvPr>
           <p:cNvPicPr>
             <a:picLocks noChangeAspect="1"/>
           </p:cNvPicPr>
@@ -11599,7 +11599,7 @@
       </p:sp>
       <p:pic>
         <p:nvPicPr>
-          <p:cNvPr id="10" name="icon-112" descr="/tmp/tmp.cGG6SXUsEK/icons/weather-clear-night.png">    </p:cNvPr>
+          <p:cNvPr id="10" name="icon-112" descr="/tmp/tmp.3zNu4FnGzV/icons/weather-clear-night.png">    </p:cNvPr>
           <p:cNvPicPr>
             <a:picLocks noChangeAspect="1"/>
           </p:cNvPicPr>
@@ -11699,7 +11699,7 @@
       </p:sp>
       <p:pic>
         <p:nvPicPr>
-          <p:cNvPr id="13" name="icon-115" descr="/tmp/tmp.cGG6SXUsEK/icons/video-display.png">    </p:cNvPr>
+          <p:cNvPr id="13" name="icon-115" descr="/tmp/tmp.3zNu4FnGzV/icons/video-display.png">    </p:cNvPr>
           <p:cNvPicPr>
             <a:picLocks noChangeAspect="1"/>
           </p:cNvPicPr>
@@ -11799,7 +11799,7 @@
       </p:sp>
       <p:pic>
         <p:nvPicPr>
-          <p:cNvPr id="16" name="icon-118" descr="/tmp/tmp.cGG6SXUsEK/icons/alarm.png">    </p:cNvPr>
+          <p:cNvPr id="16" name="icon-118" descr="/tmp/tmp.3zNu4FnGzV/icons/alarm.png">    </p:cNvPr>
           <p:cNvPicPr>
             <a:picLocks noChangeAspect="1"/>
           </p:cNvPicPr>
@@ -11899,7 +11899,7 @@
       </p:sp>
       <p:pic>
         <p:nvPicPr>
-          <p:cNvPr id="19" name="icon-121" descr="/tmp/tmp.cGG6SXUsEK/icons/system-run.png">    </p:cNvPr>
+          <p:cNvPr id="19" name="icon-121" descr="/tmp/tmp.3zNu4FnGzV/icons/system-run.png">    </p:cNvPr>
           <p:cNvPicPr>
             <a:picLocks noChangeAspect="1"/>
           </p:cNvPicPr>
@@ -12125,7 +12125,7 @@
       </p:sp>
       <p:pic>
         <p:nvPicPr>
-          <p:cNvPr id="5" name="monitor" descr="/tmp/tmp.cGG6SXUsEK/img/speedtest.jpg">    </p:cNvPr>
+          <p:cNvPr id="5" name="monitor" descr="/tmp/tmp.3zNu4FnGzV/img/speedtest.jpg">    </p:cNvPr>
           <p:cNvPicPr>
             <a:picLocks noChangeAspect="1"/>
           </p:cNvPicPr>
@@ -12156,7 +12156,7 @@
       </p:pic>
       <p:pic>
         <p:nvPicPr>
-          <p:cNvPr id="6" name="media" descr="/tmp/tmp.cGG6SXUsEK/img/media.jpg">    </p:cNvPr>
+          <p:cNvPr id="6" name="media" descr="/tmp/tmp.3zNu4FnGzV/img/media.jpg">    </p:cNvPr>
           <p:cNvPicPr>
             <a:picLocks noChangeAspect="1"/>
           </p:cNvPicPr>
@@ -12243,7 +12243,7 @@
       </p:sp>
       <p:pic>
         <p:nvPicPr>
-          <p:cNvPr id="9" name="icon-125" descr="/tmp/tmp.cGG6SXUsEK/icons/video-display.png">    </p:cNvPr>
+          <p:cNvPr id="9" name="icon-125" descr="/tmp/tmp.3zNu4FnGzV/icons/video-display.png">    </p:cNvPr>
           <p:cNvPicPr>
             <a:picLocks noChangeAspect="1"/>
           </p:cNvPicPr>
@@ -12343,7 +12343,7 @@
       </p:sp>
       <p:pic>
         <p:nvPicPr>
-          <p:cNvPr id="12" name="icon-128" descr="/tmp/tmp.cGG6SXUsEK/icons/network-workgroup.png">    </p:cNvPr>
+          <p:cNvPr id="12" name="icon-128" descr="/tmp/tmp.3zNu4FnGzV/icons/network-workgroup.png">    </p:cNvPr>
           <p:cNvPicPr>
             <a:picLocks noChangeAspect="1"/>
           </p:cNvPicPr>
@@ -12443,7 +12443,7 @@
       </p:sp>
       <p:pic>
         <p:nvPicPr>
-          <p:cNvPr id="15" name="icon-131" descr="/tmp/tmp.cGG6SXUsEK/icons/audio-speakers.png">    </p:cNvPr>
+          <p:cNvPr id="15" name="icon-131" descr="/tmp/tmp.3zNu4FnGzV/icons/audio-speakers.png">    </p:cNvPr>
           <p:cNvPicPr>
             <a:picLocks noChangeAspect="1"/>
           </p:cNvPicPr>
@@ -12543,7 +12543,7 @@
       </p:sp>
       <p:pic>
         <p:nvPicPr>
-          <p:cNvPr id="18" name="icon-134" descr="/tmp/tmp.cGG6SXUsEK/icons/edit-paste.png">    </p:cNvPr>
+          <p:cNvPr id="18" name="icon-134" descr="/tmp/tmp.3zNu4FnGzV/icons/edit-paste.png">    </p:cNvPr>
           <p:cNvPicPr>
             <a:picLocks noChangeAspect="1"/>
           </p:cNvPicPr>

</xml_diff>

<commit_message>
docs(overview): rebuild with the new tribute tower
</commit_message>
<xml_diff>
--- a/docs/MK-Workstation-Overview.pptx
+++ b/docs/MK-Workstation-Overview.pptx
@@ -120,40 +120,40 @@
   <p:extLst>
     <p:ext uri="{521415D9-36F7-43E2-AB2F-B90AF26B5E84}">
       <p14:sectionLst xmlns:p14="http://schemas.microsoft.com/office/powerpoint/2010/main">
-        <p14:section name="Introduction" id="{c2896efb-69e5-53fa-8b50-aeab402b9b39}">
+        <p14:section name="Introduction" id="{a4e91839-7d3c-9630-f0c8-593914acf940}">
           <p14:sldIdLst>
             <p14:sldId id="256"/>
             <p14:sldId id="257"/>
           </p14:sldIdLst>
         </p14:section>
-        <p14:section name="Your desktop" id="{eb507075-d200-26dd-9d41-ccba7c352e28}">
+        <p14:section name="Your desktop" id="{5d129441-d714-7ec2-185a-43c7b315cf0d}">
           <p14:sldIdLst>
             <p14:sldId id="258"/>
             <p14:sldId id="259"/>
             <p14:sldId id="260"/>
           </p14:sldIdLst>
         </p14:section>
-        <p14:section name="MK Notes" id="{b0e3f689-7657-393f-4d31-60aed8437adb}">
+        <p14:section name="MK Notes" id="{856d272f-f163-0b47-b75c-2e4f6bfc24bd}">
           <p14:sldIdLst>
             <p14:sldId id="261"/>
             <p14:sldId id="262"/>
           </p14:sldIdLst>
         </p14:section>
-        <p14:section name="Focus and tools" id="{8eb6ddc9-ff00-0d34-7e83-7efb01f6b790}">
+        <p14:section name="Focus and tools" id="{6adf2f33-0d49-014c-c98c-24c7ceb4f9ea}">
           <p14:sldIdLst>
             <p14:sldId id="263"/>
             <p14:sldId id="264"/>
             <p14:sldId id="265"/>
           </p14:sldIdLst>
         </p14:section>
-        <p14:section name="Your computer" id="{785f1f8d-6134-dabb-541e-17beb67a25bb}">
+        <p14:section name="Your computer" id="{0576ea75-b6d5-859c-14c0-418a14a68bf5}">
           <p14:sldIdLst>
             <p14:sldId id="266"/>
             <p14:sldId id="267"/>
             <p14:sldId id="268"/>
           </p14:sldIdLst>
         </p14:section>
-        <p14:section name="Get started" id="{acda5f5a-32d8-484a-ed13-5ae8f7fbd154}">
+        <p14:section name="Get started" id="{e6a8497c-4358-4496-50a6-81913220da7d}">
           <p14:sldIdLst>
             <p14:sldId id="269"/>
           </p14:sldIdLst>
@@ -2533,7 +2533,7 @@
       </p:grpSpPr>
       <p:pic>
         <p:nvPicPr>
-          <p:cNvPr id="2" name="hero" descr="/tmp/tmp.3zNu4FnGzV/img/welcome.jpg">    </p:cNvPr>
+          <p:cNvPr id="2" name="hero" descr="/tmp/tmp.d1XBSNPuR1/img/welcome.jpg">    </p:cNvPr>
           <p:cNvPicPr>
             <a:picLocks noChangeAspect="1"/>
           </p:cNvPicPr>
@@ -2805,7 +2805,7 @@
       </p:sp>
       <p:pic>
         <p:nvPicPr>
-          <p:cNvPr id="5" name="app-136" descr="/tmp/tmp.3zNu4FnGzV/apps/app.zen_browser.zen.png">    </p:cNvPr>
+          <p:cNvPr id="5" name="app-136" descr="/tmp/tmp.d1XBSNPuR1/apps/app.zen_browser.zen.png">    </p:cNvPr>
           <p:cNvPicPr>
             <a:picLocks noChangeAspect="1"/>
           </p:cNvPicPr>
@@ -2865,7 +2865,7 @@
       </p:sp>
       <p:pic>
         <p:nvPicPr>
-          <p:cNvPr id="7" name="app-138" descr="/tmp/tmp.3zNu4FnGzV/apps/net.cozic.joplin_desktop.png">    </p:cNvPr>
+          <p:cNvPr id="7" name="app-138" descr="/tmp/tmp.d1XBSNPuR1/apps/net.cozic.joplin_desktop.png">    </p:cNvPr>
           <p:cNvPicPr>
             <a:picLocks noChangeAspect="1"/>
           </p:cNvPicPr>
@@ -2925,7 +2925,7 @@
       </p:sp>
       <p:pic>
         <p:nvPicPr>
-          <p:cNvPr id="9" name="app-140" descr="/tmp/tmp.3zNu4FnGzV/apps/org.onlyoffice.desktopeditors.png">    </p:cNvPr>
+          <p:cNvPr id="9" name="app-140" descr="/tmp/tmp.d1XBSNPuR1/apps/org.onlyoffice.desktopeditors.png">    </p:cNvPr>
           <p:cNvPicPr>
             <a:picLocks noChangeAspect="1"/>
           </p:cNvPicPr>
@@ -2985,7 +2985,7 @@
       </p:sp>
       <p:pic>
         <p:nvPicPr>
-          <p:cNvPr id="11" name="app-142" descr="/tmp/tmp.3zNu4FnGzV/apps/vscode.png">    </p:cNvPr>
+          <p:cNvPr id="11" name="app-142" descr="/tmp/tmp.d1XBSNPuR1/apps/vscode.png">    </p:cNvPr>
           <p:cNvPicPr>
             <a:picLocks noChangeAspect="1"/>
           </p:cNvPicPr>
@@ -3045,7 +3045,7 @@
       </p:sp>
       <p:pic>
         <p:nvPicPr>
-          <p:cNvPr id="13" name="app-144" descr="/tmp/tmp.3zNu4FnGzV/apps/com.spotify.Client.png">    </p:cNvPr>
+          <p:cNvPr id="13" name="app-144" descr="/tmp/tmp.d1XBSNPuR1/apps/com.spotify.Client.png">    </p:cNvPr>
           <p:cNvPicPr>
             <a:picLocks noChangeAspect="1"/>
           </p:cNvPicPr>
@@ -3105,7 +3105,7 @@
       </p:sp>
       <p:pic>
         <p:nvPicPr>
-          <p:cNvPr id="15" name="app-146" descr="/tmp/tmp.3zNu4FnGzV/apps/net.lutris.Lutris.png">    </p:cNvPr>
+          <p:cNvPr id="15" name="app-146" descr="/tmp/tmp.d1XBSNPuR1/apps/net.lutris.Lutris.png">    </p:cNvPr>
           <p:cNvPicPr>
             <a:picLocks noChangeAspect="1"/>
           </p:cNvPicPr>
@@ -3165,7 +3165,7 @@
       </p:sp>
       <p:pic>
         <p:nvPicPr>
-          <p:cNvPr id="17" name="app-148" descr="/tmp/tmp.3zNu4FnGzV/apps/com.mattjakeman.ExtensionManager.png">    </p:cNvPr>
+          <p:cNvPr id="17" name="app-148" descr="/tmp/tmp.d1XBSNPuR1/apps/com.mattjakeman.ExtensionManager.png">    </p:cNvPr>
           <p:cNvPicPr>
             <a:picLocks noChangeAspect="1"/>
           </p:cNvPicPr>
@@ -3225,7 +3225,7 @@
       </p:sp>
       <p:pic>
         <p:nvPicPr>
-          <p:cNvPr id="19" name="app-150" descr="/tmp/tmp.3zNu4FnGzV/apps/net.sonobus.SonoBus.png">    </p:cNvPr>
+          <p:cNvPr id="19" name="app-150" descr="/tmp/tmp.d1XBSNPuR1/apps/net.sonobus.SonoBus.png">    </p:cNvPr>
           <p:cNvPicPr>
             <a:picLocks noChangeAspect="1"/>
           </p:cNvPicPr>
@@ -3285,7 +3285,7 @@
       </p:sp>
       <p:pic>
         <p:nvPicPr>
-          <p:cNvPr id="21" name="app-152" descr="/tmp/tmp.3zNu4FnGzV/apps/com.github.tenderowl.frog.png">    </p:cNvPr>
+          <p:cNvPr id="21" name="app-152" descr="/tmp/tmp.d1XBSNPuR1/apps/com.github.tenderowl.frog.png">    </p:cNvPr>
           <p:cNvPicPr>
             <a:picLocks noChangeAspect="1"/>
           </p:cNvPicPr>
@@ -3345,7 +3345,7 @@
       </p:sp>
       <p:pic>
         <p:nvPicPr>
-          <p:cNvPr id="23" name="app-154" descr="/tmp/tmp.3zNu4FnGzV/apps/one.alynx.FlipClock.png">    </p:cNvPr>
+          <p:cNvPr id="23" name="app-154" descr="/tmp/tmp.d1XBSNPuR1/apps/one.alynx.FlipClock.png">    </p:cNvPr>
           <p:cNvPicPr>
             <a:picLocks noChangeAspect="1"/>
           </p:cNvPicPr>
@@ -3405,7 +3405,7 @@
       </p:sp>
       <p:pic>
         <p:nvPicPr>
-          <p:cNvPr id="25" name="app-156" descr="/tmp/tmp.3zNu4FnGzV/apps/io.github.mehulk.MkNotes.png">    </p:cNvPr>
+          <p:cNvPr id="25" name="app-156" descr="/tmp/tmp.d1XBSNPuR1/apps/io.github.mehulk.MkNotes.png">    </p:cNvPr>
           <p:cNvPicPr>
             <a:picLocks noChangeAspect="1"/>
           </p:cNvPicPr>
@@ -3465,7 +3465,7 @@
       </p:sp>
       <p:pic>
         <p:nvPicPr>
-          <p:cNvPr id="27" name="app-158" descr="/tmp/tmp.3zNu4FnGzV/apps/io.github.mehulk.MkCompanion.png">    </p:cNvPr>
+          <p:cNvPr id="27" name="app-158" descr="/tmp/tmp.d1XBSNPuR1/apps/io.github.mehulk.MkCompanion.png">    </p:cNvPr>
           <p:cNvPicPr>
             <a:picLocks noChangeAspect="1"/>
           </p:cNvPicPr>
@@ -3525,7 +3525,7 @@
       </p:sp>
       <p:pic>
         <p:nvPicPr>
-          <p:cNvPr id="29" name="app-160" descr="/tmp/tmp.3zNu4FnGzV/apps/io.github.mehulk.MkTimer.png">    </p:cNvPr>
+          <p:cNvPr id="29" name="app-160" descr="/tmp/tmp.d1XBSNPuR1/apps/io.github.mehulk.MkTimer.png">    </p:cNvPr>
           <p:cNvPicPr>
             <a:picLocks noChangeAspect="1"/>
           </p:cNvPicPr>
@@ -3585,7 +3585,7 @@
       </p:sp>
       <p:pic>
         <p:nvPicPr>
-          <p:cNvPr id="31" name="app-162" descr="/tmp/tmp.3zNu4FnGzV/apps/io.github.mehulk.MkShortcuts.png">    </p:cNvPr>
+          <p:cNvPr id="31" name="app-162" descr="/tmp/tmp.d1XBSNPuR1/apps/io.github.mehulk.MkShortcuts.png">    </p:cNvPr>
           <p:cNvPicPr>
             <a:picLocks noChangeAspect="1"/>
           </p:cNvPicPr>
@@ -3869,7 +3869,7 @@
       </p:sp>
       <p:pic>
         <p:nvPicPr>
-          <p:cNvPr id="7" name="icon-166" descr="/tmp/tmp.3zNu4FnGzV/icons/auth-fingerprint.png">    </p:cNvPr>
+          <p:cNvPr id="7" name="icon-166" descr="/tmp/tmp.d1XBSNPuR1/icons/auth-fingerprint.png">    </p:cNvPr>
           <p:cNvPicPr>
             <a:picLocks noChangeAspect="1"/>
           </p:cNvPicPr>
@@ -3991,7 +3991,7 @@
       </p:sp>
       <p:pic>
         <p:nvPicPr>
-          <p:cNvPr id="11" name="icon-170" descr="/tmp/tmp.3zNu4FnGzV/icons/battery-full.png">    </p:cNvPr>
+          <p:cNvPr id="11" name="icon-170" descr="/tmp/tmp.d1XBSNPuR1/icons/battery-full.png">    </p:cNvPr>
           <p:cNvPicPr>
             <a:picLocks noChangeAspect="1"/>
           </p:cNvPicPr>
@@ -4113,7 +4113,7 @@
       </p:sp>
       <p:pic>
         <p:nvPicPr>
-          <p:cNvPr id="15" name="icon-174" descr="/tmp/tmp.3zNu4FnGzV/icons/audio-speakers.png">    </p:cNvPr>
+          <p:cNvPr id="15" name="icon-174" descr="/tmp/tmp.d1XBSNPuR1/icons/audio-speakers.png">    </p:cNvPr>
           <p:cNvPicPr>
             <a:picLocks noChangeAspect="1"/>
           </p:cNvPicPr>
@@ -4235,7 +4235,7 @@
       </p:sp>
       <p:pic>
         <p:nvPicPr>
-          <p:cNvPr id="19" name="icon-178" descr="/tmp/tmp.3zNu4FnGzV/icons/input-tablet.png">    </p:cNvPr>
+          <p:cNvPr id="19" name="icon-178" descr="/tmp/tmp.d1XBSNPuR1/icons/input-tablet.png">    </p:cNvPr>
           <p:cNvPicPr>
             <a:picLocks noChangeAspect="1"/>
           </p:cNvPicPr>
@@ -4357,7 +4357,7 @@
       </p:sp>
       <p:pic>
         <p:nvPicPr>
-          <p:cNvPr id="23" name="icon-182" descr="/tmp/tmp.3zNu4FnGzV/icons/video-display.png">    </p:cNvPr>
+          <p:cNvPr id="23" name="icon-182" descr="/tmp/tmp.d1XBSNPuR1/icons/video-display.png">    </p:cNvPr>
           <p:cNvPicPr>
             <a:picLocks noChangeAspect="1"/>
           </p:cNvPicPr>
@@ -4479,7 +4479,7 @@
       </p:sp>
       <p:pic>
         <p:nvPicPr>
-          <p:cNvPr id="27" name="icon-186" descr="/tmp/tmp.3zNu4FnGzV/icons/system-run.png">    </p:cNvPr>
+          <p:cNvPr id="27" name="icon-186" descr="/tmp/tmp.d1XBSNPuR1/icons/system-run.png">    </p:cNvPr>
           <p:cNvPicPr>
             <a:picLocks noChangeAspect="1"/>
           </p:cNvPicPr>
@@ -5645,7 +5645,7 @@
       </p:sp>
       <p:pic>
         <p:nvPicPr>
-          <p:cNvPr id="35" name="shortcuts" descr="/tmp/tmp.3zNu4FnGzV/img/shortcuts.jpg">    </p:cNvPr>
+          <p:cNvPr id="35" name="shortcuts" descr="/tmp/tmp.d1XBSNPuR1/img/shortcuts.jpg">    </p:cNvPr>
           <p:cNvPicPr>
             <a:picLocks noChangeAspect="1"/>
           </p:cNvPicPr>
@@ -5878,7 +5878,7 @@
       </p:sp>
       <p:pic>
         <p:nvPicPr>
-          <p:cNvPr id="6" name="icon-220" descr="/tmp/tmp.3zNu4FnGzV/icons/document-open-recent.png">    </p:cNvPr>
+          <p:cNvPr id="6" name="icon-220" descr="/tmp/tmp.d1XBSNPuR1/icons/document-open-recent.png">    </p:cNvPr>
           <p:cNvPicPr>
             <a:picLocks noChangeAspect="1"/>
           </p:cNvPicPr>
@@ -5978,7 +5978,7 @@
       </p:sp>
       <p:pic>
         <p:nvPicPr>
-          <p:cNvPr id="9" name="icon-223" descr="/tmp/tmp.3zNu4FnGzV/icons/user-trash.png">    </p:cNvPr>
+          <p:cNvPr id="9" name="icon-223" descr="/tmp/tmp.d1XBSNPuR1/icons/user-trash.png">    </p:cNvPr>
           <p:cNvPicPr>
             <a:picLocks noChangeAspect="1"/>
           </p:cNvPicPr>
@@ -6078,7 +6078,7 @@
       </p:sp>
       <p:pic>
         <p:nvPicPr>
-          <p:cNvPr id="12" name="icon-226" descr="/tmp/tmp.3zNu4FnGzV/icons/checkbox-checked.png">    </p:cNvPr>
+          <p:cNvPr id="12" name="icon-226" descr="/tmp/tmp.d1XBSNPuR1/icons/checkbox-checked.png">    </p:cNvPr>
           <p:cNvPicPr>
             <a:picLocks noChangeAspect="1"/>
           </p:cNvPicPr>
@@ -6178,7 +6178,7 @@
       </p:sp>
       <p:pic>
         <p:nvPicPr>
-          <p:cNvPr id="15" name="icon-229" descr="/tmp/tmp.3zNu4FnGzV/icons/x-office-document.png">    </p:cNvPr>
+          <p:cNvPr id="15" name="icon-229" descr="/tmp/tmp.d1XBSNPuR1/icons/x-office-document.png">    </p:cNvPr>
           <p:cNvPicPr>
             <a:picLocks noChangeAspect="1"/>
           </p:cNvPicPr>
@@ -6278,7 +6278,7 @@
       </p:sp>
       <p:pic>
         <p:nvPicPr>
-          <p:cNvPr id="18" name="icon-232" descr="/tmp/tmp.3zNu4FnGzV/icons/software-update-available.png">    </p:cNvPr>
+          <p:cNvPr id="18" name="icon-232" descr="/tmp/tmp.d1XBSNPuR1/icons/software-update-available.png">    </p:cNvPr>
           <p:cNvPicPr>
             <a:picLocks noChangeAspect="1"/>
           </p:cNvPicPr>
@@ -6358,7 +6358,7 @@
       </p:sp>
       <p:pic>
         <p:nvPicPr>
-          <p:cNvPr id="20" name="companion" descr="/tmp/tmp.3zNu4FnGzV/img/companion.jpg">    </p:cNvPr>
+          <p:cNvPr id="20" name="companion" descr="/tmp/tmp.d1XBSNPuR1/img/companion.jpg">    </p:cNvPr>
           <p:cNvPicPr>
             <a:picLocks noChangeAspect="1"/>
           </p:cNvPicPr>
@@ -7087,7 +7087,7 @@
       </p:sp>
       <p:pic>
         <p:nvPicPr>
-          <p:cNvPr id="7" name="icon-2" descr="/tmp/tmp.3zNu4FnGzV/icons/edit-undo.png">    </p:cNvPr>
+          <p:cNvPr id="7" name="icon-2" descr="/tmp/tmp.d1XBSNPuR1/icons/edit-undo.png">    </p:cNvPr>
           <p:cNvPicPr>
             <a:picLocks noChangeAspect="1"/>
           </p:cNvPicPr>
@@ -7187,7 +7187,7 @@
       </p:sp>
       <p:pic>
         <p:nvPicPr>
-          <p:cNvPr id="10" name="icon-5" descr="/tmp/tmp.3zNu4FnGzV/icons/software-update-available.png">    </p:cNvPr>
+          <p:cNvPr id="10" name="icon-5" descr="/tmp/tmp.d1XBSNPuR1/icons/software-update-available.png">    </p:cNvPr>
           <p:cNvPicPr>
             <a:picLocks noChangeAspect="1"/>
           </p:cNvPicPr>
@@ -7845,7 +7845,7 @@
       </p:sp>
       <p:pic>
         <p:nvPicPr>
-          <p:cNvPr id="5" name="alttab-19" descr="/tmp/tmp.3zNu4FnGzV/img/alttab.jpg">    </p:cNvPr>
+          <p:cNvPr id="5" name="alttab-19" descr="/tmp/tmp.d1XBSNPuR1/img/alttab.jpg">    </p:cNvPr>
           <p:cNvPicPr>
             <a:picLocks noChangeAspect="1"/>
           </p:cNvPicPr>
@@ -7932,7 +7932,7 @@
       </p:sp>
       <p:pic>
         <p:nvPicPr>
-          <p:cNvPr id="8" name="icon-22" descr="/tmp/tmp.3zNu4FnGzV/icons/view-grid.png">    </p:cNvPr>
+          <p:cNvPr id="8" name="icon-22" descr="/tmp/tmp.d1XBSNPuR1/icons/view-grid.png">    </p:cNvPr>
           <p:cNvPicPr>
             <a:picLocks noChangeAspect="1"/>
           </p:cNvPicPr>
@@ -8032,7 +8032,7 @@
       </p:sp>
       <p:pic>
         <p:nvPicPr>
-          <p:cNvPr id="11" name="icon-25" descr="/tmp/tmp.3zNu4FnGzV/icons/input-touchpad.png">    </p:cNvPr>
+          <p:cNvPr id="11" name="icon-25" descr="/tmp/tmp.d1XBSNPuR1/icons/input-touchpad.png">    </p:cNvPr>
           <p:cNvPicPr>
             <a:picLocks noChangeAspect="1"/>
           </p:cNvPicPr>
@@ -8132,7 +8132,7 @@
       </p:sp>
       <p:pic>
         <p:nvPicPr>
-          <p:cNvPr id="14" name="icon-28" descr="/tmp/tmp.3zNu4FnGzV/icons/view-dual.png">    </p:cNvPr>
+          <p:cNvPr id="14" name="icon-28" descr="/tmp/tmp.d1XBSNPuR1/icons/view-dual.png">    </p:cNvPr>
           <p:cNvPicPr>
             <a:picLocks noChangeAspect="1"/>
           </p:cNvPicPr>
@@ -8232,7 +8232,7 @@
       </p:sp>
       <p:pic>
         <p:nvPicPr>
-          <p:cNvPr id="17" name="icon-31" descr="/tmp/tmp.3zNu4FnGzV/icons/system-run.png">    </p:cNvPr>
+          <p:cNvPr id="17" name="icon-31" descr="/tmp/tmp.d1XBSNPuR1/icons/system-run.png">    </p:cNvPr>
           <p:cNvPicPr>
             <a:picLocks noChangeAspect="1"/>
           </p:cNvPicPr>
@@ -8458,7 +8458,7 @@
       </p:sp>
       <p:pic>
         <p:nvPicPr>
-          <p:cNvPr id="5" name="tiled-33" descr="/tmp/tmp.3zNu4FnGzV/img/tiled.jpg">    </p:cNvPr>
+          <p:cNvPr id="5" name="tiled-33" descr="/tmp/tmp.d1XBSNPuR1/img/tiled.jpg">    </p:cNvPr>
           <p:cNvPicPr>
             <a:picLocks noChangeAspect="1"/>
           </p:cNvPicPr>
@@ -8545,7 +8545,7 @@
       </p:sp>
       <p:pic>
         <p:nvPicPr>
-          <p:cNvPr id="8" name="icon-36" descr="/tmp/tmp.3zNu4FnGzV/icons/view-dual.png">    </p:cNvPr>
+          <p:cNvPr id="8" name="icon-36" descr="/tmp/tmp.d1XBSNPuR1/icons/view-dual.png">    </p:cNvPr>
           <p:cNvPicPr>
             <a:picLocks noChangeAspect="1"/>
           </p:cNvPicPr>
@@ -8645,7 +8645,7 @@
       </p:sp>
       <p:pic>
         <p:nvPicPr>
-          <p:cNvPr id="11" name="icon-39" descr="/tmp/tmp.3zNu4FnGzV/icons/window-new.png">    </p:cNvPr>
+          <p:cNvPr id="11" name="icon-39" descr="/tmp/tmp.d1XBSNPuR1/icons/window-new.png">    </p:cNvPr>
           <p:cNvPicPr>
             <a:picLocks noChangeAspect="1"/>
           </p:cNvPicPr>
@@ -8745,7 +8745,7 @@
       </p:sp>
       <p:pic>
         <p:nvPicPr>
-          <p:cNvPr id="14" name="icon-42" descr="/tmp/tmp.3zNu4FnGzV/icons/view-pin.png">    </p:cNvPr>
+          <p:cNvPr id="14" name="icon-42" descr="/tmp/tmp.d1XBSNPuR1/icons/view-pin.png">    </p:cNvPr>
           <p:cNvPicPr>
             <a:picLocks noChangeAspect="1"/>
           </p:cNvPicPr>
@@ -8845,7 +8845,7 @@
       </p:sp>
       <p:pic>
         <p:nvPicPr>
-          <p:cNvPr id="17" name="icon-45" descr="/tmp/tmp.3zNu4FnGzV/icons/view-grid.png">    </p:cNvPr>
+          <p:cNvPr id="17" name="icon-45" descr="/tmp/tmp.d1XBSNPuR1/icons/view-grid.png">    </p:cNvPr>
           <p:cNvPicPr>
             <a:picLocks noChangeAspect="1"/>
           </p:cNvPicPr>
@@ -9071,7 +9071,7 @@
       </p:sp>
       <p:pic>
         <p:nvPicPr>
-          <p:cNvPr id="5" name="welcome-47" descr="/tmp/tmp.3zNu4FnGzV/img/welcome.jpg">    </p:cNvPr>
+          <p:cNvPr id="5" name="welcome-47" descr="/tmp/tmp.d1XBSNPuR1/img/welcome.jpg">    </p:cNvPr>
           <p:cNvPicPr>
             <a:picLocks noChangeAspect="1"/>
           </p:cNvPicPr>
@@ -9158,7 +9158,7 @@
       </p:sp>
       <p:pic>
         <p:nvPicPr>
-          <p:cNvPr id="8" name="icon-50" descr="/tmp/tmp.3zNu4FnGzV/icons/weather-clear-night.png">    </p:cNvPr>
+          <p:cNvPr id="8" name="icon-50" descr="/tmp/tmp.d1XBSNPuR1/icons/weather-clear-night.png">    </p:cNvPr>
           <p:cNvPicPr>
             <a:picLocks noChangeAspect="1"/>
           </p:cNvPicPr>
@@ -9258,7 +9258,7 @@
       </p:sp>
       <p:pic>
         <p:nvPicPr>
-          <p:cNvPr id="11" name="icon-53" descr="/tmp/tmp.3zNu4FnGzV/icons/view-pin.png">    </p:cNvPr>
+          <p:cNvPr id="11" name="icon-53" descr="/tmp/tmp.d1XBSNPuR1/icons/view-pin.png">    </p:cNvPr>
           <p:cNvPicPr>
             <a:picLocks noChangeAspect="1"/>
           </p:cNvPicPr>
@@ -9358,7 +9358,7 @@
       </p:sp>
       <p:pic>
         <p:nvPicPr>
-          <p:cNvPr id="14" name="icon-56" descr="/tmp/tmp.3zNu4FnGzV/icons/face-smile.png">    </p:cNvPr>
+          <p:cNvPr id="14" name="icon-56" descr="/tmp/tmp.d1XBSNPuR1/icons/face-smile.png">    </p:cNvPr>
           <p:cNvPicPr>
             <a:picLocks noChangeAspect="1"/>
           </p:cNvPicPr>
@@ -9458,7 +9458,7 @@
       </p:sp>
       <p:pic>
         <p:nvPicPr>
-          <p:cNvPr id="17" name="icon-59" descr="/tmp/tmp.3zNu4FnGzV/icons/preferences-color.png">    </p:cNvPr>
+          <p:cNvPr id="17" name="icon-59" descr="/tmp/tmp.d1XBSNPuR1/icons/preferences-color.png">    </p:cNvPr>
           <p:cNvPicPr>
             <a:picLocks noChangeAspect="1"/>
           </p:cNvPicPr>
@@ -9684,7 +9684,7 @@
       </p:sp>
       <p:pic>
         <p:nvPicPr>
-          <p:cNvPr id="5" name="notes-split-61" descr="/tmp/tmp.3zNu4FnGzV/img/notes-split.jpg">    </p:cNvPr>
+          <p:cNvPr id="5" name="notes-split-61" descr="/tmp/tmp.d1XBSNPuR1/img/notes-split.jpg">    </p:cNvPr>
           <p:cNvPicPr>
             <a:picLocks noChangeAspect="1"/>
           </p:cNvPicPr>
@@ -9715,7 +9715,7 @@
       </p:pic>
       <p:pic>
         <p:nvPicPr>
-          <p:cNvPr id="6" name="phone" descr="/tmp/tmp.3zNu4FnGzV/img/phone-note.jpg">    </p:cNvPr>
+          <p:cNvPr id="6" name="phone" descr="/tmp/tmp.d1XBSNPuR1/img/phone-note.jpg">    </p:cNvPr>
           <p:cNvPicPr>
             <a:picLocks noChangeAspect="1"/>
           </p:cNvPicPr>
@@ -9802,7 +9802,7 @@
       </p:sp>
       <p:pic>
         <p:nvPicPr>
-          <p:cNvPr id="9" name="icon-64" descr="/tmp/tmp.3zNu4FnGzV/icons/x-office-document.png">    </p:cNvPr>
+          <p:cNvPr id="9" name="icon-64" descr="/tmp/tmp.d1XBSNPuR1/icons/x-office-document.png">    </p:cNvPr>
           <p:cNvPicPr>
             <a:picLocks noChangeAspect="1"/>
           </p:cNvPicPr>
@@ -9902,7 +9902,7 @@
       </p:sp>
       <p:pic>
         <p:nvPicPr>
-          <p:cNvPr id="12" name="icon-67" descr="/tmp/tmp.3zNu4FnGzV/icons/network-workgroup.png">    </p:cNvPr>
+          <p:cNvPr id="12" name="icon-67" descr="/tmp/tmp.d1XBSNPuR1/icons/network-workgroup.png">    </p:cNvPr>
           <p:cNvPicPr>
             <a:picLocks noChangeAspect="1"/>
           </p:cNvPicPr>
@@ -10002,7 +10002,7 @@
       </p:sp>
       <p:pic>
         <p:nvPicPr>
-          <p:cNvPr id="15" name="icon-70" descr="/tmp/tmp.3zNu4FnGzV/icons/applications-graphics.png">    </p:cNvPr>
+          <p:cNvPr id="15" name="icon-70" descr="/tmp/tmp.d1XBSNPuR1/icons/applications-graphics.png">    </p:cNvPr>
           <p:cNvPicPr>
             <a:picLocks noChangeAspect="1"/>
           </p:cNvPicPr>
@@ -10102,7 +10102,7 @@
       </p:sp>
       <p:pic>
         <p:nvPicPr>
-          <p:cNvPr id="18" name="icon-73" descr="/tmp/tmp.3zNu4FnGzV/icons/edit-paste.png">    </p:cNvPr>
+          <p:cNvPr id="18" name="icon-73" descr="/tmp/tmp.d1XBSNPuR1/icons/edit-paste.png">    </p:cNvPr>
           <p:cNvPicPr>
             <a:picLocks noChangeAspect="1"/>
           </p:cNvPicPr>
@@ -10370,7 +10370,7 @@
       </p:sp>
       <p:pic>
         <p:nvPicPr>
-          <p:cNvPr id="7" name="icon-77" descr="/tmp/tmp.3zNu4FnGzV/icons/emblem-system.png">    </p:cNvPr>
+          <p:cNvPr id="7" name="icon-77" descr="/tmp/tmp.d1XBSNPuR1/icons/emblem-system.png">    </p:cNvPr>
           <p:cNvPicPr>
             <a:picLocks noChangeAspect="1"/>
           </p:cNvPicPr>
@@ -10492,7 +10492,7 @@
       </p:sp>
       <p:pic>
         <p:nvPicPr>
-          <p:cNvPr id="11" name="icon-81" descr="/tmp/tmp.3zNu4FnGzV/icons/x-office-document.png">    </p:cNvPr>
+          <p:cNvPr id="11" name="icon-81" descr="/tmp/tmp.d1XBSNPuR1/icons/x-office-document.png">    </p:cNvPr>
           <p:cNvPicPr>
             <a:picLocks noChangeAspect="1"/>
           </p:cNvPicPr>
@@ -10614,7 +10614,7 @@
       </p:sp>
       <p:pic>
         <p:nvPicPr>
-          <p:cNvPr id="15" name="icon-85" descr="/tmp/tmp.3zNu4FnGzV/icons/network-workgroup.png">    </p:cNvPr>
+          <p:cNvPr id="15" name="icon-85" descr="/tmp/tmp.d1XBSNPuR1/icons/network-workgroup.png">    </p:cNvPr>
           <p:cNvPicPr>
             <a:picLocks noChangeAspect="1"/>
           </p:cNvPicPr>
@@ -10736,7 +10736,7 @@
       </p:sp>
       <p:pic>
         <p:nvPicPr>
-          <p:cNvPr id="19" name="icon-89" descr="/tmp/tmp.3zNu4FnGzV/icons/document-open-recent.png">    </p:cNvPr>
+          <p:cNvPr id="19" name="icon-89" descr="/tmp/tmp.d1XBSNPuR1/icons/document-open-recent.png">    </p:cNvPr>
           <p:cNvPicPr>
             <a:picLocks noChangeAspect="1"/>
           </p:cNvPicPr>
@@ -10858,7 +10858,7 @@
       </p:sp>
       <p:pic>
         <p:nvPicPr>
-          <p:cNvPr id="23" name="icon-93" descr="/tmp/tmp.3zNu4FnGzV/icons/x-office-calendar.png">    </p:cNvPr>
+          <p:cNvPr id="23" name="icon-93" descr="/tmp/tmp.d1XBSNPuR1/icons/x-office-calendar.png">    </p:cNvPr>
           <p:cNvPicPr>
             <a:picLocks noChangeAspect="1"/>
           </p:cNvPicPr>
@@ -10980,7 +10980,7 @@
       </p:sp>
       <p:pic>
         <p:nvPicPr>
-          <p:cNvPr id="27" name="icon-97" descr="/tmp/tmp.3zNu4FnGzV/icons/checkbox-checked.png">    </p:cNvPr>
+          <p:cNvPr id="27" name="icon-97" descr="/tmp/tmp.d1XBSNPuR1/icons/checkbox-checked.png">    </p:cNvPr>
           <p:cNvPicPr>
             <a:picLocks noChangeAspect="1"/>
           </p:cNvPicPr>
@@ -11102,7 +11102,7 @@
       </p:sp>
       <p:pic>
         <p:nvPicPr>
-          <p:cNvPr id="31" name="icon-101" descr="/tmp/tmp.3zNu4FnGzV/icons/edit-paste.png">    </p:cNvPr>
+          <p:cNvPr id="31" name="icon-101" descr="/tmp/tmp.d1XBSNPuR1/icons/edit-paste.png">    </p:cNvPr>
           <p:cNvPicPr>
             <a:picLocks noChangeAspect="1"/>
           </p:cNvPicPr>
@@ -11224,7 +11224,7 @@
       </p:sp>
       <p:pic>
         <p:nvPicPr>
-          <p:cNvPr id="35" name="icon-105" descr="/tmp/tmp.3zNu4FnGzV/icons/preferences-color.png">    </p:cNvPr>
+          <p:cNvPr id="35" name="icon-105" descr="/tmp/tmp.d1XBSNPuR1/icons/preferences-color.png">    </p:cNvPr>
           <p:cNvPicPr>
             <a:picLocks noChangeAspect="1"/>
           </p:cNvPicPr>
@@ -11450,7 +11450,7 @@
       </p:sp>
       <p:pic>
         <p:nvPicPr>
-          <p:cNvPr id="5" name="scene-web-107" descr="/tmp/tmp.3zNu4FnGzV/img/scene-web.jpg">    </p:cNvPr>
+          <p:cNvPr id="5" name="scene-web-107" descr="/tmp/tmp.d1XBSNPuR1/img/scene-web.jpg">    </p:cNvPr>
           <p:cNvPicPr>
             <a:picLocks noChangeAspect="1"/>
           </p:cNvPicPr>
@@ -11481,7 +11481,7 @@
       </p:pic>
       <p:pic>
         <p:nvPicPr>
-          <p:cNvPr id="6" name="scene-knight-108" descr="/tmp/tmp.3zNu4FnGzV/img/scene-knight.jpg">    </p:cNvPr>
+          <p:cNvPr id="6" name="scene-knight-108" descr="/tmp/tmp.d1XBSNPuR1/img/scene-knight.jpg">    </p:cNvPr>
           <p:cNvPicPr>
             <a:picLocks noChangeAspect="1"/>
           </p:cNvPicPr>
@@ -11512,7 +11512,7 @@
       </p:pic>
       <p:pic>
         <p:nvPicPr>
-          <p:cNvPr id="7" name="scene-matrix-109" descr="/tmp/tmp.3zNu4FnGzV/img/scene-matrix.jpg">    </p:cNvPr>
+          <p:cNvPr id="7" name="scene-matrix-109" descr="/tmp/tmp.d1XBSNPuR1/img/scene-matrix.jpg">    </p:cNvPr>
           <p:cNvPicPr>
             <a:picLocks noChangeAspect="1"/>
           </p:cNvPicPr>
@@ -11599,7 +11599,7 @@
       </p:sp>
       <p:pic>
         <p:nvPicPr>
-          <p:cNvPr id="10" name="icon-112" descr="/tmp/tmp.3zNu4FnGzV/icons/weather-clear-night.png">    </p:cNvPr>
+          <p:cNvPr id="10" name="icon-112" descr="/tmp/tmp.d1XBSNPuR1/icons/weather-clear-night.png">    </p:cNvPr>
           <p:cNvPicPr>
             <a:picLocks noChangeAspect="1"/>
           </p:cNvPicPr>
@@ -11699,7 +11699,7 @@
       </p:sp>
       <p:pic>
         <p:nvPicPr>
-          <p:cNvPr id="13" name="icon-115" descr="/tmp/tmp.3zNu4FnGzV/icons/video-display.png">    </p:cNvPr>
+          <p:cNvPr id="13" name="icon-115" descr="/tmp/tmp.d1XBSNPuR1/icons/video-display.png">    </p:cNvPr>
           <p:cNvPicPr>
             <a:picLocks noChangeAspect="1"/>
           </p:cNvPicPr>
@@ -11799,7 +11799,7 @@
       </p:sp>
       <p:pic>
         <p:nvPicPr>
-          <p:cNvPr id="16" name="icon-118" descr="/tmp/tmp.3zNu4FnGzV/icons/alarm.png">    </p:cNvPr>
+          <p:cNvPr id="16" name="icon-118" descr="/tmp/tmp.d1XBSNPuR1/icons/alarm.png">    </p:cNvPr>
           <p:cNvPicPr>
             <a:picLocks noChangeAspect="1"/>
           </p:cNvPicPr>
@@ -11899,7 +11899,7 @@
       </p:sp>
       <p:pic>
         <p:nvPicPr>
-          <p:cNvPr id="19" name="icon-121" descr="/tmp/tmp.3zNu4FnGzV/icons/system-run.png">    </p:cNvPr>
+          <p:cNvPr id="19" name="icon-121" descr="/tmp/tmp.d1XBSNPuR1/icons/system-run.png">    </p:cNvPr>
           <p:cNvPicPr>
             <a:picLocks noChangeAspect="1"/>
           </p:cNvPicPr>
@@ -12125,7 +12125,7 @@
       </p:sp>
       <p:pic>
         <p:nvPicPr>
-          <p:cNvPr id="5" name="monitor" descr="/tmp/tmp.3zNu4FnGzV/img/speedtest.jpg">    </p:cNvPr>
+          <p:cNvPr id="5" name="monitor" descr="/tmp/tmp.d1XBSNPuR1/img/speedtest.jpg">    </p:cNvPr>
           <p:cNvPicPr>
             <a:picLocks noChangeAspect="1"/>
           </p:cNvPicPr>
@@ -12156,7 +12156,7 @@
       </p:pic>
       <p:pic>
         <p:nvPicPr>
-          <p:cNvPr id="6" name="media" descr="/tmp/tmp.3zNu4FnGzV/img/media.jpg">    </p:cNvPr>
+          <p:cNvPr id="6" name="media" descr="/tmp/tmp.d1XBSNPuR1/img/media.jpg">    </p:cNvPr>
           <p:cNvPicPr>
             <a:picLocks noChangeAspect="1"/>
           </p:cNvPicPr>
@@ -12243,7 +12243,7 @@
       </p:sp>
       <p:pic>
         <p:nvPicPr>
-          <p:cNvPr id="9" name="icon-125" descr="/tmp/tmp.3zNu4FnGzV/icons/video-display.png">    </p:cNvPr>
+          <p:cNvPr id="9" name="icon-125" descr="/tmp/tmp.d1XBSNPuR1/icons/video-display.png">    </p:cNvPr>
           <p:cNvPicPr>
             <a:picLocks noChangeAspect="1"/>
           </p:cNvPicPr>
@@ -12343,7 +12343,7 @@
       </p:sp>
       <p:pic>
         <p:nvPicPr>
-          <p:cNvPr id="12" name="icon-128" descr="/tmp/tmp.3zNu4FnGzV/icons/network-workgroup.png">    </p:cNvPr>
+          <p:cNvPr id="12" name="icon-128" descr="/tmp/tmp.d1XBSNPuR1/icons/network-workgroup.png">    </p:cNvPr>
           <p:cNvPicPr>
             <a:picLocks noChangeAspect="1"/>
           </p:cNvPicPr>
@@ -12443,7 +12443,7 @@
       </p:sp>
       <p:pic>
         <p:nvPicPr>
-          <p:cNvPr id="15" name="icon-131" descr="/tmp/tmp.3zNu4FnGzV/icons/audio-speakers.png">    </p:cNvPr>
+          <p:cNvPr id="15" name="icon-131" descr="/tmp/tmp.d1XBSNPuR1/icons/audio-speakers.png">    </p:cNvPr>
           <p:cNvPicPr>
             <a:picLocks noChangeAspect="1"/>
           </p:cNvPicPr>
@@ -12543,7 +12543,7 @@
       </p:sp>
       <p:pic>
         <p:nvPicPr>
-          <p:cNvPr id="18" name="icon-134" descr="/tmp/tmp.3zNu4FnGzV/icons/edit-paste.png">    </p:cNvPr>
+          <p:cNvPr id="18" name="icon-134" descr="/tmp/tmp.d1XBSNPuR1/icons/edit-paste.png">    </p:cNvPr>
           <p:cNvPicPr>
             <a:picLocks noChangeAspect="1"/>
           </p:cNvPicPr>

</xml_diff>

<commit_message>
docs(overview): rebuild with the new portrait
</commit_message>
<xml_diff>
--- a/docs/MK-Workstation-Overview.pptx
+++ b/docs/MK-Workstation-Overview.pptx
@@ -120,40 +120,40 @@
   <p:extLst>
     <p:ext uri="{521415D9-36F7-43E2-AB2F-B90AF26B5E84}">
       <p14:sectionLst xmlns:p14="http://schemas.microsoft.com/office/powerpoint/2010/main">
-        <p14:section name="Introduction" id="{a4e91839-7d3c-9630-f0c8-593914acf940}">
+        <p14:section name="Introduction" id="{31c10559-09e1-e204-0d67-bbe9cf5d7a59}">
           <p14:sldIdLst>
             <p14:sldId id="256"/>
             <p14:sldId id="257"/>
           </p14:sldIdLst>
         </p14:section>
-        <p14:section name="Your desktop" id="{5d129441-d714-7ec2-185a-43c7b315cf0d}">
+        <p14:section name="Your desktop" id="{c2807fab-5776-b1b6-92e8-fe965b38da05}">
           <p14:sldIdLst>
             <p14:sldId id="258"/>
             <p14:sldId id="259"/>
             <p14:sldId id="260"/>
           </p14:sldIdLst>
         </p14:section>
-        <p14:section name="MK Notes" id="{856d272f-f163-0b47-b75c-2e4f6bfc24bd}">
+        <p14:section name="MK Notes" id="{fffe0bb9-94c2-c0fa-f7a8-fbabae724af8}">
           <p14:sldIdLst>
             <p14:sldId id="261"/>
             <p14:sldId id="262"/>
           </p14:sldIdLst>
         </p14:section>
-        <p14:section name="Focus and tools" id="{6adf2f33-0d49-014c-c98c-24c7ceb4f9ea}">
+        <p14:section name="Focus and tools" id="{126a9600-37da-0f0f-0e67-9816ddce905b}">
           <p14:sldIdLst>
             <p14:sldId id="263"/>
             <p14:sldId id="264"/>
             <p14:sldId id="265"/>
           </p14:sldIdLst>
         </p14:section>
-        <p14:section name="Your computer" id="{0576ea75-b6d5-859c-14c0-418a14a68bf5}">
+        <p14:section name="Your computer" id="{beb51562-1496-2da5-eddf-f45a21aed927}">
           <p14:sldIdLst>
             <p14:sldId id="266"/>
             <p14:sldId id="267"/>
             <p14:sldId id="268"/>
           </p14:sldIdLst>
         </p14:section>
-        <p14:section name="Get started" id="{e6a8497c-4358-4496-50a6-81913220da7d}">
+        <p14:section name="Get started" id="{4893a20b-310e-227c-f387-228dbd0eb82e}">
           <p14:sldIdLst>
             <p14:sldId id="269"/>
           </p14:sldIdLst>
@@ -2533,7 +2533,7 @@
       </p:grpSpPr>
       <p:pic>
         <p:nvPicPr>
-          <p:cNvPr id="2" name="hero" descr="/tmp/tmp.d1XBSNPuR1/img/welcome.jpg">    </p:cNvPr>
+          <p:cNvPr id="2" name="hero" descr="/tmp/tmp.TsTTSamSPF/img/welcome.jpg">    </p:cNvPr>
           <p:cNvPicPr>
             <a:picLocks noChangeAspect="1"/>
           </p:cNvPicPr>
@@ -2805,7 +2805,7 @@
       </p:sp>
       <p:pic>
         <p:nvPicPr>
-          <p:cNvPr id="5" name="app-136" descr="/tmp/tmp.d1XBSNPuR1/apps/app.zen_browser.zen.png">    </p:cNvPr>
+          <p:cNvPr id="5" name="app-136" descr="/tmp/tmp.TsTTSamSPF/apps/app.zen_browser.zen.png">    </p:cNvPr>
           <p:cNvPicPr>
             <a:picLocks noChangeAspect="1"/>
           </p:cNvPicPr>
@@ -2865,7 +2865,7 @@
       </p:sp>
       <p:pic>
         <p:nvPicPr>
-          <p:cNvPr id="7" name="app-138" descr="/tmp/tmp.d1XBSNPuR1/apps/net.cozic.joplin_desktop.png">    </p:cNvPr>
+          <p:cNvPr id="7" name="app-138" descr="/tmp/tmp.TsTTSamSPF/apps/net.cozic.joplin_desktop.png">    </p:cNvPr>
           <p:cNvPicPr>
             <a:picLocks noChangeAspect="1"/>
           </p:cNvPicPr>
@@ -2925,7 +2925,7 @@
       </p:sp>
       <p:pic>
         <p:nvPicPr>
-          <p:cNvPr id="9" name="app-140" descr="/tmp/tmp.d1XBSNPuR1/apps/org.onlyoffice.desktopeditors.png">    </p:cNvPr>
+          <p:cNvPr id="9" name="app-140" descr="/tmp/tmp.TsTTSamSPF/apps/org.onlyoffice.desktopeditors.png">    </p:cNvPr>
           <p:cNvPicPr>
             <a:picLocks noChangeAspect="1"/>
           </p:cNvPicPr>
@@ -2985,7 +2985,7 @@
       </p:sp>
       <p:pic>
         <p:nvPicPr>
-          <p:cNvPr id="11" name="app-142" descr="/tmp/tmp.d1XBSNPuR1/apps/vscode.png">    </p:cNvPr>
+          <p:cNvPr id="11" name="app-142" descr="/tmp/tmp.TsTTSamSPF/apps/vscode.png">    </p:cNvPr>
           <p:cNvPicPr>
             <a:picLocks noChangeAspect="1"/>
           </p:cNvPicPr>
@@ -3045,7 +3045,7 @@
       </p:sp>
       <p:pic>
         <p:nvPicPr>
-          <p:cNvPr id="13" name="app-144" descr="/tmp/tmp.d1XBSNPuR1/apps/com.spotify.Client.png">    </p:cNvPr>
+          <p:cNvPr id="13" name="app-144" descr="/tmp/tmp.TsTTSamSPF/apps/com.spotify.Client.png">    </p:cNvPr>
           <p:cNvPicPr>
             <a:picLocks noChangeAspect="1"/>
           </p:cNvPicPr>
@@ -3105,7 +3105,7 @@
       </p:sp>
       <p:pic>
         <p:nvPicPr>
-          <p:cNvPr id="15" name="app-146" descr="/tmp/tmp.d1XBSNPuR1/apps/net.lutris.Lutris.png">    </p:cNvPr>
+          <p:cNvPr id="15" name="app-146" descr="/tmp/tmp.TsTTSamSPF/apps/net.lutris.Lutris.png">    </p:cNvPr>
           <p:cNvPicPr>
             <a:picLocks noChangeAspect="1"/>
           </p:cNvPicPr>
@@ -3165,7 +3165,7 @@
       </p:sp>
       <p:pic>
         <p:nvPicPr>
-          <p:cNvPr id="17" name="app-148" descr="/tmp/tmp.d1XBSNPuR1/apps/com.mattjakeman.ExtensionManager.png">    </p:cNvPr>
+          <p:cNvPr id="17" name="app-148" descr="/tmp/tmp.TsTTSamSPF/apps/com.mattjakeman.ExtensionManager.png">    </p:cNvPr>
           <p:cNvPicPr>
             <a:picLocks noChangeAspect="1"/>
           </p:cNvPicPr>
@@ -3225,7 +3225,7 @@
       </p:sp>
       <p:pic>
         <p:nvPicPr>
-          <p:cNvPr id="19" name="app-150" descr="/tmp/tmp.d1XBSNPuR1/apps/net.sonobus.SonoBus.png">    </p:cNvPr>
+          <p:cNvPr id="19" name="app-150" descr="/tmp/tmp.TsTTSamSPF/apps/net.sonobus.SonoBus.png">    </p:cNvPr>
           <p:cNvPicPr>
             <a:picLocks noChangeAspect="1"/>
           </p:cNvPicPr>
@@ -3285,7 +3285,7 @@
       </p:sp>
       <p:pic>
         <p:nvPicPr>
-          <p:cNvPr id="21" name="app-152" descr="/tmp/tmp.d1XBSNPuR1/apps/com.github.tenderowl.frog.png">    </p:cNvPr>
+          <p:cNvPr id="21" name="app-152" descr="/tmp/tmp.TsTTSamSPF/apps/com.github.tenderowl.frog.png">    </p:cNvPr>
           <p:cNvPicPr>
             <a:picLocks noChangeAspect="1"/>
           </p:cNvPicPr>
@@ -3345,7 +3345,7 @@
       </p:sp>
       <p:pic>
         <p:nvPicPr>
-          <p:cNvPr id="23" name="app-154" descr="/tmp/tmp.d1XBSNPuR1/apps/one.alynx.FlipClock.png">    </p:cNvPr>
+          <p:cNvPr id="23" name="app-154" descr="/tmp/tmp.TsTTSamSPF/apps/one.alynx.FlipClock.png">    </p:cNvPr>
           <p:cNvPicPr>
             <a:picLocks noChangeAspect="1"/>
           </p:cNvPicPr>
@@ -3405,7 +3405,7 @@
       </p:sp>
       <p:pic>
         <p:nvPicPr>
-          <p:cNvPr id="25" name="app-156" descr="/tmp/tmp.d1XBSNPuR1/apps/io.github.mehulk.MkNotes.png">    </p:cNvPr>
+          <p:cNvPr id="25" name="app-156" descr="/tmp/tmp.TsTTSamSPF/apps/io.github.mehulk.MkNotes.png">    </p:cNvPr>
           <p:cNvPicPr>
             <a:picLocks noChangeAspect="1"/>
           </p:cNvPicPr>
@@ -3465,7 +3465,7 @@
       </p:sp>
       <p:pic>
         <p:nvPicPr>
-          <p:cNvPr id="27" name="app-158" descr="/tmp/tmp.d1XBSNPuR1/apps/io.github.mehulk.MkCompanion.png">    </p:cNvPr>
+          <p:cNvPr id="27" name="app-158" descr="/tmp/tmp.TsTTSamSPF/apps/io.github.mehulk.MkCompanion.png">    </p:cNvPr>
           <p:cNvPicPr>
             <a:picLocks noChangeAspect="1"/>
           </p:cNvPicPr>
@@ -3525,7 +3525,7 @@
       </p:sp>
       <p:pic>
         <p:nvPicPr>
-          <p:cNvPr id="29" name="app-160" descr="/tmp/tmp.d1XBSNPuR1/apps/io.github.mehulk.MkTimer.png">    </p:cNvPr>
+          <p:cNvPr id="29" name="app-160" descr="/tmp/tmp.TsTTSamSPF/apps/io.github.mehulk.MkTimer.png">    </p:cNvPr>
           <p:cNvPicPr>
             <a:picLocks noChangeAspect="1"/>
           </p:cNvPicPr>
@@ -3585,7 +3585,7 @@
       </p:sp>
       <p:pic>
         <p:nvPicPr>
-          <p:cNvPr id="31" name="app-162" descr="/tmp/tmp.d1XBSNPuR1/apps/io.github.mehulk.MkShortcuts.png">    </p:cNvPr>
+          <p:cNvPr id="31" name="app-162" descr="/tmp/tmp.TsTTSamSPF/apps/io.github.mehulk.MkShortcuts.png">    </p:cNvPr>
           <p:cNvPicPr>
             <a:picLocks noChangeAspect="1"/>
           </p:cNvPicPr>
@@ -3869,7 +3869,7 @@
       </p:sp>
       <p:pic>
         <p:nvPicPr>
-          <p:cNvPr id="7" name="icon-166" descr="/tmp/tmp.d1XBSNPuR1/icons/auth-fingerprint.png">    </p:cNvPr>
+          <p:cNvPr id="7" name="icon-166" descr="/tmp/tmp.TsTTSamSPF/icons/auth-fingerprint.png">    </p:cNvPr>
           <p:cNvPicPr>
             <a:picLocks noChangeAspect="1"/>
           </p:cNvPicPr>
@@ -3991,7 +3991,7 @@
       </p:sp>
       <p:pic>
         <p:nvPicPr>
-          <p:cNvPr id="11" name="icon-170" descr="/tmp/tmp.d1XBSNPuR1/icons/battery-full.png">    </p:cNvPr>
+          <p:cNvPr id="11" name="icon-170" descr="/tmp/tmp.TsTTSamSPF/icons/battery-full.png">    </p:cNvPr>
           <p:cNvPicPr>
             <a:picLocks noChangeAspect="1"/>
           </p:cNvPicPr>
@@ -4113,7 +4113,7 @@
       </p:sp>
       <p:pic>
         <p:nvPicPr>
-          <p:cNvPr id="15" name="icon-174" descr="/tmp/tmp.d1XBSNPuR1/icons/audio-speakers.png">    </p:cNvPr>
+          <p:cNvPr id="15" name="icon-174" descr="/tmp/tmp.TsTTSamSPF/icons/audio-speakers.png">    </p:cNvPr>
           <p:cNvPicPr>
             <a:picLocks noChangeAspect="1"/>
           </p:cNvPicPr>
@@ -4235,7 +4235,7 @@
       </p:sp>
       <p:pic>
         <p:nvPicPr>
-          <p:cNvPr id="19" name="icon-178" descr="/tmp/tmp.d1XBSNPuR1/icons/input-tablet.png">    </p:cNvPr>
+          <p:cNvPr id="19" name="icon-178" descr="/tmp/tmp.TsTTSamSPF/icons/input-tablet.png">    </p:cNvPr>
           <p:cNvPicPr>
             <a:picLocks noChangeAspect="1"/>
           </p:cNvPicPr>
@@ -4357,7 +4357,7 @@
       </p:sp>
       <p:pic>
         <p:nvPicPr>
-          <p:cNvPr id="23" name="icon-182" descr="/tmp/tmp.d1XBSNPuR1/icons/video-display.png">    </p:cNvPr>
+          <p:cNvPr id="23" name="icon-182" descr="/tmp/tmp.TsTTSamSPF/icons/video-display.png">    </p:cNvPr>
           <p:cNvPicPr>
             <a:picLocks noChangeAspect="1"/>
           </p:cNvPicPr>
@@ -4479,7 +4479,7 @@
       </p:sp>
       <p:pic>
         <p:nvPicPr>
-          <p:cNvPr id="27" name="icon-186" descr="/tmp/tmp.d1XBSNPuR1/icons/system-run.png">    </p:cNvPr>
+          <p:cNvPr id="27" name="icon-186" descr="/tmp/tmp.TsTTSamSPF/icons/system-run.png">    </p:cNvPr>
           <p:cNvPicPr>
             <a:picLocks noChangeAspect="1"/>
           </p:cNvPicPr>
@@ -5645,7 +5645,7 @@
       </p:sp>
       <p:pic>
         <p:nvPicPr>
-          <p:cNvPr id="35" name="shortcuts" descr="/tmp/tmp.d1XBSNPuR1/img/shortcuts.jpg">    </p:cNvPr>
+          <p:cNvPr id="35" name="shortcuts" descr="/tmp/tmp.TsTTSamSPF/img/shortcuts.jpg">    </p:cNvPr>
           <p:cNvPicPr>
             <a:picLocks noChangeAspect="1"/>
           </p:cNvPicPr>
@@ -5878,7 +5878,7 @@
       </p:sp>
       <p:pic>
         <p:nvPicPr>
-          <p:cNvPr id="6" name="icon-220" descr="/tmp/tmp.d1XBSNPuR1/icons/document-open-recent.png">    </p:cNvPr>
+          <p:cNvPr id="6" name="icon-220" descr="/tmp/tmp.TsTTSamSPF/icons/document-open-recent.png">    </p:cNvPr>
           <p:cNvPicPr>
             <a:picLocks noChangeAspect="1"/>
           </p:cNvPicPr>
@@ -5978,7 +5978,7 @@
       </p:sp>
       <p:pic>
         <p:nvPicPr>
-          <p:cNvPr id="9" name="icon-223" descr="/tmp/tmp.d1XBSNPuR1/icons/user-trash.png">    </p:cNvPr>
+          <p:cNvPr id="9" name="icon-223" descr="/tmp/tmp.TsTTSamSPF/icons/user-trash.png">    </p:cNvPr>
           <p:cNvPicPr>
             <a:picLocks noChangeAspect="1"/>
           </p:cNvPicPr>
@@ -6078,7 +6078,7 @@
       </p:sp>
       <p:pic>
         <p:nvPicPr>
-          <p:cNvPr id="12" name="icon-226" descr="/tmp/tmp.d1XBSNPuR1/icons/checkbox-checked.png">    </p:cNvPr>
+          <p:cNvPr id="12" name="icon-226" descr="/tmp/tmp.TsTTSamSPF/icons/checkbox-checked.png">    </p:cNvPr>
           <p:cNvPicPr>
             <a:picLocks noChangeAspect="1"/>
           </p:cNvPicPr>
@@ -6178,7 +6178,7 @@
       </p:sp>
       <p:pic>
         <p:nvPicPr>
-          <p:cNvPr id="15" name="icon-229" descr="/tmp/tmp.d1XBSNPuR1/icons/x-office-document.png">    </p:cNvPr>
+          <p:cNvPr id="15" name="icon-229" descr="/tmp/tmp.TsTTSamSPF/icons/x-office-document.png">    </p:cNvPr>
           <p:cNvPicPr>
             <a:picLocks noChangeAspect="1"/>
           </p:cNvPicPr>
@@ -6278,7 +6278,7 @@
       </p:sp>
       <p:pic>
         <p:nvPicPr>
-          <p:cNvPr id="18" name="icon-232" descr="/tmp/tmp.d1XBSNPuR1/icons/software-update-available.png">    </p:cNvPr>
+          <p:cNvPr id="18" name="icon-232" descr="/tmp/tmp.TsTTSamSPF/icons/software-update-available.png">    </p:cNvPr>
           <p:cNvPicPr>
             <a:picLocks noChangeAspect="1"/>
           </p:cNvPicPr>
@@ -6358,7 +6358,7 @@
       </p:sp>
       <p:pic>
         <p:nvPicPr>
-          <p:cNvPr id="20" name="companion" descr="/tmp/tmp.d1XBSNPuR1/img/companion.jpg">    </p:cNvPr>
+          <p:cNvPr id="20" name="companion" descr="/tmp/tmp.TsTTSamSPF/img/companion.jpg">    </p:cNvPr>
           <p:cNvPicPr>
             <a:picLocks noChangeAspect="1"/>
           </p:cNvPicPr>
@@ -7087,7 +7087,7 @@
       </p:sp>
       <p:pic>
         <p:nvPicPr>
-          <p:cNvPr id="7" name="icon-2" descr="/tmp/tmp.d1XBSNPuR1/icons/edit-undo.png">    </p:cNvPr>
+          <p:cNvPr id="7" name="icon-2" descr="/tmp/tmp.TsTTSamSPF/icons/edit-undo.png">    </p:cNvPr>
           <p:cNvPicPr>
             <a:picLocks noChangeAspect="1"/>
           </p:cNvPicPr>
@@ -7187,7 +7187,7 @@
       </p:sp>
       <p:pic>
         <p:nvPicPr>
-          <p:cNvPr id="10" name="icon-5" descr="/tmp/tmp.d1XBSNPuR1/icons/software-update-available.png">    </p:cNvPr>
+          <p:cNvPr id="10" name="icon-5" descr="/tmp/tmp.TsTTSamSPF/icons/software-update-available.png">    </p:cNvPr>
           <p:cNvPicPr>
             <a:picLocks noChangeAspect="1"/>
           </p:cNvPicPr>
@@ -7845,7 +7845,7 @@
       </p:sp>
       <p:pic>
         <p:nvPicPr>
-          <p:cNvPr id="5" name="alttab-19" descr="/tmp/tmp.d1XBSNPuR1/img/alttab.jpg">    </p:cNvPr>
+          <p:cNvPr id="5" name="alttab-19" descr="/tmp/tmp.TsTTSamSPF/img/alttab.jpg">    </p:cNvPr>
           <p:cNvPicPr>
             <a:picLocks noChangeAspect="1"/>
           </p:cNvPicPr>
@@ -7932,7 +7932,7 @@
       </p:sp>
       <p:pic>
         <p:nvPicPr>
-          <p:cNvPr id="8" name="icon-22" descr="/tmp/tmp.d1XBSNPuR1/icons/view-grid.png">    </p:cNvPr>
+          <p:cNvPr id="8" name="icon-22" descr="/tmp/tmp.TsTTSamSPF/icons/view-grid.png">    </p:cNvPr>
           <p:cNvPicPr>
             <a:picLocks noChangeAspect="1"/>
           </p:cNvPicPr>
@@ -8032,7 +8032,7 @@
       </p:sp>
       <p:pic>
         <p:nvPicPr>
-          <p:cNvPr id="11" name="icon-25" descr="/tmp/tmp.d1XBSNPuR1/icons/input-touchpad.png">    </p:cNvPr>
+          <p:cNvPr id="11" name="icon-25" descr="/tmp/tmp.TsTTSamSPF/icons/input-touchpad.png">    </p:cNvPr>
           <p:cNvPicPr>
             <a:picLocks noChangeAspect="1"/>
           </p:cNvPicPr>
@@ -8132,7 +8132,7 @@
       </p:sp>
       <p:pic>
         <p:nvPicPr>
-          <p:cNvPr id="14" name="icon-28" descr="/tmp/tmp.d1XBSNPuR1/icons/view-dual.png">    </p:cNvPr>
+          <p:cNvPr id="14" name="icon-28" descr="/tmp/tmp.TsTTSamSPF/icons/view-dual.png">    </p:cNvPr>
           <p:cNvPicPr>
             <a:picLocks noChangeAspect="1"/>
           </p:cNvPicPr>
@@ -8232,7 +8232,7 @@
       </p:sp>
       <p:pic>
         <p:nvPicPr>
-          <p:cNvPr id="17" name="icon-31" descr="/tmp/tmp.d1XBSNPuR1/icons/system-run.png">    </p:cNvPr>
+          <p:cNvPr id="17" name="icon-31" descr="/tmp/tmp.TsTTSamSPF/icons/system-run.png">    </p:cNvPr>
           <p:cNvPicPr>
             <a:picLocks noChangeAspect="1"/>
           </p:cNvPicPr>
@@ -8458,7 +8458,7 @@
       </p:sp>
       <p:pic>
         <p:nvPicPr>
-          <p:cNvPr id="5" name="tiled-33" descr="/tmp/tmp.d1XBSNPuR1/img/tiled.jpg">    </p:cNvPr>
+          <p:cNvPr id="5" name="tiled-33" descr="/tmp/tmp.TsTTSamSPF/img/tiled.jpg">    </p:cNvPr>
           <p:cNvPicPr>
             <a:picLocks noChangeAspect="1"/>
           </p:cNvPicPr>
@@ -8545,7 +8545,7 @@
       </p:sp>
       <p:pic>
         <p:nvPicPr>
-          <p:cNvPr id="8" name="icon-36" descr="/tmp/tmp.d1XBSNPuR1/icons/view-dual.png">    </p:cNvPr>
+          <p:cNvPr id="8" name="icon-36" descr="/tmp/tmp.TsTTSamSPF/icons/view-dual.png">    </p:cNvPr>
           <p:cNvPicPr>
             <a:picLocks noChangeAspect="1"/>
           </p:cNvPicPr>
@@ -8645,7 +8645,7 @@
       </p:sp>
       <p:pic>
         <p:nvPicPr>
-          <p:cNvPr id="11" name="icon-39" descr="/tmp/tmp.d1XBSNPuR1/icons/window-new.png">    </p:cNvPr>
+          <p:cNvPr id="11" name="icon-39" descr="/tmp/tmp.TsTTSamSPF/icons/window-new.png">    </p:cNvPr>
           <p:cNvPicPr>
             <a:picLocks noChangeAspect="1"/>
           </p:cNvPicPr>
@@ -8745,7 +8745,7 @@
       </p:sp>
       <p:pic>
         <p:nvPicPr>
-          <p:cNvPr id="14" name="icon-42" descr="/tmp/tmp.d1XBSNPuR1/icons/view-pin.png">    </p:cNvPr>
+          <p:cNvPr id="14" name="icon-42" descr="/tmp/tmp.TsTTSamSPF/icons/view-pin.png">    </p:cNvPr>
           <p:cNvPicPr>
             <a:picLocks noChangeAspect="1"/>
           </p:cNvPicPr>
@@ -8845,7 +8845,7 @@
       </p:sp>
       <p:pic>
         <p:nvPicPr>
-          <p:cNvPr id="17" name="icon-45" descr="/tmp/tmp.d1XBSNPuR1/icons/view-grid.png">    </p:cNvPr>
+          <p:cNvPr id="17" name="icon-45" descr="/tmp/tmp.TsTTSamSPF/icons/view-grid.png">    </p:cNvPr>
           <p:cNvPicPr>
             <a:picLocks noChangeAspect="1"/>
           </p:cNvPicPr>
@@ -9071,7 +9071,7 @@
       </p:sp>
       <p:pic>
         <p:nvPicPr>
-          <p:cNvPr id="5" name="welcome-47" descr="/tmp/tmp.d1XBSNPuR1/img/welcome.jpg">    </p:cNvPr>
+          <p:cNvPr id="5" name="welcome-47" descr="/tmp/tmp.TsTTSamSPF/img/welcome.jpg">    </p:cNvPr>
           <p:cNvPicPr>
             <a:picLocks noChangeAspect="1"/>
           </p:cNvPicPr>
@@ -9158,7 +9158,7 @@
       </p:sp>
       <p:pic>
         <p:nvPicPr>
-          <p:cNvPr id="8" name="icon-50" descr="/tmp/tmp.d1XBSNPuR1/icons/weather-clear-night.png">    </p:cNvPr>
+          <p:cNvPr id="8" name="icon-50" descr="/tmp/tmp.TsTTSamSPF/icons/weather-clear-night.png">    </p:cNvPr>
           <p:cNvPicPr>
             <a:picLocks noChangeAspect="1"/>
           </p:cNvPicPr>
@@ -9258,7 +9258,7 @@
       </p:sp>
       <p:pic>
         <p:nvPicPr>
-          <p:cNvPr id="11" name="icon-53" descr="/tmp/tmp.d1XBSNPuR1/icons/view-pin.png">    </p:cNvPr>
+          <p:cNvPr id="11" name="icon-53" descr="/tmp/tmp.TsTTSamSPF/icons/view-pin.png">    </p:cNvPr>
           <p:cNvPicPr>
             <a:picLocks noChangeAspect="1"/>
           </p:cNvPicPr>
@@ -9358,7 +9358,7 @@
       </p:sp>
       <p:pic>
         <p:nvPicPr>
-          <p:cNvPr id="14" name="icon-56" descr="/tmp/tmp.d1XBSNPuR1/icons/face-smile.png">    </p:cNvPr>
+          <p:cNvPr id="14" name="icon-56" descr="/tmp/tmp.TsTTSamSPF/icons/face-smile.png">    </p:cNvPr>
           <p:cNvPicPr>
             <a:picLocks noChangeAspect="1"/>
           </p:cNvPicPr>
@@ -9458,7 +9458,7 @@
       </p:sp>
       <p:pic>
         <p:nvPicPr>
-          <p:cNvPr id="17" name="icon-59" descr="/tmp/tmp.d1XBSNPuR1/icons/preferences-color.png">    </p:cNvPr>
+          <p:cNvPr id="17" name="icon-59" descr="/tmp/tmp.TsTTSamSPF/icons/preferences-color.png">    </p:cNvPr>
           <p:cNvPicPr>
             <a:picLocks noChangeAspect="1"/>
           </p:cNvPicPr>
@@ -9684,7 +9684,7 @@
       </p:sp>
       <p:pic>
         <p:nvPicPr>
-          <p:cNvPr id="5" name="notes-split-61" descr="/tmp/tmp.d1XBSNPuR1/img/notes-split.jpg">    </p:cNvPr>
+          <p:cNvPr id="5" name="notes-split-61" descr="/tmp/tmp.TsTTSamSPF/img/notes-split.jpg">    </p:cNvPr>
           <p:cNvPicPr>
             <a:picLocks noChangeAspect="1"/>
           </p:cNvPicPr>
@@ -9715,7 +9715,7 @@
       </p:pic>
       <p:pic>
         <p:nvPicPr>
-          <p:cNvPr id="6" name="phone" descr="/tmp/tmp.d1XBSNPuR1/img/phone-note.jpg">    </p:cNvPr>
+          <p:cNvPr id="6" name="phone" descr="/tmp/tmp.TsTTSamSPF/img/phone-note.jpg">    </p:cNvPr>
           <p:cNvPicPr>
             <a:picLocks noChangeAspect="1"/>
           </p:cNvPicPr>
@@ -9802,7 +9802,7 @@
       </p:sp>
       <p:pic>
         <p:nvPicPr>
-          <p:cNvPr id="9" name="icon-64" descr="/tmp/tmp.d1XBSNPuR1/icons/x-office-document.png">    </p:cNvPr>
+          <p:cNvPr id="9" name="icon-64" descr="/tmp/tmp.TsTTSamSPF/icons/x-office-document.png">    </p:cNvPr>
           <p:cNvPicPr>
             <a:picLocks noChangeAspect="1"/>
           </p:cNvPicPr>
@@ -9902,7 +9902,7 @@
       </p:sp>
       <p:pic>
         <p:nvPicPr>
-          <p:cNvPr id="12" name="icon-67" descr="/tmp/tmp.d1XBSNPuR1/icons/network-workgroup.png">    </p:cNvPr>
+          <p:cNvPr id="12" name="icon-67" descr="/tmp/tmp.TsTTSamSPF/icons/network-workgroup.png">    </p:cNvPr>
           <p:cNvPicPr>
             <a:picLocks noChangeAspect="1"/>
           </p:cNvPicPr>
@@ -10002,7 +10002,7 @@
       </p:sp>
       <p:pic>
         <p:nvPicPr>
-          <p:cNvPr id="15" name="icon-70" descr="/tmp/tmp.d1XBSNPuR1/icons/applications-graphics.png">    </p:cNvPr>
+          <p:cNvPr id="15" name="icon-70" descr="/tmp/tmp.TsTTSamSPF/icons/applications-graphics.png">    </p:cNvPr>
           <p:cNvPicPr>
             <a:picLocks noChangeAspect="1"/>
           </p:cNvPicPr>
@@ -10102,7 +10102,7 @@
       </p:sp>
       <p:pic>
         <p:nvPicPr>
-          <p:cNvPr id="18" name="icon-73" descr="/tmp/tmp.d1XBSNPuR1/icons/edit-paste.png">    </p:cNvPr>
+          <p:cNvPr id="18" name="icon-73" descr="/tmp/tmp.TsTTSamSPF/icons/edit-paste.png">    </p:cNvPr>
           <p:cNvPicPr>
             <a:picLocks noChangeAspect="1"/>
           </p:cNvPicPr>
@@ -10370,7 +10370,7 @@
       </p:sp>
       <p:pic>
         <p:nvPicPr>
-          <p:cNvPr id="7" name="icon-77" descr="/tmp/tmp.d1XBSNPuR1/icons/emblem-system.png">    </p:cNvPr>
+          <p:cNvPr id="7" name="icon-77" descr="/tmp/tmp.TsTTSamSPF/icons/emblem-system.png">    </p:cNvPr>
           <p:cNvPicPr>
             <a:picLocks noChangeAspect="1"/>
           </p:cNvPicPr>
@@ -10492,7 +10492,7 @@
       </p:sp>
       <p:pic>
         <p:nvPicPr>
-          <p:cNvPr id="11" name="icon-81" descr="/tmp/tmp.d1XBSNPuR1/icons/x-office-document.png">    </p:cNvPr>
+          <p:cNvPr id="11" name="icon-81" descr="/tmp/tmp.TsTTSamSPF/icons/x-office-document.png">    </p:cNvPr>
           <p:cNvPicPr>
             <a:picLocks noChangeAspect="1"/>
           </p:cNvPicPr>
@@ -10614,7 +10614,7 @@
       </p:sp>
       <p:pic>
         <p:nvPicPr>
-          <p:cNvPr id="15" name="icon-85" descr="/tmp/tmp.d1XBSNPuR1/icons/network-workgroup.png">    </p:cNvPr>
+          <p:cNvPr id="15" name="icon-85" descr="/tmp/tmp.TsTTSamSPF/icons/network-workgroup.png">    </p:cNvPr>
           <p:cNvPicPr>
             <a:picLocks noChangeAspect="1"/>
           </p:cNvPicPr>
@@ -10736,7 +10736,7 @@
       </p:sp>
       <p:pic>
         <p:nvPicPr>
-          <p:cNvPr id="19" name="icon-89" descr="/tmp/tmp.d1XBSNPuR1/icons/document-open-recent.png">    </p:cNvPr>
+          <p:cNvPr id="19" name="icon-89" descr="/tmp/tmp.TsTTSamSPF/icons/document-open-recent.png">    </p:cNvPr>
           <p:cNvPicPr>
             <a:picLocks noChangeAspect="1"/>
           </p:cNvPicPr>
@@ -10858,7 +10858,7 @@
       </p:sp>
       <p:pic>
         <p:nvPicPr>
-          <p:cNvPr id="23" name="icon-93" descr="/tmp/tmp.d1XBSNPuR1/icons/x-office-calendar.png">    </p:cNvPr>
+          <p:cNvPr id="23" name="icon-93" descr="/tmp/tmp.TsTTSamSPF/icons/x-office-calendar.png">    </p:cNvPr>
           <p:cNvPicPr>
             <a:picLocks noChangeAspect="1"/>
           </p:cNvPicPr>
@@ -10980,7 +10980,7 @@
       </p:sp>
       <p:pic>
         <p:nvPicPr>
-          <p:cNvPr id="27" name="icon-97" descr="/tmp/tmp.d1XBSNPuR1/icons/checkbox-checked.png">    </p:cNvPr>
+          <p:cNvPr id="27" name="icon-97" descr="/tmp/tmp.TsTTSamSPF/icons/checkbox-checked.png">    </p:cNvPr>
           <p:cNvPicPr>
             <a:picLocks noChangeAspect="1"/>
           </p:cNvPicPr>
@@ -11102,7 +11102,7 @@
       </p:sp>
       <p:pic>
         <p:nvPicPr>
-          <p:cNvPr id="31" name="icon-101" descr="/tmp/tmp.d1XBSNPuR1/icons/edit-paste.png">    </p:cNvPr>
+          <p:cNvPr id="31" name="icon-101" descr="/tmp/tmp.TsTTSamSPF/icons/edit-paste.png">    </p:cNvPr>
           <p:cNvPicPr>
             <a:picLocks noChangeAspect="1"/>
           </p:cNvPicPr>
@@ -11224,7 +11224,7 @@
       </p:sp>
       <p:pic>
         <p:nvPicPr>
-          <p:cNvPr id="35" name="icon-105" descr="/tmp/tmp.d1XBSNPuR1/icons/preferences-color.png">    </p:cNvPr>
+          <p:cNvPr id="35" name="icon-105" descr="/tmp/tmp.TsTTSamSPF/icons/preferences-color.png">    </p:cNvPr>
           <p:cNvPicPr>
             <a:picLocks noChangeAspect="1"/>
           </p:cNvPicPr>
@@ -11450,7 +11450,7 @@
       </p:sp>
       <p:pic>
         <p:nvPicPr>
-          <p:cNvPr id="5" name="scene-web-107" descr="/tmp/tmp.d1XBSNPuR1/img/scene-web.jpg">    </p:cNvPr>
+          <p:cNvPr id="5" name="scene-web-107" descr="/tmp/tmp.TsTTSamSPF/img/scene-web.jpg">    </p:cNvPr>
           <p:cNvPicPr>
             <a:picLocks noChangeAspect="1"/>
           </p:cNvPicPr>
@@ -11481,7 +11481,7 @@
       </p:pic>
       <p:pic>
         <p:nvPicPr>
-          <p:cNvPr id="6" name="scene-knight-108" descr="/tmp/tmp.d1XBSNPuR1/img/scene-knight.jpg">    </p:cNvPr>
+          <p:cNvPr id="6" name="scene-knight-108" descr="/tmp/tmp.TsTTSamSPF/img/scene-knight.jpg">    </p:cNvPr>
           <p:cNvPicPr>
             <a:picLocks noChangeAspect="1"/>
           </p:cNvPicPr>
@@ -11512,7 +11512,7 @@
       </p:pic>
       <p:pic>
         <p:nvPicPr>
-          <p:cNvPr id="7" name="scene-matrix-109" descr="/tmp/tmp.d1XBSNPuR1/img/scene-matrix.jpg">    </p:cNvPr>
+          <p:cNvPr id="7" name="scene-matrix-109" descr="/tmp/tmp.TsTTSamSPF/img/scene-matrix.jpg">    </p:cNvPr>
           <p:cNvPicPr>
             <a:picLocks noChangeAspect="1"/>
           </p:cNvPicPr>
@@ -11599,7 +11599,7 @@
       </p:sp>
       <p:pic>
         <p:nvPicPr>
-          <p:cNvPr id="10" name="icon-112" descr="/tmp/tmp.d1XBSNPuR1/icons/weather-clear-night.png">    </p:cNvPr>
+          <p:cNvPr id="10" name="icon-112" descr="/tmp/tmp.TsTTSamSPF/icons/weather-clear-night.png">    </p:cNvPr>
           <p:cNvPicPr>
             <a:picLocks noChangeAspect="1"/>
           </p:cNvPicPr>
@@ -11699,7 +11699,7 @@
       </p:sp>
       <p:pic>
         <p:nvPicPr>
-          <p:cNvPr id="13" name="icon-115" descr="/tmp/tmp.d1XBSNPuR1/icons/video-display.png">    </p:cNvPr>
+          <p:cNvPr id="13" name="icon-115" descr="/tmp/tmp.TsTTSamSPF/icons/video-display.png">    </p:cNvPr>
           <p:cNvPicPr>
             <a:picLocks noChangeAspect="1"/>
           </p:cNvPicPr>
@@ -11799,7 +11799,7 @@
       </p:sp>
       <p:pic>
         <p:nvPicPr>
-          <p:cNvPr id="16" name="icon-118" descr="/tmp/tmp.d1XBSNPuR1/icons/alarm.png">    </p:cNvPr>
+          <p:cNvPr id="16" name="icon-118" descr="/tmp/tmp.TsTTSamSPF/icons/alarm.png">    </p:cNvPr>
           <p:cNvPicPr>
             <a:picLocks noChangeAspect="1"/>
           </p:cNvPicPr>
@@ -11899,7 +11899,7 @@
       </p:sp>
       <p:pic>
         <p:nvPicPr>
-          <p:cNvPr id="19" name="icon-121" descr="/tmp/tmp.d1XBSNPuR1/icons/system-run.png">    </p:cNvPr>
+          <p:cNvPr id="19" name="icon-121" descr="/tmp/tmp.TsTTSamSPF/icons/system-run.png">    </p:cNvPr>
           <p:cNvPicPr>
             <a:picLocks noChangeAspect="1"/>
           </p:cNvPicPr>
@@ -12125,7 +12125,7 @@
       </p:sp>
       <p:pic>
         <p:nvPicPr>
-          <p:cNvPr id="5" name="monitor" descr="/tmp/tmp.d1XBSNPuR1/img/speedtest.jpg">    </p:cNvPr>
+          <p:cNvPr id="5" name="monitor" descr="/tmp/tmp.TsTTSamSPF/img/speedtest.jpg">    </p:cNvPr>
           <p:cNvPicPr>
             <a:picLocks noChangeAspect="1"/>
           </p:cNvPicPr>
@@ -12156,7 +12156,7 @@
       </p:pic>
       <p:pic>
         <p:nvPicPr>
-          <p:cNvPr id="6" name="media" descr="/tmp/tmp.d1XBSNPuR1/img/media.jpg">    </p:cNvPr>
+          <p:cNvPr id="6" name="media" descr="/tmp/tmp.TsTTSamSPF/img/media.jpg">    </p:cNvPr>
           <p:cNvPicPr>
             <a:picLocks noChangeAspect="1"/>
           </p:cNvPicPr>
@@ -12243,7 +12243,7 @@
       </p:sp>
       <p:pic>
         <p:nvPicPr>
-          <p:cNvPr id="9" name="icon-125" descr="/tmp/tmp.d1XBSNPuR1/icons/video-display.png">    </p:cNvPr>
+          <p:cNvPr id="9" name="icon-125" descr="/tmp/tmp.TsTTSamSPF/icons/video-display.png">    </p:cNvPr>
           <p:cNvPicPr>
             <a:picLocks noChangeAspect="1"/>
           </p:cNvPicPr>
@@ -12343,7 +12343,7 @@
       </p:sp>
       <p:pic>
         <p:nvPicPr>
-          <p:cNvPr id="12" name="icon-128" descr="/tmp/tmp.d1XBSNPuR1/icons/network-workgroup.png">    </p:cNvPr>
+          <p:cNvPr id="12" name="icon-128" descr="/tmp/tmp.TsTTSamSPF/icons/network-workgroup.png">    </p:cNvPr>
           <p:cNvPicPr>
             <a:picLocks noChangeAspect="1"/>
           </p:cNvPicPr>
@@ -12443,7 +12443,7 @@
       </p:sp>
       <p:pic>
         <p:nvPicPr>
-          <p:cNvPr id="15" name="icon-131" descr="/tmp/tmp.d1XBSNPuR1/icons/audio-speakers.png">    </p:cNvPr>
+          <p:cNvPr id="15" name="icon-131" descr="/tmp/tmp.TsTTSamSPF/icons/audio-speakers.png">    </p:cNvPr>
           <p:cNvPicPr>
             <a:picLocks noChangeAspect="1"/>
           </p:cNvPicPr>
@@ -12543,7 +12543,7 @@
       </p:sp>
       <p:pic>
         <p:nvPicPr>
-          <p:cNvPr id="18" name="icon-134" descr="/tmp/tmp.d1XBSNPuR1/icons/edit-paste.png">    </p:cNvPr>
+          <p:cNvPr id="18" name="icon-134" descr="/tmp/tmp.TsTTSamSPF/icons/edit-paste.png">    </p:cNvPr>
           <p:cNvPicPr>
             <a:picLocks noChangeAspect="1"/>
           </p:cNvPicPr>

</xml_diff>